<commit_message>
continued chapter Nietverbindungen in KE
</commit_message>
<xml_diff>
--- a/LaTeX B.Sc. LRT/Konstruktionslehre 1&2/images/KE-Images.pptx
+++ b/LaTeX B.Sc. LRT/Konstruktionslehre 1&2/images/KE-Images.pptx
@@ -11,8 +11,9 @@
     <p:sldId id="258" r:id="rId5"/>
     <p:sldId id="261" r:id="rId6"/>
     <p:sldId id="260" r:id="rId7"/>
-    <p:sldId id="263" r:id="rId8"/>
-    <p:sldId id="262" r:id="rId9"/>
+    <p:sldId id="264" r:id="rId8"/>
+    <p:sldId id="263" r:id="rId9"/>
+    <p:sldId id="262" r:id="rId10"/>
   </p:sldIdLst>
   <p:sldSz cx="3600450" cy="3600450"/>
   <p:notesSz cx="6858000" cy="9144000"/>
@@ -250,7 +251,7 @@
           <a:p>
             <a:fld id="{0F04D7A0-D8C8-4B74-9611-9A000801FA36}" type="datetimeFigureOut">
               <a:rPr lang="de-DE" smtClean="0"/>
-              <a:t>02.10.2026</a:t>
+              <a:t>06.10.2026</a:t>
             </a:fld>
             <a:endParaRPr lang="de-DE"/>
           </a:p>
@@ -420,7 +421,7 @@
           <a:p>
             <a:fld id="{0F04D7A0-D8C8-4B74-9611-9A000801FA36}" type="datetimeFigureOut">
               <a:rPr lang="de-DE" smtClean="0"/>
-              <a:t>02.10.2026</a:t>
+              <a:t>06.10.2026</a:t>
             </a:fld>
             <a:endParaRPr lang="de-DE"/>
           </a:p>
@@ -600,7 +601,7 @@
           <a:p>
             <a:fld id="{0F04D7A0-D8C8-4B74-9611-9A000801FA36}" type="datetimeFigureOut">
               <a:rPr lang="de-DE" smtClean="0"/>
-              <a:t>02.10.2026</a:t>
+              <a:t>06.10.2026</a:t>
             </a:fld>
             <a:endParaRPr lang="de-DE"/>
           </a:p>
@@ -770,7 +771,7 @@
           <a:p>
             <a:fld id="{0F04D7A0-D8C8-4B74-9611-9A000801FA36}" type="datetimeFigureOut">
               <a:rPr lang="de-DE" smtClean="0"/>
-              <a:t>02.10.2026</a:t>
+              <a:t>06.10.2026</a:t>
             </a:fld>
             <a:endParaRPr lang="de-DE"/>
           </a:p>
@@ -1016,7 +1017,7 @@
           <a:p>
             <a:fld id="{0F04D7A0-D8C8-4B74-9611-9A000801FA36}" type="datetimeFigureOut">
               <a:rPr lang="de-DE" smtClean="0"/>
-              <a:t>02.10.2026</a:t>
+              <a:t>06.10.2026</a:t>
             </a:fld>
             <a:endParaRPr lang="de-DE"/>
           </a:p>
@@ -1248,7 +1249,7 @@
           <a:p>
             <a:fld id="{0F04D7A0-D8C8-4B74-9611-9A000801FA36}" type="datetimeFigureOut">
               <a:rPr lang="de-DE" smtClean="0"/>
-              <a:t>02.10.2026</a:t>
+              <a:t>06.10.2026</a:t>
             </a:fld>
             <a:endParaRPr lang="de-DE"/>
           </a:p>
@@ -1615,7 +1616,7 @@
           <a:p>
             <a:fld id="{0F04D7A0-D8C8-4B74-9611-9A000801FA36}" type="datetimeFigureOut">
               <a:rPr lang="de-DE" smtClean="0"/>
-              <a:t>02.10.2026</a:t>
+              <a:t>06.10.2026</a:t>
             </a:fld>
             <a:endParaRPr lang="de-DE"/>
           </a:p>
@@ -1733,7 +1734,7 @@
           <a:p>
             <a:fld id="{0F04D7A0-D8C8-4B74-9611-9A000801FA36}" type="datetimeFigureOut">
               <a:rPr lang="de-DE" smtClean="0"/>
-              <a:t>02.10.2026</a:t>
+              <a:t>06.10.2026</a:t>
             </a:fld>
             <a:endParaRPr lang="de-DE"/>
           </a:p>
@@ -1828,7 +1829,7 @@
           <a:p>
             <a:fld id="{0F04D7A0-D8C8-4B74-9611-9A000801FA36}" type="datetimeFigureOut">
               <a:rPr lang="de-DE" smtClean="0"/>
-              <a:t>02.10.2026</a:t>
+              <a:t>06.10.2026</a:t>
             </a:fld>
             <a:endParaRPr lang="de-DE"/>
           </a:p>
@@ -2105,7 +2106,7 @@
           <a:p>
             <a:fld id="{0F04D7A0-D8C8-4B74-9611-9A000801FA36}" type="datetimeFigureOut">
               <a:rPr lang="de-DE" smtClean="0"/>
-              <a:t>02.10.2026</a:t>
+              <a:t>06.10.2026</a:t>
             </a:fld>
             <a:endParaRPr lang="de-DE"/>
           </a:p>
@@ -2362,7 +2363,7 @@
           <a:p>
             <a:fld id="{0F04D7A0-D8C8-4B74-9611-9A000801FA36}" type="datetimeFigureOut">
               <a:rPr lang="de-DE" smtClean="0"/>
-              <a:t>02.10.2026</a:t>
+              <a:t>06.10.2026</a:t>
             </a:fld>
             <a:endParaRPr lang="de-DE"/>
           </a:p>
@@ -2575,7 +2576,7 @@
           <a:p>
             <a:fld id="{0F04D7A0-D8C8-4B74-9611-9A000801FA36}" type="datetimeFigureOut">
               <a:rPr lang="de-DE" smtClean="0"/>
-              <a:t>02.10.2026</a:t>
+              <a:t>06.10.2026</a:t>
             </a:fld>
             <a:endParaRPr lang="de-DE"/>
           </a:p>
@@ -12911,144 +12912,6 @@
           </a:p>
         </p:txBody>
       </p:sp>
-      <p:cxnSp>
-        <p:nvCxnSpPr>
-          <p:cNvPr id="64" name="Gerade Verbindung mit Pfeil 63">
-            <a:extLst>
-              <a:ext uri="{FF2B5EF4-FFF2-40B4-BE49-F238E27FC236}">
-                <a16:creationId xmlns:a16="http://schemas.microsoft.com/office/drawing/2014/main" id="{B26BAC1B-215E-C2B9-66F8-66CE30955021}"/>
-              </a:ext>
-            </a:extLst>
-          </p:cNvPr>
-          <p:cNvCxnSpPr>
-            <a:cxnSpLocks/>
-          </p:cNvCxnSpPr>
-          <p:nvPr/>
-        </p:nvCxnSpPr>
-        <p:spPr>
-          <a:xfrm flipV="1">
-            <a:off x="644798" y="557213"/>
-            <a:ext cx="0" cy="2328862"/>
-          </a:xfrm>
-          <a:prstGeom prst="straightConnector1">
-            <a:avLst/>
-          </a:prstGeom>
-          <a:ln cap="rnd">
-            <a:solidFill>
-              <a:schemeClr val="tx1"/>
-            </a:solidFill>
-            <a:round/>
-            <a:tailEnd type="triangle"/>
-          </a:ln>
-        </p:spPr>
-        <p:style>
-          <a:lnRef idx="2">
-            <a:schemeClr val="accent1"/>
-          </a:lnRef>
-          <a:fillRef idx="0">
-            <a:schemeClr val="accent1"/>
-          </a:fillRef>
-          <a:effectRef idx="1">
-            <a:schemeClr val="accent1"/>
-          </a:effectRef>
-          <a:fontRef idx="minor">
-            <a:schemeClr val="tx1"/>
-          </a:fontRef>
-        </p:style>
-      </p:cxnSp>
-      <p:cxnSp>
-        <p:nvCxnSpPr>
-          <p:cNvPr id="65" name="Gerade Verbindung mit Pfeil 64">
-            <a:extLst>
-              <a:ext uri="{FF2B5EF4-FFF2-40B4-BE49-F238E27FC236}">
-                <a16:creationId xmlns:a16="http://schemas.microsoft.com/office/drawing/2014/main" id="{AA4A19BC-7688-3131-29B2-A8BAE1D9DF89}"/>
-              </a:ext>
-            </a:extLst>
-          </p:cNvPr>
-          <p:cNvCxnSpPr>
-            <a:cxnSpLocks/>
-          </p:cNvCxnSpPr>
-          <p:nvPr/>
-        </p:nvCxnSpPr>
-        <p:spPr>
-          <a:xfrm>
-            <a:off x="644798" y="2889647"/>
-            <a:ext cx="2455590" cy="0"/>
-          </a:xfrm>
-          <a:prstGeom prst="straightConnector1">
-            <a:avLst/>
-          </a:prstGeom>
-          <a:ln cap="rnd">
-            <a:solidFill>
-              <a:schemeClr val="tx1"/>
-            </a:solidFill>
-            <a:round/>
-            <a:tailEnd type="triangle"/>
-          </a:ln>
-        </p:spPr>
-        <p:style>
-          <a:lnRef idx="2">
-            <a:schemeClr val="accent1"/>
-          </a:lnRef>
-          <a:fillRef idx="0">
-            <a:schemeClr val="accent1"/>
-          </a:fillRef>
-          <a:effectRef idx="1">
-            <a:schemeClr val="accent1"/>
-          </a:effectRef>
-          <a:fontRef idx="minor">
-            <a:schemeClr val="tx1"/>
-          </a:fontRef>
-        </p:style>
-      </p:cxnSp>
-      <p:sp>
-        <p:nvSpPr>
-          <p:cNvPr id="69" name="Textfeld 68">
-            <a:extLst>
-              <a:ext uri="{FF2B5EF4-FFF2-40B4-BE49-F238E27FC236}">
-                <a16:creationId xmlns:a16="http://schemas.microsoft.com/office/drawing/2014/main" id="{EAD40744-6C04-749D-DD94-5D765AC3C29E}"/>
-              </a:ext>
-            </a:extLst>
-          </p:cNvPr>
-          <p:cNvSpPr txBox="1"/>
-          <p:nvPr/>
-        </p:nvSpPr>
-        <p:spPr>
-          <a:xfrm>
-            <a:off x="2952079" y="2623097"/>
-            <a:ext cx="354568" cy="261610"/>
-          </a:xfrm>
-          <a:prstGeom prst="rect">
-            <a:avLst/>
-          </a:prstGeom>
-          <a:noFill/>
-        </p:spPr>
-        <p:txBody>
-          <a:bodyPr wrap="square" rtlCol="0">
-            <a:spAutoFit/>
-          </a:bodyPr>
-          <a:lstStyle/>
-          <a:p>
-            <a:pPr algn="ctr"/>
-            <a:r>
-              <a:rPr lang="de-DE" sz="1100" i="1" dirty="0">
-                <a:latin typeface="CMU Serif" panose="02000603000000000000" pitchFamily="2" charset="0"/>
-                <a:ea typeface="CMU Serif" panose="02000603000000000000" pitchFamily="2" charset="0"/>
-                <a:cs typeface="CMU Serif" panose="02000603000000000000" pitchFamily="2" charset="0"/>
-              </a:rPr>
-              <a:t>R</a:t>
-            </a:r>
-            <a:r>
-              <a:rPr lang="de-DE" sz="1100" baseline="-25000" dirty="0">
-                <a:latin typeface="CMU Serif" panose="02000603000000000000" pitchFamily="2" charset="0"/>
-                <a:ea typeface="CMU Serif" panose="02000603000000000000" pitchFamily="2" charset="0"/>
-                <a:cs typeface="CMU Serif" panose="02000603000000000000" pitchFamily="2" charset="0"/>
-              </a:rPr>
-              <a:t>S</a:t>
-            </a:r>
-          </a:p>
-        </p:txBody>
-      </p:sp>
       <p:grpSp>
         <p:nvGrpSpPr>
           <p:cNvPr id="70" name="Gruppieren 69">
@@ -13064,9 +12927,9 @@
         <p:grpSpPr>
           <a:xfrm>
             <a:off x="352896" y="614364"/>
-            <a:ext cx="354335" cy="2386011"/>
+            <a:ext cx="354335" cy="2168913"/>
             <a:chOff x="216658" y="852398"/>
-            <a:chExt cx="354335" cy="1933564"/>
+            <a:chExt cx="354335" cy="1757633"/>
           </a:xfrm>
         </p:grpSpPr>
         <p:sp>
@@ -13459,46 +13322,101 @@
             </a:p>
           </p:txBody>
         </p:sp>
-        <p:sp>
-          <p:nvSpPr>
-            <p:cNvPr id="81" name="Textfeld 80">
-              <a:extLst>
-                <a:ext uri="{FF2B5EF4-FFF2-40B4-BE49-F238E27FC236}">
-                  <a16:creationId xmlns:a16="http://schemas.microsoft.com/office/drawing/2014/main" id="{3A79ED8B-9176-C178-D7A4-F00706874340}"/>
-                </a:ext>
-              </a:extLst>
-            </p:cNvPr>
-            <p:cNvSpPr txBox="1"/>
-            <p:nvPr/>
-          </p:nvSpPr>
-          <p:spPr>
-            <a:xfrm>
-              <a:off x="216658" y="2611726"/>
-              <a:ext cx="354330" cy="174236"/>
-            </a:xfrm>
-            <a:prstGeom prst="rect">
-              <a:avLst/>
-            </a:prstGeom>
-            <a:noFill/>
-          </p:spPr>
-          <p:txBody>
-            <a:bodyPr wrap="square" rtlCol="0">
-              <a:spAutoFit/>
-            </a:bodyPr>
-            <a:lstStyle/>
-            <a:p>
-              <a:r>
-                <a:rPr lang="de-DE" sz="800" dirty="0">
-                  <a:latin typeface="CMU Serif" panose="02000603000000000000" pitchFamily="2" charset="0"/>
-                  <a:ea typeface="CMU Serif" panose="02000603000000000000" pitchFamily="2" charset="0"/>
-                  <a:cs typeface="CMU Serif" panose="02000603000000000000" pitchFamily="2" charset="0"/>
-                </a:rPr>
-                <a:t>0,0</a:t>
-              </a:r>
-            </a:p>
-          </p:txBody>
-        </p:sp>
       </p:grpSp>
+      <p:cxnSp>
+        <p:nvCxnSpPr>
+          <p:cNvPr id="127" name="Gerader Verbinder 126">
+            <a:extLst>
+              <a:ext uri="{FF2B5EF4-FFF2-40B4-BE49-F238E27FC236}">
+                <a16:creationId xmlns:a16="http://schemas.microsoft.com/office/drawing/2014/main" id="{94DFB9E5-4789-D39C-ED45-97AD2DD7C88A}"/>
+              </a:ext>
+            </a:extLst>
+          </p:cNvPr>
+          <p:cNvCxnSpPr>
+            <a:cxnSpLocks/>
+          </p:cNvCxnSpPr>
+          <p:nvPr/>
+        </p:nvCxnSpPr>
+        <p:spPr>
+          <a:xfrm flipV="1">
+            <a:off x="646509" y="1946910"/>
+            <a:ext cx="1275636" cy="939165"/>
+          </a:xfrm>
+          <a:prstGeom prst="line">
+            <a:avLst/>
+          </a:prstGeom>
+          <a:ln cap="rnd">
+            <a:solidFill>
+              <a:schemeClr val="accent2">
+                <a:lumMod val="75000"/>
+              </a:schemeClr>
+            </a:solidFill>
+            <a:round/>
+          </a:ln>
+        </p:spPr>
+        <p:style>
+          <a:lnRef idx="2">
+            <a:schemeClr val="accent1"/>
+          </a:lnRef>
+          <a:fillRef idx="0">
+            <a:schemeClr val="accent1"/>
+          </a:fillRef>
+          <a:effectRef idx="1">
+            <a:schemeClr val="accent1"/>
+          </a:effectRef>
+          <a:fontRef idx="minor">
+            <a:schemeClr val="tx1"/>
+          </a:fontRef>
+        </p:style>
+      </p:cxnSp>
+      <p:sp>
+        <p:nvSpPr>
+          <p:cNvPr id="69" name="Textfeld 68">
+            <a:extLst>
+              <a:ext uri="{FF2B5EF4-FFF2-40B4-BE49-F238E27FC236}">
+                <a16:creationId xmlns:a16="http://schemas.microsoft.com/office/drawing/2014/main" id="{EAD40744-6C04-749D-DD94-5D765AC3C29E}"/>
+              </a:ext>
+            </a:extLst>
+          </p:cNvPr>
+          <p:cNvSpPr txBox="1"/>
+          <p:nvPr/>
+        </p:nvSpPr>
+        <p:spPr>
+          <a:xfrm>
+            <a:off x="2952079" y="2623097"/>
+            <a:ext cx="354568" cy="261610"/>
+          </a:xfrm>
+          <a:prstGeom prst="rect">
+            <a:avLst/>
+          </a:prstGeom>
+          <a:noFill/>
+        </p:spPr>
+        <p:txBody>
+          <a:bodyPr wrap="square" rtlCol="0">
+            <a:spAutoFit/>
+          </a:bodyPr>
+          <a:lstStyle/>
+          <a:p>
+            <a:pPr algn="ctr"/>
+            <a:r>
+              <a:rPr lang="de-DE" sz="1100" i="1" dirty="0">
+                <a:latin typeface="CMU Serif" panose="02000603000000000000" pitchFamily="2" charset="0"/>
+                <a:ea typeface="CMU Serif" panose="02000603000000000000" pitchFamily="2" charset="0"/>
+                <a:cs typeface="CMU Serif" panose="02000603000000000000" pitchFamily="2" charset="0"/>
+              </a:rPr>
+              <a:t>R</a:t>
+            </a:r>
+            <a:r>
+              <a:rPr lang="de-DE" sz="1100" baseline="-25000" dirty="0">
+                <a:latin typeface="CMU Serif" panose="02000603000000000000" pitchFamily="2" charset="0"/>
+                <a:ea typeface="CMU Serif" panose="02000603000000000000" pitchFamily="2" charset="0"/>
+                <a:cs typeface="CMU Serif" panose="02000603000000000000" pitchFamily="2" charset="0"/>
+              </a:rPr>
+              <a:t>S</a:t>
+            </a:r>
+          </a:p>
+        </p:txBody>
+      </p:sp>
       <p:grpSp>
         <p:nvGrpSpPr>
           <p:cNvPr id="120" name="Gruppieren 119">
@@ -13513,10 +13431,10 @@
         </p:nvGrpSpPr>
         <p:grpSpPr>
           <a:xfrm>
-            <a:off x="471452" y="2920008"/>
-            <a:ext cx="2620362" cy="215444"/>
-            <a:chOff x="471452" y="2905720"/>
-            <a:chExt cx="2620362" cy="215444"/>
+            <a:off x="698055" y="2920008"/>
+            <a:ext cx="2393759" cy="215444"/>
+            <a:chOff x="698055" y="2905720"/>
+            <a:chExt cx="2393759" cy="215444"/>
           </a:xfrm>
         </p:grpSpPr>
         <p:sp>
@@ -13919,53 +13837,197 @@
             </a:p>
           </p:txBody>
         </p:sp>
-        <p:sp>
-          <p:nvSpPr>
-            <p:cNvPr id="119" name="Textfeld 118">
-              <a:extLst>
-                <a:ext uri="{FF2B5EF4-FFF2-40B4-BE49-F238E27FC236}">
-                  <a16:creationId xmlns:a16="http://schemas.microsoft.com/office/drawing/2014/main" id="{D75FE5E2-3268-23B4-A67D-2964C9142762}"/>
-                </a:ext>
-              </a:extLst>
-            </p:cNvPr>
-            <p:cNvSpPr txBox="1"/>
-            <p:nvPr/>
-          </p:nvSpPr>
-          <p:spPr>
-            <a:xfrm>
-              <a:off x="471452" y="2905720"/>
-              <a:ext cx="354330" cy="215444"/>
-            </a:xfrm>
-            <a:prstGeom prst="rect">
-              <a:avLst/>
-            </a:prstGeom>
+      </p:grpSp>
+      <p:sp>
+        <p:nvSpPr>
+          <p:cNvPr id="8" name="Textfeld 7">
+            <a:extLst>
+              <a:ext uri="{FF2B5EF4-FFF2-40B4-BE49-F238E27FC236}">
+                <a16:creationId xmlns:a16="http://schemas.microsoft.com/office/drawing/2014/main" id="{F355BE7B-46B6-FD19-DCEE-BF3CA52EAE8F}"/>
+              </a:ext>
+            </a:extLst>
+          </p:cNvPr>
+          <p:cNvSpPr txBox="1"/>
+          <p:nvPr/>
+        </p:nvSpPr>
+        <p:spPr>
+          <a:xfrm>
+            <a:off x="319841" y="2829398"/>
+            <a:ext cx="354568" cy="261610"/>
+          </a:xfrm>
+          <a:prstGeom prst="rect">
+            <a:avLst/>
+          </a:prstGeom>
+          <a:noFill/>
+        </p:spPr>
+        <p:txBody>
+          <a:bodyPr wrap="square" rtlCol="0">
+            <a:spAutoFit/>
+          </a:bodyPr>
+          <a:lstStyle/>
+          <a:p>
+            <a:pPr algn="ctr"/>
+            <a:r>
+              <a:rPr lang="de-DE" sz="1100" dirty="0">
+                <a:solidFill>
+                  <a:schemeClr val="accent2"/>
+                </a:solidFill>
+                <a:latin typeface="CMU Serif" panose="02000603000000000000" pitchFamily="2" charset="0"/>
+                <a:ea typeface="CMU Serif" panose="02000603000000000000" pitchFamily="2" charset="0"/>
+                <a:cs typeface="CMU Serif" panose="02000603000000000000" pitchFamily="2" charset="0"/>
+              </a:rPr>
+              <a:t>O</a:t>
+            </a:r>
+          </a:p>
+        </p:txBody>
+      </p:sp>
+      <p:sp>
+        <p:nvSpPr>
+          <p:cNvPr id="12" name="Ellipse 11">
+            <a:extLst>
+              <a:ext uri="{FF2B5EF4-FFF2-40B4-BE49-F238E27FC236}">
+                <a16:creationId xmlns:a16="http://schemas.microsoft.com/office/drawing/2014/main" id="{43A8D2C9-8D44-881F-D42A-E76F1C160AA2}"/>
+              </a:ext>
+            </a:extLst>
+          </p:cNvPr>
+          <p:cNvSpPr/>
+          <p:nvPr/>
+        </p:nvSpPr>
+        <p:spPr>
+          <a:xfrm>
+            <a:off x="1679348" y="1832498"/>
+            <a:ext cx="168788" cy="168788"/>
+          </a:xfrm>
+          <a:prstGeom prst="ellipse">
+            <a:avLst/>
+          </a:prstGeom>
+          <a:solidFill>
+            <a:schemeClr val="bg1"/>
+          </a:solidFill>
+          <a:ln>
             <a:noFill/>
-          </p:spPr>
-          <p:txBody>
-            <a:bodyPr wrap="square" rtlCol="0">
-              <a:spAutoFit/>
-            </a:bodyPr>
-            <a:lstStyle/>
-            <a:p>
-              <a:pPr algn="ctr"/>
-              <a:r>
-                <a:rPr lang="de-DE" sz="800" dirty="0">
-                  <a:latin typeface="CMU Serif" panose="02000603000000000000" pitchFamily="2" charset="0"/>
-                  <a:ea typeface="CMU Serif" panose="02000603000000000000" pitchFamily="2" charset="0"/>
-                  <a:cs typeface="CMU Serif" panose="02000603000000000000" pitchFamily="2" charset="0"/>
-                </a:rPr>
-                <a:t>0,0</a:t>
-              </a:r>
-            </a:p>
-          </p:txBody>
-        </p:sp>
-      </p:grpSp>
+          </a:ln>
+        </p:spPr>
+        <p:style>
+          <a:lnRef idx="2">
+            <a:schemeClr val="accent1">
+              <a:shade val="15000"/>
+            </a:schemeClr>
+          </a:lnRef>
+          <a:fillRef idx="1">
+            <a:schemeClr val="accent1"/>
+          </a:fillRef>
+          <a:effectRef idx="0">
+            <a:schemeClr val="accent1"/>
+          </a:effectRef>
+          <a:fontRef idx="minor">
+            <a:schemeClr val="lt1"/>
+          </a:fontRef>
+        </p:style>
+        <p:txBody>
+          <a:bodyPr rtlCol="0" anchor="ctr"/>
+          <a:lstStyle/>
+          <a:p>
+            <a:pPr algn="ctr"/>
+            <a:endParaRPr lang="de-DE"/>
+          </a:p>
+        </p:txBody>
+      </p:sp>
+      <p:sp>
+        <p:nvSpPr>
+          <p:cNvPr id="6" name="Textfeld 5">
+            <a:extLst>
+              <a:ext uri="{FF2B5EF4-FFF2-40B4-BE49-F238E27FC236}">
+                <a16:creationId xmlns:a16="http://schemas.microsoft.com/office/drawing/2014/main" id="{BAAFA106-8B41-B435-7832-E9B127B764D6}"/>
+              </a:ext>
+            </a:extLst>
+          </p:cNvPr>
+          <p:cNvSpPr txBox="1"/>
+          <p:nvPr/>
+        </p:nvSpPr>
+        <p:spPr>
+          <a:xfrm>
+            <a:off x="1585440" y="1797548"/>
+            <a:ext cx="354568" cy="261610"/>
+          </a:xfrm>
+          <a:prstGeom prst="rect">
+            <a:avLst/>
+          </a:prstGeom>
+          <a:noFill/>
+        </p:spPr>
+        <p:txBody>
+          <a:bodyPr wrap="square" rtlCol="0">
+            <a:spAutoFit/>
+          </a:bodyPr>
+          <a:lstStyle/>
+          <a:p>
+            <a:pPr algn="ctr"/>
+            <a:r>
+              <a:rPr lang="de-DE" sz="1100" dirty="0">
+                <a:solidFill>
+                  <a:schemeClr val="accent2"/>
+                </a:solidFill>
+                <a:latin typeface="CMU Serif" panose="02000603000000000000" pitchFamily="2" charset="0"/>
+                <a:ea typeface="CMU Serif" panose="02000603000000000000" pitchFamily="2" charset="0"/>
+                <a:cs typeface="CMU Serif" panose="02000603000000000000" pitchFamily="2" charset="0"/>
+              </a:rPr>
+              <a:t>S</a:t>
+            </a:r>
+          </a:p>
+        </p:txBody>
+      </p:sp>
       <p:cxnSp>
         <p:nvCxnSpPr>
-          <p:cNvPr id="127" name="Gerader Verbinder 126">
+          <p:cNvPr id="13" name="Gerader Verbinder 12">
             <a:extLst>
               <a:ext uri="{FF2B5EF4-FFF2-40B4-BE49-F238E27FC236}">
-                <a16:creationId xmlns:a16="http://schemas.microsoft.com/office/drawing/2014/main" id="{94DFB9E5-4789-D39C-ED45-97AD2DD7C88A}"/>
+                <a16:creationId xmlns:a16="http://schemas.microsoft.com/office/drawing/2014/main" id="{9261AD5D-8621-7EFD-3DC3-69E8DC6962EE}"/>
+              </a:ext>
+            </a:extLst>
+          </p:cNvPr>
+          <p:cNvCxnSpPr>
+            <a:cxnSpLocks/>
+            <a:stCxn id="2" idx="4"/>
+            <a:endCxn id="2" idx="0"/>
+          </p:cNvCxnSpPr>
+          <p:nvPr/>
+        </p:nvCxnSpPr>
+        <p:spPr>
+          <a:xfrm>
+            <a:off x="642440" y="710802"/>
+            <a:ext cx="2278378" cy="2180983"/>
+          </a:xfrm>
+          <a:prstGeom prst="line">
+            <a:avLst/>
+          </a:prstGeom>
+          <a:ln cap="rnd">
+            <a:solidFill>
+              <a:srgbClr val="C00000"/>
+            </a:solidFill>
+            <a:round/>
+          </a:ln>
+        </p:spPr>
+        <p:style>
+          <a:lnRef idx="2">
+            <a:schemeClr val="accent1"/>
+          </a:lnRef>
+          <a:fillRef idx="0">
+            <a:schemeClr val="accent1"/>
+          </a:fillRef>
+          <a:effectRef idx="1">
+            <a:schemeClr val="accent1"/>
+          </a:effectRef>
+          <a:fontRef idx="minor">
+            <a:schemeClr val="tx1"/>
+          </a:fontRef>
+        </p:style>
+      </p:cxnSp>
+      <p:cxnSp>
+        <p:nvCxnSpPr>
+          <p:cNvPr id="64" name="Gerade Verbindung mit Pfeil 63">
+            <a:extLst>
+              <a:ext uri="{FF2B5EF4-FFF2-40B4-BE49-F238E27FC236}">
+                <a16:creationId xmlns:a16="http://schemas.microsoft.com/office/drawing/2014/main" id="{B26BAC1B-215E-C2B9-66F8-66CE30955021}"/>
               </a:ext>
             </a:extLst>
           </p:cNvPr>
@@ -13976,19 +14038,63 @@
         </p:nvCxnSpPr>
         <p:spPr>
           <a:xfrm flipV="1">
-            <a:off x="646509" y="1946910"/>
-            <a:ext cx="1275636" cy="939165"/>
-          </a:xfrm>
-          <a:prstGeom prst="line">
+            <a:off x="644798" y="557213"/>
+            <a:ext cx="0" cy="2328862"/>
+          </a:xfrm>
+          <a:prstGeom prst="straightConnector1">
             <a:avLst/>
           </a:prstGeom>
           <a:ln cap="rnd">
             <a:solidFill>
-              <a:schemeClr val="accent2">
-                <a:lumMod val="75000"/>
-              </a:schemeClr>
+              <a:schemeClr val="tx1"/>
             </a:solidFill>
             <a:round/>
+            <a:tailEnd type="triangle"/>
+          </a:ln>
+        </p:spPr>
+        <p:style>
+          <a:lnRef idx="2">
+            <a:schemeClr val="accent1"/>
+          </a:lnRef>
+          <a:fillRef idx="0">
+            <a:schemeClr val="accent1"/>
+          </a:fillRef>
+          <a:effectRef idx="1">
+            <a:schemeClr val="accent1"/>
+          </a:effectRef>
+          <a:fontRef idx="minor">
+            <a:schemeClr val="tx1"/>
+          </a:fontRef>
+        </p:style>
+      </p:cxnSp>
+      <p:cxnSp>
+        <p:nvCxnSpPr>
+          <p:cNvPr id="65" name="Gerade Verbindung mit Pfeil 64">
+            <a:extLst>
+              <a:ext uri="{FF2B5EF4-FFF2-40B4-BE49-F238E27FC236}">
+                <a16:creationId xmlns:a16="http://schemas.microsoft.com/office/drawing/2014/main" id="{AA4A19BC-7688-3131-29B2-A8BAE1D9DF89}"/>
+              </a:ext>
+            </a:extLst>
+          </p:cNvPr>
+          <p:cNvCxnSpPr>
+            <a:cxnSpLocks/>
+          </p:cNvCxnSpPr>
+          <p:nvPr/>
+        </p:nvCxnSpPr>
+        <p:spPr>
+          <a:xfrm>
+            <a:off x="644798" y="2889647"/>
+            <a:ext cx="2455590" cy="0"/>
+          </a:xfrm>
+          <a:prstGeom prst="straightConnector1">
+            <a:avLst/>
+          </a:prstGeom>
+          <a:ln cap="rnd">
+            <a:solidFill>
+              <a:schemeClr val="tx1"/>
+            </a:solidFill>
+            <a:round/>
+            <a:tailEnd type="triangle"/>
           </a:ln>
         </p:spPr>
         <p:style>
@@ -14021,6 +14127,555 @@
         <p:spPr>
           <a:xfrm>
             <a:off x="607219" y="2846786"/>
+            <a:ext cx="78580" cy="78580"/>
+          </a:xfrm>
+          <a:prstGeom prst="ellipse">
+            <a:avLst/>
+          </a:prstGeom>
+          <a:solidFill>
+            <a:schemeClr val="accent2"/>
+          </a:solidFill>
+          <a:ln>
+            <a:noFill/>
+          </a:ln>
+        </p:spPr>
+        <p:style>
+          <a:lnRef idx="2">
+            <a:schemeClr val="accent1">
+              <a:shade val="15000"/>
+            </a:schemeClr>
+          </a:lnRef>
+          <a:fillRef idx="1">
+            <a:schemeClr val="accent1"/>
+          </a:fillRef>
+          <a:effectRef idx="0">
+            <a:schemeClr val="accent1"/>
+          </a:effectRef>
+          <a:fontRef idx="minor">
+            <a:schemeClr val="lt1"/>
+          </a:fontRef>
+        </p:style>
+        <p:txBody>
+          <a:bodyPr rtlCol="0" anchor="ctr"/>
+          <a:lstStyle/>
+          <a:p>
+            <a:pPr algn="ctr"/>
+            <a:endParaRPr lang="de-DE"/>
+          </a:p>
+        </p:txBody>
+      </p:sp>
+      <p:sp>
+        <p:nvSpPr>
+          <p:cNvPr id="18" name="Rechteck 17">
+            <a:extLst>
+              <a:ext uri="{FF2B5EF4-FFF2-40B4-BE49-F238E27FC236}">
+                <a16:creationId xmlns:a16="http://schemas.microsoft.com/office/drawing/2014/main" id="{82ED616F-B7BC-893F-894C-82CC40E1D1E9}"/>
+              </a:ext>
+            </a:extLst>
+          </p:cNvPr>
+          <p:cNvSpPr/>
+          <p:nvPr/>
+        </p:nvSpPr>
+        <p:spPr>
+          <a:xfrm>
+            <a:off x="1579572" y="720090"/>
+            <a:ext cx="1303995" cy="207884"/>
+          </a:xfrm>
+          <a:prstGeom prst="rect">
+            <a:avLst/>
+          </a:prstGeom>
+          <a:solidFill>
+            <a:schemeClr val="bg1"/>
+          </a:solidFill>
+          <a:ln>
+            <a:noFill/>
+          </a:ln>
+        </p:spPr>
+        <p:style>
+          <a:lnRef idx="2">
+            <a:schemeClr val="accent1">
+              <a:shade val="15000"/>
+            </a:schemeClr>
+          </a:lnRef>
+          <a:fillRef idx="1">
+            <a:schemeClr val="accent1"/>
+          </a:fillRef>
+          <a:effectRef idx="0">
+            <a:schemeClr val="accent1"/>
+          </a:effectRef>
+          <a:fontRef idx="minor">
+            <a:schemeClr val="lt1"/>
+          </a:fontRef>
+        </p:style>
+        <p:txBody>
+          <a:bodyPr rtlCol="0" anchor="ctr"/>
+          <a:lstStyle/>
+          <a:p>
+            <a:pPr algn="ctr"/>
+            <a:endParaRPr lang="de-DE"/>
+          </a:p>
+        </p:txBody>
+      </p:sp>
+      <p:sp>
+        <p:nvSpPr>
+          <p:cNvPr id="20" name="Rechteck 19">
+            <a:extLst>
+              <a:ext uri="{FF2B5EF4-FFF2-40B4-BE49-F238E27FC236}">
+                <a16:creationId xmlns:a16="http://schemas.microsoft.com/office/drawing/2014/main" id="{15A1CF5B-5510-53DB-D7A7-995509BBB9F8}"/>
+              </a:ext>
+            </a:extLst>
+          </p:cNvPr>
+          <p:cNvSpPr/>
+          <p:nvPr/>
+        </p:nvSpPr>
+        <p:spPr>
+          <a:xfrm>
+            <a:off x="2011681" y="896787"/>
+            <a:ext cx="899160" cy="465288"/>
+          </a:xfrm>
+          <a:prstGeom prst="rect">
+            <a:avLst/>
+          </a:prstGeom>
+          <a:solidFill>
+            <a:schemeClr val="bg1"/>
+          </a:solidFill>
+          <a:ln>
+            <a:noFill/>
+          </a:ln>
+        </p:spPr>
+        <p:style>
+          <a:lnRef idx="2">
+            <a:schemeClr val="accent1">
+              <a:shade val="15000"/>
+            </a:schemeClr>
+          </a:lnRef>
+          <a:fillRef idx="1">
+            <a:schemeClr val="accent1"/>
+          </a:fillRef>
+          <a:effectRef idx="0">
+            <a:schemeClr val="accent1"/>
+          </a:effectRef>
+          <a:fontRef idx="minor">
+            <a:schemeClr val="lt1"/>
+          </a:fontRef>
+        </p:style>
+        <p:txBody>
+          <a:bodyPr rtlCol="0" anchor="ctr"/>
+          <a:lstStyle/>
+          <a:p>
+            <a:pPr algn="ctr"/>
+            <a:endParaRPr lang="de-DE"/>
+          </a:p>
+        </p:txBody>
+      </p:sp>
+      <p:sp>
+        <p:nvSpPr>
+          <p:cNvPr id="2" name="Rechtwinkliges Dreieck 1">
+            <a:extLst>
+              <a:ext uri="{FF2B5EF4-FFF2-40B4-BE49-F238E27FC236}">
+                <a16:creationId xmlns:a16="http://schemas.microsoft.com/office/drawing/2014/main" id="{CD17FC72-82A8-2BA2-6153-303729E2F166}"/>
+              </a:ext>
+            </a:extLst>
+          </p:cNvPr>
+          <p:cNvSpPr/>
+          <p:nvPr/>
+        </p:nvSpPr>
+        <p:spPr>
+          <a:xfrm rot="10800000">
+            <a:off x="642440" y="710802"/>
+            <a:ext cx="2278378" cy="2180983"/>
+          </a:xfrm>
+          <a:prstGeom prst="rtTriangle">
+            <a:avLst/>
+          </a:prstGeom>
+          <a:solidFill>
+            <a:srgbClr val="FF0000">
+              <a:alpha val="40000"/>
+            </a:srgbClr>
+          </a:solidFill>
+          <a:ln cap="rnd">
+            <a:noFill/>
+            <a:round/>
+          </a:ln>
+        </p:spPr>
+        <p:style>
+          <a:lnRef idx="2">
+            <a:schemeClr val="accent1">
+              <a:shade val="15000"/>
+            </a:schemeClr>
+          </a:lnRef>
+          <a:fillRef idx="1">
+            <a:schemeClr val="accent1"/>
+          </a:fillRef>
+          <a:effectRef idx="0">
+            <a:schemeClr val="accent1"/>
+          </a:effectRef>
+          <a:fontRef idx="minor">
+            <a:schemeClr val="lt1"/>
+          </a:fontRef>
+        </p:style>
+        <p:txBody>
+          <a:bodyPr rtlCol="0" anchor="ctr"/>
+          <a:lstStyle/>
+          <a:p>
+            <a:pPr algn="ctr"/>
+            <a:endParaRPr lang="de-DE"/>
+          </a:p>
+        </p:txBody>
+      </p:sp>
+      <p:sp>
+        <p:nvSpPr>
+          <p:cNvPr id="17" name="Textfeld 16">
+            <a:extLst>
+              <a:ext uri="{FF2B5EF4-FFF2-40B4-BE49-F238E27FC236}">
+                <a16:creationId xmlns:a16="http://schemas.microsoft.com/office/drawing/2014/main" id="{8E03EC9A-0A26-A82A-3CC8-7D21A8E1CCCF}"/>
+              </a:ext>
+            </a:extLst>
+          </p:cNvPr>
+          <p:cNvSpPr txBox="1"/>
+          <p:nvPr/>
+        </p:nvSpPr>
+        <p:spPr>
+          <a:xfrm>
+            <a:off x="1473376" y="697990"/>
+            <a:ext cx="1478703" cy="600164"/>
+          </a:xfrm>
+          <a:prstGeom prst="rect">
+            <a:avLst/>
+          </a:prstGeom>
+          <a:noFill/>
+        </p:spPr>
+        <p:txBody>
+          <a:bodyPr wrap="square" rtlCol="0">
+            <a:spAutoFit/>
+          </a:bodyPr>
+          <a:lstStyle/>
+          <a:p>
+            <a:pPr algn="r"/>
+            <a:r>
+              <a:rPr lang="de-DE" sz="1100" dirty="0">
+                <a:latin typeface="CMU Serif" panose="02000603000000000000" pitchFamily="2" charset="0"/>
+                <a:ea typeface="CMU Serif" panose="02000603000000000000" pitchFamily="2" charset="0"/>
+                <a:cs typeface="CMU Serif" panose="02000603000000000000" pitchFamily="2" charset="0"/>
+              </a:rPr>
+              <a:t>Unzulässiges Gebiet: Tragfähigkeit überschritten</a:t>
+            </a:r>
+          </a:p>
+        </p:txBody>
+      </p:sp>
+      <p:pic>
+        <p:nvPicPr>
+          <p:cNvPr id="28" name="Grafik 27">
+            <a:extLst>
+              <a:ext uri="{FF2B5EF4-FFF2-40B4-BE49-F238E27FC236}">
+                <a16:creationId xmlns:a16="http://schemas.microsoft.com/office/drawing/2014/main" id="{4F0BF919-C934-CBBF-102D-9E87EE37D657}"/>
+              </a:ext>
+            </a:extLst>
+          </p:cNvPr>
+          <p:cNvPicPr>
+            <a:picLocks noChangeAspect="1"/>
+          </p:cNvPicPr>
+          <p:nvPr/>
+        </p:nvPicPr>
+        <p:blipFill>
+          <a:blip r:embed="rId2"/>
+          <a:stretch>
+            <a:fillRect/>
+          </a:stretch>
+        </p:blipFill>
+        <p:spPr>
+          <a:xfrm>
+            <a:off x="690845" y="1586633"/>
+            <a:ext cx="734313" cy="209550"/>
+          </a:xfrm>
+          <a:prstGeom prst="rect">
+            <a:avLst/>
+          </a:prstGeom>
+        </p:spPr>
+      </p:pic>
+      <p:pic>
+        <p:nvPicPr>
+          <p:cNvPr id="30" name="Grafik 29">
+            <a:extLst>
+              <a:ext uri="{FF2B5EF4-FFF2-40B4-BE49-F238E27FC236}">
+                <a16:creationId xmlns:a16="http://schemas.microsoft.com/office/drawing/2014/main" id="{2E8111A2-7B9A-A893-A22B-54BC002EBC38}"/>
+              </a:ext>
+            </a:extLst>
+          </p:cNvPr>
+          <p:cNvPicPr>
+            <a:picLocks noChangeAspect="1"/>
+          </p:cNvPicPr>
+          <p:nvPr/>
+        </p:nvPicPr>
+        <p:blipFill>
+          <a:blip r:embed="rId2"/>
+          <a:stretch>
+            <a:fillRect/>
+          </a:stretch>
+        </p:blipFill>
+        <p:spPr>
+          <a:xfrm>
+            <a:off x="652441" y="1751325"/>
+            <a:ext cx="669629" cy="262259"/>
+          </a:xfrm>
+          <a:prstGeom prst="rect">
+            <a:avLst/>
+          </a:prstGeom>
+        </p:spPr>
+      </p:pic>
+      <p:sp>
+        <p:nvSpPr>
+          <p:cNvPr id="26" name="Textfeld 25">
+            <a:extLst>
+              <a:ext uri="{FF2B5EF4-FFF2-40B4-BE49-F238E27FC236}">
+                <a16:creationId xmlns:a16="http://schemas.microsoft.com/office/drawing/2014/main" id="{24601FBF-3657-D65F-E1CA-ECC202553D6C}"/>
+              </a:ext>
+            </a:extLst>
+          </p:cNvPr>
+          <p:cNvSpPr txBox="1"/>
+          <p:nvPr/>
+        </p:nvSpPr>
+        <p:spPr>
+          <a:xfrm>
+            <a:off x="654350" y="1577611"/>
+            <a:ext cx="1310077" cy="430887"/>
+          </a:xfrm>
+          <a:prstGeom prst="rect">
+            <a:avLst/>
+          </a:prstGeom>
+          <a:noFill/>
+        </p:spPr>
+        <p:txBody>
+          <a:bodyPr wrap="square" rtlCol="0">
+            <a:spAutoFit/>
+          </a:bodyPr>
+          <a:lstStyle/>
+          <a:p>
+            <a:r>
+              <a:rPr lang="de-DE" sz="1100" dirty="0">
+                <a:latin typeface="CMU Serif" panose="02000603000000000000" pitchFamily="2" charset="0"/>
+                <a:ea typeface="CMU Serif" panose="02000603000000000000" pitchFamily="2" charset="0"/>
+                <a:cs typeface="CMU Serif" panose="02000603000000000000" pitchFamily="2" charset="0"/>
+              </a:rPr>
+              <a:t>Zulässiges</a:t>
+            </a:r>
+          </a:p>
+          <a:p>
+            <a:r>
+              <a:rPr lang="de-DE" sz="1100" dirty="0">
+                <a:latin typeface="CMU Serif" panose="02000603000000000000" pitchFamily="2" charset="0"/>
+                <a:ea typeface="CMU Serif" panose="02000603000000000000" pitchFamily="2" charset="0"/>
+                <a:cs typeface="CMU Serif" panose="02000603000000000000" pitchFamily="2" charset="0"/>
+              </a:rPr>
+              <a:t>Gebiet</a:t>
+            </a:r>
+          </a:p>
+        </p:txBody>
+      </p:sp>
+      <p:cxnSp>
+        <p:nvCxnSpPr>
+          <p:cNvPr id="37" name="Gerader Verbinder 36">
+            <a:extLst>
+              <a:ext uri="{FF2B5EF4-FFF2-40B4-BE49-F238E27FC236}">
+                <a16:creationId xmlns:a16="http://schemas.microsoft.com/office/drawing/2014/main" id="{9364351A-530F-8708-EC7A-A494762AA3AB}"/>
+              </a:ext>
+            </a:extLst>
+          </p:cNvPr>
+          <p:cNvCxnSpPr>
+            <a:cxnSpLocks/>
+          </p:cNvCxnSpPr>
+          <p:nvPr/>
+        </p:nvCxnSpPr>
+        <p:spPr>
+          <a:xfrm flipV="1">
+            <a:off x="1666637" y="2135981"/>
+            <a:ext cx="0" cy="751999"/>
+          </a:xfrm>
+          <a:prstGeom prst="line">
+            <a:avLst/>
+          </a:prstGeom>
+          <a:ln cap="rnd">
+            <a:solidFill>
+              <a:schemeClr val="tx1">
+                <a:lumMod val="65000"/>
+                <a:lumOff val="35000"/>
+              </a:schemeClr>
+            </a:solidFill>
+            <a:round/>
+          </a:ln>
+        </p:spPr>
+        <p:style>
+          <a:lnRef idx="2">
+            <a:schemeClr val="accent1"/>
+          </a:lnRef>
+          <a:fillRef idx="0">
+            <a:schemeClr val="accent1"/>
+          </a:fillRef>
+          <a:effectRef idx="1">
+            <a:schemeClr val="accent1"/>
+          </a:effectRef>
+          <a:fontRef idx="minor">
+            <a:schemeClr val="tx1"/>
+          </a:fontRef>
+        </p:style>
+      </p:cxnSp>
+      <p:cxnSp>
+        <p:nvCxnSpPr>
+          <p:cNvPr id="31" name="Gerader Verbinder 30">
+            <a:extLst>
+              <a:ext uri="{FF2B5EF4-FFF2-40B4-BE49-F238E27FC236}">
+                <a16:creationId xmlns:a16="http://schemas.microsoft.com/office/drawing/2014/main" id="{D58FE67A-0C4C-AE3D-4EF6-9E126A80A175}"/>
+              </a:ext>
+            </a:extLst>
+          </p:cNvPr>
+          <p:cNvCxnSpPr>
+            <a:cxnSpLocks/>
+          </p:cNvCxnSpPr>
+          <p:nvPr/>
+        </p:nvCxnSpPr>
+        <p:spPr>
+          <a:xfrm>
+            <a:off x="646509" y="2135595"/>
+            <a:ext cx="1008356" cy="0"/>
+          </a:xfrm>
+          <a:prstGeom prst="line">
+            <a:avLst/>
+          </a:prstGeom>
+          <a:ln cap="rnd">
+            <a:solidFill>
+              <a:schemeClr val="tx1">
+                <a:lumMod val="65000"/>
+                <a:lumOff val="35000"/>
+              </a:schemeClr>
+            </a:solidFill>
+            <a:round/>
+          </a:ln>
+        </p:spPr>
+        <p:style>
+          <a:lnRef idx="2">
+            <a:schemeClr val="accent1"/>
+          </a:lnRef>
+          <a:fillRef idx="0">
+            <a:schemeClr val="accent1"/>
+          </a:fillRef>
+          <a:effectRef idx="1">
+            <a:schemeClr val="accent1"/>
+          </a:effectRef>
+          <a:fontRef idx="minor">
+            <a:schemeClr val="tx1"/>
+          </a:fontRef>
+        </p:style>
+      </p:cxnSp>
+      <p:sp>
+        <p:nvSpPr>
+          <p:cNvPr id="10" name="Ellipse 9">
+            <a:extLst>
+              <a:ext uri="{FF2B5EF4-FFF2-40B4-BE49-F238E27FC236}">
+                <a16:creationId xmlns:a16="http://schemas.microsoft.com/office/drawing/2014/main" id="{B295D815-A8C8-2EB6-3934-2362FBCE03EB}"/>
+              </a:ext>
+            </a:extLst>
+          </p:cNvPr>
+          <p:cNvSpPr/>
+          <p:nvPr/>
+        </p:nvSpPr>
+        <p:spPr>
+          <a:xfrm>
+            <a:off x="1477534" y="1952112"/>
+            <a:ext cx="168788" cy="168788"/>
+          </a:xfrm>
+          <a:prstGeom prst="ellipse">
+            <a:avLst/>
+          </a:prstGeom>
+          <a:solidFill>
+            <a:schemeClr val="bg1"/>
+          </a:solidFill>
+          <a:ln>
+            <a:noFill/>
+          </a:ln>
+        </p:spPr>
+        <p:style>
+          <a:lnRef idx="2">
+            <a:schemeClr val="accent1">
+              <a:shade val="15000"/>
+            </a:schemeClr>
+          </a:lnRef>
+          <a:fillRef idx="1">
+            <a:schemeClr val="accent1"/>
+          </a:fillRef>
+          <a:effectRef idx="0">
+            <a:schemeClr val="accent1"/>
+          </a:effectRef>
+          <a:fontRef idx="minor">
+            <a:schemeClr val="lt1"/>
+          </a:fontRef>
+        </p:style>
+        <p:txBody>
+          <a:bodyPr rtlCol="0" anchor="ctr"/>
+          <a:lstStyle/>
+          <a:p>
+            <a:pPr algn="ctr"/>
+            <a:endParaRPr lang="de-DE"/>
+          </a:p>
+        </p:txBody>
+      </p:sp>
+      <p:sp>
+        <p:nvSpPr>
+          <p:cNvPr id="4" name="Textfeld 3">
+            <a:extLst>
+              <a:ext uri="{FF2B5EF4-FFF2-40B4-BE49-F238E27FC236}">
+                <a16:creationId xmlns:a16="http://schemas.microsoft.com/office/drawing/2014/main" id="{2D296C93-A1C7-07A6-685E-83EB4E06CA12}"/>
+              </a:ext>
+            </a:extLst>
+          </p:cNvPr>
+          <p:cNvSpPr txBox="1"/>
+          <p:nvPr/>
+        </p:nvSpPr>
+        <p:spPr>
+          <a:xfrm>
+            <a:off x="1393104" y="1918470"/>
+            <a:ext cx="354568" cy="261610"/>
+          </a:xfrm>
+          <a:prstGeom prst="rect">
+            <a:avLst/>
+          </a:prstGeom>
+          <a:noFill/>
+        </p:spPr>
+        <p:txBody>
+          <a:bodyPr wrap="square" rtlCol="0">
+            <a:spAutoFit/>
+          </a:bodyPr>
+          <a:lstStyle/>
+          <a:p>
+            <a:pPr algn="ctr"/>
+            <a:r>
+              <a:rPr lang="de-DE" sz="1100" dirty="0">
+                <a:solidFill>
+                  <a:schemeClr val="accent2"/>
+                </a:solidFill>
+                <a:latin typeface="CMU Serif" panose="02000603000000000000" pitchFamily="2" charset="0"/>
+                <a:ea typeface="CMU Serif" panose="02000603000000000000" pitchFamily="2" charset="0"/>
+                <a:cs typeface="CMU Serif" panose="02000603000000000000" pitchFamily="2" charset="0"/>
+              </a:rPr>
+              <a:t>P</a:t>
+            </a:r>
+          </a:p>
+        </p:txBody>
+      </p:sp>
+      <p:sp>
+        <p:nvSpPr>
+          <p:cNvPr id="125" name="Ellipse 124">
+            <a:extLst>
+              <a:ext uri="{FF2B5EF4-FFF2-40B4-BE49-F238E27FC236}">
+                <a16:creationId xmlns:a16="http://schemas.microsoft.com/office/drawing/2014/main" id="{B5C419EF-7B07-FF61-BD55-29C4479F2EDC}"/>
+              </a:ext>
+            </a:extLst>
+          </p:cNvPr>
+          <p:cNvSpPr/>
+          <p:nvPr/>
+        </p:nvSpPr>
+        <p:spPr>
+          <a:xfrm>
+            <a:off x="1885905" y="1905232"/>
             <a:ext cx="78580" cy="78580"/>
           </a:xfrm>
           <a:prstGeom prst="ellipse">
@@ -14072,59 +14727,7 @@
         </p:nvSpPr>
         <p:spPr>
           <a:xfrm>
-            <a:off x="1626941" y="2092685"/>
-            <a:ext cx="78580" cy="78580"/>
-          </a:xfrm>
-          <a:prstGeom prst="ellipse">
-            <a:avLst/>
-          </a:prstGeom>
-          <a:solidFill>
-            <a:schemeClr val="accent2"/>
-          </a:solidFill>
-          <a:ln>
-            <a:noFill/>
-          </a:ln>
-        </p:spPr>
-        <p:style>
-          <a:lnRef idx="2">
-            <a:schemeClr val="accent1">
-              <a:shade val="15000"/>
-            </a:schemeClr>
-          </a:lnRef>
-          <a:fillRef idx="1">
-            <a:schemeClr val="accent1"/>
-          </a:fillRef>
-          <a:effectRef idx="0">
-            <a:schemeClr val="accent1"/>
-          </a:effectRef>
-          <a:fontRef idx="minor">
-            <a:schemeClr val="lt1"/>
-          </a:fontRef>
-        </p:style>
-        <p:txBody>
-          <a:bodyPr rtlCol="0" anchor="ctr"/>
-          <a:lstStyle/>
-          <a:p>
-            <a:pPr algn="ctr"/>
-            <a:endParaRPr lang="de-DE"/>
-          </a:p>
-        </p:txBody>
-      </p:sp>
-      <p:sp>
-        <p:nvSpPr>
-          <p:cNvPr id="125" name="Ellipse 124">
-            <a:extLst>
-              <a:ext uri="{FF2B5EF4-FFF2-40B4-BE49-F238E27FC236}">
-                <a16:creationId xmlns:a16="http://schemas.microsoft.com/office/drawing/2014/main" id="{B5C419EF-7B07-FF61-BD55-29C4479F2EDC}"/>
-              </a:ext>
-            </a:extLst>
-          </p:cNvPr>
-          <p:cNvSpPr/>
-          <p:nvPr/>
-        </p:nvSpPr>
-        <p:spPr>
-          <a:xfrm>
-            <a:off x="1885905" y="1905232"/>
+            <a:off x="1626941" y="2095225"/>
             <a:ext cx="78580" cy="78580"/>
           </a:xfrm>
           <a:prstGeom prst="ellipse">
@@ -14183,6 +14786,2743 @@
         <p:cNvPr id="1" name="">
           <a:extLst>
             <a:ext uri="{FF2B5EF4-FFF2-40B4-BE49-F238E27FC236}">
+              <a16:creationId xmlns:a16="http://schemas.microsoft.com/office/drawing/2014/main" id="{92299583-C570-3FC7-F4F2-5C665CB79E6F}"/>
+            </a:ext>
+          </a:extLst>
+        </p:cNvPr>
+        <p:cNvGrpSpPr/>
+        <p:nvPr/>
+      </p:nvGrpSpPr>
+      <p:grpSpPr>
+        <a:xfrm>
+          <a:off x="0" y="0"/>
+          <a:ext cx="0" cy="0"/>
+          <a:chOff x="0" y="0"/>
+          <a:chExt cx="0" cy="0"/>
+        </a:xfrm>
+      </p:grpSpPr>
+      <p:grpSp>
+        <p:nvGrpSpPr>
+          <p:cNvPr id="62" name="Gruppieren 61">
+            <a:extLst>
+              <a:ext uri="{FF2B5EF4-FFF2-40B4-BE49-F238E27FC236}">
+                <a16:creationId xmlns:a16="http://schemas.microsoft.com/office/drawing/2014/main" id="{346A92AF-35FB-FFEE-DF56-01DE1366D117}"/>
+              </a:ext>
+            </a:extLst>
+          </p:cNvPr>
+          <p:cNvGrpSpPr/>
+          <p:nvPr/>
+        </p:nvGrpSpPr>
+        <p:grpSpPr>
+          <a:xfrm>
+            <a:off x="644799" y="714375"/>
+            <a:ext cx="2269851" cy="2171700"/>
+            <a:chOff x="487680" y="949405"/>
+            <a:chExt cx="1877060" cy="1764030"/>
+          </a:xfrm>
+        </p:grpSpPr>
+        <p:grpSp>
+          <p:nvGrpSpPr>
+            <p:cNvPr id="33" name="Gruppieren 32">
+              <a:extLst>
+                <a:ext uri="{FF2B5EF4-FFF2-40B4-BE49-F238E27FC236}">
+                  <a16:creationId xmlns:a16="http://schemas.microsoft.com/office/drawing/2014/main" id="{AD72D2A4-5592-EF83-A5FC-0235149C4DEA}"/>
+                </a:ext>
+              </a:extLst>
+            </p:cNvPr>
+            <p:cNvGrpSpPr/>
+            <p:nvPr/>
+          </p:nvGrpSpPr>
+          <p:grpSpPr>
+            <a:xfrm>
+              <a:off x="487680" y="949405"/>
+              <a:ext cx="1877059" cy="1764030"/>
+              <a:chOff x="341947" y="567690"/>
+              <a:chExt cx="2918460" cy="1699260"/>
+            </a:xfrm>
+          </p:grpSpPr>
+          <p:cxnSp>
+            <p:nvCxnSpPr>
+              <p:cNvPr id="51" name="Gerader Verbinder 50">
+                <a:extLst>
+                  <a:ext uri="{FF2B5EF4-FFF2-40B4-BE49-F238E27FC236}">
+                    <a16:creationId xmlns:a16="http://schemas.microsoft.com/office/drawing/2014/main" id="{A32D81C6-8BB8-B4C2-DA48-911533574373}"/>
+                  </a:ext>
+                </a:extLst>
+              </p:cNvPr>
+              <p:cNvCxnSpPr>
+                <a:cxnSpLocks/>
+              </p:cNvCxnSpPr>
+              <p:nvPr/>
+            </p:nvCxnSpPr>
+            <p:spPr>
+              <a:xfrm>
+                <a:off x="341947" y="567690"/>
+                <a:ext cx="2918460" cy="0"/>
+              </a:xfrm>
+              <a:prstGeom prst="line">
+                <a:avLst/>
+              </a:prstGeom>
+              <a:ln w="9525" cap="rnd">
+                <a:solidFill>
+                  <a:schemeClr val="bg1">
+                    <a:lumMod val="75000"/>
+                  </a:schemeClr>
+                </a:solidFill>
+                <a:round/>
+              </a:ln>
+            </p:spPr>
+            <p:style>
+              <a:lnRef idx="2">
+                <a:schemeClr val="accent1"/>
+              </a:lnRef>
+              <a:fillRef idx="0">
+                <a:schemeClr val="accent1"/>
+              </a:fillRef>
+              <a:effectRef idx="1">
+                <a:schemeClr val="accent1"/>
+              </a:effectRef>
+              <a:fontRef idx="minor">
+                <a:schemeClr val="tx1"/>
+              </a:fontRef>
+            </p:style>
+          </p:cxnSp>
+          <p:cxnSp>
+            <p:nvCxnSpPr>
+              <p:cNvPr id="52" name="Gerader Verbinder 51">
+                <a:extLst>
+                  <a:ext uri="{FF2B5EF4-FFF2-40B4-BE49-F238E27FC236}">
+                    <a16:creationId xmlns:a16="http://schemas.microsoft.com/office/drawing/2014/main" id="{51B16870-9784-94A3-0720-C9ABBEB7011B}"/>
+                  </a:ext>
+                </a:extLst>
+              </p:cNvPr>
+              <p:cNvCxnSpPr>
+                <a:cxnSpLocks/>
+              </p:cNvCxnSpPr>
+              <p:nvPr/>
+            </p:nvCxnSpPr>
+            <p:spPr>
+              <a:xfrm>
+                <a:off x="341947" y="737616"/>
+                <a:ext cx="2918460" cy="0"/>
+              </a:xfrm>
+              <a:prstGeom prst="line">
+                <a:avLst/>
+              </a:prstGeom>
+              <a:ln w="9525" cap="rnd">
+                <a:solidFill>
+                  <a:schemeClr val="bg1">
+                    <a:lumMod val="75000"/>
+                  </a:schemeClr>
+                </a:solidFill>
+                <a:round/>
+              </a:ln>
+            </p:spPr>
+            <p:style>
+              <a:lnRef idx="2">
+                <a:schemeClr val="accent1"/>
+              </a:lnRef>
+              <a:fillRef idx="0">
+                <a:schemeClr val="accent1"/>
+              </a:fillRef>
+              <a:effectRef idx="1">
+                <a:schemeClr val="accent1"/>
+              </a:effectRef>
+              <a:fontRef idx="minor">
+                <a:schemeClr val="tx1"/>
+              </a:fontRef>
+            </p:style>
+          </p:cxnSp>
+          <p:cxnSp>
+            <p:nvCxnSpPr>
+              <p:cNvPr id="53" name="Gerader Verbinder 52">
+                <a:extLst>
+                  <a:ext uri="{FF2B5EF4-FFF2-40B4-BE49-F238E27FC236}">
+                    <a16:creationId xmlns:a16="http://schemas.microsoft.com/office/drawing/2014/main" id="{CC631D19-1344-4685-19CA-A7DF2AEE0340}"/>
+                  </a:ext>
+                </a:extLst>
+              </p:cNvPr>
+              <p:cNvCxnSpPr>
+                <a:cxnSpLocks/>
+              </p:cNvCxnSpPr>
+              <p:nvPr/>
+            </p:nvCxnSpPr>
+            <p:spPr>
+              <a:xfrm>
+                <a:off x="341947" y="907542"/>
+                <a:ext cx="2918460" cy="0"/>
+              </a:xfrm>
+              <a:prstGeom prst="line">
+                <a:avLst/>
+              </a:prstGeom>
+              <a:ln w="9525" cap="rnd">
+                <a:solidFill>
+                  <a:schemeClr val="bg1">
+                    <a:lumMod val="75000"/>
+                  </a:schemeClr>
+                </a:solidFill>
+                <a:round/>
+              </a:ln>
+            </p:spPr>
+            <p:style>
+              <a:lnRef idx="2">
+                <a:schemeClr val="accent1"/>
+              </a:lnRef>
+              <a:fillRef idx="0">
+                <a:schemeClr val="accent1"/>
+              </a:fillRef>
+              <a:effectRef idx="1">
+                <a:schemeClr val="accent1"/>
+              </a:effectRef>
+              <a:fontRef idx="minor">
+                <a:schemeClr val="tx1"/>
+              </a:fontRef>
+            </p:style>
+          </p:cxnSp>
+          <p:cxnSp>
+            <p:nvCxnSpPr>
+              <p:cNvPr id="54" name="Gerader Verbinder 53">
+                <a:extLst>
+                  <a:ext uri="{FF2B5EF4-FFF2-40B4-BE49-F238E27FC236}">
+                    <a16:creationId xmlns:a16="http://schemas.microsoft.com/office/drawing/2014/main" id="{4C7F94B2-23A5-D5AE-A04A-0B29848F04AF}"/>
+                  </a:ext>
+                </a:extLst>
+              </p:cNvPr>
+              <p:cNvCxnSpPr>
+                <a:cxnSpLocks/>
+              </p:cNvCxnSpPr>
+              <p:nvPr/>
+            </p:nvCxnSpPr>
+            <p:spPr>
+              <a:xfrm>
+                <a:off x="341947" y="1077468"/>
+                <a:ext cx="2918460" cy="0"/>
+              </a:xfrm>
+              <a:prstGeom prst="line">
+                <a:avLst/>
+              </a:prstGeom>
+              <a:ln w="9525" cap="rnd">
+                <a:solidFill>
+                  <a:schemeClr val="bg1">
+                    <a:lumMod val="75000"/>
+                  </a:schemeClr>
+                </a:solidFill>
+                <a:round/>
+              </a:ln>
+            </p:spPr>
+            <p:style>
+              <a:lnRef idx="2">
+                <a:schemeClr val="accent1"/>
+              </a:lnRef>
+              <a:fillRef idx="0">
+                <a:schemeClr val="accent1"/>
+              </a:fillRef>
+              <a:effectRef idx="1">
+                <a:schemeClr val="accent1"/>
+              </a:effectRef>
+              <a:fontRef idx="minor">
+                <a:schemeClr val="tx1"/>
+              </a:fontRef>
+            </p:style>
+          </p:cxnSp>
+          <p:cxnSp>
+            <p:nvCxnSpPr>
+              <p:cNvPr id="55" name="Gerader Verbinder 54">
+                <a:extLst>
+                  <a:ext uri="{FF2B5EF4-FFF2-40B4-BE49-F238E27FC236}">
+                    <a16:creationId xmlns:a16="http://schemas.microsoft.com/office/drawing/2014/main" id="{BE4B92E7-4295-F400-F712-631D17C9A248}"/>
+                  </a:ext>
+                </a:extLst>
+              </p:cNvPr>
+              <p:cNvCxnSpPr>
+                <a:cxnSpLocks/>
+              </p:cNvCxnSpPr>
+              <p:nvPr/>
+            </p:nvCxnSpPr>
+            <p:spPr>
+              <a:xfrm>
+                <a:off x="341947" y="1247394"/>
+                <a:ext cx="2918460" cy="0"/>
+              </a:xfrm>
+              <a:prstGeom prst="line">
+                <a:avLst/>
+              </a:prstGeom>
+              <a:ln w="9525" cap="rnd">
+                <a:solidFill>
+                  <a:schemeClr val="bg1">
+                    <a:lumMod val="75000"/>
+                  </a:schemeClr>
+                </a:solidFill>
+                <a:round/>
+              </a:ln>
+            </p:spPr>
+            <p:style>
+              <a:lnRef idx="2">
+                <a:schemeClr val="accent1"/>
+              </a:lnRef>
+              <a:fillRef idx="0">
+                <a:schemeClr val="accent1"/>
+              </a:fillRef>
+              <a:effectRef idx="1">
+                <a:schemeClr val="accent1"/>
+              </a:effectRef>
+              <a:fontRef idx="minor">
+                <a:schemeClr val="tx1"/>
+              </a:fontRef>
+            </p:style>
+          </p:cxnSp>
+          <p:cxnSp>
+            <p:nvCxnSpPr>
+              <p:cNvPr id="56" name="Gerader Verbinder 55">
+                <a:extLst>
+                  <a:ext uri="{FF2B5EF4-FFF2-40B4-BE49-F238E27FC236}">
+                    <a16:creationId xmlns:a16="http://schemas.microsoft.com/office/drawing/2014/main" id="{F1576033-5F42-3A04-5B77-6ED90FE39CF8}"/>
+                  </a:ext>
+                </a:extLst>
+              </p:cNvPr>
+              <p:cNvCxnSpPr>
+                <a:cxnSpLocks/>
+              </p:cNvCxnSpPr>
+              <p:nvPr/>
+            </p:nvCxnSpPr>
+            <p:spPr>
+              <a:xfrm>
+                <a:off x="341947" y="1417320"/>
+                <a:ext cx="2918460" cy="0"/>
+              </a:xfrm>
+              <a:prstGeom prst="line">
+                <a:avLst/>
+              </a:prstGeom>
+              <a:ln w="9525" cap="rnd">
+                <a:solidFill>
+                  <a:schemeClr val="bg1">
+                    <a:lumMod val="75000"/>
+                  </a:schemeClr>
+                </a:solidFill>
+                <a:round/>
+              </a:ln>
+            </p:spPr>
+            <p:style>
+              <a:lnRef idx="2">
+                <a:schemeClr val="accent1"/>
+              </a:lnRef>
+              <a:fillRef idx="0">
+                <a:schemeClr val="accent1"/>
+              </a:fillRef>
+              <a:effectRef idx="1">
+                <a:schemeClr val="accent1"/>
+              </a:effectRef>
+              <a:fontRef idx="minor">
+                <a:schemeClr val="tx1"/>
+              </a:fontRef>
+            </p:style>
+          </p:cxnSp>
+          <p:cxnSp>
+            <p:nvCxnSpPr>
+              <p:cNvPr id="57" name="Gerader Verbinder 56">
+                <a:extLst>
+                  <a:ext uri="{FF2B5EF4-FFF2-40B4-BE49-F238E27FC236}">
+                    <a16:creationId xmlns:a16="http://schemas.microsoft.com/office/drawing/2014/main" id="{5956CC9F-63A8-FAEC-014B-FE9D4AB050D8}"/>
+                  </a:ext>
+                </a:extLst>
+              </p:cNvPr>
+              <p:cNvCxnSpPr>
+                <a:cxnSpLocks/>
+              </p:cNvCxnSpPr>
+              <p:nvPr/>
+            </p:nvCxnSpPr>
+            <p:spPr>
+              <a:xfrm>
+                <a:off x="341947" y="1587246"/>
+                <a:ext cx="2918460" cy="0"/>
+              </a:xfrm>
+              <a:prstGeom prst="line">
+                <a:avLst/>
+              </a:prstGeom>
+              <a:ln w="9525" cap="rnd">
+                <a:solidFill>
+                  <a:schemeClr val="bg1">
+                    <a:lumMod val="75000"/>
+                  </a:schemeClr>
+                </a:solidFill>
+                <a:round/>
+              </a:ln>
+            </p:spPr>
+            <p:style>
+              <a:lnRef idx="2">
+                <a:schemeClr val="accent1"/>
+              </a:lnRef>
+              <a:fillRef idx="0">
+                <a:schemeClr val="accent1"/>
+              </a:fillRef>
+              <a:effectRef idx="1">
+                <a:schemeClr val="accent1"/>
+              </a:effectRef>
+              <a:fontRef idx="minor">
+                <a:schemeClr val="tx1"/>
+              </a:fontRef>
+            </p:style>
+          </p:cxnSp>
+          <p:cxnSp>
+            <p:nvCxnSpPr>
+              <p:cNvPr id="58" name="Gerader Verbinder 57">
+                <a:extLst>
+                  <a:ext uri="{FF2B5EF4-FFF2-40B4-BE49-F238E27FC236}">
+                    <a16:creationId xmlns:a16="http://schemas.microsoft.com/office/drawing/2014/main" id="{9A131698-3ECA-A582-718B-736C0BBB5970}"/>
+                  </a:ext>
+                </a:extLst>
+              </p:cNvPr>
+              <p:cNvCxnSpPr>
+                <a:cxnSpLocks/>
+              </p:cNvCxnSpPr>
+              <p:nvPr/>
+            </p:nvCxnSpPr>
+            <p:spPr>
+              <a:xfrm>
+                <a:off x="341947" y="1757172"/>
+                <a:ext cx="2918460" cy="0"/>
+              </a:xfrm>
+              <a:prstGeom prst="line">
+                <a:avLst/>
+              </a:prstGeom>
+              <a:ln w="9525" cap="rnd">
+                <a:solidFill>
+                  <a:schemeClr val="bg1">
+                    <a:lumMod val="75000"/>
+                  </a:schemeClr>
+                </a:solidFill>
+                <a:round/>
+              </a:ln>
+            </p:spPr>
+            <p:style>
+              <a:lnRef idx="2">
+                <a:schemeClr val="accent1"/>
+              </a:lnRef>
+              <a:fillRef idx="0">
+                <a:schemeClr val="accent1"/>
+              </a:fillRef>
+              <a:effectRef idx="1">
+                <a:schemeClr val="accent1"/>
+              </a:effectRef>
+              <a:fontRef idx="minor">
+                <a:schemeClr val="tx1"/>
+              </a:fontRef>
+            </p:style>
+          </p:cxnSp>
+          <p:cxnSp>
+            <p:nvCxnSpPr>
+              <p:cNvPr id="59" name="Gerader Verbinder 58">
+                <a:extLst>
+                  <a:ext uri="{FF2B5EF4-FFF2-40B4-BE49-F238E27FC236}">
+                    <a16:creationId xmlns:a16="http://schemas.microsoft.com/office/drawing/2014/main" id="{4F528BE2-D2D0-5C3E-6E7C-CFD20E216FE8}"/>
+                  </a:ext>
+                </a:extLst>
+              </p:cNvPr>
+              <p:cNvCxnSpPr>
+                <a:cxnSpLocks/>
+              </p:cNvCxnSpPr>
+              <p:nvPr/>
+            </p:nvCxnSpPr>
+            <p:spPr>
+              <a:xfrm>
+                <a:off x="341947" y="1927098"/>
+                <a:ext cx="2918460" cy="0"/>
+              </a:xfrm>
+              <a:prstGeom prst="line">
+                <a:avLst/>
+              </a:prstGeom>
+              <a:ln w="9525" cap="rnd">
+                <a:solidFill>
+                  <a:schemeClr val="bg1">
+                    <a:lumMod val="75000"/>
+                  </a:schemeClr>
+                </a:solidFill>
+                <a:round/>
+              </a:ln>
+            </p:spPr>
+            <p:style>
+              <a:lnRef idx="2">
+                <a:schemeClr val="accent1"/>
+              </a:lnRef>
+              <a:fillRef idx="0">
+                <a:schemeClr val="accent1"/>
+              </a:fillRef>
+              <a:effectRef idx="1">
+                <a:schemeClr val="accent1"/>
+              </a:effectRef>
+              <a:fontRef idx="minor">
+                <a:schemeClr val="tx1"/>
+              </a:fontRef>
+            </p:style>
+          </p:cxnSp>
+          <p:cxnSp>
+            <p:nvCxnSpPr>
+              <p:cNvPr id="60" name="Gerader Verbinder 59">
+                <a:extLst>
+                  <a:ext uri="{FF2B5EF4-FFF2-40B4-BE49-F238E27FC236}">
+                    <a16:creationId xmlns:a16="http://schemas.microsoft.com/office/drawing/2014/main" id="{056AB4D3-86B5-32B1-8435-F9BE0828F2EB}"/>
+                  </a:ext>
+                </a:extLst>
+              </p:cNvPr>
+              <p:cNvCxnSpPr>
+                <a:cxnSpLocks/>
+              </p:cNvCxnSpPr>
+              <p:nvPr/>
+            </p:nvCxnSpPr>
+            <p:spPr>
+              <a:xfrm>
+                <a:off x="341947" y="2097024"/>
+                <a:ext cx="2918460" cy="0"/>
+              </a:xfrm>
+              <a:prstGeom prst="line">
+                <a:avLst/>
+              </a:prstGeom>
+              <a:ln w="9525" cap="rnd">
+                <a:solidFill>
+                  <a:schemeClr val="bg1">
+                    <a:lumMod val="75000"/>
+                  </a:schemeClr>
+                </a:solidFill>
+                <a:round/>
+              </a:ln>
+            </p:spPr>
+            <p:style>
+              <a:lnRef idx="2">
+                <a:schemeClr val="accent1"/>
+              </a:lnRef>
+              <a:fillRef idx="0">
+                <a:schemeClr val="accent1"/>
+              </a:fillRef>
+              <a:effectRef idx="1">
+                <a:schemeClr val="accent1"/>
+              </a:effectRef>
+              <a:fontRef idx="minor">
+                <a:schemeClr val="tx1"/>
+              </a:fontRef>
+            </p:style>
+          </p:cxnSp>
+          <p:cxnSp>
+            <p:nvCxnSpPr>
+              <p:cNvPr id="61" name="Gerader Verbinder 60">
+                <a:extLst>
+                  <a:ext uri="{FF2B5EF4-FFF2-40B4-BE49-F238E27FC236}">
+                    <a16:creationId xmlns:a16="http://schemas.microsoft.com/office/drawing/2014/main" id="{D3307EF0-D236-E852-FE4D-F6865713E389}"/>
+                  </a:ext>
+                </a:extLst>
+              </p:cNvPr>
+              <p:cNvCxnSpPr>
+                <a:cxnSpLocks/>
+              </p:cNvCxnSpPr>
+              <p:nvPr/>
+            </p:nvCxnSpPr>
+            <p:spPr>
+              <a:xfrm>
+                <a:off x="341947" y="2266950"/>
+                <a:ext cx="2918460" cy="0"/>
+              </a:xfrm>
+              <a:prstGeom prst="line">
+                <a:avLst/>
+              </a:prstGeom>
+              <a:ln w="9525" cap="rnd">
+                <a:solidFill>
+                  <a:schemeClr val="bg1">
+                    <a:lumMod val="75000"/>
+                  </a:schemeClr>
+                </a:solidFill>
+                <a:round/>
+              </a:ln>
+            </p:spPr>
+            <p:style>
+              <a:lnRef idx="2">
+                <a:schemeClr val="accent1"/>
+              </a:lnRef>
+              <a:fillRef idx="0">
+                <a:schemeClr val="accent1"/>
+              </a:fillRef>
+              <a:effectRef idx="1">
+                <a:schemeClr val="accent1"/>
+              </a:effectRef>
+              <a:fontRef idx="minor">
+                <a:schemeClr val="tx1"/>
+              </a:fontRef>
+            </p:style>
+          </p:cxnSp>
+        </p:grpSp>
+        <p:grpSp>
+          <p:nvGrpSpPr>
+            <p:cNvPr id="34" name="Gruppieren 33">
+              <a:extLst>
+                <a:ext uri="{FF2B5EF4-FFF2-40B4-BE49-F238E27FC236}">
+                  <a16:creationId xmlns:a16="http://schemas.microsoft.com/office/drawing/2014/main" id="{667C5004-F033-4ED6-6B07-63CD94567279}"/>
+                </a:ext>
+              </a:extLst>
+            </p:cNvPr>
+            <p:cNvGrpSpPr/>
+            <p:nvPr/>
+          </p:nvGrpSpPr>
+          <p:grpSpPr>
+            <a:xfrm>
+              <a:off x="487680" y="949405"/>
+              <a:ext cx="1877060" cy="1764030"/>
+              <a:chOff x="321183" y="2689479"/>
+              <a:chExt cx="1958340" cy="1482090"/>
+            </a:xfrm>
+          </p:grpSpPr>
+          <p:cxnSp>
+            <p:nvCxnSpPr>
+              <p:cNvPr id="40" name="Gerader Verbinder 39">
+                <a:extLst>
+                  <a:ext uri="{FF2B5EF4-FFF2-40B4-BE49-F238E27FC236}">
+                    <a16:creationId xmlns:a16="http://schemas.microsoft.com/office/drawing/2014/main" id="{123719CF-18D8-32C7-DB7E-A08F03685B8C}"/>
+                  </a:ext>
+                </a:extLst>
+              </p:cNvPr>
+              <p:cNvCxnSpPr>
+                <a:cxnSpLocks/>
+              </p:cNvCxnSpPr>
+              <p:nvPr/>
+            </p:nvCxnSpPr>
+            <p:spPr>
+              <a:xfrm rot="5400000">
+                <a:off x="1538478" y="3430524"/>
+                <a:ext cx="1482090" cy="0"/>
+              </a:xfrm>
+              <a:prstGeom prst="line">
+                <a:avLst/>
+              </a:prstGeom>
+              <a:ln w="9525" cap="rnd">
+                <a:solidFill>
+                  <a:schemeClr val="bg1">
+                    <a:lumMod val="75000"/>
+                  </a:schemeClr>
+                </a:solidFill>
+                <a:round/>
+              </a:ln>
+            </p:spPr>
+            <p:style>
+              <a:lnRef idx="2">
+                <a:schemeClr val="accent1"/>
+              </a:lnRef>
+              <a:fillRef idx="0">
+                <a:schemeClr val="accent1"/>
+              </a:fillRef>
+              <a:effectRef idx="1">
+                <a:schemeClr val="accent1"/>
+              </a:effectRef>
+              <a:fontRef idx="minor">
+                <a:schemeClr val="tx1"/>
+              </a:fontRef>
+            </p:style>
+          </p:cxnSp>
+          <p:cxnSp>
+            <p:nvCxnSpPr>
+              <p:cNvPr id="41" name="Gerader Verbinder 40">
+                <a:extLst>
+                  <a:ext uri="{FF2B5EF4-FFF2-40B4-BE49-F238E27FC236}">
+                    <a16:creationId xmlns:a16="http://schemas.microsoft.com/office/drawing/2014/main" id="{30393208-6044-4881-B41D-FD693E1DECB0}"/>
+                  </a:ext>
+                </a:extLst>
+              </p:cNvPr>
+              <p:cNvCxnSpPr>
+                <a:cxnSpLocks/>
+              </p:cNvCxnSpPr>
+              <p:nvPr/>
+            </p:nvCxnSpPr>
+            <p:spPr>
+              <a:xfrm rot="5400000">
+                <a:off x="1146810" y="3430524"/>
+                <a:ext cx="1482090" cy="0"/>
+              </a:xfrm>
+              <a:prstGeom prst="line">
+                <a:avLst/>
+              </a:prstGeom>
+              <a:ln w="9525" cap="rnd">
+                <a:solidFill>
+                  <a:schemeClr val="bg1">
+                    <a:lumMod val="75000"/>
+                  </a:schemeClr>
+                </a:solidFill>
+                <a:round/>
+              </a:ln>
+            </p:spPr>
+            <p:style>
+              <a:lnRef idx="2">
+                <a:schemeClr val="accent1"/>
+              </a:lnRef>
+              <a:fillRef idx="0">
+                <a:schemeClr val="accent1"/>
+              </a:fillRef>
+              <a:effectRef idx="1">
+                <a:schemeClr val="accent1"/>
+              </a:effectRef>
+              <a:fontRef idx="minor">
+                <a:schemeClr val="tx1"/>
+              </a:fontRef>
+            </p:style>
+          </p:cxnSp>
+          <p:cxnSp>
+            <p:nvCxnSpPr>
+              <p:cNvPr id="42" name="Gerader Verbinder 41">
+                <a:extLst>
+                  <a:ext uri="{FF2B5EF4-FFF2-40B4-BE49-F238E27FC236}">
+                    <a16:creationId xmlns:a16="http://schemas.microsoft.com/office/drawing/2014/main" id="{E78FB374-8797-BA46-54F4-3531663E7AF9}"/>
+                  </a:ext>
+                </a:extLst>
+              </p:cNvPr>
+              <p:cNvCxnSpPr>
+                <a:cxnSpLocks/>
+              </p:cNvCxnSpPr>
+              <p:nvPr/>
+            </p:nvCxnSpPr>
+            <p:spPr>
+              <a:xfrm rot="5400000">
+                <a:off x="755142" y="3430524"/>
+                <a:ext cx="1482090" cy="0"/>
+              </a:xfrm>
+              <a:prstGeom prst="line">
+                <a:avLst/>
+              </a:prstGeom>
+              <a:ln w="9525" cap="rnd">
+                <a:solidFill>
+                  <a:schemeClr val="bg1">
+                    <a:lumMod val="75000"/>
+                  </a:schemeClr>
+                </a:solidFill>
+                <a:round/>
+              </a:ln>
+            </p:spPr>
+            <p:style>
+              <a:lnRef idx="2">
+                <a:schemeClr val="accent1"/>
+              </a:lnRef>
+              <a:fillRef idx="0">
+                <a:schemeClr val="accent1"/>
+              </a:fillRef>
+              <a:effectRef idx="1">
+                <a:schemeClr val="accent1"/>
+              </a:effectRef>
+              <a:fontRef idx="minor">
+                <a:schemeClr val="tx1"/>
+              </a:fontRef>
+            </p:style>
+          </p:cxnSp>
+          <p:cxnSp>
+            <p:nvCxnSpPr>
+              <p:cNvPr id="43" name="Gerader Verbinder 42">
+                <a:extLst>
+                  <a:ext uri="{FF2B5EF4-FFF2-40B4-BE49-F238E27FC236}">
+                    <a16:creationId xmlns:a16="http://schemas.microsoft.com/office/drawing/2014/main" id="{6FF69A67-6CF4-C9AB-A142-935F4AB4E1B2}"/>
+                  </a:ext>
+                </a:extLst>
+              </p:cNvPr>
+              <p:cNvCxnSpPr>
+                <a:cxnSpLocks/>
+              </p:cNvCxnSpPr>
+              <p:nvPr/>
+            </p:nvCxnSpPr>
+            <p:spPr>
+              <a:xfrm rot="5400000">
+                <a:off x="363474" y="3430524"/>
+                <a:ext cx="1482090" cy="0"/>
+              </a:xfrm>
+              <a:prstGeom prst="line">
+                <a:avLst/>
+              </a:prstGeom>
+              <a:ln w="9525" cap="rnd">
+                <a:solidFill>
+                  <a:schemeClr val="bg1">
+                    <a:lumMod val="75000"/>
+                  </a:schemeClr>
+                </a:solidFill>
+                <a:round/>
+              </a:ln>
+            </p:spPr>
+            <p:style>
+              <a:lnRef idx="2">
+                <a:schemeClr val="accent1"/>
+              </a:lnRef>
+              <a:fillRef idx="0">
+                <a:schemeClr val="accent1"/>
+              </a:fillRef>
+              <a:effectRef idx="1">
+                <a:schemeClr val="accent1"/>
+              </a:effectRef>
+              <a:fontRef idx="minor">
+                <a:schemeClr val="tx1"/>
+              </a:fontRef>
+            </p:style>
+          </p:cxnSp>
+          <p:cxnSp>
+            <p:nvCxnSpPr>
+              <p:cNvPr id="44" name="Gerader Verbinder 43">
+                <a:extLst>
+                  <a:ext uri="{FF2B5EF4-FFF2-40B4-BE49-F238E27FC236}">
+                    <a16:creationId xmlns:a16="http://schemas.microsoft.com/office/drawing/2014/main" id="{8F9DDAB2-CEFE-899E-3854-38043A19A73C}"/>
+                  </a:ext>
+                </a:extLst>
+              </p:cNvPr>
+              <p:cNvCxnSpPr>
+                <a:cxnSpLocks/>
+              </p:cNvCxnSpPr>
+              <p:nvPr/>
+            </p:nvCxnSpPr>
+            <p:spPr>
+              <a:xfrm rot="5400000">
+                <a:off x="-28194" y="3430524"/>
+                <a:ext cx="1482090" cy="0"/>
+              </a:xfrm>
+              <a:prstGeom prst="line">
+                <a:avLst/>
+              </a:prstGeom>
+              <a:ln w="9525" cap="rnd">
+                <a:solidFill>
+                  <a:schemeClr val="bg1">
+                    <a:lumMod val="75000"/>
+                  </a:schemeClr>
+                </a:solidFill>
+                <a:round/>
+              </a:ln>
+            </p:spPr>
+            <p:style>
+              <a:lnRef idx="2">
+                <a:schemeClr val="accent1"/>
+              </a:lnRef>
+              <a:fillRef idx="0">
+                <a:schemeClr val="accent1"/>
+              </a:fillRef>
+              <a:effectRef idx="1">
+                <a:schemeClr val="accent1"/>
+              </a:effectRef>
+              <a:fontRef idx="minor">
+                <a:schemeClr val="tx1"/>
+              </a:fontRef>
+            </p:style>
+          </p:cxnSp>
+          <p:cxnSp>
+            <p:nvCxnSpPr>
+              <p:cNvPr id="45" name="Gerader Verbinder 44">
+                <a:extLst>
+                  <a:ext uri="{FF2B5EF4-FFF2-40B4-BE49-F238E27FC236}">
+                    <a16:creationId xmlns:a16="http://schemas.microsoft.com/office/drawing/2014/main" id="{39955299-FB4E-4C8A-28EC-815B1187FE75}"/>
+                  </a:ext>
+                </a:extLst>
+              </p:cNvPr>
+              <p:cNvCxnSpPr>
+                <a:cxnSpLocks/>
+              </p:cNvCxnSpPr>
+              <p:nvPr/>
+            </p:nvCxnSpPr>
+            <p:spPr>
+              <a:xfrm rot="5400000">
+                <a:off x="-419862" y="3430524"/>
+                <a:ext cx="1482090" cy="0"/>
+              </a:xfrm>
+              <a:prstGeom prst="line">
+                <a:avLst/>
+              </a:prstGeom>
+              <a:ln w="9525" cap="rnd">
+                <a:solidFill>
+                  <a:schemeClr val="bg1">
+                    <a:lumMod val="75000"/>
+                  </a:schemeClr>
+                </a:solidFill>
+                <a:round/>
+              </a:ln>
+            </p:spPr>
+            <p:style>
+              <a:lnRef idx="2">
+                <a:schemeClr val="accent1"/>
+              </a:lnRef>
+              <a:fillRef idx="0">
+                <a:schemeClr val="accent1"/>
+              </a:fillRef>
+              <a:effectRef idx="1">
+                <a:schemeClr val="accent1"/>
+              </a:effectRef>
+              <a:fontRef idx="minor">
+                <a:schemeClr val="tx1"/>
+              </a:fontRef>
+            </p:style>
+          </p:cxnSp>
+          <p:cxnSp>
+            <p:nvCxnSpPr>
+              <p:cNvPr id="46" name="Gerader Verbinder 45">
+                <a:extLst>
+                  <a:ext uri="{FF2B5EF4-FFF2-40B4-BE49-F238E27FC236}">
+                    <a16:creationId xmlns:a16="http://schemas.microsoft.com/office/drawing/2014/main" id="{0356B704-2496-182D-DCDC-B4B22A05C466}"/>
+                  </a:ext>
+                </a:extLst>
+              </p:cNvPr>
+              <p:cNvCxnSpPr>
+                <a:cxnSpLocks/>
+              </p:cNvCxnSpPr>
+              <p:nvPr/>
+            </p:nvCxnSpPr>
+            <p:spPr>
+              <a:xfrm rot="5400000">
+                <a:off x="-224028" y="3430524"/>
+                <a:ext cx="1482090" cy="0"/>
+              </a:xfrm>
+              <a:prstGeom prst="line">
+                <a:avLst/>
+              </a:prstGeom>
+              <a:ln w="9525" cap="rnd">
+                <a:solidFill>
+                  <a:schemeClr val="bg1">
+                    <a:lumMod val="75000"/>
+                  </a:schemeClr>
+                </a:solidFill>
+                <a:round/>
+              </a:ln>
+            </p:spPr>
+            <p:style>
+              <a:lnRef idx="2">
+                <a:schemeClr val="accent1"/>
+              </a:lnRef>
+              <a:fillRef idx="0">
+                <a:schemeClr val="accent1"/>
+              </a:fillRef>
+              <a:effectRef idx="1">
+                <a:schemeClr val="accent1"/>
+              </a:effectRef>
+              <a:fontRef idx="minor">
+                <a:schemeClr val="tx1"/>
+              </a:fontRef>
+            </p:style>
+          </p:cxnSp>
+          <p:cxnSp>
+            <p:nvCxnSpPr>
+              <p:cNvPr id="47" name="Gerader Verbinder 46">
+                <a:extLst>
+                  <a:ext uri="{FF2B5EF4-FFF2-40B4-BE49-F238E27FC236}">
+                    <a16:creationId xmlns:a16="http://schemas.microsoft.com/office/drawing/2014/main" id="{1E8D5CE0-FE47-1AC2-9DB1-68D3C1A53D41}"/>
+                  </a:ext>
+                </a:extLst>
+              </p:cNvPr>
+              <p:cNvCxnSpPr>
+                <a:cxnSpLocks/>
+              </p:cNvCxnSpPr>
+              <p:nvPr/>
+            </p:nvCxnSpPr>
+            <p:spPr>
+              <a:xfrm rot="5400000">
+                <a:off x="167640" y="3430524"/>
+                <a:ext cx="1482090" cy="0"/>
+              </a:xfrm>
+              <a:prstGeom prst="line">
+                <a:avLst/>
+              </a:prstGeom>
+              <a:ln w="9525" cap="rnd">
+                <a:solidFill>
+                  <a:schemeClr val="bg1">
+                    <a:lumMod val="75000"/>
+                  </a:schemeClr>
+                </a:solidFill>
+                <a:round/>
+              </a:ln>
+            </p:spPr>
+            <p:style>
+              <a:lnRef idx="2">
+                <a:schemeClr val="accent1"/>
+              </a:lnRef>
+              <a:fillRef idx="0">
+                <a:schemeClr val="accent1"/>
+              </a:fillRef>
+              <a:effectRef idx="1">
+                <a:schemeClr val="accent1"/>
+              </a:effectRef>
+              <a:fontRef idx="minor">
+                <a:schemeClr val="tx1"/>
+              </a:fontRef>
+            </p:style>
+          </p:cxnSp>
+          <p:cxnSp>
+            <p:nvCxnSpPr>
+              <p:cNvPr id="48" name="Gerader Verbinder 47">
+                <a:extLst>
+                  <a:ext uri="{FF2B5EF4-FFF2-40B4-BE49-F238E27FC236}">
+                    <a16:creationId xmlns:a16="http://schemas.microsoft.com/office/drawing/2014/main" id="{0F0A7C69-9C0D-0B5A-B481-5E655DD2058C}"/>
+                  </a:ext>
+                </a:extLst>
+              </p:cNvPr>
+              <p:cNvCxnSpPr>
+                <a:cxnSpLocks/>
+              </p:cNvCxnSpPr>
+              <p:nvPr/>
+            </p:nvCxnSpPr>
+            <p:spPr>
+              <a:xfrm rot="5400000">
+                <a:off x="559308" y="3430524"/>
+                <a:ext cx="1482090" cy="0"/>
+              </a:xfrm>
+              <a:prstGeom prst="line">
+                <a:avLst/>
+              </a:prstGeom>
+              <a:ln w="9525" cap="rnd">
+                <a:solidFill>
+                  <a:schemeClr val="bg1">
+                    <a:lumMod val="75000"/>
+                  </a:schemeClr>
+                </a:solidFill>
+                <a:round/>
+              </a:ln>
+            </p:spPr>
+            <p:style>
+              <a:lnRef idx="2">
+                <a:schemeClr val="accent1"/>
+              </a:lnRef>
+              <a:fillRef idx="0">
+                <a:schemeClr val="accent1"/>
+              </a:fillRef>
+              <a:effectRef idx="1">
+                <a:schemeClr val="accent1"/>
+              </a:effectRef>
+              <a:fontRef idx="minor">
+                <a:schemeClr val="tx1"/>
+              </a:fontRef>
+            </p:style>
+          </p:cxnSp>
+          <p:cxnSp>
+            <p:nvCxnSpPr>
+              <p:cNvPr id="49" name="Gerader Verbinder 48">
+                <a:extLst>
+                  <a:ext uri="{FF2B5EF4-FFF2-40B4-BE49-F238E27FC236}">
+                    <a16:creationId xmlns:a16="http://schemas.microsoft.com/office/drawing/2014/main" id="{684BF991-0B1A-092A-5840-666574E7C261}"/>
+                  </a:ext>
+                </a:extLst>
+              </p:cNvPr>
+              <p:cNvCxnSpPr>
+                <a:cxnSpLocks/>
+              </p:cNvCxnSpPr>
+              <p:nvPr/>
+            </p:nvCxnSpPr>
+            <p:spPr>
+              <a:xfrm rot="5400000">
+                <a:off x="950976" y="3430524"/>
+                <a:ext cx="1482090" cy="0"/>
+              </a:xfrm>
+              <a:prstGeom prst="line">
+                <a:avLst/>
+              </a:prstGeom>
+              <a:ln w="9525" cap="rnd">
+                <a:solidFill>
+                  <a:schemeClr val="bg1">
+                    <a:lumMod val="75000"/>
+                  </a:schemeClr>
+                </a:solidFill>
+                <a:round/>
+              </a:ln>
+            </p:spPr>
+            <p:style>
+              <a:lnRef idx="2">
+                <a:schemeClr val="accent1"/>
+              </a:lnRef>
+              <a:fillRef idx="0">
+                <a:schemeClr val="accent1"/>
+              </a:fillRef>
+              <a:effectRef idx="1">
+                <a:schemeClr val="accent1"/>
+              </a:effectRef>
+              <a:fontRef idx="minor">
+                <a:schemeClr val="tx1"/>
+              </a:fontRef>
+            </p:style>
+          </p:cxnSp>
+          <p:cxnSp>
+            <p:nvCxnSpPr>
+              <p:cNvPr id="50" name="Gerader Verbinder 49">
+                <a:extLst>
+                  <a:ext uri="{FF2B5EF4-FFF2-40B4-BE49-F238E27FC236}">
+                    <a16:creationId xmlns:a16="http://schemas.microsoft.com/office/drawing/2014/main" id="{6D5BFAB2-039C-15C2-459D-880B77161036}"/>
+                  </a:ext>
+                </a:extLst>
+              </p:cNvPr>
+              <p:cNvCxnSpPr>
+                <a:cxnSpLocks/>
+              </p:cNvCxnSpPr>
+              <p:nvPr/>
+            </p:nvCxnSpPr>
+            <p:spPr>
+              <a:xfrm rot="5400000">
+                <a:off x="1342644" y="3430524"/>
+                <a:ext cx="1482090" cy="0"/>
+              </a:xfrm>
+              <a:prstGeom prst="line">
+                <a:avLst/>
+              </a:prstGeom>
+              <a:ln w="9525" cap="rnd">
+                <a:solidFill>
+                  <a:schemeClr val="bg1">
+                    <a:lumMod val="75000"/>
+                  </a:schemeClr>
+                </a:solidFill>
+                <a:round/>
+              </a:ln>
+            </p:spPr>
+            <p:style>
+              <a:lnRef idx="2">
+                <a:schemeClr val="accent1"/>
+              </a:lnRef>
+              <a:fillRef idx="0">
+                <a:schemeClr val="accent1"/>
+              </a:fillRef>
+              <a:effectRef idx="1">
+                <a:schemeClr val="accent1"/>
+              </a:effectRef>
+              <a:fontRef idx="minor">
+                <a:schemeClr val="tx1"/>
+              </a:fontRef>
+            </p:style>
+          </p:cxnSp>
+        </p:grpSp>
+      </p:grpSp>
+      <p:sp>
+        <p:nvSpPr>
+          <p:cNvPr id="63" name="Textfeld 62">
+            <a:extLst>
+              <a:ext uri="{FF2B5EF4-FFF2-40B4-BE49-F238E27FC236}">
+                <a16:creationId xmlns:a16="http://schemas.microsoft.com/office/drawing/2014/main" id="{1F0546A4-D8AF-DF25-23C7-BAA9F2996F10}"/>
+              </a:ext>
+            </a:extLst>
+          </p:cNvPr>
+          <p:cNvSpPr txBox="1"/>
+          <p:nvPr/>
+        </p:nvSpPr>
+        <p:spPr>
+          <a:xfrm>
+            <a:off x="648617" y="432065"/>
+            <a:ext cx="352185" cy="261610"/>
+          </a:xfrm>
+          <a:prstGeom prst="rect">
+            <a:avLst/>
+          </a:prstGeom>
+          <a:noFill/>
+        </p:spPr>
+        <p:txBody>
+          <a:bodyPr wrap="square" rtlCol="0">
+            <a:spAutoFit/>
+          </a:bodyPr>
+          <a:lstStyle/>
+          <a:p>
+            <a:pPr algn="ctr"/>
+            <a:r>
+              <a:rPr lang="de-DE" sz="1100" i="1" dirty="0">
+                <a:latin typeface="CMU Serif" panose="02000603000000000000" pitchFamily="2" charset="0"/>
+                <a:ea typeface="CMU Serif" panose="02000603000000000000" pitchFamily="2" charset="0"/>
+                <a:cs typeface="CMU Serif" panose="02000603000000000000" pitchFamily="2" charset="0"/>
+              </a:rPr>
+              <a:t>R</a:t>
+            </a:r>
+            <a:r>
+              <a:rPr lang="de-DE" sz="1100" baseline="-25000" dirty="0">
+                <a:latin typeface="CMU Serif" panose="02000603000000000000" pitchFamily="2" charset="0"/>
+                <a:ea typeface="CMU Serif" panose="02000603000000000000" pitchFamily="2" charset="0"/>
+                <a:cs typeface="CMU Serif" panose="02000603000000000000" pitchFamily="2" charset="0"/>
+              </a:rPr>
+              <a:t>Z</a:t>
+            </a:r>
+          </a:p>
+        </p:txBody>
+      </p:sp>
+      <p:grpSp>
+        <p:nvGrpSpPr>
+          <p:cNvPr id="70" name="Gruppieren 69">
+            <a:extLst>
+              <a:ext uri="{FF2B5EF4-FFF2-40B4-BE49-F238E27FC236}">
+                <a16:creationId xmlns:a16="http://schemas.microsoft.com/office/drawing/2014/main" id="{D047DF13-3CB5-3B9F-A823-307E605E46A1}"/>
+              </a:ext>
+            </a:extLst>
+          </p:cNvPr>
+          <p:cNvGrpSpPr/>
+          <p:nvPr/>
+        </p:nvGrpSpPr>
+        <p:grpSpPr>
+          <a:xfrm>
+            <a:off x="352896" y="614364"/>
+            <a:ext cx="354335" cy="2168913"/>
+            <a:chOff x="216658" y="852398"/>
+            <a:chExt cx="354335" cy="1757633"/>
+          </a:xfrm>
+        </p:grpSpPr>
+        <p:sp>
+          <p:nvSpPr>
+            <p:cNvPr id="71" name="Textfeld 70">
+              <a:extLst>
+                <a:ext uri="{FF2B5EF4-FFF2-40B4-BE49-F238E27FC236}">
+                  <a16:creationId xmlns:a16="http://schemas.microsoft.com/office/drawing/2014/main" id="{351411BF-404B-E268-4DCF-8968D32E85E5}"/>
+                </a:ext>
+              </a:extLst>
+            </p:cNvPr>
+            <p:cNvSpPr txBox="1"/>
+            <p:nvPr/>
+          </p:nvSpPr>
+          <p:spPr>
+            <a:xfrm>
+              <a:off x="216663" y="852398"/>
+              <a:ext cx="354330" cy="174236"/>
+            </a:xfrm>
+            <a:prstGeom prst="rect">
+              <a:avLst/>
+            </a:prstGeom>
+            <a:noFill/>
+          </p:spPr>
+          <p:txBody>
+            <a:bodyPr wrap="square" rtlCol="0">
+              <a:spAutoFit/>
+            </a:bodyPr>
+            <a:lstStyle/>
+            <a:p>
+              <a:r>
+                <a:rPr lang="de-DE" sz="800" dirty="0">
+                  <a:latin typeface="CMU Serif" panose="02000603000000000000" pitchFamily="2" charset="0"/>
+                  <a:ea typeface="CMU Serif" panose="02000603000000000000" pitchFamily="2" charset="0"/>
+                  <a:cs typeface="CMU Serif" panose="02000603000000000000" pitchFamily="2" charset="0"/>
+                </a:rPr>
+                <a:t>1,0</a:t>
+              </a:r>
+            </a:p>
+          </p:txBody>
+        </p:sp>
+        <p:sp>
+          <p:nvSpPr>
+            <p:cNvPr id="72" name="Textfeld 71">
+              <a:extLst>
+                <a:ext uri="{FF2B5EF4-FFF2-40B4-BE49-F238E27FC236}">
+                  <a16:creationId xmlns:a16="http://schemas.microsoft.com/office/drawing/2014/main" id="{931E7A88-DBA7-CFEB-3138-0FC018D6C768}"/>
+                </a:ext>
+              </a:extLst>
+            </p:cNvPr>
+            <p:cNvSpPr txBox="1"/>
+            <p:nvPr/>
+          </p:nvSpPr>
+          <p:spPr>
+            <a:xfrm>
+              <a:off x="216663" y="1028331"/>
+              <a:ext cx="354330" cy="174236"/>
+            </a:xfrm>
+            <a:prstGeom prst="rect">
+              <a:avLst/>
+            </a:prstGeom>
+            <a:noFill/>
+          </p:spPr>
+          <p:txBody>
+            <a:bodyPr wrap="square" rtlCol="0">
+              <a:spAutoFit/>
+            </a:bodyPr>
+            <a:lstStyle/>
+            <a:p>
+              <a:r>
+                <a:rPr lang="de-DE" sz="800" dirty="0">
+                  <a:latin typeface="CMU Serif" panose="02000603000000000000" pitchFamily="2" charset="0"/>
+                  <a:ea typeface="CMU Serif" panose="02000603000000000000" pitchFamily="2" charset="0"/>
+                  <a:cs typeface="CMU Serif" panose="02000603000000000000" pitchFamily="2" charset="0"/>
+                </a:rPr>
+                <a:t>0,9</a:t>
+              </a:r>
+            </a:p>
+          </p:txBody>
+        </p:sp>
+        <p:sp>
+          <p:nvSpPr>
+            <p:cNvPr id="73" name="Textfeld 72">
+              <a:extLst>
+                <a:ext uri="{FF2B5EF4-FFF2-40B4-BE49-F238E27FC236}">
+                  <a16:creationId xmlns:a16="http://schemas.microsoft.com/office/drawing/2014/main" id="{C2E666FC-D396-B22F-9473-EACDA065ACDE}"/>
+                </a:ext>
+              </a:extLst>
+            </p:cNvPr>
+            <p:cNvSpPr txBox="1"/>
+            <p:nvPr/>
+          </p:nvSpPr>
+          <p:spPr>
+            <a:xfrm>
+              <a:off x="216663" y="1204264"/>
+              <a:ext cx="354330" cy="174236"/>
+            </a:xfrm>
+            <a:prstGeom prst="rect">
+              <a:avLst/>
+            </a:prstGeom>
+            <a:noFill/>
+          </p:spPr>
+          <p:txBody>
+            <a:bodyPr wrap="square" rtlCol="0">
+              <a:spAutoFit/>
+            </a:bodyPr>
+            <a:lstStyle/>
+            <a:p>
+              <a:r>
+                <a:rPr lang="de-DE" sz="800" dirty="0">
+                  <a:latin typeface="CMU Serif" panose="02000603000000000000" pitchFamily="2" charset="0"/>
+                  <a:ea typeface="CMU Serif" panose="02000603000000000000" pitchFamily="2" charset="0"/>
+                  <a:cs typeface="CMU Serif" panose="02000603000000000000" pitchFamily="2" charset="0"/>
+                </a:rPr>
+                <a:t>0,8</a:t>
+              </a:r>
+            </a:p>
+          </p:txBody>
+        </p:sp>
+        <p:sp>
+          <p:nvSpPr>
+            <p:cNvPr id="74" name="Textfeld 73">
+              <a:extLst>
+                <a:ext uri="{FF2B5EF4-FFF2-40B4-BE49-F238E27FC236}">
+                  <a16:creationId xmlns:a16="http://schemas.microsoft.com/office/drawing/2014/main" id="{05FD0F27-4A66-F0BE-722B-596349C8D5DD}"/>
+                </a:ext>
+              </a:extLst>
+            </p:cNvPr>
+            <p:cNvSpPr txBox="1"/>
+            <p:nvPr/>
+          </p:nvSpPr>
+          <p:spPr>
+            <a:xfrm>
+              <a:off x="216663" y="1380197"/>
+              <a:ext cx="354330" cy="174236"/>
+            </a:xfrm>
+            <a:prstGeom prst="rect">
+              <a:avLst/>
+            </a:prstGeom>
+            <a:noFill/>
+          </p:spPr>
+          <p:txBody>
+            <a:bodyPr wrap="square" rtlCol="0">
+              <a:spAutoFit/>
+            </a:bodyPr>
+            <a:lstStyle/>
+            <a:p>
+              <a:r>
+                <a:rPr lang="de-DE" sz="800" dirty="0">
+                  <a:latin typeface="CMU Serif" panose="02000603000000000000" pitchFamily="2" charset="0"/>
+                  <a:ea typeface="CMU Serif" panose="02000603000000000000" pitchFamily="2" charset="0"/>
+                  <a:cs typeface="CMU Serif" panose="02000603000000000000" pitchFamily="2" charset="0"/>
+                </a:rPr>
+                <a:t>0,7</a:t>
+              </a:r>
+            </a:p>
+          </p:txBody>
+        </p:sp>
+        <p:sp>
+          <p:nvSpPr>
+            <p:cNvPr id="75" name="Textfeld 74">
+              <a:extLst>
+                <a:ext uri="{FF2B5EF4-FFF2-40B4-BE49-F238E27FC236}">
+                  <a16:creationId xmlns:a16="http://schemas.microsoft.com/office/drawing/2014/main" id="{DFBB46A6-F814-89A2-9107-AC31C1FE9C7E}"/>
+                </a:ext>
+              </a:extLst>
+            </p:cNvPr>
+            <p:cNvSpPr txBox="1"/>
+            <p:nvPr/>
+          </p:nvSpPr>
+          <p:spPr>
+            <a:xfrm>
+              <a:off x="216663" y="1556130"/>
+              <a:ext cx="354330" cy="174236"/>
+            </a:xfrm>
+            <a:prstGeom prst="rect">
+              <a:avLst/>
+            </a:prstGeom>
+            <a:noFill/>
+          </p:spPr>
+          <p:txBody>
+            <a:bodyPr wrap="square" rtlCol="0">
+              <a:spAutoFit/>
+            </a:bodyPr>
+            <a:lstStyle/>
+            <a:p>
+              <a:r>
+                <a:rPr lang="de-DE" sz="800" dirty="0">
+                  <a:latin typeface="CMU Serif" panose="02000603000000000000" pitchFamily="2" charset="0"/>
+                  <a:ea typeface="CMU Serif" panose="02000603000000000000" pitchFamily="2" charset="0"/>
+                  <a:cs typeface="CMU Serif" panose="02000603000000000000" pitchFamily="2" charset="0"/>
+                </a:rPr>
+                <a:t>0,6</a:t>
+              </a:r>
+            </a:p>
+          </p:txBody>
+        </p:sp>
+        <p:sp>
+          <p:nvSpPr>
+            <p:cNvPr id="76" name="Textfeld 75">
+              <a:extLst>
+                <a:ext uri="{FF2B5EF4-FFF2-40B4-BE49-F238E27FC236}">
+                  <a16:creationId xmlns:a16="http://schemas.microsoft.com/office/drawing/2014/main" id="{33C85AAC-095D-6CFD-19C2-727CB6BCBC9E}"/>
+                </a:ext>
+              </a:extLst>
+            </p:cNvPr>
+            <p:cNvSpPr txBox="1"/>
+            <p:nvPr/>
+          </p:nvSpPr>
+          <p:spPr>
+            <a:xfrm>
+              <a:off x="216662" y="1732063"/>
+              <a:ext cx="354330" cy="174236"/>
+            </a:xfrm>
+            <a:prstGeom prst="rect">
+              <a:avLst/>
+            </a:prstGeom>
+            <a:noFill/>
+          </p:spPr>
+          <p:txBody>
+            <a:bodyPr wrap="square" rtlCol="0">
+              <a:spAutoFit/>
+            </a:bodyPr>
+            <a:lstStyle/>
+            <a:p>
+              <a:r>
+                <a:rPr lang="de-DE" sz="800" dirty="0">
+                  <a:latin typeface="CMU Serif" panose="02000603000000000000" pitchFamily="2" charset="0"/>
+                  <a:ea typeface="CMU Serif" panose="02000603000000000000" pitchFamily="2" charset="0"/>
+                  <a:cs typeface="CMU Serif" panose="02000603000000000000" pitchFamily="2" charset="0"/>
+                </a:rPr>
+                <a:t>0,5</a:t>
+              </a:r>
+            </a:p>
+          </p:txBody>
+        </p:sp>
+        <p:sp>
+          <p:nvSpPr>
+            <p:cNvPr id="77" name="Textfeld 76">
+              <a:extLst>
+                <a:ext uri="{FF2B5EF4-FFF2-40B4-BE49-F238E27FC236}">
+                  <a16:creationId xmlns:a16="http://schemas.microsoft.com/office/drawing/2014/main" id="{42F3B241-B83A-7DF1-FDB3-D3C3B5F03630}"/>
+                </a:ext>
+              </a:extLst>
+            </p:cNvPr>
+            <p:cNvSpPr txBox="1"/>
+            <p:nvPr/>
+          </p:nvSpPr>
+          <p:spPr>
+            <a:xfrm>
+              <a:off x="216661" y="1907996"/>
+              <a:ext cx="354330" cy="174236"/>
+            </a:xfrm>
+            <a:prstGeom prst="rect">
+              <a:avLst/>
+            </a:prstGeom>
+            <a:noFill/>
+          </p:spPr>
+          <p:txBody>
+            <a:bodyPr wrap="square" rtlCol="0">
+              <a:spAutoFit/>
+            </a:bodyPr>
+            <a:lstStyle/>
+            <a:p>
+              <a:r>
+                <a:rPr lang="de-DE" sz="800" dirty="0">
+                  <a:latin typeface="CMU Serif" panose="02000603000000000000" pitchFamily="2" charset="0"/>
+                  <a:ea typeface="CMU Serif" panose="02000603000000000000" pitchFamily="2" charset="0"/>
+                  <a:cs typeface="CMU Serif" panose="02000603000000000000" pitchFamily="2" charset="0"/>
+                </a:rPr>
+                <a:t>0,4</a:t>
+              </a:r>
+            </a:p>
+          </p:txBody>
+        </p:sp>
+        <p:sp>
+          <p:nvSpPr>
+            <p:cNvPr id="78" name="Textfeld 77">
+              <a:extLst>
+                <a:ext uri="{FF2B5EF4-FFF2-40B4-BE49-F238E27FC236}">
+                  <a16:creationId xmlns:a16="http://schemas.microsoft.com/office/drawing/2014/main" id="{9E58C0A8-BE90-412C-83EC-5B362268C798}"/>
+                </a:ext>
+              </a:extLst>
+            </p:cNvPr>
+            <p:cNvSpPr txBox="1"/>
+            <p:nvPr/>
+          </p:nvSpPr>
+          <p:spPr>
+            <a:xfrm>
+              <a:off x="216660" y="2083929"/>
+              <a:ext cx="354330" cy="174236"/>
+            </a:xfrm>
+            <a:prstGeom prst="rect">
+              <a:avLst/>
+            </a:prstGeom>
+            <a:noFill/>
+          </p:spPr>
+          <p:txBody>
+            <a:bodyPr wrap="square" rtlCol="0">
+              <a:spAutoFit/>
+            </a:bodyPr>
+            <a:lstStyle/>
+            <a:p>
+              <a:r>
+                <a:rPr lang="de-DE" sz="800" dirty="0">
+                  <a:latin typeface="CMU Serif" panose="02000603000000000000" pitchFamily="2" charset="0"/>
+                  <a:ea typeface="CMU Serif" panose="02000603000000000000" pitchFamily="2" charset="0"/>
+                  <a:cs typeface="CMU Serif" panose="02000603000000000000" pitchFamily="2" charset="0"/>
+                </a:rPr>
+                <a:t>0,3</a:t>
+              </a:r>
+            </a:p>
+          </p:txBody>
+        </p:sp>
+        <p:sp>
+          <p:nvSpPr>
+            <p:cNvPr id="79" name="Textfeld 78">
+              <a:extLst>
+                <a:ext uri="{FF2B5EF4-FFF2-40B4-BE49-F238E27FC236}">
+                  <a16:creationId xmlns:a16="http://schemas.microsoft.com/office/drawing/2014/main" id="{8E6B3D0F-B6CC-E102-D611-1D678A31530D}"/>
+                </a:ext>
+              </a:extLst>
+            </p:cNvPr>
+            <p:cNvSpPr txBox="1"/>
+            <p:nvPr/>
+          </p:nvSpPr>
+          <p:spPr>
+            <a:xfrm>
+              <a:off x="216659" y="2259862"/>
+              <a:ext cx="354330" cy="174236"/>
+            </a:xfrm>
+            <a:prstGeom prst="rect">
+              <a:avLst/>
+            </a:prstGeom>
+            <a:noFill/>
+          </p:spPr>
+          <p:txBody>
+            <a:bodyPr wrap="square" rtlCol="0">
+              <a:spAutoFit/>
+            </a:bodyPr>
+            <a:lstStyle/>
+            <a:p>
+              <a:r>
+                <a:rPr lang="de-DE" sz="800" dirty="0">
+                  <a:latin typeface="CMU Serif" panose="02000603000000000000" pitchFamily="2" charset="0"/>
+                  <a:ea typeface="CMU Serif" panose="02000603000000000000" pitchFamily="2" charset="0"/>
+                  <a:cs typeface="CMU Serif" panose="02000603000000000000" pitchFamily="2" charset="0"/>
+                </a:rPr>
+                <a:t>0,2</a:t>
+              </a:r>
+            </a:p>
+          </p:txBody>
+        </p:sp>
+        <p:sp>
+          <p:nvSpPr>
+            <p:cNvPr id="80" name="Textfeld 79">
+              <a:extLst>
+                <a:ext uri="{FF2B5EF4-FFF2-40B4-BE49-F238E27FC236}">
+                  <a16:creationId xmlns:a16="http://schemas.microsoft.com/office/drawing/2014/main" id="{BD3635FF-1759-BCD3-4BDE-9872483BD16E}"/>
+                </a:ext>
+              </a:extLst>
+            </p:cNvPr>
+            <p:cNvSpPr txBox="1"/>
+            <p:nvPr/>
+          </p:nvSpPr>
+          <p:spPr>
+            <a:xfrm>
+              <a:off x="216658" y="2435795"/>
+              <a:ext cx="354330" cy="174236"/>
+            </a:xfrm>
+            <a:prstGeom prst="rect">
+              <a:avLst/>
+            </a:prstGeom>
+            <a:noFill/>
+          </p:spPr>
+          <p:txBody>
+            <a:bodyPr wrap="square" rtlCol="0">
+              <a:spAutoFit/>
+            </a:bodyPr>
+            <a:lstStyle/>
+            <a:p>
+              <a:r>
+                <a:rPr lang="de-DE" sz="800" dirty="0">
+                  <a:latin typeface="CMU Serif" panose="02000603000000000000" pitchFamily="2" charset="0"/>
+                  <a:ea typeface="CMU Serif" panose="02000603000000000000" pitchFamily="2" charset="0"/>
+                  <a:cs typeface="CMU Serif" panose="02000603000000000000" pitchFamily="2" charset="0"/>
+                </a:rPr>
+                <a:t>0,1</a:t>
+              </a:r>
+            </a:p>
+          </p:txBody>
+        </p:sp>
+      </p:grpSp>
+      <p:sp>
+        <p:nvSpPr>
+          <p:cNvPr id="69" name="Textfeld 68">
+            <a:extLst>
+              <a:ext uri="{FF2B5EF4-FFF2-40B4-BE49-F238E27FC236}">
+                <a16:creationId xmlns:a16="http://schemas.microsoft.com/office/drawing/2014/main" id="{8BA853AB-C2B3-7F34-9EE5-3C5403B4EC9A}"/>
+              </a:ext>
+            </a:extLst>
+          </p:cNvPr>
+          <p:cNvSpPr txBox="1"/>
+          <p:nvPr/>
+        </p:nvSpPr>
+        <p:spPr>
+          <a:xfrm>
+            <a:off x="2952079" y="2623097"/>
+            <a:ext cx="354568" cy="261610"/>
+          </a:xfrm>
+          <a:prstGeom prst="rect">
+            <a:avLst/>
+          </a:prstGeom>
+          <a:noFill/>
+        </p:spPr>
+        <p:txBody>
+          <a:bodyPr wrap="square" rtlCol="0">
+            <a:spAutoFit/>
+          </a:bodyPr>
+          <a:lstStyle/>
+          <a:p>
+            <a:pPr algn="ctr"/>
+            <a:r>
+              <a:rPr lang="de-DE" sz="1100" i="1" dirty="0">
+                <a:latin typeface="CMU Serif" panose="02000603000000000000" pitchFamily="2" charset="0"/>
+                <a:ea typeface="CMU Serif" panose="02000603000000000000" pitchFamily="2" charset="0"/>
+                <a:cs typeface="CMU Serif" panose="02000603000000000000" pitchFamily="2" charset="0"/>
+              </a:rPr>
+              <a:t>R</a:t>
+            </a:r>
+            <a:r>
+              <a:rPr lang="de-DE" sz="1100" baseline="-25000" dirty="0">
+                <a:latin typeface="CMU Serif" panose="02000603000000000000" pitchFamily="2" charset="0"/>
+                <a:ea typeface="CMU Serif" panose="02000603000000000000" pitchFamily="2" charset="0"/>
+                <a:cs typeface="CMU Serif" panose="02000603000000000000" pitchFamily="2" charset="0"/>
+              </a:rPr>
+              <a:t>S</a:t>
+            </a:r>
+          </a:p>
+        </p:txBody>
+      </p:sp>
+      <p:grpSp>
+        <p:nvGrpSpPr>
+          <p:cNvPr id="120" name="Gruppieren 119">
+            <a:extLst>
+              <a:ext uri="{FF2B5EF4-FFF2-40B4-BE49-F238E27FC236}">
+                <a16:creationId xmlns:a16="http://schemas.microsoft.com/office/drawing/2014/main" id="{4A63B04B-DD21-6246-5F14-98305C98ED8F}"/>
+              </a:ext>
+            </a:extLst>
+          </p:cNvPr>
+          <p:cNvGrpSpPr/>
+          <p:nvPr/>
+        </p:nvGrpSpPr>
+        <p:grpSpPr>
+          <a:xfrm>
+            <a:off x="698055" y="2920008"/>
+            <a:ext cx="2393759" cy="215444"/>
+            <a:chOff x="698055" y="2905720"/>
+            <a:chExt cx="2393759" cy="215444"/>
+          </a:xfrm>
+        </p:grpSpPr>
+        <p:sp>
+          <p:nvSpPr>
+            <p:cNvPr id="99" name="Textfeld 98">
+              <a:extLst>
+                <a:ext uri="{FF2B5EF4-FFF2-40B4-BE49-F238E27FC236}">
+                  <a16:creationId xmlns:a16="http://schemas.microsoft.com/office/drawing/2014/main" id="{26C97434-9210-1B68-9883-E96BAD751D39}"/>
+                </a:ext>
+              </a:extLst>
+            </p:cNvPr>
+            <p:cNvSpPr txBox="1"/>
+            <p:nvPr/>
+          </p:nvSpPr>
+          <p:spPr>
+            <a:xfrm>
+              <a:off x="2510879" y="2905720"/>
+              <a:ext cx="354330" cy="215444"/>
+            </a:xfrm>
+            <a:prstGeom prst="rect">
+              <a:avLst/>
+            </a:prstGeom>
+            <a:noFill/>
+          </p:spPr>
+          <p:txBody>
+            <a:bodyPr wrap="square" rtlCol="0">
+              <a:spAutoFit/>
+            </a:bodyPr>
+            <a:lstStyle/>
+            <a:p>
+              <a:pPr algn="ctr"/>
+              <a:r>
+                <a:rPr lang="de-DE" sz="800" dirty="0">
+                  <a:latin typeface="CMU Serif" panose="02000603000000000000" pitchFamily="2" charset="0"/>
+                  <a:ea typeface="CMU Serif" panose="02000603000000000000" pitchFamily="2" charset="0"/>
+                  <a:cs typeface="CMU Serif" panose="02000603000000000000" pitchFamily="2" charset="0"/>
+                </a:rPr>
+                <a:t>0,9</a:t>
+              </a:r>
+            </a:p>
+          </p:txBody>
+        </p:sp>
+        <p:sp>
+          <p:nvSpPr>
+            <p:cNvPr id="101" name="Textfeld 100">
+              <a:extLst>
+                <a:ext uri="{FF2B5EF4-FFF2-40B4-BE49-F238E27FC236}">
+                  <a16:creationId xmlns:a16="http://schemas.microsoft.com/office/drawing/2014/main" id="{2354630D-2D4B-C054-FA54-043369C4436C}"/>
+                </a:ext>
+              </a:extLst>
+            </p:cNvPr>
+            <p:cNvSpPr txBox="1"/>
+            <p:nvPr/>
+          </p:nvSpPr>
+          <p:spPr>
+            <a:xfrm>
+              <a:off x="2737484" y="2905720"/>
+              <a:ext cx="354330" cy="215444"/>
+            </a:xfrm>
+            <a:prstGeom prst="rect">
+              <a:avLst/>
+            </a:prstGeom>
+            <a:noFill/>
+          </p:spPr>
+          <p:txBody>
+            <a:bodyPr wrap="square" rtlCol="0">
+              <a:spAutoFit/>
+            </a:bodyPr>
+            <a:lstStyle/>
+            <a:p>
+              <a:pPr algn="ctr"/>
+              <a:r>
+                <a:rPr lang="de-DE" sz="800" dirty="0">
+                  <a:latin typeface="CMU Serif" panose="02000603000000000000" pitchFamily="2" charset="0"/>
+                  <a:ea typeface="CMU Serif" panose="02000603000000000000" pitchFamily="2" charset="0"/>
+                  <a:cs typeface="CMU Serif" panose="02000603000000000000" pitchFamily="2" charset="0"/>
+                </a:rPr>
+                <a:t>1,0</a:t>
+              </a:r>
+            </a:p>
+          </p:txBody>
+        </p:sp>
+        <p:sp>
+          <p:nvSpPr>
+            <p:cNvPr id="103" name="Textfeld 102">
+              <a:extLst>
+                <a:ext uri="{FF2B5EF4-FFF2-40B4-BE49-F238E27FC236}">
+                  <a16:creationId xmlns:a16="http://schemas.microsoft.com/office/drawing/2014/main" id="{60EEC255-3E5E-B4DE-61E3-0F520EA5D293}"/>
+                </a:ext>
+              </a:extLst>
+            </p:cNvPr>
+            <p:cNvSpPr txBox="1"/>
+            <p:nvPr/>
+          </p:nvSpPr>
+          <p:spPr>
+            <a:xfrm>
+              <a:off x="2284276" y="2905720"/>
+              <a:ext cx="354330" cy="215444"/>
+            </a:xfrm>
+            <a:prstGeom prst="rect">
+              <a:avLst/>
+            </a:prstGeom>
+            <a:noFill/>
+          </p:spPr>
+          <p:txBody>
+            <a:bodyPr wrap="square" rtlCol="0">
+              <a:spAutoFit/>
+            </a:bodyPr>
+            <a:lstStyle/>
+            <a:p>
+              <a:pPr algn="ctr"/>
+              <a:r>
+                <a:rPr lang="de-DE" sz="800" dirty="0">
+                  <a:latin typeface="CMU Serif" panose="02000603000000000000" pitchFamily="2" charset="0"/>
+                  <a:ea typeface="CMU Serif" panose="02000603000000000000" pitchFamily="2" charset="0"/>
+                  <a:cs typeface="CMU Serif" panose="02000603000000000000" pitchFamily="2" charset="0"/>
+                </a:rPr>
+                <a:t>0,8</a:t>
+              </a:r>
+            </a:p>
+          </p:txBody>
+        </p:sp>
+        <p:sp>
+          <p:nvSpPr>
+            <p:cNvPr id="105" name="Textfeld 104">
+              <a:extLst>
+                <a:ext uri="{FF2B5EF4-FFF2-40B4-BE49-F238E27FC236}">
+                  <a16:creationId xmlns:a16="http://schemas.microsoft.com/office/drawing/2014/main" id="{29E867F7-E498-4B0F-722C-7DA8E93A0873}"/>
+                </a:ext>
+              </a:extLst>
+            </p:cNvPr>
+            <p:cNvSpPr txBox="1"/>
+            <p:nvPr/>
+          </p:nvSpPr>
+          <p:spPr>
+            <a:xfrm>
+              <a:off x="2057673" y="2905720"/>
+              <a:ext cx="354330" cy="215444"/>
+            </a:xfrm>
+            <a:prstGeom prst="rect">
+              <a:avLst/>
+            </a:prstGeom>
+            <a:noFill/>
+          </p:spPr>
+          <p:txBody>
+            <a:bodyPr wrap="square" rtlCol="0">
+              <a:spAutoFit/>
+            </a:bodyPr>
+            <a:lstStyle/>
+            <a:p>
+              <a:pPr algn="ctr"/>
+              <a:r>
+                <a:rPr lang="de-DE" sz="800" dirty="0">
+                  <a:latin typeface="CMU Serif" panose="02000603000000000000" pitchFamily="2" charset="0"/>
+                  <a:ea typeface="CMU Serif" panose="02000603000000000000" pitchFamily="2" charset="0"/>
+                  <a:cs typeface="CMU Serif" panose="02000603000000000000" pitchFamily="2" charset="0"/>
+                </a:rPr>
+                <a:t>0,7</a:t>
+              </a:r>
+            </a:p>
+          </p:txBody>
+        </p:sp>
+        <p:sp>
+          <p:nvSpPr>
+            <p:cNvPr id="107" name="Textfeld 106">
+              <a:extLst>
+                <a:ext uri="{FF2B5EF4-FFF2-40B4-BE49-F238E27FC236}">
+                  <a16:creationId xmlns:a16="http://schemas.microsoft.com/office/drawing/2014/main" id="{99A3FFB7-914B-166E-0F42-439D22C232D8}"/>
+                </a:ext>
+              </a:extLst>
+            </p:cNvPr>
+            <p:cNvSpPr txBox="1"/>
+            <p:nvPr/>
+          </p:nvSpPr>
+          <p:spPr>
+            <a:xfrm>
+              <a:off x="1831070" y="2905720"/>
+              <a:ext cx="354330" cy="215444"/>
+            </a:xfrm>
+            <a:prstGeom prst="rect">
+              <a:avLst/>
+            </a:prstGeom>
+            <a:noFill/>
+          </p:spPr>
+          <p:txBody>
+            <a:bodyPr wrap="square" rtlCol="0">
+              <a:spAutoFit/>
+            </a:bodyPr>
+            <a:lstStyle/>
+            <a:p>
+              <a:pPr algn="ctr"/>
+              <a:r>
+                <a:rPr lang="de-DE" sz="800" dirty="0">
+                  <a:latin typeface="CMU Serif" panose="02000603000000000000" pitchFamily="2" charset="0"/>
+                  <a:ea typeface="CMU Serif" panose="02000603000000000000" pitchFamily="2" charset="0"/>
+                  <a:cs typeface="CMU Serif" panose="02000603000000000000" pitchFamily="2" charset="0"/>
+                </a:rPr>
+                <a:t>0,6</a:t>
+              </a:r>
+            </a:p>
+          </p:txBody>
+        </p:sp>
+        <p:sp>
+          <p:nvSpPr>
+            <p:cNvPr id="109" name="Textfeld 108">
+              <a:extLst>
+                <a:ext uri="{FF2B5EF4-FFF2-40B4-BE49-F238E27FC236}">
+                  <a16:creationId xmlns:a16="http://schemas.microsoft.com/office/drawing/2014/main" id="{103FAADD-82A7-3579-32AE-83549043D3D2}"/>
+                </a:ext>
+              </a:extLst>
+            </p:cNvPr>
+            <p:cNvSpPr txBox="1"/>
+            <p:nvPr/>
+          </p:nvSpPr>
+          <p:spPr>
+            <a:xfrm>
+              <a:off x="1604467" y="2905720"/>
+              <a:ext cx="354330" cy="215444"/>
+            </a:xfrm>
+            <a:prstGeom prst="rect">
+              <a:avLst/>
+            </a:prstGeom>
+            <a:noFill/>
+          </p:spPr>
+          <p:txBody>
+            <a:bodyPr wrap="square" rtlCol="0">
+              <a:spAutoFit/>
+            </a:bodyPr>
+            <a:lstStyle/>
+            <a:p>
+              <a:pPr algn="ctr"/>
+              <a:r>
+                <a:rPr lang="de-DE" sz="800" dirty="0">
+                  <a:latin typeface="CMU Serif" panose="02000603000000000000" pitchFamily="2" charset="0"/>
+                  <a:ea typeface="CMU Serif" panose="02000603000000000000" pitchFamily="2" charset="0"/>
+                  <a:cs typeface="CMU Serif" panose="02000603000000000000" pitchFamily="2" charset="0"/>
+                </a:rPr>
+                <a:t>0,5</a:t>
+              </a:r>
+            </a:p>
+          </p:txBody>
+        </p:sp>
+        <p:sp>
+          <p:nvSpPr>
+            <p:cNvPr id="111" name="Textfeld 110">
+              <a:extLst>
+                <a:ext uri="{FF2B5EF4-FFF2-40B4-BE49-F238E27FC236}">
+                  <a16:creationId xmlns:a16="http://schemas.microsoft.com/office/drawing/2014/main" id="{D934AF38-83F4-D9D7-4863-977E20B4F7A5}"/>
+                </a:ext>
+              </a:extLst>
+            </p:cNvPr>
+            <p:cNvSpPr txBox="1"/>
+            <p:nvPr/>
+          </p:nvSpPr>
+          <p:spPr>
+            <a:xfrm>
+              <a:off x="1377864" y="2905720"/>
+              <a:ext cx="354330" cy="215444"/>
+            </a:xfrm>
+            <a:prstGeom prst="rect">
+              <a:avLst/>
+            </a:prstGeom>
+            <a:noFill/>
+          </p:spPr>
+          <p:txBody>
+            <a:bodyPr wrap="square" rtlCol="0">
+              <a:spAutoFit/>
+            </a:bodyPr>
+            <a:lstStyle/>
+            <a:p>
+              <a:pPr algn="ctr"/>
+              <a:r>
+                <a:rPr lang="de-DE" sz="800" dirty="0">
+                  <a:latin typeface="CMU Serif" panose="02000603000000000000" pitchFamily="2" charset="0"/>
+                  <a:ea typeface="CMU Serif" panose="02000603000000000000" pitchFamily="2" charset="0"/>
+                  <a:cs typeface="CMU Serif" panose="02000603000000000000" pitchFamily="2" charset="0"/>
+                </a:rPr>
+                <a:t>0,4</a:t>
+              </a:r>
+            </a:p>
+          </p:txBody>
+        </p:sp>
+        <p:sp>
+          <p:nvSpPr>
+            <p:cNvPr id="113" name="Textfeld 112">
+              <a:extLst>
+                <a:ext uri="{FF2B5EF4-FFF2-40B4-BE49-F238E27FC236}">
+                  <a16:creationId xmlns:a16="http://schemas.microsoft.com/office/drawing/2014/main" id="{F04F32E2-BA83-3F72-E059-9CA3A7E185F4}"/>
+                </a:ext>
+              </a:extLst>
+            </p:cNvPr>
+            <p:cNvSpPr txBox="1"/>
+            <p:nvPr/>
+          </p:nvSpPr>
+          <p:spPr>
+            <a:xfrm>
+              <a:off x="1151261" y="2905720"/>
+              <a:ext cx="354330" cy="215444"/>
+            </a:xfrm>
+            <a:prstGeom prst="rect">
+              <a:avLst/>
+            </a:prstGeom>
+            <a:noFill/>
+          </p:spPr>
+          <p:txBody>
+            <a:bodyPr wrap="square" rtlCol="0">
+              <a:spAutoFit/>
+            </a:bodyPr>
+            <a:lstStyle/>
+            <a:p>
+              <a:pPr algn="ctr"/>
+              <a:r>
+                <a:rPr lang="de-DE" sz="800" dirty="0">
+                  <a:latin typeface="CMU Serif" panose="02000603000000000000" pitchFamily="2" charset="0"/>
+                  <a:ea typeface="CMU Serif" panose="02000603000000000000" pitchFamily="2" charset="0"/>
+                  <a:cs typeface="CMU Serif" panose="02000603000000000000" pitchFamily="2" charset="0"/>
+                </a:rPr>
+                <a:t>0,3</a:t>
+              </a:r>
+            </a:p>
+          </p:txBody>
+        </p:sp>
+        <p:sp>
+          <p:nvSpPr>
+            <p:cNvPr id="115" name="Textfeld 114">
+              <a:extLst>
+                <a:ext uri="{FF2B5EF4-FFF2-40B4-BE49-F238E27FC236}">
+                  <a16:creationId xmlns:a16="http://schemas.microsoft.com/office/drawing/2014/main" id="{B6A61A5B-1E53-6729-F362-F72198FCDC3A}"/>
+                </a:ext>
+              </a:extLst>
+            </p:cNvPr>
+            <p:cNvSpPr txBox="1"/>
+            <p:nvPr/>
+          </p:nvSpPr>
+          <p:spPr>
+            <a:xfrm>
+              <a:off x="924658" y="2905720"/>
+              <a:ext cx="354330" cy="215444"/>
+            </a:xfrm>
+            <a:prstGeom prst="rect">
+              <a:avLst/>
+            </a:prstGeom>
+            <a:noFill/>
+          </p:spPr>
+          <p:txBody>
+            <a:bodyPr wrap="square" rtlCol="0">
+              <a:spAutoFit/>
+            </a:bodyPr>
+            <a:lstStyle/>
+            <a:p>
+              <a:pPr algn="ctr"/>
+              <a:r>
+                <a:rPr lang="de-DE" sz="800" dirty="0">
+                  <a:latin typeface="CMU Serif" panose="02000603000000000000" pitchFamily="2" charset="0"/>
+                  <a:ea typeface="CMU Serif" panose="02000603000000000000" pitchFamily="2" charset="0"/>
+                  <a:cs typeface="CMU Serif" panose="02000603000000000000" pitchFamily="2" charset="0"/>
+                </a:rPr>
+                <a:t>0,2</a:t>
+              </a:r>
+            </a:p>
+          </p:txBody>
+        </p:sp>
+        <p:sp>
+          <p:nvSpPr>
+            <p:cNvPr id="117" name="Textfeld 116">
+              <a:extLst>
+                <a:ext uri="{FF2B5EF4-FFF2-40B4-BE49-F238E27FC236}">
+                  <a16:creationId xmlns:a16="http://schemas.microsoft.com/office/drawing/2014/main" id="{D491DCCD-E61C-D3F1-F37A-3316F2D9D95C}"/>
+                </a:ext>
+              </a:extLst>
+            </p:cNvPr>
+            <p:cNvSpPr txBox="1"/>
+            <p:nvPr/>
+          </p:nvSpPr>
+          <p:spPr>
+            <a:xfrm>
+              <a:off x="698055" y="2905720"/>
+              <a:ext cx="354330" cy="215444"/>
+            </a:xfrm>
+            <a:prstGeom prst="rect">
+              <a:avLst/>
+            </a:prstGeom>
+            <a:noFill/>
+          </p:spPr>
+          <p:txBody>
+            <a:bodyPr wrap="square" rtlCol="0">
+              <a:spAutoFit/>
+            </a:bodyPr>
+            <a:lstStyle/>
+            <a:p>
+              <a:pPr algn="ctr"/>
+              <a:r>
+                <a:rPr lang="de-DE" sz="800" dirty="0">
+                  <a:latin typeface="CMU Serif" panose="02000603000000000000" pitchFamily="2" charset="0"/>
+                  <a:ea typeface="CMU Serif" panose="02000603000000000000" pitchFamily="2" charset="0"/>
+                  <a:cs typeface="CMU Serif" panose="02000603000000000000" pitchFamily="2" charset="0"/>
+                </a:rPr>
+                <a:t>0,1</a:t>
+              </a:r>
+            </a:p>
+          </p:txBody>
+        </p:sp>
+      </p:grpSp>
+      <p:sp>
+        <p:nvSpPr>
+          <p:cNvPr id="6" name="Textfeld 5">
+            <a:extLst>
+              <a:ext uri="{FF2B5EF4-FFF2-40B4-BE49-F238E27FC236}">
+                <a16:creationId xmlns:a16="http://schemas.microsoft.com/office/drawing/2014/main" id="{72E6B809-446A-CE98-E0F3-1943AF237875}"/>
+              </a:ext>
+            </a:extLst>
+          </p:cNvPr>
+          <p:cNvSpPr txBox="1"/>
+          <p:nvPr/>
+        </p:nvSpPr>
+        <p:spPr>
+          <a:xfrm>
+            <a:off x="1505591" y="1784070"/>
+            <a:ext cx="354568" cy="261610"/>
+          </a:xfrm>
+          <a:prstGeom prst="rect">
+            <a:avLst/>
+          </a:prstGeom>
+          <a:noFill/>
+        </p:spPr>
+        <p:txBody>
+          <a:bodyPr wrap="square" rtlCol="0">
+            <a:spAutoFit/>
+          </a:bodyPr>
+          <a:lstStyle/>
+          <a:p>
+            <a:pPr algn="ctr"/>
+            <a:r>
+              <a:rPr lang="de-DE" sz="1100" dirty="0">
+                <a:solidFill>
+                  <a:srgbClr val="FF0000"/>
+                </a:solidFill>
+                <a:latin typeface="CMU Serif" panose="02000603000000000000" pitchFamily="2" charset="0"/>
+                <a:ea typeface="CMU Serif" panose="02000603000000000000" pitchFamily="2" charset="0"/>
+                <a:cs typeface="CMU Serif" panose="02000603000000000000" pitchFamily="2" charset="0"/>
+              </a:rPr>
+              <a:t>D</a:t>
+            </a:r>
+          </a:p>
+        </p:txBody>
+      </p:sp>
+      <p:cxnSp>
+        <p:nvCxnSpPr>
+          <p:cNvPr id="13" name="Gerader Verbinder 12">
+            <a:extLst>
+              <a:ext uri="{FF2B5EF4-FFF2-40B4-BE49-F238E27FC236}">
+                <a16:creationId xmlns:a16="http://schemas.microsoft.com/office/drawing/2014/main" id="{7482129F-05D5-94C3-8B79-70156BF0E0AE}"/>
+              </a:ext>
+            </a:extLst>
+          </p:cNvPr>
+          <p:cNvCxnSpPr>
+            <a:cxnSpLocks/>
+          </p:cNvCxnSpPr>
+          <p:nvPr/>
+        </p:nvCxnSpPr>
+        <p:spPr>
+          <a:xfrm>
+            <a:off x="645795" y="718185"/>
+            <a:ext cx="2266950" cy="2171700"/>
+          </a:xfrm>
+          <a:prstGeom prst="line">
+            <a:avLst/>
+          </a:prstGeom>
+          <a:ln cap="rnd">
+            <a:solidFill>
+              <a:srgbClr val="FF0000"/>
+            </a:solidFill>
+            <a:round/>
+          </a:ln>
+        </p:spPr>
+        <p:style>
+          <a:lnRef idx="2">
+            <a:schemeClr val="accent1"/>
+          </a:lnRef>
+          <a:fillRef idx="0">
+            <a:schemeClr val="accent1"/>
+          </a:fillRef>
+          <a:effectRef idx="1">
+            <a:schemeClr val="accent1"/>
+          </a:effectRef>
+          <a:fontRef idx="minor">
+            <a:schemeClr val="tx1"/>
+          </a:fontRef>
+        </p:style>
+      </p:cxnSp>
+      <p:sp>
+        <p:nvSpPr>
+          <p:cNvPr id="14" name="Freihandform: Form 13">
+            <a:extLst>
+              <a:ext uri="{FF2B5EF4-FFF2-40B4-BE49-F238E27FC236}">
+                <a16:creationId xmlns:a16="http://schemas.microsoft.com/office/drawing/2014/main" id="{C57A8FAE-00B5-0A29-B677-54FA2BB57A62}"/>
+              </a:ext>
+            </a:extLst>
+          </p:cNvPr>
+          <p:cNvSpPr/>
+          <p:nvPr/>
+        </p:nvSpPr>
+        <p:spPr>
+          <a:xfrm>
+            <a:off x="642620" y="711200"/>
+            <a:ext cx="2273300" cy="2176780"/>
+          </a:xfrm>
+          <a:custGeom>
+            <a:avLst/>
+            <a:gdLst>
+              <a:gd name="csX0" fmla="*/ 0 w 2273300"/>
+              <a:gd name="csY0" fmla="*/ 0 h 2176780"/>
+              <a:gd name="csX1" fmla="*/ 1046480 w 2273300"/>
+              <a:gd name="csY1" fmla="*/ 264160 h 2176780"/>
+              <a:gd name="csX2" fmla="*/ 1849120 w 2273300"/>
+              <a:gd name="csY2" fmla="*/ 937260 h 2176780"/>
+              <a:gd name="csX3" fmla="*/ 2273300 w 2273300"/>
+              <a:gd name="csY3" fmla="*/ 2176780 h 2176780"/>
+            </a:gdLst>
+            <a:ahLst/>
+            <a:cxnLst>
+              <a:cxn ang="0">
+                <a:pos x="csX0" y="csY0"/>
+              </a:cxn>
+              <a:cxn ang="0">
+                <a:pos x="csX1" y="csY1"/>
+              </a:cxn>
+              <a:cxn ang="0">
+                <a:pos x="csX2" y="csY2"/>
+              </a:cxn>
+              <a:cxn ang="0">
+                <a:pos x="csX3" y="csY3"/>
+              </a:cxn>
+            </a:cxnLst>
+            <a:rect l="l" t="t" r="r" b="b"/>
+            <a:pathLst>
+              <a:path w="2273300" h="2176780">
+                <a:moveTo>
+                  <a:pt x="0" y="0"/>
+                </a:moveTo>
+                <a:cubicBezTo>
+                  <a:pt x="407246" y="48471"/>
+                  <a:pt x="763693" y="120650"/>
+                  <a:pt x="1046480" y="264160"/>
+                </a:cubicBezTo>
+                <a:cubicBezTo>
+                  <a:pt x="1354590" y="420521"/>
+                  <a:pt x="1628100" y="608715"/>
+                  <a:pt x="1849120" y="937260"/>
+                </a:cubicBezTo>
+                <a:cubicBezTo>
+                  <a:pt x="2025644" y="1199663"/>
+                  <a:pt x="2219325" y="1624965"/>
+                  <a:pt x="2273300" y="2176780"/>
+                </a:cubicBezTo>
+              </a:path>
+            </a:pathLst>
+          </a:custGeom>
+          <a:noFill/>
+          <a:ln>
+            <a:solidFill>
+              <a:srgbClr val="FF9F2B"/>
+            </a:solidFill>
+          </a:ln>
+        </p:spPr>
+        <p:style>
+          <a:lnRef idx="2">
+            <a:schemeClr val="accent1">
+              <a:shade val="15000"/>
+            </a:schemeClr>
+          </a:lnRef>
+          <a:fillRef idx="1">
+            <a:schemeClr val="accent1"/>
+          </a:fillRef>
+          <a:effectRef idx="0">
+            <a:schemeClr val="accent1"/>
+          </a:effectRef>
+          <a:fontRef idx="minor">
+            <a:schemeClr val="lt1"/>
+          </a:fontRef>
+        </p:style>
+        <p:txBody>
+          <a:bodyPr rtlCol="0" anchor="ctr"/>
+          <a:lstStyle/>
+          <a:p>
+            <a:pPr algn="ctr"/>
+            <a:endParaRPr lang="de-DE"/>
+          </a:p>
+        </p:txBody>
+      </p:sp>
+      <p:sp>
+        <p:nvSpPr>
+          <p:cNvPr id="16" name="Textfeld 15">
+            <a:extLst>
+              <a:ext uri="{FF2B5EF4-FFF2-40B4-BE49-F238E27FC236}">
+                <a16:creationId xmlns:a16="http://schemas.microsoft.com/office/drawing/2014/main" id="{DBEADE45-B719-252E-6D71-016E70D7EF6D}"/>
+              </a:ext>
+            </a:extLst>
+          </p:cNvPr>
+          <p:cNvSpPr txBox="1"/>
+          <p:nvPr/>
+        </p:nvSpPr>
+        <p:spPr>
+          <a:xfrm>
+            <a:off x="1969795" y="1336331"/>
+            <a:ext cx="354568" cy="261610"/>
+          </a:xfrm>
+          <a:prstGeom prst="rect">
+            <a:avLst/>
+          </a:prstGeom>
+          <a:noFill/>
+        </p:spPr>
+        <p:txBody>
+          <a:bodyPr wrap="square" rtlCol="0">
+            <a:spAutoFit/>
+          </a:bodyPr>
+          <a:lstStyle/>
+          <a:p>
+            <a:pPr algn="ctr"/>
+            <a:r>
+              <a:rPr lang="de-DE" sz="1100" dirty="0">
+                <a:solidFill>
+                  <a:srgbClr val="FF9F2B"/>
+                </a:solidFill>
+                <a:latin typeface="CMU Serif" panose="02000603000000000000" pitchFamily="2" charset="0"/>
+                <a:ea typeface="CMU Serif" panose="02000603000000000000" pitchFamily="2" charset="0"/>
+                <a:cs typeface="CMU Serif" panose="02000603000000000000" pitchFamily="2" charset="0"/>
+              </a:rPr>
+              <a:t>C</a:t>
+            </a:r>
+          </a:p>
+        </p:txBody>
+      </p:sp>
+      <p:sp>
+        <p:nvSpPr>
+          <p:cNvPr id="21" name="Freihandform: Form 20">
+            <a:extLst>
+              <a:ext uri="{FF2B5EF4-FFF2-40B4-BE49-F238E27FC236}">
+                <a16:creationId xmlns:a16="http://schemas.microsoft.com/office/drawing/2014/main" id="{0B5CE30D-8536-146B-52C8-968BAF867D00}"/>
+              </a:ext>
+            </a:extLst>
+          </p:cNvPr>
+          <p:cNvSpPr/>
+          <p:nvPr/>
+        </p:nvSpPr>
+        <p:spPr>
+          <a:xfrm>
+            <a:off x="647700" y="714374"/>
+            <a:ext cx="2270760" cy="2176145"/>
+          </a:xfrm>
+          <a:custGeom>
+            <a:avLst/>
+            <a:gdLst>
+              <a:gd name="csX0" fmla="*/ 0 w 2270760"/>
+              <a:gd name="csY0" fmla="*/ 0 h 2181860"/>
+              <a:gd name="csX1" fmla="*/ 1206500 w 2270760"/>
+              <a:gd name="csY1" fmla="*/ 114300 h 2181860"/>
+              <a:gd name="csX2" fmla="*/ 1892300 w 2270760"/>
+              <a:gd name="csY2" fmla="*/ 891540 h 2181860"/>
+              <a:gd name="csX3" fmla="*/ 2270760 w 2270760"/>
+              <a:gd name="csY3" fmla="*/ 2181860 h 2181860"/>
+            </a:gdLst>
+            <a:ahLst/>
+            <a:cxnLst>
+              <a:cxn ang="0">
+                <a:pos x="csX0" y="csY0"/>
+              </a:cxn>
+              <a:cxn ang="0">
+                <a:pos x="csX1" y="csY1"/>
+              </a:cxn>
+              <a:cxn ang="0">
+                <a:pos x="csX2" y="csY2"/>
+              </a:cxn>
+              <a:cxn ang="0">
+                <a:pos x="csX3" y="csY3"/>
+              </a:cxn>
+            </a:cxnLst>
+            <a:rect l="l" t="t" r="r" b="b"/>
+            <a:pathLst>
+              <a:path w="2270760" h="2181860">
+                <a:moveTo>
+                  <a:pt x="0" y="0"/>
+                </a:moveTo>
+                <a:cubicBezTo>
+                  <a:pt x="491701" y="11430"/>
+                  <a:pt x="901277" y="8890"/>
+                  <a:pt x="1206500" y="114300"/>
+                </a:cubicBezTo>
+                <a:cubicBezTo>
+                  <a:pt x="1511723" y="219710"/>
+                  <a:pt x="1771227" y="556683"/>
+                  <a:pt x="1892300" y="891540"/>
+                </a:cubicBezTo>
+                <a:cubicBezTo>
+                  <a:pt x="2013373" y="1226397"/>
+                  <a:pt x="2148416" y="1674918"/>
+                  <a:pt x="2270760" y="2181860"/>
+                </a:cubicBezTo>
+              </a:path>
+            </a:pathLst>
+          </a:custGeom>
+          <a:noFill/>
+          <a:ln cap="rnd">
+            <a:solidFill>
+              <a:srgbClr val="129F57"/>
+            </a:solidFill>
+            <a:round/>
+          </a:ln>
+        </p:spPr>
+        <p:style>
+          <a:lnRef idx="2">
+            <a:schemeClr val="accent1">
+              <a:shade val="15000"/>
+            </a:schemeClr>
+          </a:lnRef>
+          <a:fillRef idx="1">
+            <a:schemeClr val="accent1"/>
+          </a:fillRef>
+          <a:effectRef idx="0">
+            <a:schemeClr val="accent1"/>
+          </a:effectRef>
+          <a:fontRef idx="minor">
+            <a:schemeClr val="lt1"/>
+          </a:fontRef>
+        </p:style>
+        <p:txBody>
+          <a:bodyPr rtlCol="0" anchor="ctr"/>
+          <a:lstStyle/>
+          <a:p>
+            <a:pPr algn="ctr"/>
+            <a:endParaRPr lang="de-DE"/>
+          </a:p>
+        </p:txBody>
+      </p:sp>
+      <p:sp>
+        <p:nvSpPr>
+          <p:cNvPr id="22" name="Freihandform: Form 21">
+            <a:extLst>
+              <a:ext uri="{FF2B5EF4-FFF2-40B4-BE49-F238E27FC236}">
+                <a16:creationId xmlns:a16="http://schemas.microsoft.com/office/drawing/2014/main" id="{1A0034CB-E2AB-6700-C959-E2AC3ED8D16F}"/>
+              </a:ext>
+            </a:extLst>
+          </p:cNvPr>
+          <p:cNvSpPr/>
+          <p:nvPr/>
+        </p:nvSpPr>
+        <p:spPr>
+          <a:xfrm>
+            <a:off x="647700" y="712470"/>
+            <a:ext cx="2268855" cy="2172970"/>
+          </a:xfrm>
+          <a:custGeom>
+            <a:avLst/>
+            <a:gdLst>
+              <a:gd name="csX0" fmla="*/ 0 w 2275840"/>
+              <a:gd name="csY0" fmla="*/ 0 h 2179320"/>
+              <a:gd name="csX1" fmla="*/ 1475740 w 2275840"/>
+              <a:gd name="csY1" fmla="*/ 63500 h 2179320"/>
+              <a:gd name="csX2" fmla="*/ 1973580 w 2275840"/>
+              <a:gd name="csY2" fmla="*/ 571500 h 2179320"/>
+              <a:gd name="csX3" fmla="*/ 2148840 w 2275840"/>
+              <a:gd name="csY3" fmla="*/ 1252220 h 2179320"/>
+              <a:gd name="csX4" fmla="*/ 2275840 w 2275840"/>
+              <a:gd name="csY4" fmla="*/ 2179320 h 2179320"/>
+            </a:gdLst>
+            <a:ahLst/>
+            <a:cxnLst>
+              <a:cxn ang="0">
+                <a:pos x="csX0" y="csY0"/>
+              </a:cxn>
+              <a:cxn ang="0">
+                <a:pos x="csX1" y="csY1"/>
+              </a:cxn>
+              <a:cxn ang="0">
+                <a:pos x="csX2" y="csY2"/>
+              </a:cxn>
+              <a:cxn ang="0">
+                <a:pos x="csX3" y="csY3"/>
+              </a:cxn>
+              <a:cxn ang="0">
+                <a:pos x="csX4" y="csY4"/>
+              </a:cxn>
+            </a:cxnLst>
+            <a:rect l="l" t="t" r="r" b="b"/>
+            <a:pathLst>
+              <a:path w="2275840" h="2179320">
+                <a:moveTo>
+                  <a:pt x="0" y="0"/>
+                </a:moveTo>
+                <a:cubicBezTo>
+                  <a:pt x="352319" y="7302"/>
+                  <a:pt x="1195070" y="8890"/>
+                  <a:pt x="1475740" y="63500"/>
+                </a:cubicBezTo>
+                <a:cubicBezTo>
+                  <a:pt x="1756410" y="118110"/>
+                  <a:pt x="1909657" y="381000"/>
+                  <a:pt x="1973580" y="571500"/>
+                </a:cubicBezTo>
+                <a:cubicBezTo>
+                  <a:pt x="2037503" y="762000"/>
+                  <a:pt x="2092113" y="965623"/>
+                  <a:pt x="2148840" y="1252220"/>
+                </a:cubicBezTo>
+                <a:cubicBezTo>
+                  <a:pt x="2205567" y="1538817"/>
+                  <a:pt x="2240703" y="1859068"/>
+                  <a:pt x="2275840" y="2179320"/>
+                </a:cubicBezTo>
+              </a:path>
+            </a:pathLst>
+          </a:custGeom>
+          <a:noFill/>
+          <a:ln cap="rnd">
+            <a:solidFill>
+              <a:srgbClr val="086FBD"/>
+            </a:solidFill>
+            <a:round/>
+          </a:ln>
+        </p:spPr>
+        <p:style>
+          <a:lnRef idx="2">
+            <a:schemeClr val="accent1">
+              <a:shade val="15000"/>
+            </a:schemeClr>
+          </a:lnRef>
+          <a:fillRef idx="1">
+            <a:schemeClr val="accent1"/>
+          </a:fillRef>
+          <a:effectRef idx="0">
+            <a:schemeClr val="accent1"/>
+          </a:effectRef>
+          <a:fontRef idx="minor">
+            <a:schemeClr val="lt1"/>
+          </a:fontRef>
+        </p:style>
+        <p:txBody>
+          <a:bodyPr rtlCol="0" anchor="ctr"/>
+          <a:lstStyle/>
+          <a:p>
+            <a:pPr algn="ctr"/>
+            <a:endParaRPr lang="de-DE"/>
+          </a:p>
+        </p:txBody>
+      </p:sp>
+      <p:cxnSp>
+        <p:nvCxnSpPr>
+          <p:cNvPr id="64" name="Gerade Verbindung mit Pfeil 63">
+            <a:extLst>
+              <a:ext uri="{FF2B5EF4-FFF2-40B4-BE49-F238E27FC236}">
+                <a16:creationId xmlns:a16="http://schemas.microsoft.com/office/drawing/2014/main" id="{B7894202-536E-567A-1130-F08889F19065}"/>
+              </a:ext>
+            </a:extLst>
+          </p:cNvPr>
+          <p:cNvCxnSpPr>
+            <a:cxnSpLocks/>
+          </p:cNvCxnSpPr>
+          <p:nvPr/>
+        </p:nvCxnSpPr>
+        <p:spPr>
+          <a:xfrm flipV="1">
+            <a:off x="644798" y="557213"/>
+            <a:ext cx="0" cy="2328862"/>
+          </a:xfrm>
+          <a:prstGeom prst="straightConnector1">
+            <a:avLst/>
+          </a:prstGeom>
+          <a:ln cap="rnd">
+            <a:solidFill>
+              <a:schemeClr val="tx1"/>
+            </a:solidFill>
+            <a:round/>
+            <a:tailEnd type="triangle"/>
+          </a:ln>
+        </p:spPr>
+        <p:style>
+          <a:lnRef idx="2">
+            <a:schemeClr val="accent1"/>
+          </a:lnRef>
+          <a:fillRef idx="0">
+            <a:schemeClr val="accent1"/>
+          </a:fillRef>
+          <a:effectRef idx="1">
+            <a:schemeClr val="accent1"/>
+          </a:effectRef>
+          <a:fontRef idx="minor">
+            <a:schemeClr val="tx1"/>
+          </a:fontRef>
+        </p:style>
+      </p:cxnSp>
+      <p:cxnSp>
+        <p:nvCxnSpPr>
+          <p:cNvPr id="65" name="Gerade Verbindung mit Pfeil 64">
+            <a:extLst>
+              <a:ext uri="{FF2B5EF4-FFF2-40B4-BE49-F238E27FC236}">
+                <a16:creationId xmlns:a16="http://schemas.microsoft.com/office/drawing/2014/main" id="{54DE20E2-E7B9-FF79-79EA-6D59AC0FD46F}"/>
+              </a:ext>
+            </a:extLst>
+          </p:cNvPr>
+          <p:cNvCxnSpPr>
+            <a:cxnSpLocks/>
+          </p:cNvCxnSpPr>
+          <p:nvPr/>
+        </p:nvCxnSpPr>
+        <p:spPr>
+          <a:xfrm>
+            <a:off x="644798" y="2889647"/>
+            <a:ext cx="2455590" cy="0"/>
+          </a:xfrm>
+          <a:prstGeom prst="straightConnector1">
+            <a:avLst/>
+          </a:prstGeom>
+          <a:ln cap="rnd">
+            <a:solidFill>
+              <a:schemeClr val="tx1"/>
+            </a:solidFill>
+            <a:round/>
+            <a:tailEnd type="triangle"/>
+          </a:ln>
+        </p:spPr>
+        <p:style>
+          <a:lnRef idx="2">
+            <a:schemeClr val="accent1"/>
+          </a:lnRef>
+          <a:fillRef idx="0">
+            <a:schemeClr val="accent1"/>
+          </a:fillRef>
+          <a:effectRef idx="1">
+            <a:schemeClr val="accent1"/>
+          </a:effectRef>
+          <a:fontRef idx="minor">
+            <a:schemeClr val="tx1"/>
+          </a:fontRef>
+        </p:style>
+      </p:cxnSp>
+      <p:sp>
+        <p:nvSpPr>
+          <p:cNvPr id="24" name="Textfeld 23">
+            <a:extLst>
+              <a:ext uri="{FF2B5EF4-FFF2-40B4-BE49-F238E27FC236}">
+                <a16:creationId xmlns:a16="http://schemas.microsoft.com/office/drawing/2014/main" id="{46AA74B7-EEE3-2869-83BA-232EE31D38D8}"/>
+              </a:ext>
+            </a:extLst>
+          </p:cNvPr>
+          <p:cNvSpPr txBox="1"/>
+          <p:nvPr/>
+        </p:nvSpPr>
+        <p:spPr>
+          <a:xfrm>
+            <a:off x="1892161" y="957290"/>
+            <a:ext cx="354568" cy="261610"/>
+          </a:xfrm>
+          <a:prstGeom prst="rect">
+            <a:avLst/>
+          </a:prstGeom>
+          <a:noFill/>
+        </p:spPr>
+        <p:txBody>
+          <a:bodyPr wrap="square" rtlCol="0">
+            <a:spAutoFit/>
+          </a:bodyPr>
+          <a:lstStyle/>
+          <a:p>
+            <a:pPr algn="ctr"/>
+            <a:r>
+              <a:rPr lang="de-DE" sz="1100" dirty="0">
+                <a:solidFill>
+                  <a:srgbClr val="129F57"/>
+                </a:solidFill>
+                <a:latin typeface="CMU Serif" panose="02000603000000000000" pitchFamily="2" charset="0"/>
+                <a:ea typeface="CMU Serif" panose="02000603000000000000" pitchFamily="2" charset="0"/>
+                <a:cs typeface="CMU Serif" panose="02000603000000000000" pitchFamily="2" charset="0"/>
+              </a:rPr>
+              <a:t>B</a:t>
+            </a:r>
+          </a:p>
+        </p:txBody>
+      </p:sp>
+      <p:sp>
+        <p:nvSpPr>
+          <p:cNvPr id="27" name="Textfeld 26">
+            <a:extLst>
+              <a:ext uri="{FF2B5EF4-FFF2-40B4-BE49-F238E27FC236}">
+                <a16:creationId xmlns:a16="http://schemas.microsoft.com/office/drawing/2014/main" id="{04AF0492-5495-FDDF-3238-0CEAEC6B5A8A}"/>
+              </a:ext>
+            </a:extLst>
+          </p:cNvPr>
+          <p:cNvSpPr txBox="1"/>
+          <p:nvPr/>
+        </p:nvSpPr>
+        <p:spPr>
+          <a:xfrm>
+            <a:off x="2355359" y="733965"/>
+            <a:ext cx="354568" cy="261610"/>
+          </a:xfrm>
+          <a:prstGeom prst="rect">
+            <a:avLst/>
+          </a:prstGeom>
+          <a:noFill/>
+        </p:spPr>
+        <p:txBody>
+          <a:bodyPr wrap="square" rtlCol="0">
+            <a:spAutoFit/>
+          </a:bodyPr>
+          <a:lstStyle/>
+          <a:p>
+            <a:pPr algn="ctr"/>
+            <a:r>
+              <a:rPr lang="de-DE" sz="1100" dirty="0">
+                <a:solidFill>
+                  <a:srgbClr val="086FBD"/>
+                </a:solidFill>
+                <a:latin typeface="CMU Serif" panose="02000603000000000000" pitchFamily="2" charset="0"/>
+                <a:ea typeface="CMU Serif" panose="02000603000000000000" pitchFamily="2" charset="0"/>
+                <a:cs typeface="CMU Serif" panose="02000603000000000000" pitchFamily="2" charset="0"/>
+              </a:rPr>
+              <a:t>A</a:t>
+            </a:r>
+          </a:p>
+        </p:txBody>
+      </p:sp>
+      <p:sp>
+        <p:nvSpPr>
+          <p:cNvPr id="32" name="Textfeld 31">
+            <a:extLst>
+              <a:ext uri="{FF2B5EF4-FFF2-40B4-BE49-F238E27FC236}">
+                <a16:creationId xmlns:a16="http://schemas.microsoft.com/office/drawing/2014/main" id="{F8515436-B1F4-56C8-74A6-807C231B60CB}"/>
+              </a:ext>
+            </a:extLst>
+          </p:cNvPr>
+          <p:cNvSpPr txBox="1"/>
+          <p:nvPr/>
+        </p:nvSpPr>
+        <p:spPr>
+          <a:xfrm>
+            <a:off x="471450" y="2920008"/>
+            <a:ext cx="354330" cy="215444"/>
+          </a:xfrm>
+          <a:prstGeom prst="rect">
+            <a:avLst/>
+          </a:prstGeom>
+          <a:noFill/>
+        </p:spPr>
+        <p:txBody>
+          <a:bodyPr wrap="square" rtlCol="0">
+            <a:spAutoFit/>
+          </a:bodyPr>
+          <a:lstStyle/>
+          <a:p>
+            <a:pPr algn="ctr"/>
+            <a:r>
+              <a:rPr lang="de-DE" sz="800" dirty="0">
+                <a:latin typeface="CMU Serif" panose="02000603000000000000" pitchFamily="2" charset="0"/>
+                <a:ea typeface="CMU Serif" panose="02000603000000000000" pitchFamily="2" charset="0"/>
+                <a:cs typeface="CMU Serif" panose="02000603000000000000" pitchFamily="2" charset="0"/>
+              </a:rPr>
+              <a:t>0,0</a:t>
+            </a:r>
+          </a:p>
+        </p:txBody>
+      </p:sp>
+      <p:sp>
+        <p:nvSpPr>
+          <p:cNvPr id="36" name="Textfeld 35">
+            <a:extLst>
+              <a:ext uri="{FF2B5EF4-FFF2-40B4-BE49-F238E27FC236}">
+                <a16:creationId xmlns:a16="http://schemas.microsoft.com/office/drawing/2014/main" id="{A627FA5D-DC75-4618-AC63-54455FEBFB4F}"/>
+              </a:ext>
+            </a:extLst>
+          </p:cNvPr>
+          <p:cNvSpPr txBox="1"/>
+          <p:nvPr/>
+        </p:nvSpPr>
+        <p:spPr>
+          <a:xfrm>
+            <a:off x="330821" y="2783342"/>
+            <a:ext cx="354330" cy="215444"/>
+          </a:xfrm>
+          <a:prstGeom prst="rect">
+            <a:avLst/>
+          </a:prstGeom>
+          <a:noFill/>
+        </p:spPr>
+        <p:txBody>
+          <a:bodyPr wrap="square" rtlCol="0">
+            <a:spAutoFit/>
+          </a:bodyPr>
+          <a:lstStyle/>
+          <a:p>
+            <a:pPr algn="ctr"/>
+            <a:r>
+              <a:rPr lang="de-DE" sz="800" dirty="0">
+                <a:latin typeface="CMU Serif" panose="02000603000000000000" pitchFamily="2" charset="0"/>
+                <a:ea typeface="CMU Serif" panose="02000603000000000000" pitchFamily="2" charset="0"/>
+                <a:cs typeface="CMU Serif" panose="02000603000000000000" pitchFamily="2" charset="0"/>
+              </a:rPr>
+              <a:t>0,0</a:t>
+            </a:r>
+          </a:p>
+        </p:txBody>
+      </p:sp>
+    </p:spTree>
+    <p:extLst>
+      <p:ext uri="{BB962C8B-B14F-4D97-AF65-F5344CB8AC3E}">
+        <p14:creationId xmlns:p14="http://schemas.microsoft.com/office/powerpoint/2010/main" val="772923145"/>
+      </p:ext>
+    </p:extLst>
+  </p:cSld>
+  <p:clrMapOvr>
+    <a:masterClrMapping/>
+  </p:clrMapOvr>
+</p:sld>
+</file>
+
+<file path=ppt/slides/slide8.xml><?xml version="1.0" encoding="utf-8"?>
+<p:sld xmlns:a="http://schemas.openxmlformats.org/drawingml/2006/main" xmlns:r="http://schemas.openxmlformats.org/officeDocument/2006/relationships" xmlns:p="http://schemas.openxmlformats.org/presentationml/2006/main">
+  <p:cSld>
+    <p:spTree>
+      <p:nvGrpSpPr>
+        <p:cNvPr id="1" name="">
+          <a:extLst>
+            <a:ext uri="{FF2B5EF4-FFF2-40B4-BE49-F238E27FC236}">
               <a16:creationId xmlns:a16="http://schemas.microsoft.com/office/drawing/2014/main" id="{E31B2FB2-E08E-97CB-B090-87F907B040CD}"/>
             </a:ext>
           </a:extLst>
@@ -14211,7 +17551,7 @@
 </p:sld>
 </file>
 
-<file path=ppt/slides/slide8.xml><?xml version="1.0" encoding="utf-8"?>
+<file path=ppt/slides/slide9.xml><?xml version="1.0" encoding="utf-8"?>
 <p:sld xmlns:a="http://schemas.openxmlformats.org/drawingml/2006/main" xmlns:r="http://schemas.openxmlformats.org/officeDocument/2006/relationships" xmlns:p="http://schemas.openxmlformats.org/presentationml/2006/main">
   <p:cSld>
     <p:spTree>

</xml_diff>

<commit_message>
continued work on chapter Schraubverbindungen in KE
</commit_message>
<xml_diff>
--- a/LaTeX B.Sc. LRT/Konstruktionslehre 1&2/images/KE-Images.pptx
+++ b/LaTeX B.Sc. LRT/Konstruktionslehre 1&2/images/KE-Images.pptx
@@ -14,7 +14,10 @@
     <p:sldId id="264" r:id="rId8"/>
     <p:sldId id="263" r:id="rId9"/>
     <p:sldId id="265" r:id="rId10"/>
-    <p:sldId id="262" r:id="rId11"/>
+    <p:sldId id="266" r:id="rId11"/>
+    <p:sldId id="268" r:id="rId12"/>
+    <p:sldId id="267" r:id="rId13"/>
+    <p:sldId id="262" r:id="rId14"/>
   </p:sldIdLst>
   <p:sldSz cx="3600450" cy="3600450"/>
   <p:notesSz cx="6858000" cy="9144000"/>
@@ -4113,6 +4116,1371 @@
         <p:cNvPr id="1" name="">
           <a:extLst>
             <a:ext uri="{FF2B5EF4-FFF2-40B4-BE49-F238E27FC236}">
+              <a16:creationId xmlns:a16="http://schemas.microsoft.com/office/drawing/2014/main" id="{B2875D4A-7296-5640-980D-8ED633D02E47}"/>
+            </a:ext>
+          </a:extLst>
+        </p:cNvPr>
+        <p:cNvGrpSpPr/>
+        <p:nvPr/>
+      </p:nvGrpSpPr>
+      <p:grpSpPr>
+        <a:xfrm>
+          <a:off x="0" y="0"/>
+          <a:ext cx="0" cy="0"/>
+          <a:chOff x="0" y="0"/>
+          <a:chExt cx="0" cy="0"/>
+        </a:xfrm>
+      </p:grpSpPr>
+      <p:grpSp>
+        <p:nvGrpSpPr>
+          <p:cNvPr id="48" name="Gruppieren 47">
+            <a:extLst>
+              <a:ext uri="{FF2B5EF4-FFF2-40B4-BE49-F238E27FC236}">
+                <a16:creationId xmlns:a16="http://schemas.microsoft.com/office/drawing/2014/main" id="{4427904A-2012-DC85-4434-A9E5CCD0E682}"/>
+              </a:ext>
+            </a:extLst>
+          </p:cNvPr>
+          <p:cNvGrpSpPr/>
+          <p:nvPr/>
+        </p:nvGrpSpPr>
+        <p:grpSpPr>
+          <a:xfrm>
+            <a:off x="406400" y="676879"/>
+            <a:ext cx="2787650" cy="2126896"/>
+            <a:chOff x="193507" y="509489"/>
+            <a:chExt cx="3186485" cy="2431196"/>
+          </a:xfrm>
+        </p:grpSpPr>
+        <p:cxnSp>
+          <p:nvCxnSpPr>
+            <p:cNvPr id="33" name="Gerader Verbinder 32">
+              <a:extLst>
+                <a:ext uri="{FF2B5EF4-FFF2-40B4-BE49-F238E27FC236}">
+                  <a16:creationId xmlns:a16="http://schemas.microsoft.com/office/drawing/2014/main" id="{89C7C0B0-2F38-D65E-8340-D4B41A4604A6}"/>
+                </a:ext>
+              </a:extLst>
+            </p:cNvPr>
+            <p:cNvCxnSpPr>
+              <a:cxnSpLocks/>
+              <a:stCxn id="2" idx="2"/>
+            </p:cNvCxnSpPr>
+            <p:nvPr/>
+          </p:nvCxnSpPr>
+          <p:spPr>
+            <a:xfrm flipV="1">
+              <a:off x="817245" y="725170"/>
+              <a:ext cx="0" cy="1232535"/>
+            </a:xfrm>
+            <a:prstGeom prst="line">
+              <a:avLst/>
+            </a:prstGeom>
+            <a:ln w="19050" cap="rnd">
+              <a:solidFill>
+                <a:schemeClr val="tx1"/>
+              </a:solidFill>
+              <a:round/>
+              <a:headEnd type="none"/>
+              <a:tailEnd type="none" w="med" len="med"/>
+            </a:ln>
+          </p:spPr>
+          <p:style>
+            <a:lnRef idx="2">
+              <a:schemeClr val="accent1"/>
+            </a:lnRef>
+            <a:fillRef idx="0">
+              <a:schemeClr val="accent1"/>
+            </a:fillRef>
+            <a:effectRef idx="1">
+              <a:schemeClr val="accent1"/>
+            </a:effectRef>
+            <a:fontRef idx="minor">
+              <a:schemeClr val="tx1"/>
+            </a:fontRef>
+          </p:style>
+        </p:cxnSp>
+        <p:cxnSp>
+          <p:nvCxnSpPr>
+            <p:cNvPr id="36" name="Gerader Verbinder 35">
+              <a:extLst>
+                <a:ext uri="{FF2B5EF4-FFF2-40B4-BE49-F238E27FC236}">
+                  <a16:creationId xmlns:a16="http://schemas.microsoft.com/office/drawing/2014/main" id="{5E7DCF88-B553-F885-39EC-09D0E757F694}"/>
+                </a:ext>
+              </a:extLst>
+            </p:cNvPr>
+            <p:cNvCxnSpPr>
+              <a:cxnSpLocks/>
+              <a:stCxn id="2" idx="6"/>
+            </p:cNvCxnSpPr>
+            <p:nvPr/>
+          </p:nvCxnSpPr>
+          <p:spPr>
+            <a:xfrm flipV="1">
+              <a:off x="2783205" y="725170"/>
+              <a:ext cx="0" cy="1232535"/>
+            </a:xfrm>
+            <a:prstGeom prst="line">
+              <a:avLst/>
+            </a:prstGeom>
+            <a:ln w="19050" cap="rnd">
+              <a:solidFill>
+                <a:schemeClr val="tx1"/>
+              </a:solidFill>
+              <a:round/>
+              <a:headEnd type="none"/>
+              <a:tailEnd type="none" w="med" len="med"/>
+            </a:ln>
+          </p:spPr>
+          <p:style>
+            <a:lnRef idx="2">
+              <a:schemeClr val="accent1"/>
+            </a:lnRef>
+            <a:fillRef idx="0">
+              <a:schemeClr val="accent1"/>
+            </a:fillRef>
+            <a:effectRef idx="1">
+              <a:schemeClr val="accent1"/>
+            </a:effectRef>
+            <a:fontRef idx="minor">
+              <a:schemeClr val="tx1"/>
+            </a:fontRef>
+          </p:style>
+        </p:cxnSp>
+        <p:sp>
+          <p:nvSpPr>
+            <p:cNvPr id="2" name="Ellipse 1">
+              <a:extLst>
+                <a:ext uri="{FF2B5EF4-FFF2-40B4-BE49-F238E27FC236}">
+                  <a16:creationId xmlns:a16="http://schemas.microsoft.com/office/drawing/2014/main" id="{E2F58065-8000-AB9D-B944-9C8A876981A6}"/>
+                </a:ext>
+              </a:extLst>
+            </p:cNvPr>
+            <p:cNvSpPr/>
+            <p:nvPr/>
+          </p:nvSpPr>
+          <p:spPr>
+            <a:xfrm>
+              <a:off x="817245" y="974725"/>
+              <a:ext cx="1965960" cy="1965960"/>
+            </a:xfrm>
+            <a:prstGeom prst="ellipse">
+              <a:avLst/>
+            </a:prstGeom>
+            <a:solidFill>
+              <a:schemeClr val="bg1"/>
+            </a:solidFill>
+            <a:ln w="25400">
+              <a:solidFill>
+                <a:schemeClr val="tx1"/>
+              </a:solidFill>
+            </a:ln>
+          </p:spPr>
+          <p:style>
+            <a:lnRef idx="2">
+              <a:schemeClr val="accent1">
+                <a:shade val="15000"/>
+              </a:schemeClr>
+            </a:lnRef>
+            <a:fillRef idx="1">
+              <a:schemeClr val="accent1"/>
+            </a:fillRef>
+            <a:effectRef idx="0">
+              <a:schemeClr val="accent1"/>
+            </a:effectRef>
+            <a:fontRef idx="minor">
+              <a:schemeClr val="lt1"/>
+            </a:fontRef>
+          </p:style>
+          <p:txBody>
+            <a:bodyPr rtlCol="0" anchor="ctr"/>
+            <a:lstStyle/>
+            <a:p>
+              <a:pPr algn="ctr"/>
+              <a:endParaRPr lang="de-DE"/>
+            </a:p>
+          </p:txBody>
+        </p:sp>
+        <p:sp>
+          <p:nvSpPr>
+            <p:cNvPr id="4" name="Ellipse 3">
+              <a:extLst>
+                <a:ext uri="{FF2B5EF4-FFF2-40B4-BE49-F238E27FC236}">
+                  <a16:creationId xmlns:a16="http://schemas.microsoft.com/office/drawing/2014/main" id="{822ADDCC-07E3-365E-CBD4-825760A5705B}"/>
+                </a:ext>
+              </a:extLst>
+            </p:cNvPr>
+            <p:cNvSpPr/>
+            <p:nvPr/>
+          </p:nvSpPr>
+          <p:spPr>
+            <a:xfrm>
+              <a:off x="899160" y="1056640"/>
+              <a:ext cx="1802130" cy="1802130"/>
+            </a:xfrm>
+            <a:prstGeom prst="ellipse">
+              <a:avLst/>
+            </a:prstGeom>
+            <a:solidFill>
+              <a:schemeClr val="bg1"/>
+            </a:solidFill>
+            <a:ln w="25400" cap="rnd">
+              <a:solidFill>
+                <a:srgbClr val="086FBD"/>
+              </a:solidFill>
+              <a:prstDash val="lgDashDot"/>
+              <a:round/>
+            </a:ln>
+          </p:spPr>
+          <p:style>
+            <a:lnRef idx="2">
+              <a:schemeClr val="accent1">
+                <a:shade val="15000"/>
+              </a:schemeClr>
+            </a:lnRef>
+            <a:fillRef idx="1">
+              <a:schemeClr val="accent1"/>
+            </a:fillRef>
+            <a:effectRef idx="0">
+              <a:schemeClr val="accent1"/>
+            </a:effectRef>
+            <a:fontRef idx="minor">
+              <a:schemeClr val="lt1"/>
+            </a:fontRef>
+          </p:style>
+          <p:txBody>
+            <a:bodyPr rtlCol="0" anchor="ctr"/>
+            <a:lstStyle/>
+            <a:p>
+              <a:pPr algn="ctr"/>
+              <a:endParaRPr lang="de-DE"/>
+            </a:p>
+          </p:txBody>
+        </p:sp>
+        <p:sp>
+          <p:nvSpPr>
+            <p:cNvPr id="6" name="Ellipse 5">
+              <a:extLst>
+                <a:ext uri="{FF2B5EF4-FFF2-40B4-BE49-F238E27FC236}">
+                  <a16:creationId xmlns:a16="http://schemas.microsoft.com/office/drawing/2014/main" id="{97023228-5B6E-AC7B-E72E-4350A671E985}"/>
+                </a:ext>
+              </a:extLst>
+            </p:cNvPr>
+            <p:cNvSpPr/>
+            <p:nvPr/>
+          </p:nvSpPr>
+          <p:spPr>
+            <a:xfrm>
+              <a:off x="984885" y="1142365"/>
+              <a:ext cx="1630680" cy="1630680"/>
+            </a:xfrm>
+            <a:prstGeom prst="ellipse">
+              <a:avLst/>
+            </a:prstGeom>
+            <a:solidFill>
+              <a:srgbClr val="129F57">
+                <a:alpha val="35000"/>
+              </a:srgbClr>
+            </a:solidFill>
+            <a:ln w="25400">
+              <a:solidFill>
+                <a:srgbClr val="129F57"/>
+              </a:solidFill>
+            </a:ln>
+          </p:spPr>
+          <p:style>
+            <a:lnRef idx="2">
+              <a:schemeClr val="accent1">
+                <a:shade val="15000"/>
+              </a:schemeClr>
+            </a:lnRef>
+            <a:fillRef idx="1">
+              <a:schemeClr val="accent1"/>
+            </a:fillRef>
+            <a:effectRef idx="0">
+              <a:schemeClr val="accent1"/>
+            </a:effectRef>
+            <a:fontRef idx="minor">
+              <a:schemeClr val="lt1"/>
+            </a:fontRef>
+          </p:style>
+          <p:txBody>
+            <a:bodyPr rtlCol="0" anchor="ctr"/>
+            <a:lstStyle/>
+            <a:p>
+              <a:pPr algn="ctr"/>
+              <a:endParaRPr lang="de-DE"/>
+            </a:p>
+          </p:txBody>
+        </p:sp>
+        <p:cxnSp>
+          <p:nvCxnSpPr>
+            <p:cNvPr id="7" name="Gerader Verbinder 6">
+              <a:extLst>
+                <a:ext uri="{FF2B5EF4-FFF2-40B4-BE49-F238E27FC236}">
+                  <a16:creationId xmlns:a16="http://schemas.microsoft.com/office/drawing/2014/main" id="{8F0A33D1-907F-F632-9881-8AE080B97D15}"/>
+                </a:ext>
+              </a:extLst>
+            </p:cNvPr>
+            <p:cNvCxnSpPr>
+              <a:cxnSpLocks/>
+            </p:cNvCxnSpPr>
+            <p:nvPr/>
+          </p:nvCxnSpPr>
+          <p:spPr>
+            <a:xfrm flipV="1">
+              <a:off x="2980783" y="1146175"/>
+              <a:ext cx="0" cy="1619885"/>
+            </a:xfrm>
+            <a:prstGeom prst="line">
+              <a:avLst/>
+            </a:prstGeom>
+            <a:ln w="19050" cap="rnd">
+              <a:solidFill>
+                <a:srgbClr val="129F57"/>
+              </a:solidFill>
+              <a:round/>
+              <a:headEnd type="triangle"/>
+              <a:tailEnd type="triangle" w="med" len="med"/>
+            </a:ln>
+          </p:spPr>
+          <p:style>
+            <a:lnRef idx="2">
+              <a:schemeClr val="accent1"/>
+            </a:lnRef>
+            <a:fillRef idx="0">
+              <a:schemeClr val="accent1"/>
+            </a:fillRef>
+            <a:effectRef idx="1">
+              <a:schemeClr val="accent1"/>
+            </a:effectRef>
+            <a:fontRef idx="minor">
+              <a:schemeClr val="tx1"/>
+            </a:fontRef>
+          </p:style>
+        </p:cxnSp>
+        <p:sp>
+          <p:nvSpPr>
+            <p:cNvPr id="8" name="Textfeld 7">
+              <a:extLst>
+                <a:ext uri="{FF2B5EF4-FFF2-40B4-BE49-F238E27FC236}">
+                  <a16:creationId xmlns:a16="http://schemas.microsoft.com/office/drawing/2014/main" id="{1CF72555-6B8F-20A1-F5CB-988FF2CB1B6D}"/>
+                </a:ext>
+              </a:extLst>
+            </p:cNvPr>
+            <p:cNvSpPr txBox="1"/>
+            <p:nvPr/>
+          </p:nvSpPr>
+          <p:spPr>
+            <a:xfrm>
+              <a:off x="2923092" y="1764210"/>
+              <a:ext cx="456900" cy="386992"/>
+            </a:xfrm>
+            <a:prstGeom prst="rect">
+              <a:avLst/>
+            </a:prstGeom>
+            <a:noFill/>
+          </p:spPr>
+          <p:txBody>
+            <a:bodyPr wrap="square" rtlCol="0" anchor="ctr">
+              <a:spAutoFit/>
+            </a:bodyPr>
+            <a:lstStyle/>
+            <a:p>
+              <a:pPr algn="ctr"/>
+              <a:r>
+                <a:rPr lang="de-DE" sz="1600" i="1" dirty="0">
+                  <a:solidFill>
+                    <a:srgbClr val="129F57"/>
+                  </a:solidFill>
+                  <a:latin typeface="CMU Serif" panose="02000603000000000000" pitchFamily="2" charset="0"/>
+                  <a:ea typeface="CMU Serif" panose="02000603000000000000" pitchFamily="2" charset="0"/>
+                  <a:cs typeface="CMU Serif" panose="02000603000000000000" pitchFamily="2" charset="0"/>
+                </a:rPr>
+                <a:t>d</a:t>
+              </a:r>
+              <a:r>
+                <a:rPr lang="de-DE" sz="1600" baseline="-25000" dirty="0">
+                  <a:solidFill>
+                    <a:srgbClr val="129F57"/>
+                  </a:solidFill>
+                  <a:latin typeface="CMU Serif" panose="02000603000000000000" pitchFamily="2" charset="0"/>
+                  <a:ea typeface="CMU Serif" panose="02000603000000000000" pitchFamily="2" charset="0"/>
+                  <a:cs typeface="CMU Serif" panose="02000603000000000000" pitchFamily="2" charset="0"/>
+                </a:rPr>
+                <a:t>3</a:t>
+              </a:r>
+            </a:p>
+          </p:txBody>
+        </p:sp>
+        <p:cxnSp>
+          <p:nvCxnSpPr>
+            <p:cNvPr id="9" name="Gerader Verbinder 8">
+              <a:extLst>
+                <a:ext uri="{FF2B5EF4-FFF2-40B4-BE49-F238E27FC236}">
+                  <a16:creationId xmlns:a16="http://schemas.microsoft.com/office/drawing/2014/main" id="{8895C2E3-6012-1A1A-7464-13223F7CD341}"/>
+                </a:ext>
+              </a:extLst>
+            </p:cNvPr>
+            <p:cNvCxnSpPr>
+              <a:cxnSpLocks/>
+              <a:endCxn id="6" idx="0"/>
+            </p:cNvCxnSpPr>
+            <p:nvPr/>
+          </p:nvCxnSpPr>
+          <p:spPr>
+            <a:xfrm flipH="1">
+              <a:off x="1800225" y="1142365"/>
+              <a:ext cx="1238250" cy="0"/>
+            </a:xfrm>
+            <a:prstGeom prst="line">
+              <a:avLst/>
+            </a:prstGeom>
+            <a:ln w="19050" cap="rnd">
+              <a:solidFill>
+                <a:srgbClr val="129F57"/>
+              </a:solidFill>
+              <a:round/>
+              <a:headEnd type="none"/>
+              <a:tailEnd type="none" w="med" len="med"/>
+            </a:ln>
+          </p:spPr>
+          <p:style>
+            <a:lnRef idx="2">
+              <a:schemeClr val="accent1"/>
+            </a:lnRef>
+            <a:fillRef idx="0">
+              <a:schemeClr val="accent1"/>
+            </a:fillRef>
+            <a:effectRef idx="1">
+              <a:schemeClr val="accent1"/>
+            </a:effectRef>
+            <a:fontRef idx="minor">
+              <a:schemeClr val="tx1"/>
+            </a:fontRef>
+          </p:style>
+        </p:cxnSp>
+        <p:cxnSp>
+          <p:nvCxnSpPr>
+            <p:cNvPr id="14" name="Gerader Verbinder 13">
+              <a:extLst>
+                <a:ext uri="{FF2B5EF4-FFF2-40B4-BE49-F238E27FC236}">
+                  <a16:creationId xmlns:a16="http://schemas.microsoft.com/office/drawing/2014/main" id="{CCE1007D-54D8-81D3-A6DB-474A4E6FEEE3}"/>
+                </a:ext>
+              </a:extLst>
+            </p:cNvPr>
+            <p:cNvCxnSpPr>
+              <a:cxnSpLocks/>
+              <a:endCxn id="6" idx="4"/>
+            </p:cNvCxnSpPr>
+            <p:nvPr/>
+          </p:nvCxnSpPr>
+          <p:spPr>
+            <a:xfrm flipH="1">
+              <a:off x="1800225" y="2773045"/>
+              <a:ext cx="1238250" cy="0"/>
+            </a:xfrm>
+            <a:prstGeom prst="line">
+              <a:avLst/>
+            </a:prstGeom>
+            <a:ln w="19050" cap="rnd">
+              <a:solidFill>
+                <a:srgbClr val="129F57"/>
+              </a:solidFill>
+              <a:round/>
+              <a:headEnd type="none"/>
+              <a:tailEnd type="none" w="med" len="med"/>
+            </a:ln>
+          </p:spPr>
+          <p:style>
+            <a:lnRef idx="2">
+              <a:schemeClr val="accent1"/>
+            </a:lnRef>
+            <a:fillRef idx="0">
+              <a:schemeClr val="accent1"/>
+            </a:fillRef>
+            <a:effectRef idx="1">
+              <a:schemeClr val="accent1"/>
+            </a:effectRef>
+            <a:fontRef idx="minor">
+              <a:schemeClr val="tx1"/>
+            </a:fontRef>
+          </p:style>
+        </p:cxnSp>
+        <p:cxnSp>
+          <p:nvCxnSpPr>
+            <p:cNvPr id="18" name="Gerader Verbinder 17">
+              <a:extLst>
+                <a:ext uri="{FF2B5EF4-FFF2-40B4-BE49-F238E27FC236}">
+                  <a16:creationId xmlns:a16="http://schemas.microsoft.com/office/drawing/2014/main" id="{437D8054-2EB3-5FAD-CDB5-EDD3A6DB6B5D}"/>
+                </a:ext>
+              </a:extLst>
+            </p:cNvPr>
+            <p:cNvCxnSpPr>
+              <a:cxnSpLocks/>
+              <a:stCxn id="4" idx="0"/>
+            </p:cNvCxnSpPr>
+            <p:nvPr/>
+          </p:nvCxnSpPr>
+          <p:spPr>
+            <a:xfrm flipH="1">
+              <a:off x="556260" y="1056640"/>
+              <a:ext cx="1243965" cy="0"/>
+            </a:xfrm>
+            <a:prstGeom prst="line">
+              <a:avLst/>
+            </a:prstGeom>
+            <a:ln w="19050" cap="rnd">
+              <a:solidFill>
+                <a:srgbClr val="086FBD"/>
+              </a:solidFill>
+              <a:round/>
+              <a:headEnd type="none"/>
+              <a:tailEnd type="none" w="med" len="med"/>
+            </a:ln>
+          </p:spPr>
+          <p:style>
+            <a:lnRef idx="2">
+              <a:schemeClr val="accent1"/>
+            </a:lnRef>
+            <a:fillRef idx="0">
+              <a:schemeClr val="accent1"/>
+            </a:fillRef>
+            <a:effectRef idx="1">
+              <a:schemeClr val="accent1"/>
+            </a:effectRef>
+            <a:fontRef idx="minor">
+              <a:schemeClr val="tx1"/>
+            </a:fontRef>
+          </p:style>
+        </p:cxnSp>
+        <p:cxnSp>
+          <p:nvCxnSpPr>
+            <p:cNvPr id="21" name="Gerader Verbinder 20">
+              <a:extLst>
+                <a:ext uri="{FF2B5EF4-FFF2-40B4-BE49-F238E27FC236}">
+                  <a16:creationId xmlns:a16="http://schemas.microsoft.com/office/drawing/2014/main" id="{E69A681B-54AF-33A8-F2AB-63D4E14DA90B}"/>
+                </a:ext>
+              </a:extLst>
+            </p:cNvPr>
+            <p:cNvCxnSpPr>
+              <a:cxnSpLocks/>
+              <a:stCxn id="4" idx="4"/>
+            </p:cNvCxnSpPr>
+            <p:nvPr/>
+          </p:nvCxnSpPr>
+          <p:spPr>
+            <a:xfrm flipH="1">
+              <a:off x="556260" y="2858770"/>
+              <a:ext cx="1243965" cy="0"/>
+            </a:xfrm>
+            <a:prstGeom prst="line">
+              <a:avLst/>
+            </a:prstGeom>
+            <a:ln w="19050" cap="rnd">
+              <a:solidFill>
+                <a:srgbClr val="086FBD"/>
+              </a:solidFill>
+              <a:round/>
+              <a:headEnd type="none"/>
+              <a:tailEnd type="none" w="med" len="med"/>
+            </a:ln>
+          </p:spPr>
+          <p:style>
+            <a:lnRef idx="2">
+              <a:schemeClr val="accent1"/>
+            </a:lnRef>
+            <a:fillRef idx="0">
+              <a:schemeClr val="accent1"/>
+            </a:fillRef>
+            <a:effectRef idx="1">
+              <a:schemeClr val="accent1"/>
+            </a:effectRef>
+            <a:fontRef idx="minor">
+              <a:schemeClr val="tx1"/>
+            </a:fontRef>
+          </p:style>
+        </p:cxnSp>
+        <p:cxnSp>
+          <p:nvCxnSpPr>
+            <p:cNvPr id="25" name="Gerader Verbinder 24">
+              <a:extLst>
+                <a:ext uri="{FF2B5EF4-FFF2-40B4-BE49-F238E27FC236}">
+                  <a16:creationId xmlns:a16="http://schemas.microsoft.com/office/drawing/2014/main" id="{752DC53A-0C50-AB97-941B-30A444624406}"/>
+                </a:ext>
+              </a:extLst>
+            </p:cNvPr>
+            <p:cNvCxnSpPr>
+              <a:cxnSpLocks/>
+            </p:cNvCxnSpPr>
+            <p:nvPr/>
+          </p:nvCxnSpPr>
+          <p:spPr>
+            <a:xfrm flipV="1">
+              <a:off x="618583" y="1064260"/>
+              <a:ext cx="0" cy="1784985"/>
+            </a:xfrm>
+            <a:prstGeom prst="line">
+              <a:avLst/>
+            </a:prstGeom>
+            <a:ln w="19050" cap="rnd">
+              <a:solidFill>
+                <a:srgbClr val="086FBD"/>
+              </a:solidFill>
+              <a:round/>
+              <a:headEnd type="triangle"/>
+              <a:tailEnd type="triangle" w="med" len="med"/>
+            </a:ln>
+          </p:spPr>
+          <p:style>
+            <a:lnRef idx="2">
+              <a:schemeClr val="accent1"/>
+            </a:lnRef>
+            <a:fillRef idx="0">
+              <a:schemeClr val="accent1"/>
+            </a:fillRef>
+            <a:effectRef idx="1">
+              <a:schemeClr val="accent1"/>
+            </a:effectRef>
+            <a:fontRef idx="minor">
+              <a:schemeClr val="tx1"/>
+            </a:fontRef>
+          </p:style>
+        </p:cxnSp>
+        <p:sp>
+          <p:nvSpPr>
+            <p:cNvPr id="32" name="Textfeld 31">
+              <a:extLst>
+                <a:ext uri="{FF2B5EF4-FFF2-40B4-BE49-F238E27FC236}">
+                  <a16:creationId xmlns:a16="http://schemas.microsoft.com/office/drawing/2014/main" id="{33191FB3-F27D-574C-FE2B-24CA0F091EA6}"/>
+                </a:ext>
+              </a:extLst>
+            </p:cNvPr>
+            <p:cNvSpPr txBox="1"/>
+            <p:nvPr/>
+          </p:nvSpPr>
+          <p:spPr>
+            <a:xfrm>
+              <a:off x="193507" y="1764210"/>
+              <a:ext cx="456901" cy="386992"/>
+            </a:xfrm>
+            <a:prstGeom prst="rect">
+              <a:avLst/>
+            </a:prstGeom>
+            <a:noFill/>
+          </p:spPr>
+          <p:txBody>
+            <a:bodyPr wrap="square" rtlCol="0" anchor="ctr">
+              <a:spAutoFit/>
+            </a:bodyPr>
+            <a:lstStyle/>
+            <a:p>
+              <a:pPr algn="ctr"/>
+              <a:r>
+                <a:rPr lang="de-DE" sz="1600" i="1" dirty="0">
+                  <a:solidFill>
+                    <a:srgbClr val="086FBD"/>
+                  </a:solidFill>
+                  <a:latin typeface="CMU Serif" panose="02000603000000000000" pitchFamily="2" charset="0"/>
+                  <a:ea typeface="CMU Serif" panose="02000603000000000000" pitchFamily="2" charset="0"/>
+                  <a:cs typeface="CMU Serif" panose="02000603000000000000" pitchFamily="2" charset="0"/>
+                </a:rPr>
+                <a:t>d</a:t>
+              </a:r>
+              <a:r>
+                <a:rPr lang="de-DE" sz="1600" baseline="-25000" dirty="0">
+                  <a:solidFill>
+                    <a:srgbClr val="086FBD"/>
+                  </a:solidFill>
+                  <a:latin typeface="CMU Serif" panose="02000603000000000000" pitchFamily="2" charset="0"/>
+                  <a:ea typeface="CMU Serif" panose="02000603000000000000" pitchFamily="2" charset="0"/>
+                  <a:cs typeface="CMU Serif" panose="02000603000000000000" pitchFamily="2" charset="0"/>
+                </a:rPr>
+                <a:t>2</a:t>
+              </a:r>
+            </a:p>
+          </p:txBody>
+        </p:sp>
+        <p:cxnSp>
+          <p:nvCxnSpPr>
+            <p:cNvPr id="40" name="Gerader Verbinder 39">
+              <a:extLst>
+                <a:ext uri="{FF2B5EF4-FFF2-40B4-BE49-F238E27FC236}">
+                  <a16:creationId xmlns:a16="http://schemas.microsoft.com/office/drawing/2014/main" id="{ECADDDB5-38C0-2603-8A95-0EAF9B3F43A7}"/>
+                </a:ext>
+              </a:extLst>
+            </p:cNvPr>
+            <p:cNvCxnSpPr>
+              <a:cxnSpLocks/>
+            </p:cNvCxnSpPr>
+            <p:nvPr/>
+          </p:nvCxnSpPr>
+          <p:spPr>
+            <a:xfrm>
+              <a:off x="825103" y="800418"/>
+              <a:ext cx="1954529" cy="0"/>
+            </a:xfrm>
+            <a:prstGeom prst="line">
+              <a:avLst/>
+            </a:prstGeom>
+            <a:ln w="19050" cap="rnd">
+              <a:solidFill>
+                <a:schemeClr val="tx1"/>
+              </a:solidFill>
+              <a:round/>
+              <a:headEnd type="triangle"/>
+              <a:tailEnd type="triangle" w="med" len="med"/>
+            </a:ln>
+          </p:spPr>
+          <p:style>
+            <a:lnRef idx="2">
+              <a:schemeClr val="accent1"/>
+            </a:lnRef>
+            <a:fillRef idx="0">
+              <a:schemeClr val="accent1"/>
+            </a:fillRef>
+            <a:effectRef idx="1">
+              <a:schemeClr val="accent1"/>
+            </a:effectRef>
+            <a:fontRef idx="minor">
+              <a:schemeClr val="tx1"/>
+            </a:fontRef>
+          </p:style>
+        </p:cxnSp>
+        <p:sp>
+          <p:nvSpPr>
+            <p:cNvPr id="47" name="Textfeld 46">
+              <a:extLst>
+                <a:ext uri="{FF2B5EF4-FFF2-40B4-BE49-F238E27FC236}">
+                  <a16:creationId xmlns:a16="http://schemas.microsoft.com/office/drawing/2014/main" id="{6DA3E31B-CA8C-D382-C140-93AAF558476E}"/>
+                </a:ext>
+              </a:extLst>
+            </p:cNvPr>
+            <p:cNvSpPr txBox="1"/>
+            <p:nvPr/>
+          </p:nvSpPr>
+          <p:spPr>
+            <a:xfrm>
+              <a:off x="1621415" y="509489"/>
+              <a:ext cx="357620" cy="338554"/>
+            </a:xfrm>
+            <a:prstGeom prst="rect">
+              <a:avLst/>
+            </a:prstGeom>
+            <a:noFill/>
+          </p:spPr>
+          <p:txBody>
+            <a:bodyPr wrap="square" rtlCol="0" anchor="ctr">
+              <a:spAutoFit/>
+            </a:bodyPr>
+            <a:lstStyle/>
+            <a:p>
+              <a:pPr algn="ctr"/>
+              <a:r>
+                <a:rPr lang="de-DE" sz="1600" i="1" dirty="0">
+                  <a:latin typeface="CMU Serif" panose="02000603000000000000" pitchFamily="2" charset="0"/>
+                  <a:ea typeface="CMU Serif" panose="02000603000000000000" pitchFamily="2" charset="0"/>
+                  <a:cs typeface="CMU Serif" panose="02000603000000000000" pitchFamily="2" charset="0"/>
+                </a:rPr>
+                <a:t>d</a:t>
+              </a:r>
+              <a:endParaRPr lang="de-DE" sz="1600" baseline="-25000" dirty="0">
+                <a:latin typeface="CMU Serif" panose="02000603000000000000" pitchFamily="2" charset="0"/>
+                <a:ea typeface="CMU Serif" panose="02000603000000000000" pitchFamily="2" charset="0"/>
+                <a:cs typeface="CMU Serif" panose="02000603000000000000" pitchFamily="2" charset="0"/>
+              </a:endParaRPr>
+            </a:p>
+          </p:txBody>
+        </p:sp>
+      </p:grpSp>
+    </p:spTree>
+    <p:extLst>
+      <p:ext uri="{BB962C8B-B14F-4D97-AF65-F5344CB8AC3E}">
+        <p14:creationId xmlns:p14="http://schemas.microsoft.com/office/powerpoint/2010/main" val="2016527129"/>
+      </p:ext>
+    </p:extLst>
+  </p:cSld>
+  <p:clrMapOvr>
+    <a:masterClrMapping/>
+  </p:clrMapOvr>
+</p:sld>
+</file>
+
+<file path=ppt/slides/slide11.xml><?xml version="1.0" encoding="utf-8"?>
+<p:sld xmlns:a="http://schemas.openxmlformats.org/drawingml/2006/main" xmlns:r="http://schemas.openxmlformats.org/officeDocument/2006/relationships" xmlns:p="http://schemas.openxmlformats.org/presentationml/2006/main">
+  <p:cSld>
+    <p:spTree>
+      <p:nvGrpSpPr>
+        <p:cNvPr id="1" name="">
+          <a:extLst>
+            <a:ext uri="{FF2B5EF4-FFF2-40B4-BE49-F238E27FC236}">
+              <a16:creationId xmlns:a16="http://schemas.microsoft.com/office/drawing/2014/main" id="{128E3B93-B037-6820-1D45-BE764485BA00}"/>
+            </a:ext>
+          </a:extLst>
+        </p:cNvPr>
+        <p:cNvGrpSpPr/>
+        <p:nvPr/>
+      </p:nvGrpSpPr>
+      <p:grpSpPr>
+        <a:xfrm>
+          <a:off x="0" y="0"/>
+          <a:ext cx="0" cy="0"/>
+          <a:chOff x="0" y="0"/>
+          <a:chExt cx="0" cy="0"/>
+        </a:xfrm>
+      </p:grpSpPr>
+      <p:cxnSp>
+        <p:nvCxnSpPr>
+          <p:cNvPr id="33" name="Gerader Verbinder 32">
+            <a:extLst>
+              <a:ext uri="{FF2B5EF4-FFF2-40B4-BE49-F238E27FC236}">
+                <a16:creationId xmlns:a16="http://schemas.microsoft.com/office/drawing/2014/main" id="{9A76A884-B71E-A9EB-5505-C6E9542D5BB5}"/>
+              </a:ext>
+            </a:extLst>
+          </p:cNvPr>
+          <p:cNvCxnSpPr>
+            <a:cxnSpLocks/>
+            <a:stCxn id="2" idx="2"/>
+          </p:cNvCxnSpPr>
+          <p:nvPr/>
+        </p:nvCxnSpPr>
+        <p:spPr>
+          <a:xfrm flipV="1">
+            <a:off x="952068" y="865564"/>
+            <a:ext cx="0" cy="1078265"/>
+          </a:xfrm>
+          <a:prstGeom prst="line">
+            <a:avLst/>
+          </a:prstGeom>
+          <a:ln w="19050" cap="rnd">
+            <a:solidFill>
+              <a:schemeClr val="tx1"/>
+            </a:solidFill>
+            <a:round/>
+            <a:headEnd type="none"/>
+            <a:tailEnd type="none" w="med" len="med"/>
+          </a:ln>
+        </p:spPr>
+        <p:style>
+          <a:lnRef idx="2">
+            <a:schemeClr val="accent1"/>
+          </a:lnRef>
+          <a:fillRef idx="0">
+            <a:schemeClr val="accent1"/>
+          </a:fillRef>
+          <a:effectRef idx="1">
+            <a:schemeClr val="accent1"/>
+          </a:effectRef>
+          <a:fontRef idx="minor">
+            <a:schemeClr val="tx1"/>
+          </a:fontRef>
+        </p:style>
+      </p:cxnSp>
+      <p:cxnSp>
+        <p:nvCxnSpPr>
+          <p:cNvPr id="36" name="Gerader Verbinder 35">
+            <a:extLst>
+              <a:ext uri="{FF2B5EF4-FFF2-40B4-BE49-F238E27FC236}">
+                <a16:creationId xmlns:a16="http://schemas.microsoft.com/office/drawing/2014/main" id="{E9D8D0B3-ED75-0329-9190-B25103E32616}"/>
+              </a:ext>
+            </a:extLst>
+          </p:cNvPr>
+          <p:cNvCxnSpPr>
+            <a:cxnSpLocks/>
+            <a:stCxn id="2" idx="6"/>
+          </p:cNvCxnSpPr>
+          <p:nvPr/>
+        </p:nvCxnSpPr>
+        <p:spPr>
+          <a:xfrm flipV="1">
+            <a:off x="2671960" y="865564"/>
+            <a:ext cx="0" cy="1078265"/>
+          </a:xfrm>
+          <a:prstGeom prst="line">
+            <a:avLst/>
+          </a:prstGeom>
+          <a:ln w="19050" cap="rnd">
+            <a:solidFill>
+              <a:schemeClr val="tx1"/>
+            </a:solidFill>
+            <a:round/>
+            <a:headEnd type="none"/>
+            <a:tailEnd type="none" w="med" len="med"/>
+          </a:ln>
+        </p:spPr>
+        <p:style>
+          <a:lnRef idx="2">
+            <a:schemeClr val="accent1"/>
+          </a:lnRef>
+          <a:fillRef idx="0">
+            <a:schemeClr val="accent1"/>
+          </a:fillRef>
+          <a:effectRef idx="1">
+            <a:schemeClr val="accent1"/>
+          </a:effectRef>
+          <a:fontRef idx="minor">
+            <a:schemeClr val="tx1"/>
+          </a:fontRef>
+        </p:style>
+      </p:cxnSp>
+      <p:sp>
+        <p:nvSpPr>
+          <p:cNvPr id="2" name="Ellipse 1">
+            <a:extLst>
+              <a:ext uri="{FF2B5EF4-FFF2-40B4-BE49-F238E27FC236}">
+                <a16:creationId xmlns:a16="http://schemas.microsoft.com/office/drawing/2014/main" id="{62173DF4-37DE-E070-E2BA-03EC2A21A9B6}"/>
+              </a:ext>
+            </a:extLst>
+          </p:cNvPr>
+          <p:cNvSpPr/>
+          <p:nvPr/>
+        </p:nvSpPr>
+        <p:spPr>
+          <a:xfrm>
+            <a:off x="952068" y="1083884"/>
+            <a:ext cx="1719891" cy="1719891"/>
+          </a:xfrm>
+          <a:prstGeom prst="ellipse">
+            <a:avLst/>
+          </a:prstGeom>
+          <a:solidFill>
+            <a:schemeClr val="bg1"/>
+          </a:solidFill>
+          <a:ln w="25400">
+            <a:solidFill>
+              <a:schemeClr val="tx1"/>
+            </a:solidFill>
+          </a:ln>
+        </p:spPr>
+        <p:style>
+          <a:lnRef idx="2">
+            <a:schemeClr val="accent1">
+              <a:shade val="15000"/>
+            </a:schemeClr>
+          </a:lnRef>
+          <a:fillRef idx="1">
+            <a:schemeClr val="accent1"/>
+          </a:fillRef>
+          <a:effectRef idx="0">
+            <a:schemeClr val="accent1"/>
+          </a:effectRef>
+          <a:fontRef idx="minor">
+            <a:schemeClr val="lt1"/>
+          </a:fontRef>
+        </p:style>
+        <p:txBody>
+          <a:bodyPr rtlCol="0" anchor="ctr"/>
+          <a:lstStyle/>
+          <a:p>
+            <a:pPr algn="ctr"/>
+            <a:endParaRPr lang="de-DE"/>
+          </a:p>
+        </p:txBody>
+      </p:sp>
+      <p:sp>
+        <p:nvSpPr>
+          <p:cNvPr id="6" name="Ellipse 5">
+            <a:extLst>
+              <a:ext uri="{FF2B5EF4-FFF2-40B4-BE49-F238E27FC236}">
+                <a16:creationId xmlns:a16="http://schemas.microsoft.com/office/drawing/2014/main" id="{A75D84EB-4F7F-95DF-E3CA-9B82E7884A0D}"/>
+              </a:ext>
+            </a:extLst>
+          </p:cNvPr>
+          <p:cNvSpPr/>
+          <p:nvPr/>
+        </p:nvSpPr>
+        <p:spPr>
+          <a:xfrm>
+            <a:off x="1098726" y="1318171"/>
+            <a:ext cx="1426577" cy="1426576"/>
+          </a:xfrm>
+          <a:prstGeom prst="ellipse">
+            <a:avLst/>
+          </a:prstGeom>
+          <a:solidFill>
+            <a:srgbClr val="FF0000">
+              <a:alpha val="35000"/>
+            </a:srgbClr>
+          </a:solidFill>
+          <a:ln w="25400">
+            <a:solidFill>
+              <a:srgbClr val="FF0000"/>
+            </a:solidFill>
+          </a:ln>
+        </p:spPr>
+        <p:style>
+          <a:lnRef idx="2">
+            <a:schemeClr val="accent1">
+              <a:shade val="15000"/>
+            </a:schemeClr>
+          </a:lnRef>
+          <a:fillRef idx="1">
+            <a:schemeClr val="accent1"/>
+          </a:fillRef>
+          <a:effectRef idx="0">
+            <a:schemeClr val="accent1"/>
+          </a:effectRef>
+          <a:fontRef idx="minor">
+            <a:schemeClr val="lt1"/>
+          </a:fontRef>
+        </p:style>
+        <p:txBody>
+          <a:bodyPr rtlCol="0" anchor="ctr"/>
+          <a:lstStyle/>
+          <a:p>
+            <a:pPr algn="ctr"/>
+            <a:endParaRPr lang="de-DE"/>
+          </a:p>
+        </p:txBody>
+      </p:sp>
+      <p:cxnSp>
+        <p:nvCxnSpPr>
+          <p:cNvPr id="7" name="Gerader Verbinder 6">
+            <a:extLst>
+              <a:ext uri="{FF2B5EF4-FFF2-40B4-BE49-F238E27FC236}">
+                <a16:creationId xmlns:a16="http://schemas.microsoft.com/office/drawing/2014/main" id="{860ECBBB-B0AA-CFA2-BB95-2DDCD482CCEE}"/>
+              </a:ext>
+            </a:extLst>
+          </p:cNvPr>
+          <p:cNvCxnSpPr>
+            <a:cxnSpLocks/>
+          </p:cNvCxnSpPr>
+          <p:nvPr/>
+        </p:nvCxnSpPr>
+        <p:spPr>
+          <a:xfrm flipV="1">
+            <a:off x="2844808" y="1321504"/>
+            <a:ext cx="0" cy="1417133"/>
+          </a:xfrm>
+          <a:prstGeom prst="line">
+            <a:avLst/>
+          </a:prstGeom>
+          <a:ln w="19050" cap="rnd">
+            <a:solidFill>
+              <a:srgbClr val="FF0000"/>
+            </a:solidFill>
+            <a:round/>
+            <a:headEnd type="triangle"/>
+            <a:tailEnd type="triangle" w="med" len="med"/>
+          </a:ln>
+        </p:spPr>
+        <p:style>
+          <a:lnRef idx="2">
+            <a:schemeClr val="accent1"/>
+          </a:lnRef>
+          <a:fillRef idx="0">
+            <a:schemeClr val="accent1"/>
+          </a:fillRef>
+          <a:effectRef idx="1">
+            <a:schemeClr val="accent1"/>
+          </a:effectRef>
+          <a:fontRef idx="minor">
+            <a:schemeClr val="tx1"/>
+          </a:fontRef>
+        </p:style>
+      </p:cxnSp>
+      <p:sp>
+        <p:nvSpPr>
+          <p:cNvPr id="8" name="Textfeld 7">
+            <a:extLst>
+              <a:ext uri="{FF2B5EF4-FFF2-40B4-BE49-F238E27FC236}">
+                <a16:creationId xmlns:a16="http://schemas.microsoft.com/office/drawing/2014/main" id="{AB5E0D72-3967-004B-1C08-E34B7335F5B6}"/>
+              </a:ext>
+            </a:extLst>
+          </p:cNvPr>
+          <p:cNvSpPr txBox="1"/>
+          <p:nvPr/>
+        </p:nvSpPr>
+        <p:spPr>
+          <a:xfrm>
+            <a:off x="2779098" y="1862182"/>
+            <a:ext cx="399712" cy="338554"/>
+          </a:xfrm>
+          <a:prstGeom prst="rect">
+            <a:avLst/>
+          </a:prstGeom>
+          <a:noFill/>
+        </p:spPr>
+        <p:txBody>
+          <a:bodyPr wrap="square" rtlCol="0" anchor="ctr">
+            <a:spAutoFit/>
+          </a:bodyPr>
+          <a:lstStyle/>
+          <a:p>
+            <a:pPr algn="ctr"/>
+            <a:r>
+              <a:rPr lang="de-DE" sz="1600" i="1" dirty="0" err="1">
+                <a:solidFill>
+                  <a:srgbClr val="FF0000"/>
+                </a:solidFill>
+                <a:latin typeface="CMU Serif" panose="02000603000000000000" pitchFamily="2" charset="0"/>
+                <a:ea typeface="CMU Serif" panose="02000603000000000000" pitchFamily="2" charset="0"/>
+                <a:cs typeface="CMU Serif" panose="02000603000000000000" pitchFamily="2" charset="0"/>
+              </a:rPr>
+              <a:t>d</a:t>
+            </a:r>
+            <a:r>
+              <a:rPr lang="de-DE" sz="1600" baseline="-25000" dirty="0" err="1">
+                <a:solidFill>
+                  <a:srgbClr val="FF0000"/>
+                </a:solidFill>
+                <a:latin typeface="CMU Serif" panose="02000603000000000000" pitchFamily="2" charset="0"/>
+                <a:ea typeface="CMU Serif" panose="02000603000000000000" pitchFamily="2" charset="0"/>
+                <a:cs typeface="CMU Serif" panose="02000603000000000000" pitchFamily="2" charset="0"/>
+              </a:rPr>
+              <a:t>S</a:t>
+            </a:r>
+            <a:endParaRPr lang="de-DE" sz="1600" baseline="-25000" dirty="0">
+              <a:solidFill>
+                <a:srgbClr val="FF0000"/>
+              </a:solidFill>
+              <a:latin typeface="CMU Serif" panose="02000603000000000000" pitchFamily="2" charset="0"/>
+              <a:ea typeface="CMU Serif" panose="02000603000000000000" pitchFamily="2" charset="0"/>
+              <a:cs typeface="CMU Serif" panose="02000603000000000000" pitchFamily="2" charset="0"/>
+            </a:endParaRPr>
+          </a:p>
+        </p:txBody>
+      </p:sp>
+      <p:cxnSp>
+        <p:nvCxnSpPr>
+          <p:cNvPr id="9" name="Gerader Verbinder 8">
+            <a:extLst>
+              <a:ext uri="{FF2B5EF4-FFF2-40B4-BE49-F238E27FC236}">
+                <a16:creationId xmlns:a16="http://schemas.microsoft.com/office/drawing/2014/main" id="{840C3713-1D5D-13FB-4E2B-583064C6197A}"/>
+              </a:ext>
+            </a:extLst>
+          </p:cNvPr>
+          <p:cNvCxnSpPr>
+            <a:cxnSpLocks/>
+            <a:endCxn id="6" idx="0"/>
+          </p:cNvCxnSpPr>
+          <p:nvPr/>
+        </p:nvCxnSpPr>
+        <p:spPr>
+          <a:xfrm flipH="1">
+            <a:off x="1812014" y="1318171"/>
+            <a:ext cx="1083265" cy="0"/>
+          </a:xfrm>
+          <a:prstGeom prst="line">
+            <a:avLst/>
+          </a:prstGeom>
+          <a:ln w="19050" cap="rnd">
+            <a:solidFill>
+              <a:srgbClr val="FF0000"/>
+            </a:solidFill>
+            <a:round/>
+            <a:headEnd type="none"/>
+            <a:tailEnd type="none" w="med" len="med"/>
+          </a:ln>
+        </p:spPr>
+        <p:style>
+          <a:lnRef idx="2">
+            <a:schemeClr val="accent1"/>
+          </a:lnRef>
+          <a:fillRef idx="0">
+            <a:schemeClr val="accent1"/>
+          </a:fillRef>
+          <a:effectRef idx="1">
+            <a:schemeClr val="accent1"/>
+          </a:effectRef>
+          <a:fontRef idx="minor">
+            <a:schemeClr val="tx1"/>
+          </a:fontRef>
+        </p:style>
+      </p:cxnSp>
+      <p:cxnSp>
+        <p:nvCxnSpPr>
+          <p:cNvPr id="14" name="Gerader Verbinder 13">
+            <a:extLst>
+              <a:ext uri="{FF2B5EF4-FFF2-40B4-BE49-F238E27FC236}">
+                <a16:creationId xmlns:a16="http://schemas.microsoft.com/office/drawing/2014/main" id="{345E3E20-58B2-7B94-CB36-4C88808636E1}"/>
+              </a:ext>
+            </a:extLst>
+          </p:cNvPr>
+          <p:cNvCxnSpPr>
+            <a:cxnSpLocks/>
+            <a:endCxn id="6" idx="4"/>
+          </p:cNvCxnSpPr>
+          <p:nvPr/>
+        </p:nvCxnSpPr>
+        <p:spPr>
+          <a:xfrm flipH="1">
+            <a:off x="1812014" y="2744748"/>
+            <a:ext cx="1083265" cy="0"/>
+          </a:xfrm>
+          <a:prstGeom prst="line">
+            <a:avLst/>
+          </a:prstGeom>
+          <a:ln w="19050" cap="rnd">
+            <a:solidFill>
+              <a:srgbClr val="FF0000"/>
+            </a:solidFill>
+            <a:round/>
+            <a:headEnd type="none"/>
+            <a:tailEnd type="none" w="med" len="med"/>
+          </a:ln>
+        </p:spPr>
+        <p:style>
+          <a:lnRef idx="2">
+            <a:schemeClr val="accent1"/>
+          </a:lnRef>
+          <a:fillRef idx="0">
+            <a:schemeClr val="accent1"/>
+          </a:fillRef>
+          <a:effectRef idx="1">
+            <a:schemeClr val="accent1"/>
+          </a:effectRef>
+          <a:fontRef idx="minor">
+            <a:schemeClr val="tx1"/>
+          </a:fontRef>
+        </p:style>
+      </p:cxnSp>
+      <p:cxnSp>
+        <p:nvCxnSpPr>
+          <p:cNvPr id="40" name="Gerader Verbinder 39">
+            <a:extLst>
+              <a:ext uri="{FF2B5EF4-FFF2-40B4-BE49-F238E27FC236}">
+                <a16:creationId xmlns:a16="http://schemas.microsoft.com/office/drawing/2014/main" id="{10D0A3A3-5027-E18C-DFD3-1CA948834B96}"/>
+              </a:ext>
+            </a:extLst>
+          </p:cNvPr>
+          <p:cNvCxnSpPr>
+            <a:cxnSpLocks/>
+          </p:cNvCxnSpPr>
+          <p:nvPr/>
+        </p:nvCxnSpPr>
+        <p:spPr>
+          <a:xfrm>
+            <a:off x="958943" y="931394"/>
+            <a:ext cx="1709891" cy="0"/>
+          </a:xfrm>
+          <a:prstGeom prst="line">
+            <a:avLst/>
+          </a:prstGeom>
+          <a:ln w="19050" cap="rnd">
+            <a:solidFill>
+              <a:schemeClr val="tx1"/>
+            </a:solidFill>
+            <a:round/>
+            <a:headEnd type="triangle"/>
+            <a:tailEnd type="triangle" w="med" len="med"/>
+          </a:ln>
+        </p:spPr>
+        <p:style>
+          <a:lnRef idx="2">
+            <a:schemeClr val="accent1"/>
+          </a:lnRef>
+          <a:fillRef idx="0">
+            <a:schemeClr val="accent1"/>
+          </a:fillRef>
+          <a:effectRef idx="1">
+            <a:schemeClr val="accent1"/>
+          </a:effectRef>
+          <a:fontRef idx="minor">
+            <a:schemeClr val="tx1"/>
+          </a:fontRef>
+        </p:style>
+      </p:cxnSp>
+      <p:sp>
+        <p:nvSpPr>
+          <p:cNvPr id="47" name="Textfeld 46">
+            <a:extLst>
+              <a:ext uri="{FF2B5EF4-FFF2-40B4-BE49-F238E27FC236}">
+                <a16:creationId xmlns:a16="http://schemas.microsoft.com/office/drawing/2014/main" id="{46BB7BED-85B5-1734-20DB-CB5852400559}"/>
+              </a:ext>
+            </a:extLst>
+          </p:cNvPr>
+          <p:cNvSpPr txBox="1"/>
+          <p:nvPr/>
+        </p:nvSpPr>
+        <p:spPr>
+          <a:xfrm>
+            <a:off x="1655585" y="676879"/>
+            <a:ext cx="312859" cy="296179"/>
+          </a:xfrm>
+          <a:prstGeom prst="rect">
+            <a:avLst/>
+          </a:prstGeom>
+          <a:noFill/>
+        </p:spPr>
+        <p:txBody>
+          <a:bodyPr wrap="square" rtlCol="0" anchor="ctr">
+            <a:spAutoFit/>
+          </a:bodyPr>
+          <a:lstStyle/>
+          <a:p>
+            <a:pPr algn="ctr"/>
+            <a:r>
+              <a:rPr lang="de-DE" sz="1600" i="1" dirty="0">
+                <a:latin typeface="CMU Serif" panose="02000603000000000000" pitchFamily="2" charset="0"/>
+                <a:ea typeface="CMU Serif" panose="02000603000000000000" pitchFamily="2" charset="0"/>
+                <a:cs typeface="CMU Serif" panose="02000603000000000000" pitchFamily="2" charset="0"/>
+              </a:rPr>
+              <a:t>d</a:t>
+            </a:r>
+            <a:endParaRPr lang="de-DE" sz="1600" baseline="-25000" dirty="0">
+              <a:latin typeface="CMU Serif" panose="02000603000000000000" pitchFamily="2" charset="0"/>
+              <a:ea typeface="CMU Serif" panose="02000603000000000000" pitchFamily="2" charset="0"/>
+              <a:cs typeface="CMU Serif" panose="02000603000000000000" pitchFamily="2" charset="0"/>
+            </a:endParaRPr>
+          </a:p>
+        </p:txBody>
+      </p:sp>
+    </p:spTree>
+    <p:extLst>
+      <p:ext uri="{BB962C8B-B14F-4D97-AF65-F5344CB8AC3E}">
+        <p14:creationId xmlns:p14="http://schemas.microsoft.com/office/powerpoint/2010/main" val="3209520519"/>
+      </p:ext>
+    </p:extLst>
+  </p:cSld>
+  <p:clrMapOvr>
+    <a:masterClrMapping/>
+  </p:clrMapOvr>
+</p:sld>
+</file>
+
+<file path=ppt/slides/slide12.xml><?xml version="1.0" encoding="utf-8"?>
+<p:sld xmlns:a="http://schemas.openxmlformats.org/drawingml/2006/main" xmlns:r="http://schemas.openxmlformats.org/officeDocument/2006/relationships" xmlns:p="http://schemas.openxmlformats.org/presentationml/2006/main">
+  <p:cSld>
+    <p:spTree>
+      <p:nvGrpSpPr>
+        <p:cNvPr id="1" name="">
+          <a:extLst>
+            <a:ext uri="{FF2B5EF4-FFF2-40B4-BE49-F238E27FC236}">
+              <a16:creationId xmlns:a16="http://schemas.microsoft.com/office/drawing/2014/main" id="{99241980-70C7-5D62-6D52-EB2048297287}"/>
+            </a:ext>
+          </a:extLst>
+        </p:cNvPr>
+        <p:cNvGrpSpPr/>
+        <p:nvPr/>
+      </p:nvGrpSpPr>
+      <p:grpSpPr>
+        <a:xfrm>
+          <a:off x="0" y="0"/>
+          <a:ext cx="0" cy="0"/>
+          <a:chOff x="0" y="0"/>
+          <a:chExt cx="0" cy="0"/>
+        </a:xfrm>
+      </p:grpSpPr>
+    </p:spTree>
+    <p:extLst>
+      <p:ext uri="{BB962C8B-B14F-4D97-AF65-F5344CB8AC3E}">
+        <p14:creationId xmlns:p14="http://schemas.microsoft.com/office/powerpoint/2010/main" val="1801935156"/>
+      </p:ext>
+    </p:extLst>
+  </p:cSld>
+  <p:clrMapOvr>
+    <a:masterClrMapping/>
+  </p:clrMapOvr>
+</p:sld>
+</file>
+
+<file path=ppt/slides/slide13.xml><?xml version="1.0" encoding="utf-8"?>
+<p:sld xmlns:a="http://schemas.openxmlformats.org/drawingml/2006/main" xmlns:r="http://schemas.openxmlformats.org/officeDocument/2006/relationships" xmlns:p="http://schemas.openxmlformats.org/presentationml/2006/main">
+  <p:cSld>
+    <p:spTree>
+      <p:nvGrpSpPr>
+        <p:cNvPr id="1" name="">
+          <a:extLst>
+            <a:ext uri="{FF2B5EF4-FFF2-40B4-BE49-F238E27FC236}">
               <a16:creationId xmlns:a16="http://schemas.microsoft.com/office/drawing/2014/main" id="{C89CF2A0-DAC2-87C4-3842-ABC4376283C7}"/>
             </a:ext>
           </a:extLst>
@@ -5689,10 +7057,10 @@
       </p:grpSp>
       <p:grpSp>
         <p:nvGrpSpPr>
-          <p:cNvPr id="76" name="Gruppieren 75">
+          <p:cNvPr id="5" name="Gruppieren 4">
             <a:extLst>
               <a:ext uri="{FF2B5EF4-FFF2-40B4-BE49-F238E27FC236}">
-                <a16:creationId xmlns:a16="http://schemas.microsoft.com/office/drawing/2014/main" id="{488E61C5-A9E1-C414-0A4C-5B175CBF5F36}"/>
+                <a16:creationId xmlns:a16="http://schemas.microsoft.com/office/drawing/2014/main" id="{505722B4-1AF1-0711-D416-DD349D491D3F}"/>
               </a:ext>
             </a:extLst>
           </p:cNvPr>
@@ -5701,10 +7069,10 @@
         </p:nvGrpSpPr>
         <p:grpSpPr>
           <a:xfrm>
-            <a:off x="318395" y="1734843"/>
-            <a:ext cx="757238" cy="1759103"/>
-            <a:chOff x="318395" y="1574823"/>
-            <a:chExt cx="757238" cy="1759103"/>
+            <a:off x="309936" y="1605956"/>
+            <a:ext cx="757238" cy="1877825"/>
+            <a:chOff x="318395" y="1696933"/>
+            <a:chExt cx="757238" cy="1877825"/>
           </a:xfrm>
         </p:grpSpPr>
         <p:sp>
@@ -5721,7 +7089,7 @@
           </p:nvSpPr>
           <p:spPr>
             <a:xfrm>
-              <a:off x="533877" y="2758440"/>
+              <a:off x="533877" y="2918460"/>
               <a:ext cx="321234" cy="497840"/>
             </a:xfrm>
             <a:prstGeom prst="rect">
@@ -5780,7 +7148,7 @@
           </p:nvSpPr>
           <p:spPr>
             <a:xfrm>
-              <a:off x="318395" y="2078830"/>
+              <a:off x="318395" y="2238850"/>
               <a:ext cx="757238" cy="757238"/>
             </a:xfrm>
             <a:prstGeom prst="ellipse">
@@ -5839,7 +7207,7 @@
           </p:nvSpPr>
           <p:spPr>
             <a:xfrm>
-              <a:off x="464703" y="2227658"/>
+              <a:off x="464703" y="2387678"/>
               <a:ext cx="459582" cy="459582"/>
             </a:xfrm>
             <a:prstGeom prst="ellipse">
@@ -5896,7 +7264,7 @@
           </p:nvSpPr>
           <p:spPr>
             <a:xfrm>
-              <a:off x="595434" y="1619329"/>
+              <a:off x="595434" y="1779349"/>
               <a:ext cx="198120" cy="808911"/>
             </a:xfrm>
             <a:prstGeom prst="roundRect">
@@ -5957,7 +7325,7 @@
           </p:nvSpPr>
           <p:spPr>
             <a:xfrm>
-              <a:off x="539115" y="2710180"/>
+              <a:off x="539115" y="2870200"/>
               <a:ext cx="312420" cy="197088"/>
             </a:xfrm>
             <a:prstGeom prst="rect">
@@ -6011,7 +7379,7 @@
           </p:nvSpPr>
           <p:spPr>
             <a:xfrm rot="5400000">
-              <a:off x="484255" y="1597020"/>
+              <a:off x="495817" y="1719130"/>
               <a:ext cx="393090" cy="348695"/>
             </a:xfrm>
             <a:prstGeom prst="rect">
@@ -6073,7 +7441,7 @@
           </p:nvSpPr>
           <p:spPr>
             <a:xfrm rot="16200000">
-              <a:off x="471855" y="2881495"/>
+              <a:off x="502353" y="3122327"/>
               <a:ext cx="393090" cy="511771"/>
             </a:xfrm>
             <a:prstGeom prst="rect">
@@ -24614,6 +25982,1526 @@
           <a:chExt cx="0" cy="0"/>
         </a:xfrm>
       </p:grpSpPr>
+      <p:cxnSp>
+        <p:nvCxnSpPr>
+          <p:cNvPr id="83" name="Gerader Verbinder 82">
+            <a:extLst>
+              <a:ext uri="{FF2B5EF4-FFF2-40B4-BE49-F238E27FC236}">
+                <a16:creationId xmlns:a16="http://schemas.microsoft.com/office/drawing/2014/main" id="{FFA60373-C3E4-8175-6240-0960A7F5AD82}"/>
+              </a:ext>
+            </a:extLst>
+          </p:cNvPr>
+          <p:cNvCxnSpPr>
+            <a:cxnSpLocks/>
+          </p:cNvCxnSpPr>
+          <p:nvPr/>
+        </p:nvCxnSpPr>
+        <p:spPr>
+          <a:xfrm flipV="1">
+            <a:off x="3033712" y="1768782"/>
+            <a:ext cx="0" cy="1056571"/>
+          </a:xfrm>
+          <a:prstGeom prst="line">
+            <a:avLst/>
+          </a:prstGeom>
+          <a:ln w="19050" cap="rnd">
+            <a:solidFill>
+              <a:srgbClr val="086FBD"/>
+            </a:solidFill>
+            <a:round/>
+            <a:headEnd type="none"/>
+            <a:tailEnd type="triangle" w="med" len="med"/>
+          </a:ln>
+        </p:spPr>
+        <p:style>
+          <a:lnRef idx="2">
+            <a:schemeClr val="accent1"/>
+          </a:lnRef>
+          <a:fillRef idx="0">
+            <a:schemeClr val="accent1"/>
+          </a:fillRef>
+          <a:effectRef idx="1">
+            <a:schemeClr val="accent1"/>
+          </a:effectRef>
+          <a:fontRef idx="minor">
+            <a:schemeClr val="tx1"/>
+          </a:fontRef>
+        </p:style>
+      </p:cxnSp>
+      <p:sp>
+        <p:nvSpPr>
+          <p:cNvPr id="41" name="Freihandform: Form 40">
+            <a:extLst>
+              <a:ext uri="{FF2B5EF4-FFF2-40B4-BE49-F238E27FC236}">
+                <a16:creationId xmlns:a16="http://schemas.microsoft.com/office/drawing/2014/main" id="{17D34BE9-A51C-CFBC-DACE-957F7227016C}"/>
+              </a:ext>
+            </a:extLst>
+          </p:cNvPr>
+          <p:cNvSpPr/>
+          <p:nvPr/>
+        </p:nvSpPr>
+        <p:spPr>
+          <a:xfrm>
+            <a:off x="1123474" y="1299447"/>
+            <a:ext cx="1718310" cy="1262380"/>
+          </a:xfrm>
+          <a:custGeom>
+            <a:avLst/>
+            <a:gdLst>
+              <a:gd name="csX0" fmla="*/ 0 w 1711960"/>
+              <a:gd name="csY0" fmla="*/ 508000 h 1262380"/>
+              <a:gd name="csX1" fmla="*/ 256540 w 1711960"/>
+              <a:gd name="csY1" fmla="*/ 957580 h 1262380"/>
+              <a:gd name="csX2" fmla="*/ 309880 w 1711960"/>
+              <a:gd name="csY2" fmla="*/ 1010920 h 1262380"/>
+              <a:gd name="csX3" fmla="*/ 375920 w 1711960"/>
+              <a:gd name="csY3" fmla="*/ 1041400 h 1262380"/>
+              <a:gd name="csX4" fmla="*/ 444500 w 1711960"/>
+              <a:gd name="csY4" fmla="*/ 1056640 h 1262380"/>
+              <a:gd name="csX5" fmla="*/ 525780 w 1711960"/>
+              <a:gd name="csY5" fmla="*/ 1043940 h 1262380"/>
+              <a:gd name="csX6" fmla="*/ 594360 w 1711960"/>
+              <a:gd name="csY6" fmla="*/ 1016000 h 1262380"/>
+              <a:gd name="csX7" fmla="*/ 650240 w 1711960"/>
+              <a:gd name="csY7" fmla="*/ 952500 h 1262380"/>
+              <a:gd name="csX8" fmla="*/ 716280 w 1711960"/>
+              <a:gd name="csY8" fmla="*/ 840740 h 1262380"/>
+              <a:gd name="csX9" fmla="*/ 1201420 w 1711960"/>
+              <a:gd name="csY9" fmla="*/ 2540 h 1262380"/>
+              <a:gd name="csX10" fmla="*/ 1536700 w 1711960"/>
+              <a:gd name="csY10" fmla="*/ 0 h 1262380"/>
+              <a:gd name="csX11" fmla="*/ 1711960 w 1711960"/>
+              <a:gd name="csY11" fmla="*/ 299720 h 1262380"/>
+              <a:gd name="csX12" fmla="*/ 1711960 w 1711960"/>
+              <a:gd name="csY12" fmla="*/ 1262380 h 1262380"/>
+              <a:gd name="csX13" fmla="*/ 2540 w 1711960"/>
+              <a:gd name="csY13" fmla="*/ 1262380 h 1262380"/>
+              <a:gd name="csX14" fmla="*/ 0 w 1711960"/>
+              <a:gd name="csY14" fmla="*/ 508000 h 1262380"/>
+            </a:gdLst>
+            <a:ahLst/>
+            <a:cxnLst>
+              <a:cxn ang="0">
+                <a:pos x="csX0" y="csY0"/>
+              </a:cxn>
+              <a:cxn ang="0">
+                <a:pos x="csX1" y="csY1"/>
+              </a:cxn>
+              <a:cxn ang="0">
+                <a:pos x="csX2" y="csY2"/>
+              </a:cxn>
+              <a:cxn ang="0">
+                <a:pos x="csX3" y="csY3"/>
+              </a:cxn>
+              <a:cxn ang="0">
+                <a:pos x="csX4" y="csY4"/>
+              </a:cxn>
+              <a:cxn ang="0">
+                <a:pos x="csX5" y="csY5"/>
+              </a:cxn>
+              <a:cxn ang="0">
+                <a:pos x="csX6" y="csY6"/>
+              </a:cxn>
+              <a:cxn ang="0">
+                <a:pos x="csX7" y="csY7"/>
+              </a:cxn>
+              <a:cxn ang="0">
+                <a:pos x="csX8" y="csY8"/>
+              </a:cxn>
+              <a:cxn ang="0">
+                <a:pos x="csX9" y="csY9"/>
+              </a:cxn>
+              <a:cxn ang="0">
+                <a:pos x="csX10" y="csY10"/>
+              </a:cxn>
+              <a:cxn ang="0">
+                <a:pos x="csX11" y="csY11"/>
+              </a:cxn>
+              <a:cxn ang="0">
+                <a:pos x="csX12" y="csY12"/>
+              </a:cxn>
+              <a:cxn ang="0">
+                <a:pos x="csX13" y="csY13"/>
+              </a:cxn>
+              <a:cxn ang="0">
+                <a:pos x="csX14" y="csY14"/>
+              </a:cxn>
+            </a:cxnLst>
+            <a:rect l="l" t="t" r="r" b="b"/>
+            <a:pathLst>
+              <a:path w="1711960" h="1262380">
+                <a:moveTo>
+                  <a:pt x="0" y="508000"/>
+                </a:moveTo>
+                <a:lnTo>
+                  <a:pt x="256540" y="957580"/>
+                </a:lnTo>
+                <a:lnTo>
+                  <a:pt x="309880" y="1010920"/>
+                </a:lnTo>
+                <a:lnTo>
+                  <a:pt x="375920" y="1041400"/>
+                </a:lnTo>
+                <a:lnTo>
+                  <a:pt x="444500" y="1056640"/>
+                </a:lnTo>
+                <a:lnTo>
+                  <a:pt x="525780" y="1043940"/>
+                </a:lnTo>
+                <a:lnTo>
+                  <a:pt x="594360" y="1016000"/>
+                </a:lnTo>
+                <a:lnTo>
+                  <a:pt x="650240" y="952500"/>
+                </a:lnTo>
+                <a:lnTo>
+                  <a:pt x="716280" y="840740"/>
+                </a:lnTo>
+                <a:lnTo>
+                  <a:pt x="1201420" y="2540"/>
+                </a:lnTo>
+                <a:lnTo>
+                  <a:pt x="1536700" y="0"/>
+                </a:lnTo>
+                <a:lnTo>
+                  <a:pt x="1711960" y="299720"/>
+                </a:lnTo>
+                <a:lnTo>
+                  <a:pt x="1711960" y="1262380"/>
+                </a:lnTo>
+                <a:lnTo>
+                  <a:pt x="2540" y="1262380"/>
+                </a:lnTo>
+                <a:cubicBezTo>
+                  <a:pt x="1693" y="1010920"/>
+                  <a:pt x="847" y="759460"/>
+                  <a:pt x="0" y="508000"/>
+                </a:cubicBezTo>
+                <a:close/>
+              </a:path>
+            </a:pathLst>
+          </a:custGeom>
+          <a:solidFill>
+            <a:schemeClr val="bg1">
+              <a:lumMod val="75000"/>
+            </a:schemeClr>
+          </a:solidFill>
+          <a:ln>
+            <a:noFill/>
+          </a:ln>
+        </p:spPr>
+        <p:style>
+          <a:lnRef idx="2">
+            <a:schemeClr val="accent1">
+              <a:shade val="15000"/>
+            </a:schemeClr>
+          </a:lnRef>
+          <a:fillRef idx="1">
+            <a:schemeClr val="accent1"/>
+          </a:fillRef>
+          <a:effectRef idx="0">
+            <a:schemeClr val="accent1"/>
+          </a:effectRef>
+          <a:fontRef idx="minor">
+            <a:schemeClr val="lt1"/>
+          </a:fontRef>
+        </p:style>
+        <p:txBody>
+          <a:bodyPr rtlCol="0" anchor="ctr"/>
+          <a:lstStyle/>
+          <a:p>
+            <a:pPr algn="ctr"/>
+            <a:endParaRPr lang="de-DE"/>
+          </a:p>
+        </p:txBody>
+      </p:sp>
+      <p:sp>
+        <p:nvSpPr>
+          <p:cNvPr id="28" name="Freihandform: Form 27">
+            <a:extLst>
+              <a:ext uri="{FF2B5EF4-FFF2-40B4-BE49-F238E27FC236}">
+                <a16:creationId xmlns:a16="http://schemas.microsoft.com/office/drawing/2014/main" id="{FEEE085C-6F06-1EBC-1930-EDF143B7720B}"/>
+              </a:ext>
+            </a:extLst>
+          </p:cNvPr>
+          <p:cNvSpPr/>
+          <p:nvPr/>
+        </p:nvSpPr>
+        <p:spPr>
+          <a:xfrm>
+            <a:off x="1254284" y="842247"/>
+            <a:ext cx="1579880" cy="1315720"/>
+          </a:xfrm>
+          <a:custGeom>
+            <a:avLst/>
+            <a:gdLst>
+              <a:gd name="csX0" fmla="*/ 0 w 1574800"/>
+              <a:gd name="csY0" fmla="*/ 0 h 1305560"/>
+              <a:gd name="csX1" fmla="*/ 1574800 w 1574800"/>
+              <a:gd name="csY1" fmla="*/ 0 h 1305560"/>
+              <a:gd name="csX2" fmla="*/ 1574800 w 1574800"/>
+              <a:gd name="csY2" fmla="*/ 685165 h 1305560"/>
+              <a:gd name="csX3" fmla="*/ 1374140 w 1574800"/>
+              <a:gd name="csY3" fmla="*/ 340360 h 1305560"/>
+              <a:gd name="csX4" fmla="*/ 1097280 w 1574800"/>
+              <a:gd name="csY4" fmla="*/ 340360 h 1305560"/>
+              <a:gd name="csX5" fmla="*/ 546100 w 1574800"/>
+              <a:gd name="csY5" fmla="*/ 1305560 h 1305560"/>
+              <a:gd name="csX6" fmla="*/ 111760 w 1574800"/>
+              <a:gd name="csY6" fmla="*/ 1305560 h 1305560"/>
+              <a:gd name="csX7" fmla="*/ 2540 w 1574800"/>
+              <a:gd name="csY7" fmla="*/ 1117600 h 1305560"/>
+              <a:gd name="csX8" fmla="*/ 0 w 1574800"/>
+              <a:gd name="csY8" fmla="*/ 0 h 1305560"/>
+            </a:gdLst>
+            <a:ahLst/>
+            <a:cxnLst>
+              <a:cxn ang="0">
+                <a:pos x="csX0" y="csY0"/>
+              </a:cxn>
+              <a:cxn ang="0">
+                <a:pos x="csX1" y="csY1"/>
+              </a:cxn>
+              <a:cxn ang="0">
+                <a:pos x="csX2" y="csY2"/>
+              </a:cxn>
+              <a:cxn ang="0">
+                <a:pos x="csX3" y="csY3"/>
+              </a:cxn>
+              <a:cxn ang="0">
+                <a:pos x="csX4" y="csY4"/>
+              </a:cxn>
+              <a:cxn ang="0">
+                <a:pos x="csX5" y="csY5"/>
+              </a:cxn>
+              <a:cxn ang="0">
+                <a:pos x="csX6" y="csY6"/>
+              </a:cxn>
+              <a:cxn ang="0">
+                <a:pos x="csX7" y="csY7"/>
+              </a:cxn>
+              <a:cxn ang="0">
+                <a:pos x="csX8" y="csY8"/>
+              </a:cxn>
+            </a:cxnLst>
+            <a:rect l="l" t="t" r="r" b="b"/>
+            <a:pathLst>
+              <a:path w="1574800" h="1305560">
+                <a:moveTo>
+                  <a:pt x="0" y="0"/>
+                </a:moveTo>
+                <a:lnTo>
+                  <a:pt x="1574800" y="0"/>
+                </a:lnTo>
+                <a:lnTo>
+                  <a:pt x="1574800" y="685165"/>
+                </a:lnTo>
+                <a:lnTo>
+                  <a:pt x="1374140" y="340360"/>
+                </a:lnTo>
+                <a:lnTo>
+                  <a:pt x="1097280" y="340360"/>
+                </a:lnTo>
+                <a:lnTo>
+                  <a:pt x="546100" y="1305560"/>
+                </a:lnTo>
+                <a:lnTo>
+                  <a:pt x="111760" y="1305560"/>
+                </a:lnTo>
+                <a:lnTo>
+                  <a:pt x="2540" y="1117600"/>
+                </a:lnTo>
+                <a:cubicBezTo>
+                  <a:pt x="1693" y="745067"/>
+                  <a:pt x="847" y="372533"/>
+                  <a:pt x="0" y="0"/>
+                </a:cubicBezTo>
+                <a:close/>
+              </a:path>
+            </a:pathLst>
+          </a:custGeom>
+          <a:solidFill>
+            <a:schemeClr val="bg1">
+              <a:lumMod val="50000"/>
+            </a:schemeClr>
+          </a:solidFill>
+          <a:ln>
+            <a:noFill/>
+          </a:ln>
+        </p:spPr>
+        <p:style>
+          <a:lnRef idx="2">
+            <a:schemeClr val="accent1">
+              <a:shade val="15000"/>
+            </a:schemeClr>
+          </a:lnRef>
+          <a:fillRef idx="1">
+            <a:schemeClr val="accent1"/>
+          </a:fillRef>
+          <a:effectRef idx="0">
+            <a:schemeClr val="accent1"/>
+          </a:effectRef>
+          <a:fontRef idx="minor">
+            <a:schemeClr val="lt1"/>
+          </a:fontRef>
+        </p:style>
+        <p:txBody>
+          <a:bodyPr rtlCol="0" anchor="ctr"/>
+          <a:lstStyle/>
+          <a:p>
+            <a:pPr algn="ctr"/>
+            <a:endParaRPr lang="de-DE"/>
+          </a:p>
+        </p:txBody>
+      </p:sp>
+      <p:cxnSp>
+        <p:nvCxnSpPr>
+          <p:cNvPr id="3" name="Gerader Verbinder 2">
+            <a:extLst>
+              <a:ext uri="{FF2B5EF4-FFF2-40B4-BE49-F238E27FC236}">
+                <a16:creationId xmlns:a16="http://schemas.microsoft.com/office/drawing/2014/main" id="{E1B3E2A9-E25C-B824-5F5E-00EE664F8481}"/>
+              </a:ext>
+            </a:extLst>
+          </p:cNvPr>
+          <p:cNvCxnSpPr>
+            <a:cxnSpLocks/>
+          </p:cNvCxnSpPr>
+          <p:nvPr/>
+        </p:nvCxnSpPr>
+        <p:spPr>
+          <a:xfrm>
+            <a:off x="1253728" y="853677"/>
+            <a:ext cx="0" cy="1114425"/>
+          </a:xfrm>
+          <a:prstGeom prst="line">
+            <a:avLst/>
+          </a:prstGeom>
+          <a:ln w="25400" cap="rnd">
+            <a:solidFill>
+              <a:schemeClr val="tx1">
+                <a:lumMod val="75000"/>
+                <a:lumOff val="25000"/>
+              </a:schemeClr>
+            </a:solidFill>
+            <a:round/>
+          </a:ln>
+        </p:spPr>
+        <p:style>
+          <a:lnRef idx="2">
+            <a:schemeClr val="accent1"/>
+          </a:lnRef>
+          <a:fillRef idx="0">
+            <a:schemeClr val="accent1"/>
+          </a:fillRef>
+          <a:effectRef idx="1">
+            <a:schemeClr val="accent1"/>
+          </a:effectRef>
+          <a:fontRef idx="minor">
+            <a:schemeClr val="tx1"/>
+          </a:fontRef>
+        </p:style>
+      </p:cxnSp>
+      <p:cxnSp>
+        <p:nvCxnSpPr>
+          <p:cNvPr id="18" name="Gerader Verbinder 17">
+            <a:extLst>
+              <a:ext uri="{FF2B5EF4-FFF2-40B4-BE49-F238E27FC236}">
+                <a16:creationId xmlns:a16="http://schemas.microsoft.com/office/drawing/2014/main" id="{C1A2AD43-7A9D-D0EC-5F74-D6BD6D064950}"/>
+              </a:ext>
+            </a:extLst>
+          </p:cNvPr>
+          <p:cNvCxnSpPr>
+            <a:cxnSpLocks/>
+          </p:cNvCxnSpPr>
+          <p:nvPr/>
+        </p:nvCxnSpPr>
+        <p:spPr>
+          <a:xfrm>
+            <a:off x="1253728" y="1968102"/>
+            <a:ext cx="110595" cy="191557"/>
+          </a:xfrm>
+          <a:prstGeom prst="line">
+            <a:avLst/>
+          </a:prstGeom>
+          <a:ln w="25400" cap="rnd">
+            <a:solidFill>
+              <a:schemeClr val="tx1">
+                <a:lumMod val="75000"/>
+                <a:lumOff val="25000"/>
+              </a:schemeClr>
+            </a:solidFill>
+            <a:round/>
+          </a:ln>
+        </p:spPr>
+        <p:style>
+          <a:lnRef idx="2">
+            <a:schemeClr val="accent1"/>
+          </a:lnRef>
+          <a:fillRef idx="0">
+            <a:schemeClr val="accent1"/>
+          </a:fillRef>
+          <a:effectRef idx="1">
+            <a:schemeClr val="accent1"/>
+          </a:effectRef>
+          <a:fontRef idx="minor">
+            <a:schemeClr val="tx1"/>
+          </a:fontRef>
+        </p:style>
+      </p:cxnSp>
+      <p:cxnSp>
+        <p:nvCxnSpPr>
+          <p:cNvPr id="20" name="Gerader Verbinder 19">
+            <a:extLst>
+              <a:ext uri="{FF2B5EF4-FFF2-40B4-BE49-F238E27FC236}">
+                <a16:creationId xmlns:a16="http://schemas.microsoft.com/office/drawing/2014/main" id="{3FF345EE-94E1-7CB0-7A7F-539C6E656808}"/>
+              </a:ext>
+            </a:extLst>
+          </p:cNvPr>
+          <p:cNvCxnSpPr>
+            <a:cxnSpLocks/>
+          </p:cNvCxnSpPr>
+          <p:nvPr/>
+        </p:nvCxnSpPr>
+        <p:spPr>
+          <a:xfrm flipH="1">
+            <a:off x="1364323" y="2159660"/>
+            <a:ext cx="432330" cy="0"/>
+          </a:xfrm>
+          <a:prstGeom prst="line">
+            <a:avLst/>
+          </a:prstGeom>
+          <a:ln w="25400" cap="rnd">
+            <a:solidFill>
+              <a:schemeClr val="tx1">
+                <a:lumMod val="75000"/>
+                <a:lumOff val="25000"/>
+              </a:schemeClr>
+            </a:solidFill>
+            <a:round/>
+          </a:ln>
+        </p:spPr>
+        <p:style>
+          <a:lnRef idx="2">
+            <a:schemeClr val="accent1"/>
+          </a:lnRef>
+          <a:fillRef idx="0">
+            <a:schemeClr val="accent1"/>
+          </a:fillRef>
+          <a:effectRef idx="1">
+            <a:schemeClr val="accent1"/>
+          </a:effectRef>
+          <a:fontRef idx="minor">
+            <a:schemeClr val="tx1"/>
+          </a:fontRef>
+        </p:style>
+      </p:cxnSp>
+      <p:cxnSp>
+        <p:nvCxnSpPr>
+          <p:cNvPr id="23" name="Gerader Verbinder 22">
+            <a:extLst>
+              <a:ext uri="{FF2B5EF4-FFF2-40B4-BE49-F238E27FC236}">
+                <a16:creationId xmlns:a16="http://schemas.microsoft.com/office/drawing/2014/main" id="{30F250E1-4E7A-318B-21DE-F98119F337EC}"/>
+              </a:ext>
+            </a:extLst>
+          </p:cNvPr>
+          <p:cNvCxnSpPr>
+            <a:cxnSpLocks/>
+          </p:cNvCxnSpPr>
+          <p:nvPr/>
+        </p:nvCxnSpPr>
+        <p:spPr>
+          <a:xfrm>
+            <a:off x="2625328" y="1192026"/>
+            <a:ext cx="196228" cy="339878"/>
+          </a:xfrm>
+          <a:prstGeom prst="line">
+            <a:avLst/>
+          </a:prstGeom>
+          <a:ln w="25400" cap="rnd">
+            <a:solidFill>
+              <a:schemeClr val="tx1">
+                <a:lumMod val="75000"/>
+                <a:lumOff val="25000"/>
+              </a:schemeClr>
+            </a:solidFill>
+            <a:round/>
+          </a:ln>
+        </p:spPr>
+        <p:style>
+          <a:lnRef idx="2">
+            <a:schemeClr val="accent1"/>
+          </a:lnRef>
+          <a:fillRef idx="0">
+            <a:schemeClr val="accent1"/>
+          </a:fillRef>
+          <a:effectRef idx="1">
+            <a:schemeClr val="accent1"/>
+          </a:effectRef>
+          <a:fontRef idx="minor">
+            <a:schemeClr val="tx1"/>
+          </a:fontRef>
+        </p:style>
+      </p:cxnSp>
+      <p:cxnSp>
+        <p:nvCxnSpPr>
+          <p:cNvPr id="29" name="Gerader Verbinder 28">
+            <a:extLst>
+              <a:ext uri="{FF2B5EF4-FFF2-40B4-BE49-F238E27FC236}">
+                <a16:creationId xmlns:a16="http://schemas.microsoft.com/office/drawing/2014/main" id="{10CB9BD4-5B5B-6B11-92FE-03FA64F64090}"/>
+              </a:ext>
+            </a:extLst>
+          </p:cNvPr>
+          <p:cNvCxnSpPr>
+            <a:cxnSpLocks/>
+          </p:cNvCxnSpPr>
+          <p:nvPr/>
+        </p:nvCxnSpPr>
+        <p:spPr>
+          <a:xfrm>
+            <a:off x="1134958" y="1810835"/>
+            <a:ext cx="246326" cy="426651"/>
+          </a:xfrm>
+          <a:prstGeom prst="line">
+            <a:avLst/>
+          </a:prstGeom>
+          <a:ln w="25400" cap="rnd">
+            <a:solidFill>
+              <a:schemeClr val="tx1">
+                <a:lumMod val="50000"/>
+                <a:lumOff val="50000"/>
+              </a:schemeClr>
+            </a:solidFill>
+            <a:round/>
+          </a:ln>
+        </p:spPr>
+        <p:style>
+          <a:lnRef idx="2">
+            <a:schemeClr val="accent1"/>
+          </a:lnRef>
+          <a:fillRef idx="0">
+            <a:schemeClr val="accent1"/>
+          </a:fillRef>
+          <a:effectRef idx="1">
+            <a:schemeClr val="accent1"/>
+          </a:effectRef>
+          <a:fontRef idx="minor">
+            <a:schemeClr val="tx1"/>
+          </a:fontRef>
+        </p:style>
+      </p:cxnSp>
+      <p:cxnSp>
+        <p:nvCxnSpPr>
+          <p:cNvPr id="34" name="Gerader Verbinder 33">
+            <a:extLst>
+              <a:ext uri="{FF2B5EF4-FFF2-40B4-BE49-F238E27FC236}">
+                <a16:creationId xmlns:a16="http://schemas.microsoft.com/office/drawing/2014/main" id="{2B6AE206-B998-25EF-5F9C-2AF0B0842AA6}"/>
+              </a:ext>
+            </a:extLst>
+          </p:cNvPr>
+          <p:cNvCxnSpPr>
+            <a:cxnSpLocks/>
+          </p:cNvCxnSpPr>
+          <p:nvPr/>
+        </p:nvCxnSpPr>
+        <p:spPr>
+          <a:xfrm>
+            <a:off x="2660068" y="1299265"/>
+            <a:ext cx="167282" cy="289742"/>
+          </a:xfrm>
+          <a:prstGeom prst="line">
+            <a:avLst/>
+          </a:prstGeom>
+          <a:ln w="25400" cap="rnd">
+            <a:solidFill>
+              <a:schemeClr val="tx1">
+                <a:lumMod val="50000"/>
+                <a:lumOff val="50000"/>
+              </a:schemeClr>
+            </a:solidFill>
+            <a:round/>
+          </a:ln>
+        </p:spPr>
+        <p:style>
+          <a:lnRef idx="2">
+            <a:schemeClr val="accent1"/>
+          </a:lnRef>
+          <a:fillRef idx="0">
+            <a:schemeClr val="accent1"/>
+          </a:fillRef>
+          <a:effectRef idx="1">
+            <a:schemeClr val="accent1"/>
+          </a:effectRef>
+          <a:fontRef idx="minor">
+            <a:schemeClr val="tx1"/>
+          </a:fontRef>
+        </p:style>
+      </p:cxnSp>
+      <p:cxnSp>
+        <p:nvCxnSpPr>
+          <p:cNvPr id="22" name="Gerader Verbinder 21">
+            <a:extLst>
+              <a:ext uri="{FF2B5EF4-FFF2-40B4-BE49-F238E27FC236}">
+                <a16:creationId xmlns:a16="http://schemas.microsoft.com/office/drawing/2014/main" id="{6089DF4C-8452-2402-51AA-59A54FE20195}"/>
+              </a:ext>
+            </a:extLst>
+          </p:cNvPr>
+          <p:cNvCxnSpPr>
+            <a:cxnSpLocks/>
+          </p:cNvCxnSpPr>
+          <p:nvPr/>
+        </p:nvCxnSpPr>
+        <p:spPr>
+          <a:xfrm rot="1800000">
+            <a:off x="2075259" y="1119888"/>
+            <a:ext cx="0" cy="1114425"/>
+          </a:xfrm>
+          <a:prstGeom prst="line">
+            <a:avLst/>
+          </a:prstGeom>
+          <a:ln w="25400" cap="rnd">
+            <a:solidFill>
+              <a:schemeClr val="tx1">
+                <a:lumMod val="75000"/>
+                <a:lumOff val="25000"/>
+              </a:schemeClr>
+            </a:solidFill>
+            <a:round/>
+          </a:ln>
+        </p:spPr>
+        <p:style>
+          <a:lnRef idx="2">
+            <a:schemeClr val="accent1"/>
+          </a:lnRef>
+          <a:fillRef idx="0">
+            <a:schemeClr val="accent1"/>
+          </a:fillRef>
+          <a:effectRef idx="1">
+            <a:schemeClr val="accent1"/>
+          </a:effectRef>
+          <a:fontRef idx="minor">
+            <a:schemeClr val="tx1"/>
+          </a:fontRef>
+        </p:style>
+      </p:cxnSp>
+      <p:cxnSp>
+        <p:nvCxnSpPr>
+          <p:cNvPr id="24" name="Gerader Verbinder 23">
+            <a:extLst>
+              <a:ext uri="{FF2B5EF4-FFF2-40B4-BE49-F238E27FC236}">
+                <a16:creationId xmlns:a16="http://schemas.microsoft.com/office/drawing/2014/main" id="{5D31078C-16A4-CBDA-9E46-41535DCDE69F}"/>
+              </a:ext>
+            </a:extLst>
+          </p:cNvPr>
+          <p:cNvCxnSpPr>
+            <a:cxnSpLocks/>
+          </p:cNvCxnSpPr>
+          <p:nvPr/>
+        </p:nvCxnSpPr>
+        <p:spPr>
+          <a:xfrm flipH="1">
+            <a:off x="2353866" y="1192026"/>
+            <a:ext cx="271462" cy="0"/>
+          </a:xfrm>
+          <a:prstGeom prst="line">
+            <a:avLst/>
+          </a:prstGeom>
+          <a:ln w="25400" cap="rnd">
+            <a:solidFill>
+              <a:schemeClr val="tx1">
+                <a:lumMod val="75000"/>
+                <a:lumOff val="25000"/>
+              </a:schemeClr>
+            </a:solidFill>
+            <a:round/>
+          </a:ln>
+        </p:spPr>
+        <p:style>
+          <a:lnRef idx="2">
+            <a:schemeClr val="accent1"/>
+          </a:lnRef>
+          <a:fillRef idx="0">
+            <a:schemeClr val="accent1"/>
+          </a:fillRef>
+          <a:effectRef idx="1">
+            <a:schemeClr val="accent1"/>
+          </a:effectRef>
+          <a:fontRef idx="minor">
+            <a:schemeClr val="tx1"/>
+          </a:fontRef>
+        </p:style>
+      </p:cxnSp>
+      <p:cxnSp>
+        <p:nvCxnSpPr>
+          <p:cNvPr id="47" name="Gerader Verbinder 46">
+            <a:extLst>
+              <a:ext uri="{FF2B5EF4-FFF2-40B4-BE49-F238E27FC236}">
+                <a16:creationId xmlns:a16="http://schemas.microsoft.com/office/drawing/2014/main" id="{1AB57A79-F17E-36CC-846E-BAEBB8EE38DF}"/>
+              </a:ext>
+            </a:extLst>
+          </p:cNvPr>
+          <p:cNvCxnSpPr>
+            <a:cxnSpLocks/>
+          </p:cNvCxnSpPr>
+          <p:nvPr/>
+        </p:nvCxnSpPr>
+        <p:spPr>
+          <a:xfrm flipV="1">
+            <a:off x="534591" y="1307306"/>
+            <a:ext cx="0" cy="1518047"/>
+          </a:xfrm>
+          <a:prstGeom prst="line">
+            <a:avLst/>
+          </a:prstGeom>
+          <a:ln w="19050" cap="rnd">
+            <a:solidFill>
+              <a:schemeClr val="tx1"/>
+            </a:solidFill>
+            <a:round/>
+            <a:headEnd type="none"/>
+            <a:tailEnd type="triangle" w="med" len="med"/>
+          </a:ln>
+        </p:spPr>
+        <p:style>
+          <a:lnRef idx="2">
+            <a:schemeClr val="accent1"/>
+          </a:lnRef>
+          <a:fillRef idx="0">
+            <a:schemeClr val="accent1"/>
+          </a:fillRef>
+          <a:effectRef idx="1">
+            <a:schemeClr val="accent1"/>
+          </a:effectRef>
+          <a:fontRef idx="minor">
+            <a:schemeClr val="tx1"/>
+          </a:fontRef>
+        </p:style>
+      </p:cxnSp>
+      <p:cxnSp>
+        <p:nvCxnSpPr>
+          <p:cNvPr id="50" name="Gerader Verbinder 49">
+            <a:extLst>
+              <a:ext uri="{FF2B5EF4-FFF2-40B4-BE49-F238E27FC236}">
+                <a16:creationId xmlns:a16="http://schemas.microsoft.com/office/drawing/2014/main" id="{92646F9A-D16D-32F2-BAF6-C6387CBA3DF2}"/>
+              </a:ext>
+            </a:extLst>
+          </p:cNvPr>
+          <p:cNvCxnSpPr>
+            <a:cxnSpLocks/>
+          </p:cNvCxnSpPr>
+          <p:nvPr/>
+        </p:nvCxnSpPr>
+        <p:spPr>
+          <a:xfrm flipV="1">
+            <a:off x="944169" y="2357437"/>
+            <a:ext cx="0" cy="467916"/>
+          </a:xfrm>
+          <a:prstGeom prst="line">
+            <a:avLst/>
+          </a:prstGeom>
+          <a:ln w="19050" cap="rnd">
+            <a:solidFill>
+              <a:srgbClr val="129F57"/>
+            </a:solidFill>
+            <a:round/>
+            <a:headEnd type="none"/>
+            <a:tailEnd type="triangle" w="med" len="med"/>
+          </a:ln>
+        </p:spPr>
+        <p:style>
+          <a:lnRef idx="2">
+            <a:schemeClr val="accent1"/>
+          </a:lnRef>
+          <a:fillRef idx="0">
+            <a:schemeClr val="accent1"/>
+          </a:fillRef>
+          <a:effectRef idx="1">
+            <a:schemeClr val="accent1"/>
+          </a:effectRef>
+          <a:fontRef idx="minor">
+            <a:schemeClr val="tx1"/>
+          </a:fontRef>
+        </p:style>
+      </p:cxnSp>
+      <p:cxnSp>
+        <p:nvCxnSpPr>
+          <p:cNvPr id="54" name="Gerader Verbinder 53">
+            <a:extLst>
+              <a:ext uri="{FF2B5EF4-FFF2-40B4-BE49-F238E27FC236}">
+                <a16:creationId xmlns:a16="http://schemas.microsoft.com/office/drawing/2014/main" id="{48176325-072D-8C14-DCE1-A505285255AF}"/>
+              </a:ext>
+            </a:extLst>
+          </p:cNvPr>
+          <p:cNvCxnSpPr>
+            <a:cxnSpLocks/>
+          </p:cNvCxnSpPr>
+          <p:nvPr/>
+        </p:nvCxnSpPr>
+        <p:spPr>
+          <a:xfrm>
+            <a:off x="871538" y="2351007"/>
+            <a:ext cx="707231" cy="0"/>
+          </a:xfrm>
+          <a:prstGeom prst="line">
+            <a:avLst/>
+          </a:prstGeom>
+          <a:ln w="19050" cap="rnd">
+            <a:solidFill>
+              <a:srgbClr val="129F57"/>
+            </a:solidFill>
+            <a:round/>
+            <a:headEnd type="none"/>
+            <a:tailEnd type="none" w="med" len="med"/>
+          </a:ln>
+        </p:spPr>
+        <p:style>
+          <a:lnRef idx="2">
+            <a:schemeClr val="accent1"/>
+          </a:lnRef>
+          <a:fillRef idx="0">
+            <a:schemeClr val="accent1"/>
+          </a:fillRef>
+          <a:effectRef idx="1">
+            <a:schemeClr val="accent1"/>
+          </a:effectRef>
+          <a:fontRef idx="minor">
+            <a:schemeClr val="tx1"/>
+          </a:fontRef>
+        </p:style>
+      </p:cxnSp>
+      <p:sp>
+        <p:nvSpPr>
+          <p:cNvPr id="40" name="Bogen 39">
+            <a:extLst>
+              <a:ext uri="{FF2B5EF4-FFF2-40B4-BE49-F238E27FC236}">
+                <a16:creationId xmlns:a16="http://schemas.microsoft.com/office/drawing/2014/main" id="{63779C0E-8A0B-6911-7CB9-2BE8535F563D}"/>
+              </a:ext>
+            </a:extLst>
+          </p:cNvPr>
+          <p:cNvSpPr/>
+          <p:nvPr/>
+        </p:nvSpPr>
+        <p:spPr>
+          <a:xfrm>
+            <a:off x="1350662" y="1892599"/>
+            <a:ext cx="458408" cy="458408"/>
+          </a:xfrm>
+          <a:prstGeom prst="arc">
+            <a:avLst>
+              <a:gd name="adj1" fmla="val 1702990"/>
+              <a:gd name="adj2" fmla="val 9095753"/>
+            </a:avLst>
+          </a:prstGeom>
+          <a:ln w="25400" cap="rnd">
+            <a:solidFill>
+              <a:schemeClr val="tx1">
+                <a:lumMod val="50000"/>
+                <a:lumOff val="50000"/>
+              </a:schemeClr>
+            </a:solidFill>
+            <a:round/>
+          </a:ln>
+        </p:spPr>
+        <p:style>
+          <a:lnRef idx="2">
+            <a:schemeClr val="accent1"/>
+          </a:lnRef>
+          <a:fillRef idx="0">
+            <a:schemeClr val="accent1"/>
+          </a:fillRef>
+          <a:effectRef idx="1">
+            <a:schemeClr val="accent1"/>
+          </a:effectRef>
+          <a:fontRef idx="minor">
+            <a:schemeClr val="tx1"/>
+          </a:fontRef>
+        </p:style>
+        <p:txBody>
+          <a:bodyPr rtlCol="0" anchor="ctr"/>
+          <a:lstStyle/>
+          <a:p>
+            <a:pPr algn="ctr"/>
+            <a:endParaRPr lang="de-DE"/>
+          </a:p>
+        </p:txBody>
+      </p:sp>
+      <p:cxnSp>
+        <p:nvCxnSpPr>
+          <p:cNvPr id="42" name="Gerader Verbinder 41">
+            <a:extLst>
+              <a:ext uri="{FF2B5EF4-FFF2-40B4-BE49-F238E27FC236}">
+                <a16:creationId xmlns:a16="http://schemas.microsoft.com/office/drawing/2014/main" id="{3D8C3FA1-9986-F923-AD94-D25533B59BBF}"/>
+              </a:ext>
+            </a:extLst>
+          </p:cNvPr>
+          <p:cNvCxnSpPr>
+            <a:cxnSpLocks/>
+          </p:cNvCxnSpPr>
+          <p:nvPr/>
+        </p:nvCxnSpPr>
+        <p:spPr>
+          <a:xfrm flipH="1">
+            <a:off x="464344" y="1299186"/>
+            <a:ext cx="1889522" cy="0"/>
+          </a:xfrm>
+          <a:prstGeom prst="line">
+            <a:avLst/>
+          </a:prstGeom>
+          <a:ln w="19050" cap="rnd">
+            <a:solidFill>
+              <a:schemeClr val="tx1"/>
+            </a:solidFill>
+            <a:round/>
+          </a:ln>
+        </p:spPr>
+        <p:style>
+          <a:lnRef idx="2">
+            <a:schemeClr val="accent1"/>
+          </a:lnRef>
+          <a:fillRef idx="0">
+            <a:schemeClr val="accent1"/>
+          </a:fillRef>
+          <a:effectRef idx="1">
+            <a:schemeClr val="accent1"/>
+          </a:effectRef>
+          <a:fontRef idx="minor">
+            <a:schemeClr val="tx1"/>
+          </a:fontRef>
+        </p:style>
+      </p:cxnSp>
+      <p:cxnSp>
+        <p:nvCxnSpPr>
+          <p:cNvPr id="38" name="Gerader Verbinder 37">
+            <a:extLst>
+              <a:ext uri="{FF2B5EF4-FFF2-40B4-BE49-F238E27FC236}">
+                <a16:creationId xmlns:a16="http://schemas.microsoft.com/office/drawing/2014/main" id="{E0FAF1BD-CFD3-1962-B4E0-F89200F8836C}"/>
+              </a:ext>
+            </a:extLst>
+          </p:cNvPr>
+          <p:cNvCxnSpPr>
+            <a:cxnSpLocks/>
+          </p:cNvCxnSpPr>
+          <p:nvPr/>
+        </p:nvCxnSpPr>
+        <p:spPr>
+          <a:xfrm flipH="1">
+            <a:off x="2326278" y="1299265"/>
+            <a:ext cx="333790" cy="0"/>
+          </a:xfrm>
+          <a:prstGeom prst="line">
+            <a:avLst/>
+          </a:prstGeom>
+          <a:ln w="25400" cap="rnd">
+            <a:solidFill>
+              <a:schemeClr val="tx1">
+                <a:lumMod val="50000"/>
+                <a:lumOff val="50000"/>
+              </a:schemeClr>
+            </a:solidFill>
+            <a:round/>
+          </a:ln>
+        </p:spPr>
+        <p:style>
+          <a:lnRef idx="2">
+            <a:schemeClr val="accent1"/>
+          </a:lnRef>
+          <a:fillRef idx="0">
+            <a:schemeClr val="accent1"/>
+          </a:fillRef>
+          <a:effectRef idx="1">
+            <a:schemeClr val="accent1"/>
+          </a:effectRef>
+          <a:fontRef idx="minor">
+            <a:schemeClr val="tx1"/>
+          </a:fontRef>
+        </p:style>
+      </p:cxnSp>
+      <p:cxnSp>
+        <p:nvCxnSpPr>
+          <p:cNvPr id="31" name="Gerader Verbinder 30">
+            <a:extLst>
+              <a:ext uri="{FF2B5EF4-FFF2-40B4-BE49-F238E27FC236}">
+                <a16:creationId xmlns:a16="http://schemas.microsoft.com/office/drawing/2014/main" id="{30F8BD50-2FDD-CED7-E5E6-AB541FA02ACD}"/>
+              </a:ext>
+            </a:extLst>
+          </p:cNvPr>
+          <p:cNvCxnSpPr>
+            <a:cxnSpLocks/>
+          </p:cNvCxnSpPr>
+          <p:nvPr/>
+        </p:nvCxnSpPr>
+        <p:spPr>
+          <a:xfrm flipH="1">
+            <a:off x="1776543" y="1299265"/>
+            <a:ext cx="542152" cy="939034"/>
+          </a:xfrm>
+          <a:prstGeom prst="line">
+            <a:avLst/>
+          </a:prstGeom>
+          <a:ln w="25400" cap="rnd">
+            <a:solidFill>
+              <a:schemeClr val="tx1">
+                <a:lumMod val="50000"/>
+                <a:lumOff val="50000"/>
+              </a:schemeClr>
+            </a:solidFill>
+            <a:round/>
+          </a:ln>
+        </p:spPr>
+        <p:style>
+          <a:lnRef idx="2">
+            <a:schemeClr val="accent1"/>
+          </a:lnRef>
+          <a:fillRef idx="0">
+            <a:schemeClr val="accent1"/>
+          </a:fillRef>
+          <a:effectRef idx="1">
+            <a:schemeClr val="accent1"/>
+          </a:effectRef>
+          <a:fontRef idx="minor">
+            <a:schemeClr val="tx1"/>
+          </a:fontRef>
+        </p:style>
+      </p:cxnSp>
+      <p:sp>
+        <p:nvSpPr>
+          <p:cNvPr id="69" name="Bogen 68">
+            <a:extLst>
+              <a:ext uri="{FF2B5EF4-FFF2-40B4-BE49-F238E27FC236}">
+                <a16:creationId xmlns:a16="http://schemas.microsoft.com/office/drawing/2014/main" id="{83938D83-386C-6130-3C04-83D6A5E0A15C}"/>
+              </a:ext>
+            </a:extLst>
+          </p:cNvPr>
+          <p:cNvSpPr/>
+          <p:nvPr/>
+        </p:nvSpPr>
+        <p:spPr>
+          <a:xfrm>
+            <a:off x="1943100" y="522025"/>
+            <a:ext cx="1097280" cy="1097280"/>
+          </a:xfrm>
+          <a:prstGeom prst="arc">
+            <a:avLst>
+              <a:gd name="adj1" fmla="val 3444594"/>
+              <a:gd name="adj2" fmla="val 7362056"/>
+            </a:avLst>
+          </a:prstGeom>
+          <a:ln w="19050" cap="rnd">
+            <a:solidFill>
+              <a:schemeClr val="accent5">
+                <a:lumMod val="75000"/>
+              </a:schemeClr>
+            </a:solidFill>
+            <a:round/>
+            <a:headEnd type="triangle"/>
+            <a:tailEnd type="triangle"/>
+          </a:ln>
+        </p:spPr>
+        <p:style>
+          <a:lnRef idx="2">
+            <a:schemeClr val="accent1"/>
+          </a:lnRef>
+          <a:fillRef idx="0">
+            <a:schemeClr val="accent1"/>
+          </a:fillRef>
+          <a:effectRef idx="1">
+            <a:schemeClr val="accent1"/>
+          </a:effectRef>
+          <a:fontRef idx="minor">
+            <a:schemeClr val="tx1"/>
+          </a:fontRef>
+        </p:style>
+        <p:txBody>
+          <a:bodyPr rtlCol="0" anchor="ctr"/>
+          <a:lstStyle/>
+          <a:p>
+            <a:pPr algn="ctr"/>
+            <a:endParaRPr lang="de-DE"/>
+          </a:p>
+        </p:txBody>
+      </p:sp>
+      <p:sp>
+        <p:nvSpPr>
+          <p:cNvPr id="71" name="Textfeld 70">
+            <a:extLst>
+              <a:ext uri="{FF2B5EF4-FFF2-40B4-BE49-F238E27FC236}">
+                <a16:creationId xmlns:a16="http://schemas.microsoft.com/office/drawing/2014/main" id="{227C6A32-67F6-767E-1D8B-39F2FAB97710}"/>
+              </a:ext>
+            </a:extLst>
+          </p:cNvPr>
+          <p:cNvSpPr txBox="1"/>
+          <p:nvPr/>
+        </p:nvSpPr>
+        <p:spPr>
+          <a:xfrm>
+            <a:off x="2251263" y="1294728"/>
+            <a:ext cx="542152" cy="338554"/>
+          </a:xfrm>
+          <a:prstGeom prst="rect">
+            <a:avLst/>
+          </a:prstGeom>
+          <a:noFill/>
+        </p:spPr>
+        <p:txBody>
+          <a:bodyPr wrap="square" rtlCol="0" anchor="ctr">
+            <a:spAutoFit/>
+          </a:bodyPr>
+          <a:lstStyle/>
+          <a:p>
+            <a:pPr algn="ctr"/>
+            <a:r>
+              <a:rPr lang="de-DE" sz="1600" dirty="0">
+                <a:solidFill>
+                  <a:schemeClr val="accent5">
+                    <a:lumMod val="75000"/>
+                  </a:schemeClr>
+                </a:solidFill>
+                <a:latin typeface="CMU Serif" panose="02000603000000000000" pitchFamily="2" charset="0"/>
+                <a:ea typeface="CMU Serif" panose="02000603000000000000" pitchFamily="2" charset="0"/>
+                <a:cs typeface="CMU Serif" panose="02000603000000000000" pitchFamily="2" charset="0"/>
+              </a:rPr>
+              <a:t>60°</a:t>
+            </a:r>
+          </a:p>
+        </p:txBody>
+      </p:sp>
+      <p:sp>
+        <p:nvSpPr>
+          <p:cNvPr id="73" name="Textfeld 72">
+            <a:extLst>
+              <a:ext uri="{FF2B5EF4-FFF2-40B4-BE49-F238E27FC236}">
+                <a16:creationId xmlns:a16="http://schemas.microsoft.com/office/drawing/2014/main" id="{406BE07A-AA2A-4A01-ED39-74AEF838B39D}"/>
+              </a:ext>
+            </a:extLst>
+          </p:cNvPr>
+          <p:cNvSpPr txBox="1"/>
+          <p:nvPr/>
+        </p:nvSpPr>
+        <p:spPr>
+          <a:xfrm>
+            <a:off x="1271032" y="814443"/>
+            <a:ext cx="936022" cy="338554"/>
+          </a:xfrm>
+          <a:prstGeom prst="rect">
+            <a:avLst/>
+          </a:prstGeom>
+          <a:noFill/>
+        </p:spPr>
+        <p:txBody>
+          <a:bodyPr wrap="square" rtlCol="0" anchor="ctr">
+            <a:spAutoFit/>
+          </a:bodyPr>
+          <a:lstStyle/>
+          <a:p>
+            <a:pPr algn="ctr"/>
+            <a:r>
+              <a:rPr lang="de-DE" sz="1600" dirty="0">
+                <a:solidFill>
+                  <a:schemeClr val="bg1"/>
+                </a:solidFill>
+                <a:latin typeface="CMU Serif" panose="02000603000000000000" pitchFamily="2" charset="0"/>
+                <a:ea typeface="CMU Serif" panose="02000603000000000000" pitchFamily="2" charset="0"/>
+                <a:cs typeface="CMU Serif" panose="02000603000000000000" pitchFamily="2" charset="0"/>
+              </a:rPr>
+              <a:t>Mutter</a:t>
+            </a:r>
+          </a:p>
+        </p:txBody>
+      </p:sp>
+      <p:sp>
+        <p:nvSpPr>
+          <p:cNvPr id="75" name="Textfeld 74">
+            <a:extLst>
+              <a:ext uri="{FF2B5EF4-FFF2-40B4-BE49-F238E27FC236}">
+                <a16:creationId xmlns:a16="http://schemas.microsoft.com/office/drawing/2014/main" id="{637D8646-A935-83C2-6161-58DB3B85D5D9}"/>
+              </a:ext>
+            </a:extLst>
+          </p:cNvPr>
+          <p:cNvSpPr txBox="1"/>
+          <p:nvPr/>
+        </p:nvSpPr>
+        <p:spPr>
+          <a:xfrm>
+            <a:off x="1830705" y="2264307"/>
+            <a:ext cx="1062272" cy="338554"/>
+          </a:xfrm>
+          <a:prstGeom prst="rect">
+            <a:avLst/>
+          </a:prstGeom>
+          <a:noFill/>
+        </p:spPr>
+        <p:txBody>
+          <a:bodyPr wrap="square" rtlCol="0" anchor="ctr">
+            <a:spAutoFit/>
+          </a:bodyPr>
+          <a:lstStyle/>
+          <a:p>
+            <a:pPr algn="ctr"/>
+            <a:r>
+              <a:rPr lang="de-DE" sz="1600" dirty="0">
+                <a:latin typeface="CMU Serif" panose="02000603000000000000" pitchFamily="2" charset="0"/>
+                <a:ea typeface="CMU Serif" panose="02000603000000000000" pitchFamily="2" charset="0"/>
+                <a:cs typeface="CMU Serif" panose="02000603000000000000" pitchFamily="2" charset="0"/>
+              </a:rPr>
+              <a:t>Schraube</a:t>
+            </a:r>
+          </a:p>
+        </p:txBody>
+      </p:sp>
+      <p:sp>
+        <p:nvSpPr>
+          <p:cNvPr id="77" name="Rechteck 76">
+            <a:extLst>
+              <a:ext uri="{FF2B5EF4-FFF2-40B4-BE49-F238E27FC236}">
+                <a16:creationId xmlns:a16="http://schemas.microsoft.com/office/drawing/2014/main" id="{C8EC96EF-A4F1-5933-9BD7-17B0BDB79FDE}"/>
+              </a:ext>
+            </a:extLst>
+          </p:cNvPr>
+          <p:cNvSpPr/>
+          <p:nvPr/>
+        </p:nvSpPr>
+        <p:spPr>
+          <a:xfrm rot="16200000">
+            <a:off x="1727587" y="1231094"/>
+            <a:ext cx="210739" cy="3092075"/>
+          </a:xfrm>
+          <a:prstGeom prst="rect">
+            <a:avLst/>
+          </a:prstGeom>
+          <a:gradFill>
+            <a:gsLst>
+              <a:gs pos="50000">
+                <a:schemeClr val="bg1"/>
+              </a:gs>
+              <a:gs pos="100000">
+                <a:schemeClr val="bg1">
+                  <a:alpha val="0"/>
+                </a:schemeClr>
+              </a:gs>
+            </a:gsLst>
+            <a:lin ang="0" scaled="0"/>
+          </a:gradFill>
+          <a:ln>
+            <a:noFill/>
+          </a:ln>
+        </p:spPr>
+        <p:style>
+          <a:lnRef idx="2">
+            <a:schemeClr val="accent1">
+              <a:shade val="15000"/>
+            </a:schemeClr>
+          </a:lnRef>
+          <a:fillRef idx="1">
+            <a:schemeClr val="accent1"/>
+          </a:fillRef>
+          <a:effectRef idx="0">
+            <a:schemeClr val="accent1"/>
+          </a:effectRef>
+          <a:fontRef idx="minor">
+            <a:schemeClr val="lt1"/>
+          </a:fontRef>
+        </p:style>
+        <p:txBody>
+          <a:bodyPr rtlCol="0" anchor="ctr"/>
+          <a:lstStyle/>
+          <a:p>
+            <a:pPr algn="ctr"/>
+            <a:endParaRPr lang="de-DE"/>
+          </a:p>
+        </p:txBody>
+      </p:sp>
+      <p:sp>
+        <p:nvSpPr>
+          <p:cNvPr id="62" name="Textfeld 61">
+            <a:extLst>
+              <a:ext uri="{FF2B5EF4-FFF2-40B4-BE49-F238E27FC236}">
+                <a16:creationId xmlns:a16="http://schemas.microsoft.com/office/drawing/2014/main" id="{1561EB07-B67D-7CB8-D5AD-EE55718FD0EF}"/>
+              </a:ext>
+            </a:extLst>
+          </p:cNvPr>
+          <p:cNvSpPr txBox="1"/>
+          <p:nvPr/>
+        </p:nvSpPr>
+        <p:spPr>
+          <a:xfrm>
+            <a:off x="293783" y="1854883"/>
+            <a:ext cx="220157" cy="338554"/>
+          </a:xfrm>
+          <a:prstGeom prst="rect">
+            <a:avLst/>
+          </a:prstGeom>
+          <a:noFill/>
+        </p:spPr>
+        <p:txBody>
+          <a:bodyPr wrap="square" rtlCol="0" anchor="ctr">
+            <a:spAutoFit/>
+          </a:bodyPr>
+          <a:lstStyle/>
+          <a:p>
+            <a:pPr algn="ctr"/>
+            <a:r>
+              <a:rPr lang="de-DE" sz="1600" i="1" dirty="0">
+                <a:latin typeface="CMU Serif" panose="02000603000000000000" pitchFamily="2" charset="0"/>
+                <a:ea typeface="CMU Serif" panose="02000603000000000000" pitchFamily="2" charset="0"/>
+                <a:cs typeface="CMU Serif" panose="02000603000000000000" pitchFamily="2" charset="0"/>
+              </a:rPr>
+              <a:t>d</a:t>
+            </a:r>
+          </a:p>
+        </p:txBody>
+      </p:sp>
+      <p:sp>
+        <p:nvSpPr>
+          <p:cNvPr id="64" name="Textfeld 63">
+            <a:extLst>
+              <a:ext uri="{FF2B5EF4-FFF2-40B4-BE49-F238E27FC236}">
+                <a16:creationId xmlns:a16="http://schemas.microsoft.com/office/drawing/2014/main" id="{5AE8FFFC-09F5-EE07-4FA7-63DFB991AA5B}"/>
+              </a:ext>
+            </a:extLst>
+          </p:cNvPr>
+          <p:cNvSpPr txBox="1"/>
+          <p:nvPr/>
+        </p:nvSpPr>
+        <p:spPr>
+          <a:xfrm>
+            <a:off x="596096" y="2392550"/>
+            <a:ext cx="357620" cy="338554"/>
+          </a:xfrm>
+          <a:prstGeom prst="rect">
+            <a:avLst/>
+          </a:prstGeom>
+          <a:noFill/>
+        </p:spPr>
+        <p:txBody>
+          <a:bodyPr wrap="square" rtlCol="0" anchor="ctr">
+            <a:spAutoFit/>
+          </a:bodyPr>
+          <a:lstStyle/>
+          <a:p>
+            <a:pPr algn="ctr"/>
+            <a:r>
+              <a:rPr lang="de-DE" sz="1600" i="1" dirty="0">
+                <a:solidFill>
+                  <a:srgbClr val="129F57"/>
+                </a:solidFill>
+                <a:latin typeface="CMU Serif" panose="02000603000000000000" pitchFamily="2" charset="0"/>
+                <a:ea typeface="CMU Serif" panose="02000603000000000000" pitchFamily="2" charset="0"/>
+                <a:cs typeface="CMU Serif" panose="02000603000000000000" pitchFamily="2" charset="0"/>
+              </a:rPr>
+              <a:t>d</a:t>
+            </a:r>
+            <a:r>
+              <a:rPr lang="de-DE" sz="1600" baseline="-25000" dirty="0">
+                <a:solidFill>
+                  <a:srgbClr val="129F57"/>
+                </a:solidFill>
+                <a:latin typeface="CMU Serif" panose="02000603000000000000" pitchFamily="2" charset="0"/>
+                <a:ea typeface="CMU Serif" panose="02000603000000000000" pitchFamily="2" charset="0"/>
+                <a:cs typeface="CMU Serif" panose="02000603000000000000" pitchFamily="2" charset="0"/>
+              </a:rPr>
+              <a:t>3</a:t>
+            </a:r>
+          </a:p>
+        </p:txBody>
+      </p:sp>
+      <p:cxnSp>
+        <p:nvCxnSpPr>
+          <p:cNvPr id="80" name="Gerader Verbinder 79">
+            <a:extLst>
+              <a:ext uri="{FF2B5EF4-FFF2-40B4-BE49-F238E27FC236}">
+                <a16:creationId xmlns:a16="http://schemas.microsoft.com/office/drawing/2014/main" id="{BA97D623-D15D-46D0-E160-8D188240D0F0}"/>
+              </a:ext>
+            </a:extLst>
+          </p:cNvPr>
+          <p:cNvCxnSpPr>
+            <a:cxnSpLocks/>
+          </p:cNvCxnSpPr>
+          <p:nvPr/>
+        </p:nvCxnSpPr>
+        <p:spPr>
+          <a:xfrm flipH="1">
+            <a:off x="914400" y="1768782"/>
+            <a:ext cx="2164557" cy="0"/>
+          </a:xfrm>
+          <a:prstGeom prst="line">
+            <a:avLst/>
+          </a:prstGeom>
+          <a:ln w="12700" cap="rnd">
+            <a:solidFill>
+              <a:srgbClr val="086FBD"/>
+            </a:solidFill>
+            <a:prstDash val="lgDashDot"/>
+            <a:round/>
+          </a:ln>
+        </p:spPr>
+        <p:style>
+          <a:lnRef idx="2">
+            <a:schemeClr val="accent1"/>
+          </a:lnRef>
+          <a:fillRef idx="0">
+            <a:schemeClr val="accent1"/>
+          </a:fillRef>
+          <a:effectRef idx="1">
+            <a:schemeClr val="accent1"/>
+          </a:effectRef>
+          <a:fontRef idx="minor">
+            <a:schemeClr val="tx1"/>
+          </a:fontRef>
+        </p:style>
+      </p:cxnSp>
+      <p:sp>
+        <p:nvSpPr>
+          <p:cNvPr id="86" name="Textfeld 85">
+            <a:extLst>
+              <a:ext uri="{FF2B5EF4-FFF2-40B4-BE49-F238E27FC236}">
+                <a16:creationId xmlns:a16="http://schemas.microsoft.com/office/drawing/2014/main" id="{EFEF53EA-4794-3F70-7C46-8456415EBA8C}"/>
+              </a:ext>
+            </a:extLst>
+          </p:cNvPr>
+          <p:cNvSpPr txBox="1"/>
+          <p:nvPr/>
+        </p:nvSpPr>
+        <p:spPr>
+          <a:xfrm>
+            <a:off x="2981840" y="2124044"/>
+            <a:ext cx="357620" cy="338554"/>
+          </a:xfrm>
+          <a:prstGeom prst="rect">
+            <a:avLst/>
+          </a:prstGeom>
+          <a:noFill/>
+        </p:spPr>
+        <p:txBody>
+          <a:bodyPr wrap="square" rtlCol="0" anchor="ctr">
+            <a:spAutoFit/>
+          </a:bodyPr>
+          <a:lstStyle/>
+          <a:p>
+            <a:pPr algn="ctr"/>
+            <a:r>
+              <a:rPr lang="de-DE" sz="1600" i="1" dirty="0">
+                <a:solidFill>
+                  <a:srgbClr val="086FBD"/>
+                </a:solidFill>
+                <a:latin typeface="CMU Serif" panose="02000603000000000000" pitchFamily="2" charset="0"/>
+                <a:ea typeface="CMU Serif" panose="02000603000000000000" pitchFamily="2" charset="0"/>
+                <a:cs typeface="CMU Serif" panose="02000603000000000000" pitchFamily="2" charset="0"/>
+              </a:rPr>
+              <a:t>d</a:t>
+            </a:r>
+            <a:r>
+              <a:rPr lang="de-DE" sz="1600" baseline="-25000" dirty="0">
+                <a:solidFill>
+                  <a:srgbClr val="086FBD"/>
+                </a:solidFill>
+                <a:latin typeface="CMU Serif" panose="02000603000000000000" pitchFamily="2" charset="0"/>
+                <a:ea typeface="CMU Serif" panose="02000603000000000000" pitchFamily="2" charset="0"/>
+                <a:cs typeface="CMU Serif" panose="02000603000000000000" pitchFamily="2" charset="0"/>
+              </a:rPr>
+              <a:t>2</a:t>
+            </a:r>
+          </a:p>
+        </p:txBody>
+      </p:sp>
     </p:spTree>
     <p:extLst>
       <p:ext uri="{BB962C8B-B14F-4D97-AF65-F5344CB8AC3E}">

</xml_diff>

<commit_message>
added the first detailed screw case image
</commit_message>
<xml_diff>
--- a/LaTeX B.Sc. LRT/Konstruktionslehre 1&2/images/KE-Images.pptx
+++ b/LaTeX B.Sc. LRT/Konstruktionslehre 1&2/images/KE-Images.pptx
@@ -13,11 +13,13 @@
     <p:sldId id="260" r:id="rId7"/>
     <p:sldId id="264" r:id="rId8"/>
     <p:sldId id="263" r:id="rId9"/>
-    <p:sldId id="265" r:id="rId10"/>
-    <p:sldId id="266" r:id="rId11"/>
-    <p:sldId id="268" r:id="rId12"/>
-    <p:sldId id="267" r:id="rId13"/>
-    <p:sldId id="262" r:id="rId14"/>
+    <p:sldId id="269" r:id="rId10"/>
+    <p:sldId id="270" r:id="rId11"/>
+    <p:sldId id="265" r:id="rId12"/>
+    <p:sldId id="266" r:id="rId13"/>
+    <p:sldId id="268" r:id="rId14"/>
+    <p:sldId id="267" r:id="rId15"/>
+    <p:sldId id="262" r:id="rId16"/>
   </p:sldIdLst>
   <p:sldSz cx="3600450" cy="3600450"/>
   <p:notesSz cx="6858000" cy="9144000"/>
@@ -4116,6 +4118,1598 @@
         <p:cNvPr id="1" name="">
           <a:extLst>
             <a:ext uri="{FF2B5EF4-FFF2-40B4-BE49-F238E27FC236}">
+              <a16:creationId xmlns:a16="http://schemas.microsoft.com/office/drawing/2014/main" id="{1F9182D3-A7B3-D870-3FDF-692324BE56A1}"/>
+            </a:ext>
+          </a:extLst>
+        </p:cNvPr>
+        <p:cNvGrpSpPr/>
+        <p:nvPr/>
+      </p:nvGrpSpPr>
+      <p:grpSpPr>
+        <a:xfrm>
+          <a:off x="0" y="0"/>
+          <a:ext cx="0" cy="0"/>
+          <a:chOff x="0" y="0"/>
+          <a:chExt cx="0" cy="0"/>
+        </a:xfrm>
+      </p:grpSpPr>
+    </p:spTree>
+    <p:extLst>
+      <p:ext uri="{BB962C8B-B14F-4D97-AF65-F5344CB8AC3E}">
+        <p14:creationId xmlns:p14="http://schemas.microsoft.com/office/powerpoint/2010/main" val="1677922483"/>
+      </p:ext>
+    </p:extLst>
+  </p:cSld>
+  <p:clrMapOvr>
+    <a:masterClrMapping/>
+  </p:clrMapOvr>
+</p:sld>
+</file>
+
+<file path=ppt/slides/slide11.xml><?xml version="1.0" encoding="utf-8"?>
+<p:sld xmlns:a="http://schemas.openxmlformats.org/drawingml/2006/main" xmlns:r="http://schemas.openxmlformats.org/officeDocument/2006/relationships" xmlns:p="http://schemas.openxmlformats.org/presentationml/2006/main">
+  <p:cSld>
+    <p:spTree>
+      <p:nvGrpSpPr>
+        <p:cNvPr id="1" name="">
+          <a:extLst>
+            <a:ext uri="{FF2B5EF4-FFF2-40B4-BE49-F238E27FC236}">
+              <a16:creationId xmlns:a16="http://schemas.microsoft.com/office/drawing/2014/main" id="{53CD3648-99FD-DF6F-11C6-F125396BDC19}"/>
+            </a:ext>
+          </a:extLst>
+        </p:cNvPr>
+        <p:cNvGrpSpPr/>
+        <p:nvPr/>
+      </p:nvGrpSpPr>
+      <p:grpSpPr>
+        <a:xfrm>
+          <a:off x="0" y="0"/>
+          <a:ext cx="0" cy="0"/>
+          <a:chOff x="0" y="0"/>
+          <a:chExt cx="0" cy="0"/>
+        </a:xfrm>
+      </p:grpSpPr>
+      <p:cxnSp>
+        <p:nvCxnSpPr>
+          <p:cNvPr id="83" name="Gerader Verbinder 82">
+            <a:extLst>
+              <a:ext uri="{FF2B5EF4-FFF2-40B4-BE49-F238E27FC236}">
+                <a16:creationId xmlns:a16="http://schemas.microsoft.com/office/drawing/2014/main" id="{FFA60373-C3E4-8175-6240-0960A7F5AD82}"/>
+              </a:ext>
+            </a:extLst>
+          </p:cNvPr>
+          <p:cNvCxnSpPr>
+            <a:cxnSpLocks/>
+          </p:cNvCxnSpPr>
+          <p:nvPr/>
+        </p:nvCxnSpPr>
+        <p:spPr>
+          <a:xfrm flipV="1">
+            <a:off x="3033712" y="1768782"/>
+            <a:ext cx="0" cy="1056571"/>
+          </a:xfrm>
+          <a:prstGeom prst="line">
+            <a:avLst/>
+          </a:prstGeom>
+          <a:ln w="19050" cap="rnd">
+            <a:solidFill>
+              <a:srgbClr val="086FBD"/>
+            </a:solidFill>
+            <a:round/>
+            <a:headEnd type="none"/>
+            <a:tailEnd type="triangle" w="med" len="med"/>
+          </a:ln>
+        </p:spPr>
+        <p:style>
+          <a:lnRef idx="2">
+            <a:schemeClr val="accent1"/>
+          </a:lnRef>
+          <a:fillRef idx="0">
+            <a:schemeClr val="accent1"/>
+          </a:fillRef>
+          <a:effectRef idx="1">
+            <a:schemeClr val="accent1"/>
+          </a:effectRef>
+          <a:fontRef idx="minor">
+            <a:schemeClr val="tx1"/>
+          </a:fontRef>
+        </p:style>
+      </p:cxnSp>
+      <p:sp>
+        <p:nvSpPr>
+          <p:cNvPr id="41" name="Freihandform: Form 40">
+            <a:extLst>
+              <a:ext uri="{FF2B5EF4-FFF2-40B4-BE49-F238E27FC236}">
+                <a16:creationId xmlns:a16="http://schemas.microsoft.com/office/drawing/2014/main" id="{17D34BE9-A51C-CFBC-DACE-957F7227016C}"/>
+              </a:ext>
+            </a:extLst>
+          </p:cNvPr>
+          <p:cNvSpPr/>
+          <p:nvPr/>
+        </p:nvSpPr>
+        <p:spPr>
+          <a:xfrm>
+            <a:off x="1123474" y="1299447"/>
+            <a:ext cx="1718310" cy="1262380"/>
+          </a:xfrm>
+          <a:custGeom>
+            <a:avLst/>
+            <a:gdLst>
+              <a:gd name="csX0" fmla="*/ 0 w 1711960"/>
+              <a:gd name="csY0" fmla="*/ 508000 h 1262380"/>
+              <a:gd name="csX1" fmla="*/ 256540 w 1711960"/>
+              <a:gd name="csY1" fmla="*/ 957580 h 1262380"/>
+              <a:gd name="csX2" fmla="*/ 309880 w 1711960"/>
+              <a:gd name="csY2" fmla="*/ 1010920 h 1262380"/>
+              <a:gd name="csX3" fmla="*/ 375920 w 1711960"/>
+              <a:gd name="csY3" fmla="*/ 1041400 h 1262380"/>
+              <a:gd name="csX4" fmla="*/ 444500 w 1711960"/>
+              <a:gd name="csY4" fmla="*/ 1056640 h 1262380"/>
+              <a:gd name="csX5" fmla="*/ 525780 w 1711960"/>
+              <a:gd name="csY5" fmla="*/ 1043940 h 1262380"/>
+              <a:gd name="csX6" fmla="*/ 594360 w 1711960"/>
+              <a:gd name="csY6" fmla="*/ 1016000 h 1262380"/>
+              <a:gd name="csX7" fmla="*/ 650240 w 1711960"/>
+              <a:gd name="csY7" fmla="*/ 952500 h 1262380"/>
+              <a:gd name="csX8" fmla="*/ 716280 w 1711960"/>
+              <a:gd name="csY8" fmla="*/ 840740 h 1262380"/>
+              <a:gd name="csX9" fmla="*/ 1201420 w 1711960"/>
+              <a:gd name="csY9" fmla="*/ 2540 h 1262380"/>
+              <a:gd name="csX10" fmla="*/ 1536700 w 1711960"/>
+              <a:gd name="csY10" fmla="*/ 0 h 1262380"/>
+              <a:gd name="csX11" fmla="*/ 1711960 w 1711960"/>
+              <a:gd name="csY11" fmla="*/ 299720 h 1262380"/>
+              <a:gd name="csX12" fmla="*/ 1711960 w 1711960"/>
+              <a:gd name="csY12" fmla="*/ 1262380 h 1262380"/>
+              <a:gd name="csX13" fmla="*/ 2540 w 1711960"/>
+              <a:gd name="csY13" fmla="*/ 1262380 h 1262380"/>
+              <a:gd name="csX14" fmla="*/ 0 w 1711960"/>
+              <a:gd name="csY14" fmla="*/ 508000 h 1262380"/>
+            </a:gdLst>
+            <a:ahLst/>
+            <a:cxnLst>
+              <a:cxn ang="0">
+                <a:pos x="csX0" y="csY0"/>
+              </a:cxn>
+              <a:cxn ang="0">
+                <a:pos x="csX1" y="csY1"/>
+              </a:cxn>
+              <a:cxn ang="0">
+                <a:pos x="csX2" y="csY2"/>
+              </a:cxn>
+              <a:cxn ang="0">
+                <a:pos x="csX3" y="csY3"/>
+              </a:cxn>
+              <a:cxn ang="0">
+                <a:pos x="csX4" y="csY4"/>
+              </a:cxn>
+              <a:cxn ang="0">
+                <a:pos x="csX5" y="csY5"/>
+              </a:cxn>
+              <a:cxn ang="0">
+                <a:pos x="csX6" y="csY6"/>
+              </a:cxn>
+              <a:cxn ang="0">
+                <a:pos x="csX7" y="csY7"/>
+              </a:cxn>
+              <a:cxn ang="0">
+                <a:pos x="csX8" y="csY8"/>
+              </a:cxn>
+              <a:cxn ang="0">
+                <a:pos x="csX9" y="csY9"/>
+              </a:cxn>
+              <a:cxn ang="0">
+                <a:pos x="csX10" y="csY10"/>
+              </a:cxn>
+              <a:cxn ang="0">
+                <a:pos x="csX11" y="csY11"/>
+              </a:cxn>
+              <a:cxn ang="0">
+                <a:pos x="csX12" y="csY12"/>
+              </a:cxn>
+              <a:cxn ang="0">
+                <a:pos x="csX13" y="csY13"/>
+              </a:cxn>
+              <a:cxn ang="0">
+                <a:pos x="csX14" y="csY14"/>
+              </a:cxn>
+            </a:cxnLst>
+            <a:rect l="l" t="t" r="r" b="b"/>
+            <a:pathLst>
+              <a:path w="1711960" h="1262380">
+                <a:moveTo>
+                  <a:pt x="0" y="508000"/>
+                </a:moveTo>
+                <a:lnTo>
+                  <a:pt x="256540" y="957580"/>
+                </a:lnTo>
+                <a:lnTo>
+                  <a:pt x="309880" y="1010920"/>
+                </a:lnTo>
+                <a:lnTo>
+                  <a:pt x="375920" y="1041400"/>
+                </a:lnTo>
+                <a:lnTo>
+                  <a:pt x="444500" y="1056640"/>
+                </a:lnTo>
+                <a:lnTo>
+                  <a:pt x="525780" y="1043940"/>
+                </a:lnTo>
+                <a:lnTo>
+                  <a:pt x="594360" y="1016000"/>
+                </a:lnTo>
+                <a:lnTo>
+                  <a:pt x="650240" y="952500"/>
+                </a:lnTo>
+                <a:lnTo>
+                  <a:pt x="716280" y="840740"/>
+                </a:lnTo>
+                <a:lnTo>
+                  <a:pt x="1201420" y="2540"/>
+                </a:lnTo>
+                <a:lnTo>
+                  <a:pt x="1536700" y="0"/>
+                </a:lnTo>
+                <a:lnTo>
+                  <a:pt x="1711960" y="299720"/>
+                </a:lnTo>
+                <a:lnTo>
+                  <a:pt x="1711960" y="1262380"/>
+                </a:lnTo>
+                <a:lnTo>
+                  <a:pt x="2540" y="1262380"/>
+                </a:lnTo>
+                <a:cubicBezTo>
+                  <a:pt x="1693" y="1010920"/>
+                  <a:pt x="847" y="759460"/>
+                  <a:pt x="0" y="508000"/>
+                </a:cubicBezTo>
+                <a:close/>
+              </a:path>
+            </a:pathLst>
+          </a:custGeom>
+          <a:solidFill>
+            <a:schemeClr val="bg1">
+              <a:lumMod val="75000"/>
+            </a:schemeClr>
+          </a:solidFill>
+          <a:ln>
+            <a:noFill/>
+          </a:ln>
+        </p:spPr>
+        <p:style>
+          <a:lnRef idx="2">
+            <a:schemeClr val="accent1">
+              <a:shade val="15000"/>
+            </a:schemeClr>
+          </a:lnRef>
+          <a:fillRef idx="1">
+            <a:schemeClr val="accent1"/>
+          </a:fillRef>
+          <a:effectRef idx="0">
+            <a:schemeClr val="accent1"/>
+          </a:effectRef>
+          <a:fontRef idx="minor">
+            <a:schemeClr val="lt1"/>
+          </a:fontRef>
+        </p:style>
+        <p:txBody>
+          <a:bodyPr rtlCol="0" anchor="ctr"/>
+          <a:lstStyle/>
+          <a:p>
+            <a:pPr algn="ctr"/>
+            <a:endParaRPr lang="de-DE"/>
+          </a:p>
+        </p:txBody>
+      </p:sp>
+      <p:sp>
+        <p:nvSpPr>
+          <p:cNvPr id="28" name="Freihandform: Form 27">
+            <a:extLst>
+              <a:ext uri="{FF2B5EF4-FFF2-40B4-BE49-F238E27FC236}">
+                <a16:creationId xmlns:a16="http://schemas.microsoft.com/office/drawing/2014/main" id="{FEEE085C-6F06-1EBC-1930-EDF143B7720B}"/>
+              </a:ext>
+            </a:extLst>
+          </p:cNvPr>
+          <p:cNvSpPr/>
+          <p:nvPr/>
+        </p:nvSpPr>
+        <p:spPr>
+          <a:xfrm>
+            <a:off x="1254284" y="842247"/>
+            <a:ext cx="1579880" cy="1315720"/>
+          </a:xfrm>
+          <a:custGeom>
+            <a:avLst/>
+            <a:gdLst>
+              <a:gd name="csX0" fmla="*/ 0 w 1574800"/>
+              <a:gd name="csY0" fmla="*/ 0 h 1305560"/>
+              <a:gd name="csX1" fmla="*/ 1574800 w 1574800"/>
+              <a:gd name="csY1" fmla="*/ 0 h 1305560"/>
+              <a:gd name="csX2" fmla="*/ 1574800 w 1574800"/>
+              <a:gd name="csY2" fmla="*/ 685165 h 1305560"/>
+              <a:gd name="csX3" fmla="*/ 1374140 w 1574800"/>
+              <a:gd name="csY3" fmla="*/ 340360 h 1305560"/>
+              <a:gd name="csX4" fmla="*/ 1097280 w 1574800"/>
+              <a:gd name="csY4" fmla="*/ 340360 h 1305560"/>
+              <a:gd name="csX5" fmla="*/ 546100 w 1574800"/>
+              <a:gd name="csY5" fmla="*/ 1305560 h 1305560"/>
+              <a:gd name="csX6" fmla="*/ 111760 w 1574800"/>
+              <a:gd name="csY6" fmla="*/ 1305560 h 1305560"/>
+              <a:gd name="csX7" fmla="*/ 2540 w 1574800"/>
+              <a:gd name="csY7" fmla="*/ 1117600 h 1305560"/>
+              <a:gd name="csX8" fmla="*/ 0 w 1574800"/>
+              <a:gd name="csY8" fmla="*/ 0 h 1305560"/>
+            </a:gdLst>
+            <a:ahLst/>
+            <a:cxnLst>
+              <a:cxn ang="0">
+                <a:pos x="csX0" y="csY0"/>
+              </a:cxn>
+              <a:cxn ang="0">
+                <a:pos x="csX1" y="csY1"/>
+              </a:cxn>
+              <a:cxn ang="0">
+                <a:pos x="csX2" y="csY2"/>
+              </a:cxn>
+              <a:cxn ang="0">
+                <a:pos x="csX3" y="csY3"/>
+              </a:cxn>
+              <a:cxn ang="0">
+                <a:pos x="csX4" y="csY4"/>
+              </a:cxn>
+              <a:cxn ang="0">
+                <a:pos x="csX5" y="csY5"/>
+              </a:cxn>
+              <a:cxn ang="0">
+                <a:pos x="csX6" y="csY6"/>
+              </a:cxn>
+              <a:cxn ang="0">
+                <a:pos x="csX7" y="csY7"/>
+              </a:cxn>
+              <a:cxn ang="0">
+                <a:pos x="csX8" y="csY8"/>
+              </a:cxn>
+            </a:cxnLst>
+            <a:rect l="l" t="t" r="r" b="b"/>
+            <a:pathLst>
+              <a:path w="1574800" h="1305560">
+                <a:moveTo>
+                  <a:pt x="0" y="0"/>
+                </a:moveTo>
+                <a:lnTo>
+                  <a:pt x="1574800" y="0"/>
+                </a:lnTo>
+                <a:lnTo>
+                  <a:pt x="1574800" y="685165"/>
+                </a:lnTo>
+                <a:lnTo>
+                  <a:pt x="1374140" y="340360"/>
+                </a:lnTo>
+                <a:lnTo>
+                  <a:pt x="1097280" y="340360"/>
+                </a:lnTo>
+                <a:lnTo>
+                  <a:pt x="546100" y="1305560"/>
+                </a:lnTo>
+                <a:lnTo>
+                  <a:pt x="111760" y="1305560"/>
+                </a:lnTo>
+                <a:lnTo>
+                  <a:pt x="2540" y="1117600"/>
+                </a:lnTo>
+                <a:cubicBezTo>
+                  <a:pt x="1693" y="745067"/>
+                  <a:pt x="847" y="372533"/>
+                  <a:pt x="0" y="0"/>
+                </a:cubicBezTo>
+                <a:close/>
+              </a:path>
+            </a:pathLst>
+          </a:custGeom>
+          <a:solidFill>
+            <a:schemeClr val="bg1">
+              <a:lumMod val="50000"/>
+            </a:schemeClr>
+          </a:solidFill>
+          <a:ln>
+            <a:noFill/>
+          </a:ln>
+        </p:spPr>
+        <p:style>
+          <a:lnRef idx="2">
+            <a:schemeClr val="accent1">
+              <a:shade val="15000"/>
+            </a:schemeClr>
+          </a:lnRef>
+          <a:fillRef idx="1">
+            <a:schemeClr val="accent1"/>
+          </a:fillRef>
+          <a:effectRef idx="0">
+            <a:schemeClr val="accent1"/>
+          </a:effectRef>
+          <a:fontRef idx="minor">
+            <a:schemeClr val="lt1"/>
+          </a:fontRef>
+        </p:style>
+        <p:txBody>
+          <a:bodyPr rtlCol="0" anchor="ctr"/>
+          <a:lstStyle/>
+          <a:p>
+            <a:pPr algn="ctr"/>
+            <a:endParaRPr lang="de-DE"/>
+          </a:p>
+        </p:txBody>
+      </p:sp>
+      <p:cxnSp>
+        <p:nvCxnSpPr>
+          <p:cNvPr id="3" name="Gerader Verbinder 2">
+            <a:extLst>
+              <a:ext uri="{FF2B5EF4-FFF2-40B4-BE49-F238E27FC236}">
+                <a16:creationId xmlns:a16="http://schemas.microsoft.com/office/drawing/2014/main" id="{E1B3E2A9-E25C-B824-5F5E-00EE664F8481}"/>
+              </a:ext>
+            </a:extLst>
+          </p:cNvPr>
+          <p:cNvCxnSpPr>
+            <a:cxnSpLocks/>
+          </p:cNvCxnSpPr>
+          <p:nvPr/>
+        </p:nvCxnSpPr>
+        <p:spPr>
+          <a:xfrm>
+            <a:off x="1253728" y="853677"/>
+            <a:ext cx="0" cy="1114425"/>
+          </a:xfrm>
+          <a:prstGeom prst="line">
+            <a:avLst/>
+          </a:prstGeom>
+          <a:ln w="25400" cap="rnd">
+            <a:solidFill>
+              <a:schemeClr val="tx1">
+                <a:lumMod val="75000"/>
+                <a:lumOff val="25000"/>
+              </a:schemeClr>
+            </a:solidFill>
+            <a:round/>
+          </a:ln>
+        </p:spPr>
+        <p:style>
+          <a:lnRef idx="2">
+            <a:schemeClr val="accent1"/>
+          </a:lnRef>
+          <a:fillRef idx="0">
+            <a:schemeClr val="accent1"/>
+          </a:fillRef>
+          <a:effectRef idx="1">
+            <a:schemeClr val="accent1"/>
+          </a:effectRef>
+          <a:fontRef idx="minor">
+            <a:schemeClr val="tx1"/>
+          </a:fontRef>
+        </p:style>
+      </p:cxnSp>
+      <p:cxnSp>
+        <p:nvCxnSpPr>
+          <p:cNvPr id="18" name="Gerader Verbinder 17">
+            <a:extLst>
+              <a:ext uri="{FF2B5EF4-FFF2-40B4-BE49-F238E27FC236}">
+                <a16:creationId xmlns:a16="http://schemas.microsoft.com/office/drawing/2014/main" id="{C1A2AD43-7A9D-D0EC-5F74-D6BD6D064950}"/>
+              </a:ext>
+            </a:extLst>
+          </p:cNvPr>
+          <p:cNvCxnSpPr>
+            <a:cxnSpLocks/>
+          </p:cNvCxnSpPr>
+          <p:nvPr/>
+        </p:nvCxnSpPr>
+        <p:spPr>
+          <a:xfrm>
+            <a:off x="1253728" y="1968102"/>
+            <a:ext cx="110595" cy="191557"/>
+          </a:xfrm>
+          <a:prstGeom prst="line">
+            <a:avLst/>
+          </a:prstGeom>
+          <a:ln w="25400" cap="rnd">
+            <a:solidFill>
+              <a:schemeClr val="tx1">
+                <a:lumMod val="75000"/>
+                <a:lumOff val="25000"/>
+              </a:schemeClr>
+            </a:solidFill>
+            <a:round/>
+          </a:ln>
+        </p:spPr>
+        <p:style>
+          <a:lnRef idx="2">
+            <a:schemeClr val="accent1"/>
+          </a:lnRef>
+          <a:fillRef idx="0">
+            <a:schemeClr val="accent1"/>
+          </a:fillRef>
+          <a:effectRef idx="1">
+            <a:schemeClr val="accent1"/>
+          </a:effectRef>
+          <a:fontRef idx="minor">
+            <a:schemeClr val="tx1"/>
+          </a:fontRef>
+        </p:style>
+      </p:cxnSp>
+      <p:cxnSp>
+        <p:nvCxnSpPr>
+          <p:cNvPr id="20" name="Gerader Verbinder 19">
+            <a:extLst>
+              <a:ext uri="{FF2B5EF4-FFF2-40B4-BE49-F238E27FC236}">
+                <a16:creationId xmlns:a16="http://schemas.microsoft.com/office/drawing/2014/main" id="{3FF345EE-94E1-7CB0-7A7F-539C6E656808}"/>
+              </a:ext>
+            </a:extLst>
+          </p:cNvPr>
+          <p:cNvCxnSpPr>
+            <a:cxnSpLocks/>
+          </p:cNvCxnSpPr>
+          <p:nvPr/>
+        </p:nvCxnSpPr>
+        <p:spPr>
+          <a:xfrm flipH="1">
+            <a:off x="1364323" y="2159660"/>
+            <a:ext cx="432330" cy="0"/>
+          </a:xfrm>
+          <a:prstGeom prst="line">
+            <a:avLst/>
+          </a:prstGeom>
+          <a:ln w="25400" cap="rnd">
+            <a:solidFill>
+              <a:schemeClr val="tx1">
+                <a:lumMod val="75000"/>
+                <a:lumOff val="25000"/>
+              </a:schemeClr>
+            </a:solidFill>
+            <a:round/>
+          </a:ln>
+        </p:spPr>
+        <p:style>
+          <a:lnRef idx="2">
+            <a:schemeClr val="accent1"/>
+          </a:lnRef>
+          <a:fillRef idx="0">
+            <a:schemeClr val="accent1"/>
+          </a:fillRef>
+          <a:effectRef idx="1">
+            <a:schemeClr val="accent1"/>
+          </a:effectRef>
+          <a:fontRef idx="minor">
+            <a:schemeClr val="tx1"/>
+          </a:fontRef>
+        </p:style>
+      </p:cxnSp>
+      <p:cxnSp>
+        <p:nvCxnSpPr>
+          <p:cNvPr id="23" name="Gerader Verbinder 22">
+            <a:extLst>
+              <a:ext uri="{FF2B5EF4-FFF2-40B4-BE49-F238E27FC236}">
+                <a16:creationId xmlns:a16="http://schemas.microsoft.com/office/drawing/2014/main" id="{30F250E1-4E7A-318B-21DE-F98119F337EC}"/>
+              </a:ext>
+            </a:extLst>
+          </p:cNvPr>
+          <p:cNvCxnSpPr>
+            <a:cxnSpLocks/>
+          </p:cNvCxnSpPr>
+          <p:nvPr/>
+        </p:nvCxnSpPr>
+        <p:spPr>
+          <a:xfrm>
+            <a:off x="2625328" y="1192026"/>
+            <a:ext cx="196228" cy="339878"/>
+          </a:xfrm>
+          <a:prstGeom prst="line">
+            <a:avLst/>
+          </a:prstGeom>
+          <a:ln w="25400" cap="rnd">
+            <a:solidFill>
+              <a:schemeClr val="tx1">
+                <a:lumMod val="75000"/>
+                <a:lumOff val="25000"/>
+              </a:schemeClr>
+            </a:solidFill>
+            <a:round/>
+          </a:ln>
+        </p:spPr>
+        <p:style>
+          <a:lnRef idx="2">
+            <a:schemeClr val="accent1"/>
+          </a:lnRef>
+          <a:fillRef idx="0">
+            <a:schemeClr val="accent1"/>
+          </a:fillRef>
+          <a:effectRef idx="1">
+            <a:schemeClr val="accent1"/>
+          </a:effectRef>
+          <a:fontRef idx="minor">
+            <a:schemeClr val="tx1"/>
+          </a:fontRef>
+        </p:style>
+      </p:cxnSp>
+      <p:cxnSp>
+        <p:nvCxnSpPr>
+          <p:cNvPr id="29" name="Gerader Verbinder 28">
+            <a:extLst>
+              <a:ext uri="{FF2B5EF4-FFF2-40B4-BE49-F238E27FC236}">
+                <a16:creationId xmlns:a16="http://schemas.microsoft.com/office/drawing/2014/main" id="{10CB9BD4-5B5B-6B11-92FE-03FA64F64090}"/>
+              </a:ext>
+            </a:extLst>
+          </p:cNvPr>
+          <p:cNvCxnSpPr>
+            <a:cxnSpLocks/>
+          </p:cNvCxnSpPr>
+          <p:nvPr/>
+        </p:nvCxnSpPr>
+        <p:spPr>
+          <a:xfrm>
+            <a:off x="1134958" y="1810835"/>
+            <a:ext cx="246326" cy="426651"/>
+          </a:xfrm>
+          <a:prstGeom prst="line">
+            <a:avLst/>
+          </a:prstGeom>
+          <a:ln w="25400" cap="rnd">
+            <a:solidFill>
+              <a:schemeClr val="tx1">
+                <a:lumMod val="50000"/>
+                <a:lumOff val="50000"/>
+              </a:schemeClr>
+            </a:solidFill>
+            <a:round/>
+          </a:ln>
+        </p:spPr>
+        <p:style>
+          <a:lnRef idx="2">
+            <a:schemeClr val="accent1"/>
+          </a:lnRef>
+          <a:fillRef idx="0">
+            <a:schemeClr val="accent1"/>
+          </a:fillRef>
+          <a:effectRef idx="1">
+            <a:schemeClr val="accent1"/>
+          </a:effectRef>
+          <a:fontRef idx="minor">
+            <a:schemeClr val="tx1"/>
+          </a:fontRef>
+        </p:style>
+      </p:cxnSp>
+      <p:cxnSp>
+        <p:nvCxnSpPr>
+          <p:cNvPr id="34" name="Gerader Verbinder 33">
+            <a:extLst>
+              <a:ext uri="{FF2B5EF4-FFF2-40B4-BE49-F238E27FC236}">
+                <a16:creationId xmlns:a16="http://schemas.microsoft.com/office/drawing/2014/main" id="{2B6AE206-B998-25EF-5F9C-2AF0B0842AA6}"/>
+              </a:ext>
+            </a:extLst>
+          </p:cNvPr>
+          <p:cNvCxnSpPr>
+            <a:cxnSpLocks/>
+          </p:cNvCxnSpPr>
+          <p:nvPr/>
+        </p:nvCxnSpPr>
+        <p:spPr>
+          <a:xfrm>
+            <a:off x="2660068" y="1299265"/>
+            <a:ext cx="167282" cy="289742"/>
+          </a:xfrm>
+          <a:prstGeom prst="line">
+            <a:avLst/>
+          </a:prstGeom>
+          <a:ln w="25400" cap="rnd">
+            <a:solidFill>
+              <a:schemeClr val="tx1">
+                <a:lumMod val="50000"/>
+                <a:lumOff val="50000"/>
+              </a:schemeClr>
+            </a:solidFill>
+            <a:round/>
+          </a:ln>
+        </p:spPr>
+        <p:style>
+          <a:lnRef idx="2">
+            <a:schemeClr val="accent1"/>
+          </a:lnRef>
+          <a:fillRef idx="0">
+            <a:schemeClr val="accent1"/>
+          </a:fillRef>
+          <a:effectRef idx="1">
+            <a:schemeClr val="accent1"/>
+          </a:effectRef>
+          <a:fontRef idx="minor">
+            <a:schemeClr val="tx1"/>
+          </a:fontRef>
+        </p:style>
+      </p:cxnSp>
+      <p:cxnSp>
+        <p:nvCxnSpPr>
+          <p:cNvPr id="22" name="Gerader Verbinder 21">
+            <a:extLst>
+              <a:ext uri="{FF2B5EF4-FFF2-40B4-BE49-F238E27FC236}">
+                <a16:creationId xmlns:a16="http://schemas.microsoft.com/office/drawing/2014/main" id="{6089DF4C-8452-2402-51AA-59A54FE20195}"/>
+              </a:ext>
+            </a:extLst>
+          </p:cNvPr>
+          <p:cNvCxnSpPr>
+            <a:cxnSpLocks/>
+          </p:cNvCxnSpPr>
+          <p:nvPr/>
+        </p:nvCxnSpPr>
+        <p:spPr>
+          <a:xfrm rot="1800000">
+            <a:off x="2075259" y="1119888"/>
+            <a:ext cx="0" cy="1114425"/>
+          </a:xfrm>
+          <a:prstGeom prst="line">
+            <a:avLst/>
+          </a:prstGeom>
+          <a:ln w="25400" cap="rnd">
+            <a:solidFill>
+              <a:schemeClr val="tx1">
+                <a:lumMod val="75000"/>
+                <a:lumOff val="25000"/>
+              </a:schemeClr>
+            </a:solidFill>
+            <a:round/>
+          </a:ln>
+        </p:spPr>
+        <p:style>
+          <a:lnRef idx="2">
+            <a:schemeClr val="accent1"/>
+          </a:lnRef>
+          <a:fillRef idx="0">
+            <a:schemeClr val="accent1"/>
+          </a:fillRef>
+          <a:effectRef idx="1">
+            <a:schemeClr val="accent1"/>
+          </a:effectRef>
+          <a:fontRef idx="minor">
+            <a:schemeClr val="tx1"/>
+          </a:fontRef>
+        </p:style>
+      </p:cxnSp>
+      <p:cxnSp>
+        <p:nvCxnSpPr>
+          <p:cNvPr id="24" name="Gerader Verbinder 23">
+            <a:extLst>
+              <a:ext uri="{FF2B5EF4-FFF2-40B4-BE49-F238E27FC236}">
+                <a16:creationId xmlns:a16="http://schemas.microsoft.com/office/drawing/2014/main" id="{5D31078C-16A4-CBDA-9E46-41535DCDE69F}"/>
+              </a:ext>
+            </a:extLst>
+          </p:cNvPr>
+          <p:cNvCxnSpPr>
+            <a:cxnSpLocks/>
+          </p:cNvCxnSpPr>
+          <p:nvPr/>
+        </p:nvCxnSpPr>
+        <p:spPr>
+          <a:xfrm flipH="1">
+            <a:off x="2353866" y="1192026"/>
+            <a:ext cx="271462" cy="0"/>
+          </a:xfrm>
+          <a:prstGeom prst="line">
+            <a:avLst/>
+          </a:prstGeom>
+          <a:ln w="25400" cap="rnd">
+            <a:solidFill>
+              <a:schemeClr val="tx1">
+                <a:lumMod val="75000"/>
+                <a:lumOff val="25000"/>
+              </a:schemeClr>
+            </a:solidFill>
+            <a:round/>
+          </a:ln>
+        </p:spPr>
+        <p:style>
+          <a:lnRef idx="2">
+            <a:schemeClr val="accent1"/>
+          </a:lnRef>
+          <a:fillRef idx="0">
+            <a:schemeClr val="accent1"/>
+          </a:fillRef>
+          <a:effectRef idx="1">
+            <a:schemeClr val="accent1"/>
+          </a:effectRef>
+          <a:fontRef idx="minor">
+            <a:schemeClr val="tx1"/>
+          </a:fontRef>
+        </p:style>
+      </p:cxnSp>
+      <p:cxnSp>
+        <p:nvCxnSpPr>
+          <p:cNvPr id="47" name="Gerader Verbinder 46">
+            <a:extLst>
+              <a:ext uri="{FF2B5EF4-FFF2-40B4-BE49-F238E27FC236}">
+                <a16:creationId xmlns:a16="http://schemas.microsoft.com/office/drawing/2014/main" id="{1AB57A79-F17E-36CC-846E-BAEBB8EE38DF}"/>
+              </a:ext>
+            </a:extLst>
+          </p:cNvPr>
+          <p:cNvCxnSpPr>
+            <a:cxnSpLocks/>
+          </p:cNvCxnSpPr>
+          <p:nvPr/>
+        </p:nvCxnSpPr>
+        <p:spPr>
+          <a:xfrm flipV="1">
+            <a:off x="534591" y="1307306"/>
+            <a:ext cx="0" cy="1518047"/>
+          </a:xfrm>
+          <a:prstGeom prst="line">
+            <a:avLst/>
+          </a:prstGeom>
+          <a:ln w="19050" cap="rnd">
+            <a:solidFill>
+              <a:schemeClr val="tx1"/>
+            </a:solidFill>
+            <a:round/>
+            <a:headEnd type="none"/>
+            <a:tailEnd type="triangle" w="med" len="med"/>
+          </a:ln>
+        </p:spPr>
+        <p:style>
+          <a:lnRef idx="2">
+            <a:schemeClr val="accent1"/>
+          </a:lnRef>
+          <a:fillRef idx="0">
+            <a:schemeClr val="accent1"/>
+          </a:fillRef>
+          <a:effectRef idx="1">
+            <a:schemeClr val="accent1"/>
+          </a:effectRef>
+          <a:fontRef idx="minor">
+            <a:schemeClr val="tx1"/>
+          </a:fontRef>
+        </p:style>
+      </p:cxnSp>
+      <p:cxnSp>
+        <p:nvCxnSpPr>
+          <p:cNvPr id="50" name="Gerader Verbinder 49">
+            <a:extLst>
+              <a:ext uri="{FF2B5EF4-FFF2-40B4-BE49-F238E27FC236}">
+                <a16:creationId xmlns:a16="http://schemas.microsoft.com/office/drawing/2014/main" id="{92646F9A-D16D-32F2-BAF6-C6387CBA3DF2}"/>
+              </a:ext>
+            </a:extLst>
+          </p:cNvPr>
+          <p:cNvCxnSpPr>
+            <a:cxnSpLocks/>
+          </p:cNvCxnSpPr>
+          <p:nvPr/>
+        </p:nvCxnSpPr>
+        <p:spPr>
+          <a:xfrm flipV="1">
+            <a:off x="944169" y="2357437"/>
+            <a:ext cx="0" cy="467916"/>
+          </a:xfrm>
+          <a:prstGeom prst="line">
+            <a:avLst/>
+          </a:prstGeom>
+          <a:ln w="19050" cap="rnd">
+            <a:solidFill>
+              <a:srgbClr val="129F57"/>
+            </a:solidFill>
+            <a:round/>
+            <a:headEnd type="none"/>
+            <a:tailEnd type="triangle" w="med" len="med"/>
+          </a:ln>
+        </p:spPr>
+        <p:style>
+          <a:lnRef idx="2">
+            <a:schemeClr val="accent1"/>
+          </a:lnRef>
+          <a:fillRef idx="0">
+            <a:schemeClr val="accent1"/>
+          </a:fillRef>
+          <a:effectRef idx="1">
+            <a:schemeClr val="accent1"/>
+          </a:effectRef>
+          <a:fontRef idx="minor">
+            <a:schemeClr val="tx1"/>
+          </a:fontRef>
+        </p:style>
+      </p:cxnSp>
+      <p:cxnSp>
+        <p:nvCxnSpPr>
+          <p:cNvPr id="54" name="Gerader Verbinder 53">
+            <a:extLst>
+              <a:ext uri="{FF2B5EF4-FFF2-40B4-BE49-F238E27FC236}">
+                <a16:creationId xmlns:a16="http://schemas.microsoft.com/office/drawing/2014/main" id="{48176325-072D-8C14-DCE1-A505285255AF}"/>
+              </a:ext>
+            </a:extLst>
+          </p:cNvPr>
+          <p:cNvCxnSpPr>
+            <a:cxnSpLocks/>
+          </p:cNvCxnSpPr>
+          <p:nvPr/>
+        </p:nvCxnSpPr>
+        <p:spPr>
+          <a:xfrm>
+            <a:off x="871538" y="2351007"/>
+            <a:ext cx="707231" cy="0"/>
+          </a:xfrm>
+          <a:prstGeom prst="line">
+            <a:avLst/>
+          </a:prstGeom>
+          <a:ln w="19050" cap="rnd">
+            <a:solidFill>
+              <a:srgbClr val="129F57"/>
+            </a:solidFill>
+            <a:round/>
+            <a:headEnd type="none"/>
+            <a:tailEnd type="none" w="med" len="med"/>
+          </a:ln>
+        </p:spPr>
+        <p:style>
+          <a:lnRef idx="2">
+            <a:schemeClr val="accent1"/>
+          </a:lnRef>
+          <a:fillRef idx="0">
+            <a:schemeClr val="accent1"/>
+          </a:fillRef>
+          <a:effectRef idx="1">
+            <a:schemeClr val="accent1"/>
+          </a:effectRef>
+          <a:fontRef idx="minor">
+            <a:schemeClr val="tx1"/>
+          </a:fontRef>
+        </p:style>
+      </p:cxnSp>
+      <p:sp>
+        <p:nvSpPr>
+          <p:cNvPr id="40" name="Bogen 39">
+            <a:extLst>
+              <a:ext uri="{FF2B5EF4-FFF2-40B4-BE49-F238E27FC236}">
+                <a16:creationId xmlns:a16="http://schemas.microsoft.com/office/drawing/2014/main" id="{63779C0E-8A0B-6911-7CB9-2BE8535F563D}"/>
+              </a:ext>
+            </a:extLst>
+          </p:cNvPr>
+          <p:cNvSpPr/>
+          <p:nvPr/>
+        </p:nvSpPr>
+        <p:spPr>
+          <a:xfrm>
+            <a:off x="1350662" y="1892599"/>
+            <a:ext cx="458408" cy="458408"/>
+          </a:xfrm>
+          <a:prstGeom prst="arc">
+            <a:avLst>
+              <a:gd name="adj1" fmla="val 1702990"/>
+              <a:gd name="adj2" fmla="val 9095753"/>
+            </a:avLst>
+          </a:prstGeom>
+          <a:ln w="25400" cap="rnd">
+            <a:solidFill>
+              <a:schemeClr val="tx1">
+                <a:lumMod val="50000"/>
+                <a:lumOff val="50000"/>
+              </a:schemeClr>
+            </a:solidFill>
+            <a:round/>
+          </a:ln>
+        </p:spPr>
+        <p:style>
+          <a:lnRef idx="2">
+            <a:schemeClr val="accent1"/>
+          </a:lnRef>
+          <a:fillRef idx="0">
+            <a:schemeClr val="accent1"/>
+          </a:fillRef>
+          <a:effectRef idx="1">
+            <a:schemeClr val="accent1"/>
+          </a:effectRef>
+          <a:fontRef idx="minor">
+            <a:schemeClr val="tx1"/>
+          </a:fontRef>
+        </p:style>
+        <p:txBody>
+          <a:bodyPr rtlCol="0" anchor="ctr"/>
+          <a:lstStyle/>
+          <a:p>
+            <a:pPr algn="ctr"/>
+            <a:endParaRPr lang="de-DE"/>
+          </a:p>
+        </p:txBody>
+      </p:sp>
+      <p:cxnSp>
+        <p:nvCxnSpPr>
+          <p:cNvPr id="42" name="Gerader Verbinder 41">
+            <a:extLst>
+              <a:ext uri="{FF2B5EF4-FFF2-40B4-BE49-F238E27FC236}">
+                <a16:creationId xmlns:a16="http://schemas.microsoft.com/office/drawing/2014/main" id="{3D8C3FA1-9986-F923-AD94-D25533B59BBF}"/>
+              </a:ext>
+            </a:extLst>
+          </p:cNvPr>
+          <p:cNvCxnSpPr>
+            <a:cxnSpLocks/>
+          </p:cNvCxnSpPr>
+          <p:nvPr/>
+        </p:nvCxnSpPr>
+        <p:spPr>
+          <a:xfrm flipH="1">
+            <a:off x="464344" y="1299186"/>
+            <a:ext cx="1889522" cy="0"/>
+          </a:xfrm>
+          <a:prstGeom prst="line">
+            <a:avLst/>
+          </a:prstGeom>
+          <a:ln w="19050" cap="rnd">
+            <a:solidFill>
+              <a:schemeClr val="tx1"/>
+            </a:solidFill>
+            <a:round/>
+          </a:ln>
+        </p:spPr>
+        <p:style>
+          <a:lnRef idx="2">
+            <a:schemeClr val="accent1"/>
+          </a:lnRef>
+          <a:fillRef idx="0">
+            <a:schemeClr val="accent1"/>
+          </a:fillRef>
+          <a:effectRef idx="1">
+            <a:schemeClr val="accent1"/>
+          </a:effectRef>
+          <a:fontRef idx="minor">
+            <a:schemeClr val="tx1"/>
+          </a:fontRef>
+        </p:style>
+      </p:cxnSp>
+      <p:cxnSp>
+        <p:nvCxnSpPr>
+          <p:cNvPr id="38" name="Gerader Verbinder 37">
+            <a:extLst>
+              <a:ext uri="{FF2B5EF4-FFF2-40B4-BE49-F238E27FC236}">
+                <a16:creationId xmlns:a16="http://schemas.microsoft.com/office/drawing/2014/main" id="{E0FAF1BD-CFD3-1962-B4E0-F89200F8836C}"/>
+              </a:ext>
+            </a:extLst>
+          </p:cNvPr>
+          <p:cNvCxnSpPr>
+            <a:cxnSpLocks/>
+          </p:cNvCxnSpPr>
+          <p:nvPr/>
+        </p:nvCxnSpPr>
+        <p:spPr>
+          <a:xfrm flipH="1">
+            <a:off x="2326278" y="1299265"/>
+            <a:ext cx="333790" cy="0"/>
+          </a:xfrm>
+          <a:prstGeom prst="line">
+            <a:avLst/>
+          </a:prstGeom>
+          <a:ln w="25400" cap="rnd">
+            <a:solidFill>
+              <a:schemeClr val="tx1">
+                <a:lumMod val="50000"/>
+                <a:lumOff val="50000"/>
+              </a:schemeClr>
+            </a:solidFill>
+            <a:round/>
+          </a:ln>
+        </p:spPr>
+        <p:style>
+          <a:lnRef idx="2">
+            <a:schemeClr val="accent1"/>
+          </a:lnRef>
+          <a:fillRef idx="0">
+            <a:schemeClr val="accent1"/>
+          </a:fillRef>
+          <a:effectRef idx="1">
+            <a:schemeClr val="accent1"/>
+          </a:effectRef>
+          <a:fontRef idx="minor">
+            <a:schemeClr val="tx1"/>
+          </a:fontRef>
+        </p:style>
+      </p:cxnSp>
+      <p:cxnSp>
+        <p:nvCxnSpPr>
+          <p:cNvPr id="31" name="Gerader Verbinder 30">
+            <a:extLst>
+              <a:ext uri="{FF2B5EF4-FFF2-40B4-BE49-F238E27FC236}">
+                <a16:creationId xmlns:a16="http://schemas.microsoft.com/office/drawing/2014/main" id="{30F8BD50-2FDD-CED7-E5E6-AB541FA02ACD}"/>
+              </a:ext>
+            </a:extLst>
+          </p:cNvPr>
+          <p:cNvCxnSpPr>
+            <a:cxnSpLocks/>
+          </p:cNvCxnSpPr>
+          <p:nvPr/>
+        </p:nvCxnSpPr>
+        <p:spPr>
+          <a:xfrm flipH="1">
+            <a:off x="1776543" y="1299265"/>
+            <a:ext cx="542152" cy="939034"/>
+          </a:xfrm>
+          <a:prstGeom prst="line">
+            <a:avLst/>
+          </a:prstGeom>
+          <a:ln w="25400" cap="rnd">
+            <a:solidFill>
+              <a:schemeClr val="tx1">
+                <a:lumMod val="50000"/>
+                <a:lumOff val="50000"/>
+              </a:schemeClr>
+            </a:solidFill>
+            <a:round/>
+          </a:ln>
+        </p:spPr>
+        <p:style>
+          <a:lnRef idx="2">
+            <a:schemeClr val="accent1"/>
+          </a:lnRef>
+          <a:fillRef idx="0">
+            <a:schemeClr val="accent1"/>
+          </a:fillRef>
+          <a:effectRef idx="1">
+            <a:schemeClr val="accent1"/>
+          </a:effectRef>
+          <a:fontRef idx="minor">
+            <a:schemeClr val="tx1"/>
+          </a:fontRef>
+        </p:style>
+      </p:cxnSp>
+      <p:sp>
+        <p:nvSpPr>
+          <p:cNvPr id="69" name="Bogen 68">
+            <a:extLst>
+              <a:ext uri="{FF2B5EF4-FFF2-40B4-BE49-F238E27FC236}">
+                <a16:creationId xmlns:a16="http://schemas.microsoft.com/office/drawing/2014/main" id="{83938D83-386C-6130-3C04-83D6A5E0A15C}"/>
+              </a:ext>
+            </a:extLst>
+          </p:cNvPr>
+          <p:cNvSpPr/>
+          <p:nvPr/>
+        </p:nvSpPr>
+        <p:spPr>
+          <a:xfrm>
+            <a:off x="1943100" y="522025"/>
+            <a:ext cx="1097280" cy="1097280"/>
+          </a:xfrm>
+          <a:prstGeom prst="arc">
+            <a:avLst>
+              <a:gd name="adj1" fmla="val 3444594"/>
+              <a:gd name="adj2" fmla="val 7362056"/>
+            </a:avLst>
+          </a:prstGeom>
+          <a:ln w="19050" cap="rnd">
+            <a:solidFill>
+              <a:schemeClr val="accent5">
+                <a:lumMod val="75000"/>
+              </a:schemeClr>
+            </a:solidFill>
+            <a:round/>
+            <a:headEnd type="triangle"/>
+            <a:tailEnd type="triangle"/>
+          </a:ln>
+        </p:spPr>
+        <p:style>
+          <a:lnRef idx="2">
+            <a:schemeClr val="accent1"/>
+          </a:lnRef>
+          <a:fillRef idx="0">
+            <a:schemeClr val="accent1"/>
+          </a:fillRef>
+          <a:effectRef idx="1">
+            <a:schemeClr val="accent1"/>
+          </a:effectRef>
+          <a:fontRef idx="minor">
+            <a:schemeClr val="tx1"/>
+          </a:fontRef>
+        </p:style>
+        <p:txBody>
+          <a:bodyPr rtlCol="0" anchor="ctr"/>
+          <a:lstStyle/>
+          <a:p>
+            <a:pPr algn="ctr"/>
+            <a:endParaRPr lang="de-DE"/>
+          </a:p>
+        </p:txBody>
+      </p:sp>
+      <p:sp>
+        <p:nvSpPr>
+          <p:cNvPr id="71" name="Textfeld 70">
+            <a:extLst>
+              <a:ext uri="{FF2B5EF4-FFF2-40B4-BE49-F238E27FC236}">
+                <a16:creationId xmlns:a16="http://schemas.microsoft.com/office/drawing/2014/main" id="{227C6A32-67F6-767E-1D8B-39F2FAB97710}"/>
+              </a:ext>
+            </a:extLst>
+          </p:cNvPr>
+          <p:cNvSpPr txBox="1"/>
+          <p:nvPr/>
+        </p:nvSpPr>
+        <p:spPr>
+          <a:xfrm>
+            <a:off x="2251263" y="1294728"/>
+            <a:ext cx="542152" cy="338554"/>
+          </a:xfrm>
+          <a:prstGeom prst="rect">
+            <a:avLst/>
+          </a:prstGeom>
+          <a:noFill/>
+        </p:spPr>
+        <p:txBody>
+          <a:bodyPr wrap="square" rtlCol="0" anchor="ctr">
+            <a:spAutoFit/>
+          </a:bodyPr>
+          <a:lstStyle/>
+          <a:p>
+            <a:pPr algn="ctr"/>
+            <a:r>
+              <a:rPr lang="de-DE" sz="1600" dirty="0">
+                <a:solidFill>
+                  <a:schemeClr val="accent5">
+                    <a:lumMod val="75000"/>
+                  </a:schemeClr>
+                </a:solidFill>
+                <a:latin typeface="CMU Serif" panose="02000603000000000000" pitchFamily="2" charset="0"/>
+                <a:ea typeface="CMU Serif" panose="02000603000000000000" pitchFamily="2" charset="0"/>
+                <a:cs typeface="CMU Serif" panose="02000603000000000000" pitchFamily="2" charset="0"/>
+              </a:rPr>
+              <a:t>60°</a:t>
+            </a:r>
+          </a:p>
+        </p:txBody>
+      </p:sp>
+      <p:sp>
+        <p:nvSpPr>
+          <p:cNvPr id="73" name="Textfeld 72">
+            <a:extLst>
+              <a:ext uri="{FF2B5EF4-FFF2-40B4-BE49-F238E27FC236}">
+                <a16:creationId xmlns:a16="http://schemas.microsoft.com/office/drawing/2014/main" id="{406BE07A-AA2A-4A01-ED39-74AEF838B39D}"/>
+              </a:ext>
+            </a:extLst>
+          </p:cNvPr>
+          <p:cNvSpPr txBox="1"/>
+          <p:nvPr/>
+        </p:nvSpPr>
+        <p:spPr>
+          <a:xfrm>
+            <a:off x="1271032" y="814443"/>
+            <a:ext cx="936022" cy="338554"/>
+          </a:xfrm>
+          <a:prstGeom prst="rect">
+            <a:avLst/>
+          </a:prstGeom>
+          <a:noFill/>
+        </p:spPr>
+        <p:txBody>
+          <a:bodyPr wrap="square" rtlCol="0" anchor="ctr">
+            <a:spAutoFit/>
+          </a:bodyPr>
+          <a:lstStyle/>
+          <a:p>
+            <a:pPr algn="ctr"/>
+            <a:r>
+              <a:rPr lang="de-DE" sz="1600" dirty="0">
+                <a:solidFill>
+                  <a:schemeClr val="bg1"/>
+                </a:solidFill>
+                <a:latin typeface="CMU Serif" panose="02000603000000000000" pitchFamily="2" charset="0"/>
+                <a:ea typeface="CMU Serif" panose="02000603000000000000" pitchFamily="2" charset="0"/>
+                <a:cs typeface="CMU Serif" panose="02000603000000000000" pitchFamily="2" charset="0"/>
+              </a:rPr>
+              <a:t>Mutter</a:t>
+            </a:r>
+          </a:p>
+        </p:txBody>
+      </p:sp>
+      <p:sp>
+        <p:nvSpPr>
+          <p:cNvPr id="75" name="Textfeld 74">
+            <a:extLst>
+              <a:ext uri="{FF2B5EF4-FFF2-40B4-BE49-F238E27FC236}">
+                <a16:creationId xmlns:a16="http://schemas.microsoft.com/office/drawing/2014/main" id="{637D8646-A935-83C2-6161-58DB3B85D5D9}"/>
+              </a:ext>
+            </a:extLst>
+          </p:cNvPr>
+          <p:cNvSpPr txBox="1"/>
+          <p:nvPr/>
+        </p:nvSpPr>
+        <p:spPr>
+          <a:xfrm>
+            <a:off x="1830705" y="2264307"/>
+            <a:ext cx="1062272" cy="338554"/>
+          </a:xfrm>
+          <a:prstGeom prst="rect">
+            <a:avLst/>
+          </a:prstGeom>
+          <a:noFill/>
+        </p:spPr>
+        <p:txBody>
+          <a:bodyPr wrap="square" rtlCol="0" anchor="ctr">
+            <a:spAutoFit/>
+          </a:bodyPr>
+          <a:lstStyle/>
+          <a:p>
+            <a:pPr algn="ctr"/>
+            <a:r>
+              <a:rPr lang="de-DE" sz="1600" dirty="0">
+                <a:latin typeface="CMU Serif" panose="02000603000000000000" pitchFamily="2" charset="0"/>
+                <a:ea typeface="CMU Serif" panose="02000603000000000000" pitchFamily="2" charset="0"/>
+                <a:cs typeface="CMU Serif" panose="02000603000000000000" pitchFamily="2" charset="0"/>
+              </a:rPr>
+              <a:t>Schraube</a:t>
+            </a:r>
+          </a:p>
+        </p:txBody>
+      </p:sp>
+      <p:sp>
+        <p:nvSpPr>
+          <p:cNvPr id="77" name="Rechteck 76">
+            <a:extLst>
+              <a:ext uri="{FF2B5EF4-FFF2-40B4-BE49-F238E27FC236}">
+                <a16:creationId xmlns:a16="http://schemas.microsoft.com/office/drawing/2014/main" id="{C8EC96EF-A4F1-5933-9BD7-17B0BDB79FDE}"/>
+              </a:ext>
+            </a:extLst>
+          </p:cNvPr>
+          <p:cNvSpPr/>
+          <p:nvPr/>
+        </p:nvSpPr>
+        <p:spPr>
+          <a:xfrm rot="16200000">
+            <a:off x="1727587" y="1231094"/>
+            <a:ext cx="210739" cy="3092075"/>
+          </a:xfrm>
+          <a:prstGeom prst="rect">
+            <a:avLst/>
+          </a:prstGeom>
+          <a:gradFill>
+            <a:gsLst>
+              <a:gs pos="50000">
+                <a:schemeClr val="bg1"/>
+              </a:gs>
+              <a:gs pos="100000">
+                <a:schemeClr val="bg1">
+                  <a:alpha val="0"/>
+                </a:schemeClr>
+              </a:gs>
+            </a:gsLst>
+            <a:lin ang="0" scaled="0"/>
+          </a:gradFill>
+          <a:ln>
+            <a:noFill/>
+          </a:ln>
+        </p:spPr>
+        <p:style>
+          <a:lnRef idx="2">
+            <a:schemeClr val="accent1">
+              <a:shade val="15000"/>
+            </a:schemeClr>
+          </a:lnRef>
+          <a:fillRef idx="1">
+            <a:schemeClr val="accent1"/>
+          </a:fillRef>
+          <a:effectRef idx="0">
+            <a:schemeClr val="accent1"/>
+          </a:effectRef>
+          <a:fontRef idx="minor">
+            <a:schemeClr val="lt1"/>
+          </a:fontRef>
+        </p:style>
+        <p:txBody>
+          <a:bodyPr rtlCol="0" anchor="ctr"/>
+          <a:lstStyle/>
+          <a:p>
+            <a:pPr algn="ctr"/>
+            <a:endParaRPr lang="de-DE"/>
+          </a:p>
+        </p:txBody>
+      </p:sp>
+      <p:sp>
+        <p:nvSpPr>
+          <p:cNvPr id="62" name="Textfeld 61">
+            <a:extLst>
+              <a:ext uri="{FF2B5EF4-FFF2-40B4-BE49-F238E27FC236}">
+                <a16:creationId xmlns:a16="http://schemas.microsoft.com/office/drawing/2014/main" id="{1561EB07-B67D-7CB8-D5AD-EE55718FD0EF}"/>
+              </a:ext>
+            </a:extLst>
+          </p:cNvPr>
+          <p:cNvSpPr txBox="1"/>
+          <p:nvPr/>
+        </p:nvSpPr>
+        <p:spPr>
+          <a:xfrm>
+            <a:off x="293783" y="1854883"/>
+            <a:ext cx="220157" cy="338554"/>
+          </a:xfrm>
+          <a:prstGeom prst="rect">
+            <a:avLst/>
+          </a:prstGeom>
+          <a:noFill/>
+        </p:spPr>
+        <p:txBody>
+          <a:bodyPr wrap="square" rtlCol="0" anchor="ctr">
+            <a:spAutoFit/>
+          </a:bodyPr>
+          <a:lstStyle/>
+          <a:p>
+            <a:pPr algn="ctr"/>
+            <a:r>
+              <a:rPr lang="de-DE" sz="1600" i="1" dirty="0">
+                <a:latin typeface="CMU Serif" panose="02000603000000000000" pitchFamily="2" charset="0"/>
+                <a:ea typeface="CMU Serif" panose="02000603000000000000" pitchFamily="2" charset="0"/>
+                <a:cs typeface="CMU Serif" panose="02000603000000000000" pitchFamily="2" charset="0"/>
+              </a:rPr>
+              <a:t>d</a:t>
+            </a:r>
+          </a:p>
+        </p:txBody>
+      </p:sp>
+      <p:sp>
+        <p:nvSpPr>
+          <p:cNvPr id="64" name="Textfeld 63">
+            <a:extLst>
+              <a:ext uri="{FF2B5EF4-FFF2-40B4-BE49-F238E27FC236}">
+                <a16:creationId xmlns:a16="http://schemas.microsoft.com/office/drawing/2014/main" id="{5AE8FFFC-09F5-EE07-4FA7-63DFB991AA5B}"/>
+              </a:ext>
+            </a:extLst>
+          </p:cNvPr>
+          <p:cNvSpPr txBox="1"/>
+          <p:nvPr/>
+        </p:nvSpPr>
+        <p:spPr>
+          <a:xfrm>
+            <a:off x="596096" y="2392550"/>
+            <a:ext cx="357620" cy="338554"/>
+          </a:xfrm>
+          <a:prstGeom prst="rect">
+            <a:avLst/>
+          </a:prstGeom>
+          <a:noFill/>
+        </p:spPr>
+        <p:txBody>
+          <a:bodyPr wrap="square" rtlCol="0" anchor="ctr">
+            <a:spAutoFit/>
+          </a:bodyPr>
+          <a:lstStyle/>
+          <a:p>
+            <a:pPr algn="ctr"/>
+            <a:r>
+              <a:rPr lang="de-DE" sz="1600" i="1" dirty="0">
+                <a:solidFill>
+                  <a:srgbClr val="129F57"/>
+                </a:solidFill>
+                <a:latin typeface="CMU Serif" panose="02000603000000000000" pitchFamily="2" charset="0"/>
+                <a:ea typeface="CMU Serif" panose="02000603000000000000" pitchFamily="2" charset="0"/>
+                <a:cs typeface="CMU Serif" panose="02000603000000000000" pitchFamily="2" charset="0"/>
+              </a:rPr>
+              <a:t>d</a:t>
+            </a:r>
+            <a:r>
+              <a:rPr lang="de-DE" sz="1600" baseline="-25000" dirty="0">
+                <a:solidFill>
+                  <a:srgbClr val="129F57"/>
+                </a:solidFill>
+                <a:latin typeface="CMU Serif" panose="02000603000000000000" pitchFamily="2" charset="0"/>
+                <a:ea typeface="CMU Serif" panose="02000603000000000000" pitchFamily="2" charset="0"/>
+                <a:cs typeface="CMU Serif" panose="02000603000000000000" pitchFamily="2" charset="0"/>
+              </a:rPr>
+              <a:t>3</a:t>
+            </a:r>
+          </a:p>
+        </p:txBody>
+      </p:sp>
+      <p:cxnSp>
+        <p:nvCxnSpPr>
+          <p:cNvPr id="80" name="Gerader Verbinder 79">
+            <a:extLst>
+              <a:ext uri="{FF2B5EF4-FFF2-40B4-BE49-F238E27FC236}">
+                <a16:creationId xmlns:a16="http://schemas.microsoft.com/office/drawing/2014/main" id="{BA97D623-D15D-46D0-E160-8D188240D0F0}"/>
+              </a:ext>
+            </a:extLst>
+          </p:cNvPr>
+          <p:cNvCxnSpPr>
+            <a:cxnSpLocks/>
+          </p:cNvCxnSpPr>
+          <p:nvPr/>
+        </p:nvCxnSpPr>
+        <p:spPr>
+          <a:xfrm flipH="1">
+            <a:off x="914400" y="1768782"/>
+            <a:ext cx="2164557" cy="0"/>
+          </a:xfrm>
+          <a:prstGeom prst="line">
+            <a:avLst/>
+          </a:prstGeom>
+          <a:ln w="12700" cap="rnd">
+            <a:solidFill>
+              <a:srgbClr val="086FBD"/>
+            </a:solidFill>
+            <a:prstDash val="lgDashDot"/>
+            <a:round/>
+          </a:ln>
+        </p:spPr>
+        <p:style>
+          <a:lnRef idx="2">
+            <a:schemeClr val="accent1"/>
+          </a:lnRef>
+          <a:fillRef idx="0">
+            <a:schemeClr val="accent1"/>
+          </a:fillRef>
+          <a:effectRef idx="1">
+            <a:schemeClr val="accent1"/>
+          </a:effectRef>
+          <a:fontRef idx="minor">
+            <a:schemeClr val="tx1"/>
+          </a:fontRef>
+        </p:style>
+      </p:cxnSp>
+      <p:sp>
+        <p:nvSpPr>
+          <p:cNvPr id="86" name="Textfeld 85">
+            <a:extLst>
+              <a:ext uri="{FF2B5EF4-FFF2-40B4-BE49-F238E27FC236}">
+                <a16:creationId xmlns:a16="http://schemas.microsoft.com/office/drawing/2014/main" id="{EFEF53EA-4794-3F70-7C46-8456415EBA8C}"/>
+              </a:ext>
+            </a:extLst>
+          </p:cNvPr>
+          <p:cNvSpPr txBox="1"/>
+          <p:nvPr/>
+        </p:nvSpPr>
+        <p:spPr>
+          <a:xfrm>
+            <a:off x="2981840" y="2124044"/>
+            <a:ext cx="357620" cy="338554"/>
+          </a:xfrm>
+          <a:prstGeom prst="rect">
+            <a:avLst/>
+          </a:prstGeom>
+          <a:noFill/>
+        </p:spPr>
+        <p:txBody>
+          <a:bodyPr wrap="square" rtlCol="0" anchor="ctr">
+            <a:spAutoFit/>
+          </a:bodyPr>
+          <a:lstStyle/>
+          <a:p>
+            <a:pPr algn="ctr"/>
+            <a:r>
+              <a:rPr lang="de-DE" sz="1600" i="1" dirty="0">
+                <a:solidFill>
+                  <a:srgbClr val="086FBD"/>
+                </a:solidFill>
+                <a:latin typeface="CMU Serif" panose="02000603000000000000" pitchFamily="2" charset="0"/>
+                <a:ea typeface="CMU Serif" panose="02000603000000000000" pitchFamily="2" charset="0"/>
+                <a:cs typeface="CMU Serif" panose="02000603000000000000" pitchFamily="2" charset="0"/>
+              </a:rPr>
+              <a:t>d</a:t>
+            </a:r>
+            <a:r>
+              <a:rPr lang="de-DE" sz="1600" baseline="-25000" dirty="0">
+                <a:solidFill>
+                  <a:srgbClr val="086FBD"/>
+                </a:solidFill>
+                <a:latin typeface="CMU Serif" panose="02000603000000000000" pitchFamily="2" charset="0"/>
+                <a:ea typeface="CMU Serif" panose="02000603000000000000" pitchFamily="2" charset="0"/>
+                <a:cs typeface="CMU Serif" panose="02000603000000000000" pitchFamily="2" charset="0"/>
+              </a:rPr>
+              <a:t>2</a:t>
+            </a:r>
+          </a:p>
+        </p:txBody>
+      </p:sp>
+    </p:spTree>
+    <p:extLst>
+      <p:ext uri="{BB962C8B-B14F-4D97-AF65-F5344CB8AC3E}">
+        <p14:creationId xmlns:p14="http://schemas.microsoft.com/office/powerpoint/2010/main" val="2917571994"/>
+      </p:ext>
+    </p:extLst>
+  </p:cSld>
+  <p:clrMapOvr>
+    <a:masterClrMapping/>
+  </p:clrMapOvr>
+</p:sld>
+</file>
+
+<file path=ppt/slides/slide12.xml><?xml version="1.0" encoding="utf-8"?>
+<p:sld xmlns:a="http://schemas.openxmlformats.org/drawingml/2006/main" xmlns:r="http://schemas.openxmlformats.org/officeDocument/2006/relationships" xmlns:p="http://schemas.openxmlformats.org/presentationml/2006/main">
+  <p:cSld>
+    <p:spTree>
+      <p:nvGrpSpPr>
+        <p:cNvPr id="1" name="">
+          <a:extLst>
+            <a:ext uri="{FF2B5EF4-FFF2-40B4-BE49-F238E27FC236}">
               <a16:creationId xmlns:a16="http://schemas.microsoft.com/office/drawing/2014/main" id="{B2875D4A-7296-5640-980D-8ED633D02E47}"/>
             </a:ext>
           </a:extLst>
@@ -4904,7 +6498,7 @@
 </p:sld>
 </file>
 
-<file path=ppt/slides/slide11.xml><?xml version="1.0" encoding="utf-8"?>
+<file path=ppt/slides/slide13.xml><?xml version="1.0" encoding="utf-8"?>
 <p:sld xmlns:a="http://schemas.openxmlformats.org/drawingml/2006/main" xmlns:r="http://schemas.openxmlformats.org/officeDocument/2006/relationships" xmlns:p="http://schemas.openxmlformats.org/presentationml/2006/main">
   <p:cSld>
     <p:spTree>
@@ -5437,7 +7031,7 @@
 </p:sld>
 </file>
 
-<file path=ppt/slides/slide12.xml><?xml version="1.0" encoding="utf-8"?>
+<file path=ppt/slides/slide14.xml><?xml version="1.0" encoding="utf-8"?>
 <p:sld xmlns:a="http://schemas.openxmlformats.org/drawingml/2006/main" xmlns:r="http://schemas.openxmlformats.org/officeDocument/2006/relationships" xmlns:p="http://schemas.openxmlformats.org/presentationml/2006/main">
   <p:cSld>
     <p:spTree>
@@ -5473,7 +7067,7 @@
 </p:sld>
 </file>
 
-<file path=ppt/slides/slide13.xml><?xml version="1.0" encoding="utf-8"?>
+<file path=ppt/slides/slide15.xml><?xml version="1.0" encoding="utf-8"?>
 <p:sld xmlns:a="http://schemas.openxmlformats.org/drawingml/2006/main" xmlns:r="http://schemas.openxmlformats.org/officeDocument/2006/relationships" xmlns:p="http://schemas.openxmlformats.org/presentationml/2006/main">
   <p:cSld>
     <p:spTree>
@@ -25964,13 +27558,7 @@
   <p:cSld>
     <p:spTree>
       <p:nvGrpSpPr>
-        <p:cNvPr id="1" name="">
-          <a:extLst>
-            <a:ext uri="{FF2B5EF4-FFF2-40B4-BE49-F238E27FC236}">
-              <a16:creationId xmlns:a16="http://schemas.microsoft.com/office/drawing/2014/main" id="{53CD3648-99FD-DF6F-11C6-F125396BDC19}"/>
-            </a:ext>
-          </a:extLst>
-        </p:cNvPr>
+        <p:cNvPr id="1" name=""/>
         <p:cNvGrpSpPr/>
         <p:nvPr/>
       </p:nvGrpSpPr>
@@ -25982,58 +27570,12 @@
           <a:chExt cx="0" cy="0"/>
         </a:xfrm>
       </p:grpSpPr>
-      <p:cxnSp>
-        <p:nvCxnSpPr>
-          <p:cNvPr id="83" name="Gerader Verbinder 82">
+      <p:sp>
+        <p:nvSpPr>
+          <p:cNvPr id="10" name="Rechteck 9">
             <a:extLst>
               <a:ext uri="{FF2B5EF4-FFF2-40B4-BE49-F238E27FC236}">
-                <a16:creationId xmlns:a16="http://schemas.microsoft.com/office/drawing/2014/main" id="{FFA60373-C3E4-8175-6240-0960A7F5AD82}"/>
-              </a:ext>
-            </a:extLst>
-          </p:cNvPr>
-          <p:cNvCxnSpPr>
-            <a:cxnSpLocks/>
-          </p:cNvCxnSpPr>
-          <p:nvPr/>
-        </p:nvCxnSpPr>
-        <p:spPr>
-          <a:xfrm flipV="1">
-            <a:off x="3033712" y="1768782"/>
-            <a:ext cx="0" cy="1056571"/>
-          </a:xfrm>
-          <a:prstGeom prst="line">
-            <a:avLst/>
-          </a:prstGeom>
-          <a:ln w="19050" cap="rnd">
-            <a:solidFill>
-              <a:srgbClr val="086FBD"/>
-            </a:solidFill>
-            <a:round/>
-            <a:headEnd type="none"/>
-            <a:tailEnd type="triangle" w="med" len="med"/>
-          </a:ln>
-        </p:spPr>
-        <p:style>
-          <a:lnRef idx="2">
-            <a:schemeClr val="accent1"/>
-          </a:lnRef>
-          <a:fillRef idx="0">
-            <a:schemeClr val="accent1"/>
-          </a:fillRef>
-          <a:effectRef idx="1">
-            <a:schemeClr val="accent1"/>
-          </a:effectRef>
-          <a:fontRef idx="minor">
-            <a:schemeClr val="tx1"/>
-          </a:fontRef>
-        </p:style>
-      </p:cxnSp>
-      <p:sp>
-        <p:nvSpPr>
-          <p:cNvPr id="41" name="Freihandform: Form 40">
-            <a:extLst>
-              <a:ext uri="{FF2B5EF4-FFF2-40B4-BE49-F238E27FC236}">
-                <a16:creationId xmlns:a16="http://schemas.microsoft.com/office/drawing/2014/main" id="{17D34BE9-A51C-CFBC-DACE-957F7227016C}"/>
+                <a16:creationId xmlns:a16="http://schemas.microsoft.com/office/drawing/2014/main" id="{D8B496CC-717F-E511-D485-3153A717F0A1}"/>
               </a:ext>
             </a:extLst>
           </p:cNvPr>
@@ -26042,42 +27584,266 @@
         </p:nvSpPr>
         <p:spPr>
           <a:xfrm>
-            <a:off x="1123474" y="1299447"/>
-            <a:ext cx="1718310" cy="1262380"/>
+            <a:off x="1470183" y="1019176"/>
+            <a:ext cx="330042" cy="1112044"/>
+          </a:xfrm>
+          <a:prstGeom prst="rect">
+            <a:avLst/>
+          </a:prstGeom>
+          <a:solidFill>
+            <a:schemeClr val="bg1">
+              <a:lumMod val="50000"/>
+            </a:schemeClr>
+          </a:solidFill>
+          <a:ln cap="rnd">
+            <a:solidFill>
+              <a:schemeClr val="tx1">
+                <a:lumMod val="75000"/>
+                <a:lumOff val="25000"/>
+              </a:schemeClr>
+            </a:solidFill>
+            <a:round/>
+          </a:ln>
+        </p:spPr>
+        <p:style>
+          <a:lnRef idx="2">
+            <a:schemeClr val="accent1">
+              <a:shade val="15000"/>
+            </a:schemeClr>
+          </a:lnRef>
+          <a:fillRef idx="1">
+            <a:schemeClr val="accent1"/>
+          </a:fillRef>
+          <a:effectRef idx="0">
+            <a:schemeClr val="accent1"/>
+          </a:effectRef>
+          <a:fontRef idx="minor">
+            <a:schemeClr val="lt1"/>
+          </a:fontRef>
+        </p:style>
+        <p:txBody>
+          <a:bodyPr rtlCol="0" anchor="ctr"/>
+          <a:lstStyle/>
+          <a:p>
+            <a:pPr algn="ctr"/>
+            <a:endParaRPr lang="de-DE"/>
+          </a:p>
+        </p:txBody>
+      </p:sp>
+      <p:sp>
+        <p:nvSpPr>
+          <p:cNvPr id="8" name="Rechteck 7">
+            <a:extLst>
+              <a:ext uri="{FF2B5EF4-FFF2-40B4-BE49-F238E27FC236}">
+                <a16:creationId xmlns:a16="http://schemas.microsoft.com/office/drawing/2014/main" id="{3ADC5996-183F-92D1-BA16-EECA3A6F0B1B}"/>
+              </a:ext>
+            </a:extLst>
+          </p:cNvPr>
+          <p:cNvSpPr/>
+          <p:nvPr/>
+        </p:nvSpPr>
+        <p:spPr>
+          <a:xfrm>
+            <a:off x="1816893" y="1019176"/>
+            <a:ext cx="330042" cy="1112044"/>
+          </a:xfrm>
+          <a:prstGeom prst="rect">
+            <a:avLst/>
+          </a:prstGeom>
+          <a:solidFill>
+            <a:schemeClr val="bg1">
+              <a:lumMod val="75000"/>
+            </a:schemeClr>
+          </a:solidFill>
+          <a:ln cap="rnd">
+            <a:solidFill>
+              <a:schemeClr val="tx1">
+                <a:lumMod val="50000"/>
+                <a:lumOff val="50000"/>
+              </a:schemeClr>
+            </a:solidFill>
+            <a:round/>
+          </a:ln>
+        </p:spPr>
+        <p:style>
+          <a:lnRef idx="2">
+            <a:schemeClr val="accent1">
+              <a:shade val="15000"/>
+            </a:schemeClr>
+          </a:lnRef>
+          <a:fillRef idx="1">
+            <a:schemeClr val="accent1"/>
+          </a:fillRef>
+          <a:effectRef idx="0">
+            <a:schemeClr val="accent1"/>
+          </a:effectRef>
+          <a:fontRef idx="minor">
+            <a:schemeClr val="lt1"/>
+          </a:fontRef>
+        </p:style>
+        <p:txBody>
+          <a:bodyPr rtlCol="0" anchor="ctr"/>
+          <a:lstStyle/>
+          <a:p>
+            <a:pPr algn="ctr"/>
+            <a:endParaRPr lang="de-DE"/>
+          </a:p>
+        </p:txBody>
+      </p:sp>
+      <p:sp>
+        <p:nvSpPr>
+          <p:cNvPr id="4" name="Rechteck 3">
+            <a:extLst>
+              <a:ext uri="{FF2B5EF4-FFF2-40B4-BE49-F238E27FC236}">
+                <a16:creationId xmlns:a16="http://schemas.microsoft.com/office/drawing/2014/main" id="{F230ADE9-3357-3C47-8FC0-E9211A350732}"/>
+              </a:ext>
+            </a:extLst>
+          </p:cNvPr>
+          <p:cNvSpPr/>
+          <p:nvPr/>
+        </p:nvSpPr>
+        <p:spPr>
+          <a:xfrm>
+            <a:off x="307181" y="2091690"/>
+            <a:ext cx="1493044" cy="321469"/>
+          </a:xfrm>
+          <a:prstGeom prst="rect">
+            <a:avLst/>
+          </a:prstGeom>
+          <a:solidFill>
+            <a:schemeClr val="bg1">
+              <a:lumMod val="50000"/>
+            </a:schemeClr>
+          </a:solidFill>
+          <a:ln cap="rnd">
+            <a:solidFill>
+              <a:schemeClr val="tx1">
+                <a:lumMod val="75000"/>
+                <a:lumOff val="25000"/>
+              </a:schemeClr>
+            </a:solidFill>
+            <a:round/>
+          </a:ln>
+        </p:spPr>
+        <p:style>
+          <a:lnRef idx="2">
+            <a:schemeClr val="accent1">
+              <a:shade val="15000"/>
+            </a:schemeClr>
+          </a:lnRef>
+          <a:fillRef idx="1">
+            <a:schemeClr val="accent1"/>
+          </a:fillRef>
+          <a:effectRef idx="0">
+            <a:schemeClr val="accent1"/>
+          </a:effectRef>
+          <a:fontRef idx="minor">
+            <a:schemeClr val="lt1"/>
+          </a:fontRef>
+        </p:style>
+        <p:txBody>
+          <a:bodyPr rtlCol="0" anchor="ctr"/>
+          <a:lstStyle/>
+          <a:p>
+            <a:pPr algn="ctr"/>
+            <a:endParaRPr lang="de-DE"/>
+          </a:p>
+        </p:txBody>
+      </p:sp>
+      <p:sp>
+        <p:nvSpPr>
+          <p:cNvPr id="6" name="Rechteck 5">
+            <a:extLst>
+              <a:ext uri="{FF2B5EF4-FFF2-40B4-BE49-F238E27FC236}">
+                <a16:creationId xmlns:a16="http://schemas.microsoft.com/office/drawing/2014/main" id="{E77F7C9F-2F49-5753-BFE4-8C5F5FBEAD22}"/>
+              </a:ext>
+            </a:extLst>
+          </p:cNvPr>
+          <p:cNvSpPr/>
+          <p:nvPr/>
+        </p:nvSpPr>
+        <p:spPr>
+          <a:xfrm>
+            <a:off x="1816893" y="2091690"/>
+            <a:ext cx="1493044" cy="321469"/>
+          </a:xfrm>
+          <a:prstGeom prst="rect">
+            <a:avLst/>
+          </a:prstGeom>
+          <a:solidFill>
+            <a:schemeClr val="bg1">
+              <a:lumMod val="75000"/>
+            </a:schemeClr>
+          </a:solidFill>
+          <a:ln cap="rnd">
+            <a:solidFill>
+              <a:schemeClr val="tx1">
+                <a:lumMod val="50000"/>
+                <a:lumOff val="50000"/>
+              </a:schemeClr>
+            </a:solidFill>
+            <a:round/>
+          </a:ln>
+        </p:spPr>
+        <p:style>
+          <a:lnRef idx="2">
+            <a:schemeClr val="accent1">
+              <a:shade val="15000"/>
+            </a:schemeClr>
+          </a:lnRef>
+          <a:fillRef idx="1">
+            <a:schemeClr val="accent1"/>
+          </a:fillRef>
+          <a:effectRef idx="0">
+            <a:schemeClr val="accent1"/>
+          </a:effectRef>
+          <a:fontRef idx="minor">
+            <a:schemeClr val="lt1"/>
+          </a:fontRef>
+        </p:style>
+        <p:txBody>
+          <a:bodyPr rtlCol="0" anchor="ctr"/>
+          <a:lstStyle/>
+          <a:p>
+            <a:pPr algn="ctr"/>
+            <a:endParaRPr lang="de-DE"/>
+          </a:p>
+        </p:txBody>
+      </p:sp>
+      <p:sp>
+        <p:nvSpPr>
+          <p:cNvPr id="12" name="Rechteck 11">
+            <a:extLst>
+              <a:ext uri="{FF2B5EF4-FFF2-40B4-BE49-F238E27FC236}">
+                <a16:creationId xmlns:a16="http://schemas.microsoft.com/office/drawing/2014/main" id="{2D5620D1-1C9D-5EFC-287F-088C3E8CFCD9}"/>
+              </a:ext>
+            </a:extLst>
+          </p:cNvPr>
+          <p:cNvSpPr/>
+          <p:nvPr/>
+        </p:nvSpPr>
+        <p:spPr>
+          <a:xfrm>
+            <a:off x="1442085" y="1387771"/>
+            <a:ext cx="1354455" cy="337228"/>
           </a:xfrm>
           <a:custGeom>
             <a:avLst/>
             <a:gdLst>
-              <a:gd name="csX0" fmla="*/ 0 w 1711960"/>
-              <a:gd name="csY0" fmla="*/ 508000 h 1262380"/>
-              <a:gd name="csX1" fmla="*/ 256540 w 1711960"/>
-              <a:gd name="csY1" fmla="*/ 957580 h 1262380"/>
-              <a:gd name="csX2" fmla="*/ 309880 w 1711960"/>
-              <a:gd name="csY2" fmla="*/ 1010920 h 1262380"/>
-              <a:gd name="csX3" fmla="*/ 375920 w 1711960"/>
-              <a:gd name="csY3" fmla="*/ 1041400 h 1262380"/>
-              <a:gd name="csX4" fmla="*/ 444500 w 1711960"/>
-              <a:gd name="csY4" fmla="*/ 1056640 h 1262380"/>
-              <a:gd name="csX5" fmla="*/ 525780 w 1711960"/>
-              <a:gd name="csY5" fmla="*/ 1043940 h 1262380"/>
-              <a:gd name="csX6" fmla="*/ 594360 w 1711960"/>
-              <a:gd name="csY6" fmla="*/ 1016000 h 1262380"/>
-              <a:gd name="csX7" fmla="*/ 650240 w 1711960"/>
-              <a:gd name="csY7" fmla="*/ 952500 h 1262380"/>
-              <a:gd name="csX8" fmla="*/ 716280 w 1711960"/>
-              <a:gd name="csY8" fmla="*/ 840740 h 1262380"/>
-              <a:gd name="csX9" fmla="*/ 1201420 w 1711960"/>
-              <a:gd name="csY9" fmla="*/ 2540 h 1262380"/>
-              <a:gd name="csX10" fmla="*/ 1536700 w 1711960"/>
-              <a:gd name="csY10" fmla="*/ 0 h 1262380"/>
-              <a:gd name="csX11" fmla="*/ 1711960 w 1711960"/>
-              <a:gd name="csY11" fmla="*/ 299720 h 1262380"/>
-              <a:gd name="csX12" fmla="*/ 1711960 w 1711960"/>
-              <a:gd name="csY12" fmla="*/ 1262380 h 1262380"/>
-              <a:gd name="csX13" fmla="*/ 2540 w 1711960"/>
-              <a:gd name="csY13" fmla="*/ 1262380 h 1262380"/>
-              <a:gd name="csX14" fmla="*/ 0 w 1711960"/>
-              <a:gd name="csY14" fmla="*/ 508000 h 1262380"/>
+              <a:gd name="csX0" fmla="*/ 0 w 1021954"/>
+              <a:gd name="csY0" fmla="*/ 483 h 259520"/>
+              <a:gd name="csX1" fmla="*/ 964300 w 1021954"/>
+              <a:gd name="csY1" fmla="*/ 0 h 259520"/>
+              <a:gd name="csX2" fmla="*/ 1020050 w 1021954"/>
+              <a:gd name="csY2" fmla="*/ 33315 h 259520"/>
+              <a:gd name="csX3" fmla="*/ 1021954 w 1021954"/>
+              <a:gd name="csY3" fmla="*/ 222386 h 259520"/>
+              <a:gd name="csX4" fmla="*/ 971046 w 1021954"/>
+              <a:gd name="csY4" fmla="*/ 259520 h 259520"/>
+              <a:gd name="csX5" fmla="*/ 0 w 1021954"/>
+              <a:gd name="csY5" fmla="*/ 259520 h 259520"/>
+              <a:gd name="csX6" fmla="*/ 0 w 1021954"/>
+              <a:gd name="csY6" fmla="*/ 483 h 259520"/>
             </a:gdLst>
             <a:ahLst/>
             <a:cxnLst>
@@ -26102,92 +27868,596 @@
               <a:cxn ang="0">
                 <a:pos x="csX6" y="csY6"/>
               </a:cxn>
-              <a:cxn ang="0">
-                <a:pos x="csX7" y="csY7"/>
-              </a:cxn>
-              <a:cxn ang="0">
-                <a:pos x="csX8" y="csY8"/>
-              </a:cxn>
-              <a:cxn ang="0">
-                <a:pos x="csX9" y="csY9"/>
-              </a:cxn>
-              <a:cxn ang="0">
-                <a:pos x="csX10" y="csY10"/>
-              </a:cxn>
-              <a:cxn ang="0">
-                <a:pos x="csX11" y="csY11"/>
-              </a:cxn>
-              <a:cxn ang="0">
-                <a:pos x="csX12" y="csY12"/>
-              </a:cxn>
-              <a:cxn ang="0">
-                <a:pos x="csX13" y="csY13"/>
-              </a:cxn>
-              <a:cxn ang="0">
-                <a:pos x="csX14" y="csY14"/>
-              </a:cxn>
             </a:cxnLst>
             <a:rect l="l" t="t" r="r" b="b"/>
             <a:pathLst>
-              <a:path w="1711960" h="1262380">
+              <a:path w="1021954" h="259520">
                 <a:moveTo>
-                  <a:pt x="0" y="508000"/>
+                  <a:pt x="0" y="483"/>
                 </a:moveTo>
                 <a:lnTo>
-                  <a:pt x="256540" y="957580"/>
+                  <a:pt x="964300" y="0"/>
                 </a:lnTo>
                 <a:lnTo>
-                  <a:pt x="309880" y="1010920"/>
+                  <a:pt x="1020050" y="33315"/>
+                </a:lnTo>
+                <a:cubicBezTo>
+                  <a:pt x="1020393" y="96500"/>
+                  <a:pt x="1021611" y="159201"/>
+                  <a:pt x="1021954" y="222386"/>
+                </a:cubicBezTo>
+                <a:lnTo>
+                  <a:pt x="971046" y="259520"/>
                 </a:lnTo>
                 <a:lnTo>
-                  <a:pt x="375920" y="1041400"/>
+                  <a:pt x="0" y="259520"/>
                 </a:lnTo>
                 <a:lnTo>
-                  <a:pt x="444500" y="1056640"/>
+                  <a:pt x="0" y="483"/>
                 </a:lnTo>
-                <a:lnTo>
-                  <a:pt x="525780" y="1043940"/>
-                </a:lnTo>
-                <a:lnTo>
-                  <a:pt x="594360" y="1016000"/>
-                </a:lnTo>
-                <a:lnTo>
-                  <a:pt x="650240" y="952500"/>
-                </a:lnTo>
-                <a:lnTo>
-                  <a:pt x="716280" y="840740"/>
-                </a:lnTo>
-                <a:lnTo>
-                  <a:pt x="1201420" y="2540"/>
-                </a:lnTo>
-                <a:lnTo>
-                  <a:pt x="1536700" y="0"/>
-                </a:lnTo>
-                <a:lnTo>
-                  <a:pt x="1711960" y="299720"/>
-                </a:lnTo>
-                <a:lnTo>
-                  <a:pt x="1711960" y="1262380"/>
-                </a:lnTo>
-                <a:lnTo>
-                  <a:pt x="2540" y="1262380"/>
-                </a:lnTo>
-                <a:cubicBezTo>
-                  <a:pt x="1693" y="1010920"/>
-                  <a:pt x="847" y="759460"/>
-                  <a:pt x="0" y="508000"/>
-                </a:cubicBezTo>
                 <a:close/>
               </a:path>
             </a:pathLst>
           </a:custGeom>
           <a:solidFill>
             <a:schemeClr val="bg1">
-              <a:lumMod val="75000"/>
+              <a:lumMod val="85000"/>
             </a:schemeClr>
           </a:solidFill>
-          <a:ln>
-            <a:noFill/>
+          <a:ln w="19050" cap="rnd">
+            <a:solidFill>
+              <a:schemeClr val="tx1">
+                <a:lumMod val="65000"/>
+                <a:lumOff val="35000"/>
+              </a:schemeClr>
+            </a:solidFill>
+            <a:round/>
+          </a:ln>
+        </p:spPr>
+        <p:style>
+          <a:lnRef idx="2">
+            <a:schemeClr val="accent1">
+              <a:shade val="15000"/>
+            </a:schemeClr>
+          </a:lnRef>
+          <a:fillRef idx="1">
+            <a:schemeClr val="accent1"/>
+          </a:fillRef>
+          <a:effectRef idx="0">
+            <a:schemeClr val="accent1"/>
+          </a:effectRef>
+          <a:fontRef idx="minor">
+            <a:schemeClr val="lt1"/>
+          </a:fontRef>
+        </p:style>
+        <p:txBody>
+          <a:bodyPr rtlCol="0" anchor="ctr"/>
+          <a:lstStyle/>
+          <a:p>
+            <a:pPr algn="ctr"/>
+            <a:endParaRPr lang="de-DE"/>
+          </a:p>
+        </p:txBody>
+      </p:sp>
+      <p:grpSp>
+        <p:nvGrpSpPr>
+          <p:cNvPr id="23" name="Gruppieren 22">
+            <a:extLst>
+              <a:ext uri="{FF2B5EF4-FFF2-40B4-BE49-F238E27FC236}">
+                <a16:creationId xmlns:a16="http://schemas.microsoft.com/office/drawing/2014/main" id="{0FCFB003-BAD5-FFA2-C3EC-1AC0F8958140}"/>
+              </a:ext>
+            </a:extLst>
+          </p:cNvPr>
+          <p:cNvGrpSpPr/>
+          <p:nvPr/>
+        </p:nvGrpSpPr>
+        <p:grpSpPr>
+          <a:xfrm>
+            <a:off x="1087278" y="1178264"/>
+            <a:ext cx="303372" cy="756241"/>
+            <a:chOff x="1133952" y="1178264"/>
+            <a:chExt cx="303372" cy="756241"/>
+          </a:xfrm>
+        </p:grpSpPr>
+        <p:sp>
+          <p:nvSpPr>
+            <p:cNvPr id="22" name="Rechteck 21">
+              <a:extLst>
+                <a:ext uri="{FF2B5EF4-FFF2-40B4-BE49-F238E27FC236}">
+                  <a16:creationId xmlns:a16="http://schemas.microsoft.com/office/drawing/2014/main" id="{04A0398A-1E96-C97B-62D4-B99FCD3AC204}"/>
+                </a:ext>
+              </a:extLst>
+            </p:cNvPr>
+            <p:cNvSpPr/>
+            <p:nvPr/>
+          </p:nvSpPr>
+          <p:spPr>
+            <a:xfrm>
+              <a:off x="1137285" y="1264920"/>
+              <a:ext cx="298611" cy="582930"/>
+            </a:xfrm>
+            <a:prstGeom prst="rect">
+              <a:avLst/>
+            </a:prstGeom>
+            <a:solidFill>
+              <a:schemeClr val="bg1">
+                <a:lumMod val="85000"/>
+              </a:schemeClr>
+            </a:solidFill>
+            <a:ln cap="rnd">
+              <a:solidFill>
+                <a:schemeClr val="tx1">
+                  <a:lumMod val="65000"/>
+                  <a:lumOff val="35000"/>
+                </a:schemeClr>
+              </a:solidFill>
+              <a:round/>
+            </a:ln>
+          </p:spPr>
+          <p:style>
+            <a:lnRef idx="2">
+              <a:schemeClr val="accent1">
+                <a:shade val="15000"/>
+              </a:schemeClr>
+            </a:lnRef>
+            <a:fillRef idx="1">
+              <a:schemeClr val="accent1"/>
+            </a:fillRef>
+            <a:effectRef idx="0">
+              <a:schemeClr val="accent1"/>
+            </a:effectRef>
+            <a:fontRef idx="minor">
+              <a:schemeClr val="lt1"/>
+            </a:fontRef>
+          </p:style>
+          <p:txBody>
+            <a:bodyPr rtlCol="0" anchor="ctr"/>
+            <a:lstStyle/>
+            <a:p>
+              <a:pPr algn="ctr"/>
+              <a:endParaRPr lang="de-DE"/>
+            </a:p>
+          </p:txBody>
+        </p:sp>
+        <p:sp>
+          <p:nvSpPr>
+            <p:cNvPr id="16" name="Freihandform: Form 15">
+              <a:extLst>
+                <a:ext uri="{FF2B5EF4-FFF2-40B4-BE49-F238E27FC236}">
+                  <a16:creationId xmlns:a16="http://schemas.microsoft.com/office/drawing/2014/main" id="{A27847D1-D65C-DF3E-687E-9E75863C359D}"/>
+                </a:ext>
+              </a:extLst>
+            </p:cNvPr>
+            <p:cNvSpPr/>
+            <p:nvPr/>
+          </p:nvSpPr>
+          <p:spPr>
+            <a:xfrm>
+              <a:off x="1133952" y="1178264"/>
+              <a:ext cx="303372" cy="179070"/>
+            </a:xfrm>
+            <a:custGeom>
+              <a:avLst/>
+              <a:gdLst>
+                <a:gd name="csX0" fmla="*/ 57153 w 352459"/>
+                <a:gd name="csY0" fmla="*/ 382905 h 382905"/>
+                <a:gd name="csX1" fmla="*/ 3 w 352459"/>
+                <a:gd name="csY1" fmla="*/ 196215 h 382905"/>
+                <a:gd name="csX2" fmla="*/ 55248 w 352459"/>
+                <a:gd name="csY2" fmla="*/ 0 h 382905"/>
+                <a:gd name="csX3" fmla="*/ 299088 w 352459"/>
+                <a:gd name="csY3" fmla="*/ 0 h 382905"/>
+                <a:gd name="csX4" fmla="*/ 352428 w 352459"/>
+                <a:gd name="csY4" fmla="*/ 192405 h 382905"/>
+                <a:gd name="csX5" fmla="*/ 300013 w 352459"/>
+                <a:gd name="csY5" fmla="*/ 381000 h 382905"/>
+                <a:gd name="csX6" fmla="*/ 57153 w 352459"/>
+                <a:gd name="csY6" fmla="*/ 382905 h 382905"/>
+              </a:gdLst>
+              <a:ahLst/>
+              <a:cxnLst>
+                <a:cxn ang="0">
+                  <a:pos x="csX0" y="csY0"/>
+                </a:cxn>
+                <a:cxn ang="0">
+                  <a:pos x="csX1" y="csY1"/>
+                </a:cxn>
+                <a:cxn ang="0">
+                  <a:pos x="csX2" y="csY2"/>
+                </a:cxn>
+                <a:cxn ang="0">
+                  <a:pos x="csX3" y="csY3"/>
+                </a:cxn>
+                <a:cxn ang="0">
+                  <a:pos x="csX4" y="csY4"/>
+                </a:cxn>
+                <a:cxn ang="0">
+                  <a:pos x="csX5" y="csY5"/>
+                </a:cxn>
+                <a:cxn ang="0">
+                  <a:pos x="csX6" y="csY6"/>
+                </a:cxn>
+              </a:cxnLst>
+              <a:rect l="l" t="t" r="r" b="b"/>
+              <a:pathLst>
+                <a:path w="352459" h="382905">
+                  <a:moveTo>
+                    <a:pt x="57153" y="382905"/>
+                  </a:moveTo>
+                  <a:cubicBezTo>
+                    <a:pt x="20481" y="318928"/>
+                    <a:pt x="320" y="260032"/>
+                    <a:pt x="3" y="196215"/>
+                  </a:cubicBezTo>
+                  <a:cubicBezTo>
+                    <a:pt x="-314" y="132398"/>
+                    <a:pt x="24768" y="51435"/>
+                    <a:pt x="55248" y="0"/>
+                  </a:cubicBezTo>
+                  <a:lnTo>
+                    <a:pt x="299088" y="0"/>
+                  </a:lnTo>
+                  <a:cubicBezTo>
+                    <a:pt x="332743" y="53975"/>
+                    <a:pt x="353381" y="128905"/>
+                    <a:pt x="352428" y="192405"/>
+                  </a:cubicBezTo>
+                  <a:cubicBezTo>
+                    <a:pt x="351476" y="255905"/>
+                    <a:pt x="340018" y="328930"/>
+                    <a:pt x="300013" y="381000"/>
+                  </a:cubicBezTo>
+                  <a:lnTo>
+                    <a:pt x="57153" y="382905"/>
+                  </a:lnTo>
+                  <a:close/>
+                </a:path>
+              </a:pathLst>
+            </a:custGeom>
+            <a:solidFill>
+              <a:schemeClr val="bg1">
+                <a:lumMod val="85000"/>
+              </a:schemeClr>
+            </a:solidFill>
+            <a:ln w="12700" cap="rnd">
+              <a:solidFill>
+                <a:schemeClr val="tx1">
+                  <a:lumMod val="65000"/>
+                  <a:lumOff val="35000"/>
+                </a:schemeClr>
+              </a:solidFill>
+              <a:round/>
+            </a:ln>
+          </p:spPr>
+          <p:style>
+            <a:lnRef idx="2">
+              <a:schemeClr val="accent1">
+                <a:shade val="15000"/>
+              </a:schemeClr>
+            </a:lnRef>
+            <a:fillRef idx="1">
+              <a:schemeClr val="accent1"/>
+            </a:fillRef>
+            <a:effectRef idx="0">
+              <a:schemeClr val="accent1"/>
+            </a:effectRef>
+            <a:fontRef idx="minor">
+              <a:schemeClr val="lt1"/>
+            </a:fontRef>
+          </p:style>
+          <p:txBody>
+            <a:bodyPr rtlCol="0" anchor="ctr"/>
+            <a:lstStyle/>
+            <a:p>
+              <a:pPr algn="ctr"/>
+              <a:endParaRPr lang="de-DE"/>
+            </a:p>
+          </p:txBody>
+        </p:sp>
+        <p:sp>
+          <p:nvSpPr>
+            <p:cNvPr id="18" name="Freihandform: Form 17">
+              <a:extLst>
+                <a:ext uri="{FF2B5EF4-FFF2-40B4-BE49-F238E27FC236}">
+                  <a16:creationId xmlns:a16="http://schemas.microsoft.com/office/drawing/2014/main" id="{6768FF53-5599-C0EB-97D5-CEC1DDF75D13}"/>
+                </a:ext>
+              </a:extLst>
+            </p:cNvPr>
+            <p:cNvSpPr/>
+            <p:nvPr/>
+          </p:nvSpPr>
+          <p:spPr>
+            <a:xfrm>
+              <a:off x="1133952" y="1357335"/>
+              <a:ext cx="303372" cy="398102"/>
+            </a:xfrm>
+            <a:custGeom>
+              <a:avLst/>
+              <a:gdLst>
+                <a:gd name="csX0" fmla="*/ 57153 w 352459"/>
+                <a:gd name="csY0" fmla="*/ 382905 h 382905"/>
+                <a:gd name="csX1" fmla="*/ 3 w 352459"/>
+                <a:gd name="csY1" fmla="*/ 196215 h 382905"/>
+                <a:gd name="csX2" fmla="*/ 55248 w 352459"/>
+                <a:gd name="csY2" fmla="*/ 0 h 382905"/>
+                <a:gd name="csX3" fmla="*/ 299088 w 352459"/>
+                <a:gd name="csY3" fmla="*/ 0 h 382905"/>
+                <a:gd name="csX4" fmla="*/ 352428 w 352459"/>
+                <a:gd name="csY4" fmla="*/ 192405 h 382905"/>
+                <a:gd name="csX5" fmla="*/ 300013 w 352459"/>
+                <a:gd name="csY5" fmla="*/ 381000 h 382905"/>
+                <a:gd name="csX6" fmla="*/ 57153 w 352459"/>
+                <a:gd name="csY6" fmla="*/ 382905 h 382905"/>
+              </a:gdLst>
+              <a:ahLst/>
+              <a:cxnLst>
+                <a:cxn ang="0">
+                  <a:pos x="csX0" y="csY0"/>
+                </a:cxn>
+                <a:cxn ang="0">
+                  <a:pos x="csX1" y="csY1"/>
+                </a:cxn>
+                <a:cxn ang="0">
+                  <a:pos x="csX2" y="csY2"/>
+                </a:cxn>
+                <a:cxn ang="0">
+                  <a:pos x="csX3" y="csY3"/>
+                </a:cxn>
+                <a:cxn ang="0">
+                  <a:pos x="csX4" y="csY4"/>
+                </a:cxn>
+                <a:cxn ang="0">
+                  <a:pos x="csX5" y="csY5"/>
+                </a:cxn>
+                <a:cxn ang="0">
+                  <a:pos x="csX6" y="csY6"/>
+                </a:cxn>
+              </a:cxnLst>
+              <a:rect l="l" t="t" r="r" b="b"/>
+              <a:pathLst>
+                <a:path w="352459" h="382905">
+                  <a:moveTo>
+                    <a:pt x="57153" y="382905"/>
+                  </a:moveTo>
+                  <a:cubicBezTo>
+                    <a:pt x="20481" y="318928"/>
+                    <a:pt x="320" y="260032"/>
+                    <a:pt x="3" y="196215"/>
+                  </a:cubicBezTo>
+                  <a:cubicBezTo>
+                    <a:pt x="-314" y="132398"/>
+                    <a:pt x="24768" y="51435"/>
+                    <a:pt x="55248" y="0"/>
+                  </a:cubicBezTo>
+                  <a:lnTo>
+                    <a:pt x="299088" y="0"/>
+                  </a:lnTo>
+                  <a:cubicBezTo>
+                    <a:pt x="332743" y="53975"/>
+                    <a:pt x="353381" y="128905"/>
+                    <a:pt x="352428" y="192405"/>
+                  </a:cubicBezTo>
+                  <a:cubicBezTo>
+                    <a:pt x="351476" y="255905"/>
+                    <a:pt x="340018" y="328930"/>
+                    <a:pt x="300013" y="381000"/>
+                  </a:cubicBezTo>
+                  <a:lnTo>
+                    <a:pt x="57153" y="382905"/>
+                  </a:lnTo>
+                  <a:close/>
+                </a:path>
+              </a:pathLst>
+            </a:custGeom>
+            <a:solidFill>
+              <a:schemeClr val="bg1">
+                <a:lumMod val="85000"/>
+              </a:schemeClr>
+            </a:solidFill>
+            <a:ln w="12700" cap="rnd">
+              <a:solidFill>
+                <a:schemeClr val="tx1">
+                  <a:lumMod val="65000"/>
+                  <a:lumOff val="35000"/>
+                </a:schemeClr>
+              </a:solidFill>
+              <a:round/>
+            </a:ln>
+          </p:spPr>
+          <p:style>
+            <a:lnRef idx="2">
+              <a:schemeClr val="accent1">
+                <a:shade val="15000"/>
+              </a:schemeClr>
+            </a:lnRef>
+            <a:fillRef idx="1">
+              <a:schemeClr val="accent1"/>
+            </a:fillRef>
+            <a:effectRef idx="0">
+              <a:schemeClr val="accent1"/>
+            </a:effectRef>
+            <a:fontRef idx="minor">
+              <a:schemeClr val="lt1"/>
+            </a:fontRef>
+          </p:style>
+          <p:txBody>
+            <a:bodyPr rtlCol="0" anchor="ctr"/>
+            <a:lstStyle/>
+            <a:p>
+              <a:pPr algn="ctr"/>
+              <a:endParaRPr lang="de-DE"/>
+            </a:p>
+          </p:txBody>
+        </p:sp>
+        <p:sp>
+          <p:nvSpPr>
+            <p:cNvPr id="20" name="Freihandform: Form 19">
+              <a:extLst>
+                <a:ext uri="{FF2B5EF4-FFF2-40B4-BE49-F238E27FC236}">
+                  <a16:creationId xmlns:a16="http://schemas.microsoft.com/office/drawing/2014/main" id="{7CF4EBF6-3A38-E722-C2EB-4B753D970A66}"/>
+                </a:ext>
+              </a:extLst>
+            </p:cNvPr>
+            <p:cNvSpPr/>
+            <p:nvPr/>
+          </p:nvSpPr>
+          <p:spPr>
+            <a:xfrm>
+              <a:off x="1133952" y="1755435"/>
+              <a:ext cx="303372" cy="179070"/>
+            </a:xfrm>
+            <a:custGeom>
+              <a:avLst/>
+              <a:gdLst>
+                <a:gd name="csX0" fmla="*/ 57153 w 352459"/>
+                <a:gd name="csY0" fmla="*/ 382905 h 382905"/>
+                <a:gd name="csX1" fmla="*/ 3 w 352459"/>
+                <a:gd name="csY1" fmla="*/ 196215 h 382905"/>
+                <a:gd name="csX2" fmla="*/ 55248 w 352459"/>
+                <a:gd name="csY2" fmla="*/ 0 h 382905"/>
+                <a:gd name="csX3" fmla="*/ 299088 w 352459"/>
+                <a:gd name="csY3" fmla="*/ 0 h 382905"/>
+                <a:gd name="csX4" fmla="*/ 352428 w 352459"/>
+                <a:gd name="csY4" fmla="*/ 192405 h 382905"/>
+                <a:gd name="csX5" fmla="*/ 300013 w 352459"/>
+                <a:gd name="csY5" fmla="*/ 381000 h 382905"/>
+                <a:gd name="csX6" fmla="*/ 57153 w 352459"/>
+                <a:gd name="csY6" fmla="*/ 382905 h 382905"/>
+              </a:gdLst>
+              <a:ahLst/>
+              <a:cxnLst>
+                <a:cxn ang="0">
+                  <a:pos x="csX0" y="csY0"/>
+                </a:cxn>
+                <a:cxn ang="0">
+                  <a:pos x="csX1" y="csY1"/>
+                </a:cxn>
+                <a:cxn ang="0">
+                  <a:pos x="csX2" y="csY2"/>
+                </a:cxn>
+                <a:cxn ang="0">
+                  <a:pos x="csX3" y="csY3"/>
+                </a:cxn>
+                <a:cxn ang="0">
+                  <a:pos x="csX4" y="csY4"/>
+                </a:cxn>
+                <a:cxn ang="0">
+                  <a:pos x="csX5" y="csY5"/>
+                </a:cxn>
+                <a:cxn ang="0">
+                  <a:pos x="csX6" y="csY6"/>
+                </a:cxn>
+              </a:cxnLst>
+              <a:rect l="l" t="t" r="r" b="b"/>
+              <a:pathLst>
+                <a:path w="352459" h="382905">
+                  <a:moveTo>
+                    <a:pt x="57153" y="382905"/>
+                  </a:moveTo>
+                  <a:cubicBezTo>
+                    <a:pt x="20481" y="318928"/>
+                    <a:pt x="320" y="260032"/>
+                    <a:pt x="3" y="196215"/>
+                  </a:cubicBezTo>
+                  <a:cubicBezTo>
+                    <a:pt x="-314" y="132398"/>
+                    <a:pt x="24768" y="51435"/>
+                    <a:pt x="55248" y="0"/>
+                  </a:cubicBezTo>
+                  <a:lnTo>
+                    <a:pt x="299088" y="0"/>
+                  </a:lnTo>
+                  <a:cubicBezTo>
+                    <a:pt x="332743" y="53975"/>
+                    <a:pt x="353381" y="128905"/>
+                    <a:pt x="352428" y="192405"/>
+                  </a:cubicBezTo>
+                  <a:cubicBezTo>
+                    <a:pt x="351476" y="255905"/>
+                    <a:pt x="340018" y="328930"/>
+                    <a:pt x="300013" y="381000"/>
+                  </a:cubicBezTo>
+                  <a:lnTo>
+                    <a:pt x="57153" y="382905"/>
+                  </a:lnTo>
+                  <a:close/>
+                </a:path>
+              </a:pathLst>
+            </a:custGeom>
+            <a:solidFill>
+              <a:schemeClr val="bg1">
+                <a:lumMod val="85000"/>
+              </a:schemeClr>
+            </a:solidFill>
+            <a:ln w="12700" cap="rnd">
+              <a:solidFill>
+                <a:schemeClr val="tx1">
+                  <a:lumMod val="65000"/>
+                  <a:lumOff val="35000"/>
+                </a:schemeClr>
+              </a:solidFill>
+              <a:round/>
+            </a:ln>
+          </p:spPr>
+          <p:style>
+            <a:lnRef idx="2">
+              <a:schemeClr val="accent1">
+                <a:shade val="15000"/>
+              </a:schemeClr>
+            </a:lnRef>
+            <a:fillRef idx="1">
+              <a:schemeClr val="accent1"/>
+            </a:fillRef>
+            <a:effectRef idx="0">
+              <a:schemeClr val="accent1"/>
+            </a:effectRef>
+            <a:fontRef idx="minor">
+              <a:schemeClr val="lt1"/>
+            </a:fontRef>
+          </p:style>
+          <p:txBody>
+            <a:bodyPr rtlCol="0" anchor="ctr"/>
+            <a:lstStyle/>
+            <a:p>
+              <a:pPr algn="ctr"/>
+              <a:endParaRPr lang="de-DE"/>
+            </a:p>
+          </p:txBody>
+        </p:sp>
+      </p:grpSp>
+      <p:sp>
+        <p:nvSpPr>
+          <p:cNvPr id="25" name="Rechteck 24">
+            <a:extLst>
+              <a:ext uri="{FF2B5EF4-FFF2-40B4-BE49-F238E27FC236}">
+                <a16:creationId xmlns:a16="http://schemas.microsoft.com/office/drawing/2014/main" id="{65432FA2-A63C-CF83-FC35-2FB516D15F95}"/>
+              </a:ext>
+            </a:extLst>
+          </p:cNvPr>
+          <p:cNvSpPr/>
+          <p:nvPr/>
+        </p:nvSpPr>
+        <p:spPr>
+          <a:xfrm>
+            <a:off x="1405890" y="1120140"/>
+            <a:ext cx="45720" cy="872490"/>
+          </a:xfrm>
+          <a:prstGeom prst="rect">
+            <a:avLst/>
+          </a:prstGeom>
+          <a:solidFill>
+            <a:schemeClr val="bg1">
+              <a:lumMod val="85000"/>
+            </a:schemeClr>
+          </a:solidFill>
+          <a:ln cap="rnd">
+            <a:solidFill>
+              <a:schemeClr val="tx1">
+                <a:lumMod val="65000"/>
+                <a:lumOff val="35000"/>
+              </a:schemeClr>
+            </a:solidFill>
+            <a:round/>
           </a:ln>
         </p:spPr>
         <p:style>
@@ -26217,10 +28487,10 @@
       </p:sp>
       <p:sp>
         <p:nvSpPr>
-          <p:cNvPr id="28" name="Freihandform: Form 27">
+          <p:cNvPr id="29" name="Rechteck 28">
             <a:extLst>
               <a:ext uri="{FF2B5EF4-FFF2-40B4-BE49-F238E27FC236}">
-                <a16:creationId xmlns:a16="http://schemas.microsoft.com/office/drawing/2014/main" id="{FEEE085C-6F06-1EBC-1930-EDF143B7720B}"/>
+                <a16:creationId xmlns:a16="http://schemas.microsoft.com/office/drawing/2014/main" id="{A6E99AC8-9FAE-42E9-B580-D5B996AB680C}"/>
               </a:ext>
             </a:extLst>
           </p:cNvPr>
@@ -26229,104 +28499,76 @@
         </p:nvSpPr>
         <p:spPr>
           <a:xfrm>
-            <a:off x="1254284" y="842247"/>
-            <a:ext cx="1579880" cy="1315720"/>
+            <a:off x="1827846" y="1970485"/>
+            <a:ext cx="309564" cy="321469"/>
           </a:xfrm>
-          <a:custGeom>
+          <a:prstGeom prst="rect">
             <a:avLst/>
-            <a:gdLst>
-              <a:gd name="csX0" fmla="*/ 0 w 1574800"/>
-              <a:gd name="csY0" fmla="*/ 0 h 1305560"/>
-              <a:gd name="csX1" fmla="*/ 1574800 w 1574800"/>
-              <a:gd name="csY1" fmla="*/ 0 h 1305560"/>
-              <a:gd name="csX2" fmla="*/ 1574800 w 1574800"/>
-              <a:gd name="csY2" fmla="*/ 685165 h 1305560"/>
-              <a:gd name="csX3" fmla="*/ 1374140 w 1574800"/>
-              <a:gd name="csY3" fmla="*/ 340360 h 1305560"/>
-              <a:gd name="csX4" fmla="*/ 1097280 w 1574800"/>
-              <a:gd name="csY4" fmla="*/ 340360 h 1305560"/>
-              <a:gd name="csX5" fmla="*/ 546100 w 1574800"/>
-              <a:gd name="csY5" fmla="*/ 1305560 h 1305560"/>
-              <a:gd name="csX6" fmla="*/ 111760 w 1574800"/>
-              <a:gd name="csY6" fmla="*/ 1305560 h 1305560"/>
-              <a:gd name="csX7" fmla="*/ 2540 w 1574800"/>
-              <a:gd name="csY7" fmla="*/ 1117600 h 1305560"/>
-              <a:gd name="csX8" fmla="*/ 0 w 1574800"/>
-              <a:gd name="csY8" fmla="*/ 0 h 1305560"/>
-            </a:gdLst>
-            <a:ahLst/>
-            <a:cxnLst>
-              <a:cxn ang="0">
-                <a:pos x="csX0" y="csY0"/>
-              </a:cxn>
-              <a:cxn ang="0">
-                <a:pos x="csX1" y="csY1"/>
-              </a:cxn>
-              <a:cxn ang="0">
-                <a:pos x="csX2" y="csY2"/>
-              </a:cxn>
-              <a:cxn ang="0">
-                <a:pos x="csX3" y="csY3"/>
-              </a:cxn>
-              <a:cxn ang="0">
-                <a:pos x="csX4" y="csY4"/>
-              </a:cxn>
-              <a:cxn ang="0">
-                <a:pos x="csX5" y="csY5"/>
-              </a:cxn>
-              <a:cxn ang="0">
-                <a:pos x="csX6" y="csY6"/>
-              </a:cxn>
-              <a:cxn ang="0">
-                <a:pos x="csX7" y="csY7"/>
-              </a:cxn>
-              <a:cxn ang="0">
-                <a:pos x="csX8" y="csY8"/>
-              </a:cxn>
-            </a:cxnLst>
-            <a:rect l="l" t="t" r="r" b="b"/>
-            <a:pathLst>
-              <a:path w="1574800" h="1305560">
-                <a:moveTo>
-                  <a:pt x="0" y="0"/>
-                </a:moveTo>
-                <a:lnTo>
-                  <a:pt x="1574800" y="0"/>
-                </a:lnTo>
-                <a:lnTo>
-                  <a:pt x="1574800" y="685165"/>
-                </a:lnTo>
-                <a:lnTo>
-                  <a:pt x="1374140" y="340360"/>
-                </a:lnTo>
-                <a:lnTo>
-                  <a:pt x="1097280" y="340360"/>
-                </a:lnTo>
-                <a:lnTo>
-                  <a:pt x="546100" y="1305560"/>
-                </a:lnTo>
-                <a:lnTo>
-                  <a:pt x="111760" y="1305560"/>
-                </a:lnTo>
-                <a:lnTo>
-                  <a:pt x="2540" y="1117600"/>
-                </a:lnTo>
-                <a:cubicBezTo>
-                  <a:pt x="1693" y="745067"/>
-                  <a:pt x="847" y="372533"/>
-                  <a:pt x="0" y="0"/>
-                </a:cubicBezTo>
-                <a:close/>
-              </a:path>
-            </a:pathLst>
-          </a:custGeom>
+          </a:prstGeom>
           <a:solidFill>
             <a:schemeClr val="bg1">
-              <a:lumMod val="50000"/>
+              <a:lumMod val="75000"/>
             </a:schemeClr>
           </a:solidFill>
-          <a:ln>
+          <a:ln cap="rnd">
             <a:noFill/>
+            <a:round/>
+          </a:ln>
+        </p:spPr>
+        <p:style>
+          <a:lnRef idx="2">
+            <a:schemeClr val="accent1">
+              <a:shade val="15000"/>
+            </a:schemeClr>
+          </a:lnRef>
+          <a:fillRef idx="1">
+            <a:schemeClr val="accent1"/>
+          </a:fillRef>
+          <a:effectRef idx="0">
+            <a:schemeClr val="accent1"/>
+          </a:effectRef>
+          <a:fontRef idx="minor">
+            <a:schemeClr val="lt1"/>
+          </a:fontRef>
+        </p:style>
+        <p:txBody>
+          <a:bodyPr rtlCol="0" anchor="ctr"/>
+          <a:lstStyle/>
+          <a:p>
+            <a:pPr algn="ctr"/>
+            <a:endParaRPr lang="de-DE"/>
+          </a:p>
+        </p:txBody>
+      </p:sp>
+      <p:sp>
+        <p:nvSpPr>
+          <p:cNvPr id="31" name="Rechteck 30">
+            <a:extLst>
+              <a:ext uri="{FF2B5EF4-FFF2-40B4-BE49-F238E27FC236}">
+                <a16:creationId xmlns:a16="http://schemas.microsoft.com/office/drawing/2014/main" id="{1288D5E7-ACFC-C848-CDDF-D42800ECB377}"/>
+              </a:ext>
+            </a:extLst>
+          </p:cNvPr>
+          <p:cNvSpPr/>
+          <p:nvPr/>
+        </p:nvSpPr>
+        <p:spPr>
+          <a:xfrm>
+            <a:off x="1480422" y="1927124"/>
+            <a:ext cx="309564" cy="321469"/>
+          </a:xfrm>
+          <a:prstGeom prst="rect">
+            <a:avLst/>
+          </a:prstGeom>
+          <a:solidFill>
+            <a:schemeClr val="tx1">
+              <a:lumMod val="50000"/>
+              <a:lumOff val="50000"/>
+            </a:schemeClr>
+          </a:solidFill>
+          <a:ln cap="rnd">
+            <a:noFill/>
+            <a:round/>
           </a:ln>
         </p:spPr>
         <p:style>
@@ -26356,10 +28598,10 @@
       </p:sp>
       <p:cxnSp>
         <p:nvCxnSpPr>
-          <p:cNvPr id="3" name="Gerader Verbinder 2">
+          <p:cNvPr id="38" name="Gerader Verbinder 37">
             <a:extLst>
               <a:ext uri="{FF2B5EF4-FFF2-40B4-BE49-F238E27FC236}">
-                <a16:creationId xmlns:a16="http://schemas.microsoft.com/office/drawing/2014/main" id="{E1B3E2A9-E25C-B824-5F5E-00EE664F8481}"/>
+                <a16:creationId xmlns:a16="http://schemas.microsoft.com/office/drawing/2014/main" id="{69558260-A7F9-3E81-84C0-DDDFA4DBFA26}"/>
               </a:ext>
             </a:extLst>
           </p:cNvPr>
@@ -26370,17 +28612,17 @@
         </p:nvCxnSpPr>
         <p:spPr>
           <a:xfrm>
-            <a:off x="1253728" y="853677"/>
-            <a:ext cx="0" cy="1114425"/>
+            <a:off x="1755458" y="1418252"/>
+            <a:ext cx="1014412" cy="0"/>
           </a:xfrm>
           <a:prstGeom prst="line">
             <a:avLst/>
           </a:prstGeom>
-          <a:ln w="25400" cap="rnd">
+          <a:ln w="9525" cap="rnd">
             <a:solidFill>
               <a:schemeClr val="tx1">
-                <a:lumMod val="75000"/>
-                <a:lumOff val="25000"/>
+                <a:lumMod val="65000"/>
+                <a:lumOff val="35000"/>
               </a:schemeClr>
             </a:solidFill>
             <a:round/>
@@ -26403,10 +28645,10 @@
       </p:cxnSp>
       <p:cxnSp>
         <p:nvCxnSpPr>
-          <p:cNvPr id="18" name="Gerader Verbinder 17">
+          <p:cNvPr id="40" name="Gerader Verbinder 39">
             <a:extLst>
               <a:ext uri="{FF2B5EF4-FFF2-40B4-BE49-F238E27FC236}">
-                <a16:creationId xmlns:a16="http://schemas.microsoft.com/office/drawing/2014/main" id="{C1A2AD43-7A9D-D0EC-5F74-D6BD6D064950}"/>
+                <a16:creationId xmlns:a16="http://schemas.microsoft.com/office/drawing/2014/main" id="{CFDAB459-C719-208E-6755-842983A01D45}"/>
               </a:ext>
             </a:extLst>
           </p:cNvPr>
@@ -26417,17 +28659,17 @@
         </p:nvCxnSpPr>
         <p:spPr>
           <a:xfrm>
-            <a:off x="1253728" y="1968102"/>
-            <a:ext cx="110595" cy="191557"/>
+            <a:off x="1758315" y="1694477"/>
+            <a:ext cx="1015365" cy="0"/>
           </a:xfrm>
           <a:prstGeom prst="line">
             <a:avLst/>
           </a:prstGeom>
-          <a:ln w="25400" cap="rnd">
+          <a:ln w="9525" cap="rnd">
             <a:solidFill>
               <a:schemeClr val="tx1">
-                <a:lumMod val="75000"/>
-                <a:lumOff val="25000"/>
+                <a:lumMod val="65000"/>
+                <a:lumOff val="35000"/>
               </a:schemeClr>
             </a:solidFill>
             <a:round/>
@@ -26450,57 +28692,10 @@
       </p:cxnSp>
       <p:cxnSp>
         <p:nvCxnSpPr>
-          <p:cNvPr id="20" name="Gerader Verbinder 19">
+          <p:cNvPr id="51" name="Gerader Verbinder 50">
             <a:extLst>
               <a:ext uri="{FF2B5EF4-FFF2-40B4-BE49-F238E27FC236}">
-                <a16:creationId xmlns:a16="http://schemas.microsoft.com/office/drawing/2014/main" id="{3FF345EE-94E1-7CB0-7A7F-539C6E656808}"/>
-              </a:ext>
-            </a:extLst>
-          </p:cNvPr>
-          <p:cNvCxnSpPr>
-            <a:cxnSpLocks/>
-          </p:cNvCxnSpPr>
-          <p:nvPr/>
-        </p:nvCxnSpPr>
-        <p:spPr>
-          <a:xfrm flipH="1">
-            <a:off x="1364323" y="2159660"/>
-            <a:ext cx="432330" cy="0"/>
-          </a:xfrm>
-          <a:prstGeom prst="line">
-            <a:avLst/>
-          </a:prstGeom>
-          <a:ln w="25400" cap="rnd">
-            <a:solidFill>
-              <a:schemeClr val="tx1">
-                <a:lumMod val="75000"/>
-                <a:lumOff val="25000"/>
-              </a:schemeClr>
-            </a:solidFill>
-            <a:round/>
-          </a:ln>
-        </p:spPr>
-        <p:style>
-          <a:lnRef idx="2">
-            <a:schemeClr val="accent1"/>
-          </a:lnRef>
-          <a:fillRef idx="0">
-            <a:schemeClr val="accent1"/>
-          </a:fillRef>
-          <a:effectRef idx="1">
-            <a:schemeClr val="accent1"/>
-          </a:effectRef>
-          <a:fontRef idx="minor">
-            <a:schemeClr val="tx1"/>
-          </a:fontRef>
-        </p:style>
-      </p:cxnSp>
-      <p:cxnSp>
-        <p:nvCxnSpPr>
-          <p:cNvPr id="23" name="Gerader Verbinder 22">
-            <a:extLst>
-              <a:ext uri="{FF2B5EF4-FFF2-40B4-BE49-F238E27FC236}">
-                <a16:creationId xmlns:a16="http://schemas.microsoft.com/office/drawing/2014/main" id="{30F250E1-4E7A-318B-21DE-F98119F337EC}"/>
+                <a16:creationId xmlns:a16="http://schemas.microsoft.com/office/drawing/2014/main" id="{366099A2-EBB2-0DB1-C01C-98C258FAC372}"/>
               </a:ext>
             </a:extLst>
           </p:cNvPr>
@@ -26511,17 +28706,17 @@
         </p:nvCxnSpPr>
         <p:spPr>
           <a:xfrm>
-            <a:off x="2625328" y="1192026"/>
-            <a:ext cx="196228" cy="339878"/>
+            <a:off x="1710692" y="1381125"/>
+            <a:ext cx="44766" cy="35730"/>
           </a:xfrm>
           <a:prstGeom prst="line">
             <a:avLst/>
           </a:prstGeom>
-          <a:ln w="25400" cap="rnd">
+          <a:ln w="9525" cap="rnd">
             <a:solidFill>
               <a:schemeClr val="tx1">
-                <a:lumMod val="75000"/>
-                <a:lumOff val="25000"/>
+                <a:lumMod val="65000"/>
+                <a:lumOff val="35000"/>
               </a:schemeClr>
             </a:solidFill>
             <a:round/>
@@ -26544,198 +28739,10 @@
       </p:cxnSp>
       <p:cxnSp>
         <p:nvCxnSpPr>
-          <p:cNvPr id="29" name="Gerader Verbinder 28">
+          <p:cNvPr id="55" name="Gerader Verbinder 54">
             <a:extLst>
               <a:ext uri="{FF2B5EF4-FFF2-40B4-BE49-F238E27FC236}">
-                <a16:creationId xmlns:a16="http://schemas.microsoft.com/office/drawing/2014/main" id="{10CB9BD4-5B5B-6B11-92FE-03FA64F64090}"/>
-              </a:ext>
-            </a:extLst>
-          </p:cNvPr>
-          <p:cNvCxnSpPr>
-            <a:cxnSpLocks/>
-          </p:cNvCxnSpPr>
-          <p:nvPr/>
-        </p:nvCxnSpPr>
-        <p:spPr>
-          <a:xfrm>
-            <a:off x="1134958" y="1810835"/>
-            <a:ext cx="246326" cy="426651"/>
-          </a:xfrm>
-          <a:prstGeom prst="line">
-            <a:avLst/>
-          </a:prstGeom>
-          <a:ln w="25400" cap="rnd">
-            <a:solidFill>
-              <a:schemeClr val="tx1">
-                <a:lumMod val="50000"/>
-                <a:lumOff val="50000"/>
-              </a:schemeClr>
-            </a:solidFill>
-            <a:round/>
-          </a:ln>
-        </p:spPr>
-        <p:style>
-          <a:lnRef idx="2">
-            <a:schemeClr val="accent1"/>
-          </a:lnRef>
-          <a:fillRef idx="0">
-            <a:schemeClr val="accent1"/>
-          </a:fillRef>
-          <a:effectRef idx="1">
-            <a:schemeClr val="accent1"/>
-          </a:effectRef>
-          <a:fontRef idx="minor">
-            <a:schemeClr val="tx1"/>
-          </a:fontRef>
-        </p:style>
-      </p:cxnSp>
-      <p:cxnSp>
-        <p:nvCxnSpPr>
-          <p:cNvPr id="34" name="Gerader Verbinder 33">
-            <a:extLst>
-              <a:ext uri="{FF2B5EF4-FFF2-40B4-BE49-F238E27FC236}">
-                <a16:creationId xmlns:a16="http://schemas.microsoft.com/office/drawing/2014/main" id="{2B6AE206-B998-25EF-5F9C-2AF0B0842AA6}"/>
-              </a:ext>
-            </a:extLst>
-          </p:cNvPr>
-          <p:cNvCxnSpPr>
-            <a:cxnSpLocks/>
-          </p:cNvCxnSpPr>
-          <p:nvPr/>
-        </p:nvCxnSpPr>
-        <p:spPr>
-          <a:xfrm>
-            <a:off x="2660068" y="1299265"/>
-            <a:ext cx="167282" cy="289742"/>
-          </a:xfrm>
-          <a:prstGeom prst="line">
-            <a:avLst/>
-          </a:prstGeom>
-          <a:ln w="25400" cap="rnd">
-            <a:solidFill>
-              <a:schemeClr val="tx1">
-                <a:lumMod val="50000"/>
-                <a:lumOff val="50000"/>
-              </a:schemeClr>
-            </a:solidFill>
-            <a:round/>
-          </a:ln>
-        </p:spPr>
-        <p:style>
-          <a:lnRef idx="2">
-            <a:schemeClr val="accent1"/>
-          </a:lnRef>
-          <a:fillRef idx="0">
-            <a:schemeClr val="accent1"/>
-          </a:fillRef>
-          <a:effectRef idx="1">
-            <a:schemeClr val="accent1"/>
-          </a:effectRef>
-          <a:fontRef idx="minor">
-            <a:schemeClr val="tx1"/>
-          </a:fontRef>
-        </p:style>
-      </p:cxnSp>
-      <p:cxnSp>
-        <p:nvCxnSpPr>
-          <p:cNvPr id="22" name="Gerader Verbinder 21">
-            <a:extLst>
-              <a:ext uri="{FF2B5EF4-FFF2-40B4-BE49-F238E27FC236}">
-                <a16:creationId xmlns:a16="http://schemas.microsoft.com/office/drawing/2014/main" id="{6089DF4C-8452-2402-51AA-59A54FE20195}"/>
-              </a:ext>
-            </a:extLst>
-          </p:cNvPr>
-          <p:cNvCxnSpPr>
-            <a:cxnSpLocks/>
-          </p:cNvCxnSpPr>
-          <p:nvPr/>
-        </p:nvCxnSpPr>
-        <p:spPr>
-          <a:xfrm rot="1800000">
-            <a:off x="2075259" y="1119888"/>
-            <a:ext cx="0" cy="1114425"/>
-          </a:xfrm>
-          <a:prstGeom prst="line">
-            <a:avLst/>
-          </a:prstGeom>
-          <a:ln w="25400" cap="rnd">
-            <a:solidFill>
-              <a:schemeClr val="tx1">
-                <a:lumMod val="75000"/>
-                <a:lumOff val="25000"/>
-              </a:schemeClr>
-            </a:solidFill>
-            <a:round/>
-          </a:ln>
-        </p:spPr>
-        <p:style>
-          <a:lnRef idx="2">
-            <a:schemeClr val="accent1"/>
-          </a:lnRef>
-          <a:fillRef idx="0">
-            <a:schemeClr val="accent1"/>
-          </a:fillRef>
-          <a:effectRef idx="1">
-            <a:schemeClr val="accent1"/>
-          </a:effectRef>
-          <a:fontRef idx="minor">
-            <a:schemeClr val="tx1"/>
-          </a:fontRef>
-        </p:style>
-      </p:cxnSp>
-      <p:cxnSp>
-        <p:nvCxnSpPr>
-          <p:cNvPr id="24" name="Gerader Verbinder 23">
-            <a:extLst>
-              <a:ext uri="{FF2B5EF4-FFF2-40B4-BE49-F238E27FC236}">
-                <a16:creationId xmlns:a16="http://schemas.microsoft.com/office/drawing/2014/main" id="{5D31078C-16A4-CBDA-9E46-41535DCDE69F}"/>
-              </a:ext>
-            </a:extLst>
-          </p:cNvPr>
-          <p:cNvCxnSpPr>
-            <a:cxnSpLocks/>
-          </p:cNvCxnSpPr>
-          <p:nvPr/>
-        </p:nvCxnSpPr>
-        <p:spPr>
-          <a:xfrm flipH="1">
-            <a:off x="2353866" y="1192026"/>
-            <a:ext cx="271462" cy="0"/>
-          </a:xfrm>
-          <a:prstGeom prst="line">
-            <a:avLst/>
-          </a:prstGeom>
-          <a:ln w="25400" cap="rnd">
-            <a:solidFill>
-              <a:schemeClr val="tx1">
-                <a:lumMod val="75000"/>
-                <a:lumOff val="25000"/>
-              </a:schemeClr>
-            </a:solidFill>
-            <a:round/>
-          </a:ln>
-        </p:spPr>
-        <p:style>
-          <a:lnRef idx="2">
-            <a:schemeClr val="accent1"/>
-          </a:lnRef>
-          <a:fillRef idx="0">
-            <a:schemeClr val="accent1"/>
-          </a:fillRef>
-          <a:effectRef idx="1">
-            <a:schemeClr val="accent1"/>
-          </a:effectRef>
-          <a:fontRef idx="minor">
-            <a:schemeClr val="tx1"/>
-          </a:fontRef>
-        </p:style>
-      </p:cxnSp>
-      <p:cxnSp>
-        <p:nvCxnSpPr>
-          <p:cNvPr id="47" name="Gerader Verbinder 46">
-            <a:extLst>
-              <a:ext uri="{FF2B5EF4-FFF2-40B4-BE49-F238E27FC236}">
-                <a16:creationId xmlns:a16="http://schemas.microsoft.com/office/drawing/2014/main" id="{1AB57A79-F17E-36CC-846E-BAEBB8EE38DF}"/>
+                <a16:creationId xmlns:a16="http://schemas.microsoft.com/office/drawing/2014/main" id="{2814265C-14F8-D486-24E6-9064AF40EF94}"/>
               </a:ext>
             </a:extLst>
           </p:cNvPr>
@@ -26746,111 +28753,20 @@
         </p:nvCxnSpPr>
         <p:spPr>
           <a:xfrm flipV="1">
-            <a:off x="534591" y="1307306"/>
-            <a:ext cx="0" cy="1518047"/>
+            <a:off x="1710692" y="1693483"/>
+            <a:ext cx="44766" cy="35730"/>
           </a:xfrm>
           <a:prstGeom prst="line">
             <a:avLst/>
           </a:prstGeom>
-          <a:ln w="19050" cap="rnd">
+          <a:ln w="9525" cap="rnd">
             <a:solidFill>
-              <a:schemeClr val="tx1"/>
+              <a:schemeClr val="tx1">
+                <a:lumMod val="65000"/>
+                <a:lumOff val="35000"/>
+              </a:schemeClr>
             </a:solidFill>
             <a:round/>
-            <a:headEnd type="none"/>
-            <a:tailEnd type="triangle" w="med" len="med"/>
-          </a:ln>
-        </p:spPr>
-        <p:style>
-          <a:lnRef idx="2">
-            <a:schemeClr val="accent1"/>
-          </a:lnRef>
-          <a:fillRef idx="0">
-            <a:schemeClr val="accent1"/>
-          </a:fillRef>
-          <a:effectRef idx="1">
-            <a:schemeClr val="accent1"/>
-          </a:effectRef>
-          <a:fontRef idx="minor">
-            <a:schemeClr val="tx1"/>
-          </a:fontRef>
-        </p:style>
-      </p:cxnSp>
-      <p:cxnSp>
-        <p:nvCxnSpPr>
-          <p:cNvPr id="50" name="Gerader Verbinder 49">
-            <a:extLst>
-              <a:ext uri="{FF2B5EF4-FFF2-40B4-BE49-F238E27FC236}">
-                <a16:creationId xmlns:a16="http://schemas.microsoft.com/office/drawing/2014/main" id="{92646F9A-D16D-32F2-BAF6-C6387CBA3DF2}"/>
-              </a:ext>
-            </a:extLst>
-          </p:cNvPr>
-          <p:cNvCxnSpPr>
-            <a:cxnSpLocks/>
-          </p:cNvCxnSpPr>
-          <p:nvPr/>
-        </p:nvCxnSpPr>
-        <p:spPr>
-          <a:xfrm flipV="1">
-            <a:off x="944169" y="2357437"/>
-            <a:ext cx="0" cy="467916"/>
-          </a:xfrm>
-          <a:prstGeom prst="line">
-            <a:avLst/>
-          </a:prstGeom>
-          <a:ln w="19050" cap="rnd">
-            <a:solidFill>
-              <a:srgbClr val="129F57"/>
-            </a:solidFill>
-            <a:round/>
-            <a:headEnd type="none"/>
-            <a:tailEnd type="triangle" w="med" len="med"/>
-          </a:ln>
-        </p:spPr>
-        <p:style>
-          <a:lnRef idx="2">
-            <a:schemeClr val="accent1"/>
-          </a:lnRef>
-          <a:fillRef idx="0">
-            <a:schemeClr val="accent1"/>
-          </a:fillRef>
-          <a:effectRef idx="1">
-            <a:schemeClr val="accent1"/>
-          </a:effectRef>
-          <a:fontRef idx="minor">
-            <a:schemeClr val="tx1"/>
-          </a:fontRef>
-        </p:style>
-      </p:cxnSp>
-      <p:cxnSp>
-        <p:nvCxnSpPr>
-          <p:cNvPr id="54" name="Gerader Verbinder 53">
-            <a:extLst>
-              <a:ext uri="{FF2B5EF4-FFF2-40B4-BE49-F238E27FC236}">
-                <a16:creationId xmlns:a16="http://schemas.microsoft.com/office/drawing/2014/main" id="{48176325-072D-8C14-DCE1-A505285255AF}"/>
-              </a:ext>
-            </a:extLst>
-          </p:cNvPr>
-          <p:cNvCxnSpPr>
-            <a:cxnSpLocks/>
-          </p:cNvCxnSpPr>
-          <p:nvPr/>
-        </p:nvCxnSpPr>
-        <p:spPr>
-          <a:xfrm>
-            <a:off x="871538" y="2351007"/>
-            <a:ext cx="707231" cy="0"/>
-          </a:xfrm>
-          <a:prstGeom prst="line">
-            <a:avLst/>
-          </a:prstGeom>
-          <a:ln w="19050" cap="rnd">
-            <a:solidFill>
-              <a:srgbClr val="129F57"/>
-            </a:solidFill>
-            <a:round/>
-            <a:headEnd type="none"/>
-            <a:tailEnd type="none" w="med" len="med"/>
           </a:ln>
         </p:spPr>
         <p:style>
@@ -26870,10 +28786,10 @@
       </p:cxnSp>
       <p:sp>
         <p:nvSpPr>
-          <p:cNvPr id="40" name="Bogen 39">
+          <p:cNvPr id="27" name="Rechteck 26">
             <a:extLst>
               <a:ext uri="{FF2B5EF4-FFF2-40B4-BE49-F238E27FC236}">
-                <a16:creationId xmlns:a16="http://schemas.microsoft.com/office/drawing/2014/main" id="{63779C0E-8A0B-6911-7CB9-2BE8535F563D}"/>
+                <a16:creationId xmlns:a16="http://schemas.microsoft.com/office/drawing/2014/main" id="{A6611235-7DE4-D681-C4CC-15CA9F140086}"/>
               </a:ext>
             </a:extLst>
           </p:cNvPr>
@@ -26882,406 +28798,25 @@
         </p:nvSpPr>
         <p:spPr>
           <a:xfrm>
-            <a:off x="1350662" y="1892599"/>
-            <a:ext cx="458408" cy="458408"/>
-          </a:xfrm>
-          <a:prstGeom prst="arc">
-            <a:avLst>
-              <a:gd name="adj1" fmla="val 1702990"/>
-              <a:gd name="adj2" fmla="val 9095753"/>
-            </a:avLst>
-          </a:prstGeom>
-          <a:ln w="25400" cap="rnd">
-            <a:solidFill>
-              <a:schemeClr val="tx1">
-                <a:lumMod val="50000"/>
-                <a:lumOff val="50000"/>
-              </a:schemeClr>
-            </a:solidFill>
-            <a:round/>
-          </a:ln>
-        </p:spPr>
-        <p:style>
-          <a:lnRef idx="2">
-            <a:schemeClr val="accent1"/>
-          </a:lnRef>
-          <a:fillRef idx="0">
-            <a:schemeClr val="accent1"/>
-          </a:fillRef>
-          <a:effectRef idx="1">
-            <a:schemeClr val="accent1"/>
-          </a:effectRef>
-          <a:fontRef idx="minor">
-            <a:schemeClr val="tx1"/>
-          </a:fontRef>
-        </p:style>
-        <p:txBody>
-          <a:bodyPr rtlCol="0" anchor="ctr"/>
-          <a:lstStyle/>
-          <a:p>
-            <a:pPr algn="ctr"/>
-            <a:endParaRPr lang="de-DE"/>
-          </a:p>
-        </p:txBody>
-      </p:sp>
-      <p:cxnSp>
-        <p:nvCxnSpPr>
-          <p:cNvPr id="42" name="Gerader Verbinder 41">
-            <a:extLst>
-              <a:ext uri="{FF2B5EF4-FFF2-40B4-BE49-F238E27FC236}">
-                <a16:creationId xmlns:a16="http://schemas.microsoft.com/office/drawing/2014/main" id="{3D8C3FA1-9986-F923-AD94-D25533B59BBF}"/>
-              </a:ext>
-            </a:extLst>
-          </p:cNvPr>
-          <p:cNvCxnSpPr>
-            <a:cxnSpLocks/>
-          </p:cNvCxnSpPr>
-          <p:nvPr/>
-        </p:nvCxnSpPr>
-        <p:spPr>
-          <a:xfrm flipH="1">
-            <a:off x="464344" y="1299186"/>
-            <a:ext cx="1889522" cy="0"/>
-          </a:xfrm>
-          <a:prstGeom prst="line">
-            <a:avLst/>
-          </a:prstGeom>
-          <a:ln w="19050" cap="rnd">
-            <a:solidFill>
-              <a:schemeClr val="tx1"/>
-            </a:solidFill>
-            <a:round/>
-          </a:ln>
-        </p:spPr>
-        <p:style>
-          <a:lnRef idx="2">
-            <a:schemeClr val="accent1"/>
-          </a:lnRef>
-          <a:fillRef idx="0">
-            <a:schemeClr val="accent1"/>
-          </a:fillRef>
-          <a:effectRef idx="1">
-            <a:schemeClr val="accent1"/>
-          </a:effectRef>
-          <a:fontRef idx="minor">
-            <a:schemeClr val="tx1"/>
-          </a:fontRef>
-        </p:style>
-      </p:cxnSp>
-      <p:cxnSp>
-        <p:nvCxnSpPr>
-          <p:cNvPr id="38" name="Gerader Verbinder 37">
-            <a:extLst>
-              <a:ext uri="{FF2B5EF4-FFF2-40B4-BE49-F238E27FC236}">
-                <a16:creationId xmlns:a16="http://schemas.microsoft.com/office/drawing/2014/main" id="{E0FAF1BD-CFD3-1962-B4E0-F89200F8836C}"/>
-              </a:ext>
-            </a:extLst>
-          </p:cNvPr>
-          <p:cNvCxnSpPr>
-            <a:cxnSpLocks/>
-          </p:cNvCxnSpPr>
-          <p:nvPr/>
-        </p:nvCxnSpPr>
-        <p:spPr>
-          <a:xfrm flipH="1">
-            <a:off x="2326278" y="1299265"/>
-            <a:ext cx="333790" cy="0"/>
-          </a:xfrm>
-          <a:prstGeom prst="line">
-            <a:avLst/>
-          </a:prstGeom>
-          <a:ln w="25400" cap="rnd">
-            <a:solidFill>
-              <a:schemeClr val="tx1">
-                <a:lumMod val="50000"/>
-                <a:lumOff val="50000"/>
-              </a:schemeClr>
-            </a:solidFill>
-            <a:round/>
-          </a:ln>
-        </p:spPr>
-        <p:style>
-          <a:lnRef idx="2">
-            <a:schemeClr val="accent1"/>
-          </a:lnRef>
-          <a:fillRef idx="0">
-            <a:schemeClr val="accent1"/>
-          </a:fillRef>
-          <a:effectRef idx="1">
-            <a:schemeClr val="accent1"/>
-          </a:effectRef>
-          <a:fontRef idx="minor">
-            <a:schemeClr val="tx1"/>
-          </a:fontRef>
-        </p:style>
-      </p:cxnSp>
-      <p:cxnSp>
-        <p:nvCxnSpPr>
-          <p:cNvPr id="31" name="Gerader Verbinder 30">
-            <a:extLst>
-              <a:ext uri="{FF2B5EF4-FFF2-40B4-BE49-F238E27FC236}">
-                <a16:creationId xmlns:a16="http://schemas.microsoft.com/office/drawing/2014/main" id="{30F8BD50-2FDD-CED7-E5E6-AB541FA02ACD}"/>
-              </a:ext>
-            </a:extLst>
-          </p:cNvPr>
-          <p:cNvCxnSpPr>
-            <a:cxnSpLocks/>
-          </p:cNvCxnSpPr>
-          <p:nvPr/>
-        </p:nvCxnSpPr>
-        <p:spPr>
-          <a:xfrm flipH="1">
-            <a:off x="1776543" y="1299265"/>
-            <a:ext cx="542152" cy="939034"/>
-          </a:xfrm>
-          <a:prstGeom prst="line">
-            <a:avLst/>
-          </a:prstGeom>
-          <a:ln w="25400" cap="rnd">
-            <a:solidFill>
-              <a:schemeClr val="tx1">
-                <a:lumMod val="50000"/>
-                <a:lumOff val="50000"/>
-              </a:schemeClr>
-            </a:solidFill>
-            <a:round/>
-          </a:ln>
-        </p:spPr>
-        <p:style>
-          <a:lnRef idx="2">
-            <a:schemeClr val="accent1"/>
-          </a:lnRef>
-          <a:fillRef idx="0">
-            <a:schemeClr val="accent1"/>
-          </a:fillRef>
-          <a:effectRef idx="1">
-            <a:schemeClr val="accent1"/>
-          </a:effectRef>
-          <a:fontRef idx="minor">
-            <a:schemeClr val="tx1"/>
-          </a:fontRef>
-        </p:style>
-      </p:cxnSp>
-      <p:sp>
-        <p:nvSpPr>
-          <p:cNvPr id="69" name="Bogen 68">
-            <a:extLst>
-              <a:ext uri="{FF2B5EF4-FFF2-40B4-BE49-F238E27FC236}">
-                <a16:creationId xmlns:a16="http://schemas.microsoft.com/office/drawing/2014/main" id="{83938D83-386C-6130-3C04-83D6A5E0A15C}"/>
-              </a:ext>
-            </a:extLst>
-          </p:cNvPr>
-          <p:cNvSpPr/>
-          <p:nvPr/>
-        </p:nvSpPr>
-        <p:spPr>
-          <a:xfrm>
-            <a:off x="1943100" y="522025"/>
-            <a:ext cx="1097280" cy="1097280"/>
-          </a:xfrm>
-          <a:prstGeom prst="arc">
-            <a:avLst>
-              <a:gd name="adj1" fmla="val 3444594"/>
-              <a:gd name="adj2" fmla="val 7362056"/>
-            </a:avLst>
-          </a:prstGeom>
-          <a:ln w="19050" cap="rnd">
-            <a:solidFill>
-              <a:schemeClr val="accent5">
-                <a:lumMod val="75000"/>
-              </a:schemeClr>
-            </a:solidFill>
-            <a:round/>
-            <a:headEnd type="triangle"/>
-            <a:tailEnd type="triangle"/>
-          </a:ln>
-        </p:spPr>
-        <p:style>
-          <a:lnRef idx="2">
-            <a:schemeClr val="accent1"/>
-          </a:lnRef>
-          <a:fillRef idx="0">
-            <a:schemeClr val="accent1"/>
-          </a:fillRef>
-          <a:effectRef idx="1">
-            <a:schemeClr val="accent1"/>
-          </a:effectRef>
-          <a:fontRef idx="minor">
-            <a:schemeClr val="tx1"/>
-          </a:fontRef>
-        </p:style>
-        <p:txBody>
-          <a:bodyPr rtlCol="0" anchor="ctr"/>
-          <a:lstStyle/>
-          <a:p>
-            <a:pPr algn="ctr"/>
-            <a:endParaRPr lang="de-DE"/>
-          </a:p>
-        </p:txBody>
-      </p:sp>
-      <p:sp>
-        <p:nvSpPr>
-          <p:cNvPr id="71" name="Textfeld 70">
-            <a:extLst>
-              <a:ext uri="{FF2B5EF4-FFF2-40B4-BE49-F238E27FC236}">
-                <a16:creationId xmlns:a16="http://schemas.microsoft.com/office/drawing/2014/main" id="{227C6A32-67F6-767E-1D8B-39F2FAB97710}"/>
-              </a:ext>
-            </a:extLst>
-          </p:cNvPr>
-          <p:cNvSpPr txBox="1"/>
-          <p:nvPr/>
-        </p:nvSpPr>
-        <p:spPr>
-          <a:xfrm>
-            <a:off x="2251263" y="1294728"/>
-            <a:ext cx="542152" cy="338554"/>
+            <a:off x="2163603" y="1120140"/>
+            <a:ext cx="45720" cy="872490"/>
           </a:xfrm>
           <a:prstGeom prst="rect">
             <a:avLst/>
           </a:prstGeom>
-          <a:noFill/>
-        </p:spPr>
-        <p:txBody>
-          <a:bodyPr wrap="square" rtlCol="0" anchor="ctr">
-            <a:spAutoFit/>
-          </a:bodyPr>
-          <a:lstStyle/>
-          <a:p>
-            <a:pPr algn="ctr"/>
-            <a:r>
-              <a:rPr lang="de-DE" sz="1600" dirty="0">
-                <a:solidFill>
-                  <a:schemeClr val="accent5">
-                    <a:lumMod val="75000"/>
-                  </a:schemeClr>
-                </a:solidFill>
-                <a:latin typeface="CMU Serif" panose="02000603000000000000" pitchFamily="2" charset="0"/>
-                <a:ea typeface="CMU Serif" panose="02000603000000000000" pitchFamily="2" charset="0"/>
-                <a:cs typeface="CMU Serif" panose="02000603000000000000" pitchFamily="2" charset="0"/>
-              </a:rPr>
-              <a:t>60°</a:t>
-            </a:r>
-          </a:p>
-        </p:txBody>
-      </p:sp>
-      <p:sp>
-        <p:nvSpPr>
-          <p:cNvPr id="73" name="Textfeld 72">
-            <a:extLst>
-              <a:ext uri="{FF2B5EF4-FFF2-40B4-BE49-F238E27FC236}">
-                <a16:creationId xmlns:a16="http://schemas.microsoft.com/office/drawing/2014/main" id="{406BE07A-AA2A-4A01-ED39-74AEF838B39D}"/>
-              </a:ext>
-            </a:extLst>
-          </p:cNvPr>
-          <p:cNvSpPr txBox="1"/>
-          <p:nvPr/>
-        </p:nvSpPr>
-        <p:spPr>
-          <a:xfrm>
-            <a:off x="1271032" y="814443"/>
-            <a:ext cx="936022" cy="338554"/>
-          </a:xfrm>
-          <a:prstGeom prst="rect">
-            <a:avLst/>
-          </a:prstGeom>
-          <a:noFill/>
-        </p:spPr>
-        <p:txBody>
-          <a:bodyPr wrap="square" rtlCol="0" anchor="ctr">
-            <a:spAutoFit/>
-          </a:bodyPr>
-          <a:lstStyle/>
-          <a:p>
-            <a:pPr algn="ctr"/>
-            <a:r>
-              <a:rPr lang="de-DE" sz="1600" dirty="0">
-                <a:solidFill>
-                  <a:schemeClr val="bg1"/>
-                </a:solidFill>
-                <a:latin typeface="CMU Serif" panose="02000603000000000000" pitchFamily="2" charset="0"/>
-                <a:ea typeface="CMU Serif" panose="02000603000000000000" pitchFamily="2" charset="0"/>
-                <a:cs typeface="CMU Serif" panose="02000603000000000000" pitchFamily="2" charset="0"/>
-              </a:rPr>
-              <a:t>Mutter</a:t>
-            </a:r>
-          </a:p>
-        </p:txBody>
-      </p:sp>
-      <p:sp>
-        <p:nvSpPr>
-          <p:cNvPr id="75" name="Textfeld 74">
-            <a:extLst>
-              <a:ext uri="{FF2B5EF4-FFF2-40B4-BE49-F238E27FC236}">
-                <a16:creationId xmlns:a16="http://schemas.microsoft.com/office/drawing/2014/main" id="{637D8646-A935-83C2-6161-58DB3B85D5D9}"/>
-              </a:ext>
-            </a:extLst>
-          </p:cNvPr>
-          <p:cNvSpPr txBox="1"/>
-          <p:nvPr/>
-        </p:nvSpPr>
-        <p:spPr>
-          <a:xfrm>
-            <a:off x="1830705" y="2264307"/>
-            <a:ext cx="1062272" cy="338554"/>
-          </a:xfrm>
-          <a:prstGeom prst="rect">
-            <a:avLst/>
-          </a:prstGeom>
-          <a:noFill/>
-        </p:spPr>
-        <p:txBody>
-          <a:bodyPr wrap="square" rtlCol="0" anchor="ctr">
-            <a:spAutoFit/>
-          </a:bodyPr>
-          <a:lstStyle/>
-          <a:p>
-            <a:pPr algn="ctr"/>
-            <a:r>
-              <a:rPr lang="de-DE" sz="1600" dirty="0">
-                <a:latin typeface="CMU Serif" panose="02000603000000000000" pitchFamily="2" charset="0"/>
-                <a:ea typeface="CMU Serif" panose="02000603000000000000" pitchFamily="2" charset="0"/>
-                <a:cs typeface="CMU Serif" panose="02000603000000000000" pitchFamily="2" charset="0"/>
-              </a:rPr>
-              <a:t>Schraube</a:t>
-            </a:r>
-          </a:p>
-        </p:txBody>
-      </p:sp>
-      <p:sp>
-        <p:nvSpPr>
-          <p:cNvPr id="77" name="Rechteck 76">
-            <a:extLst>
-              <a:ext uri="{FF2B5EF4-FFF2-40B4-BE49-F238E27FC236}">
-                <a16:creationId xmlns:a16="http://schemas.microsoft.com/office/drawing/2014/main" id="{C8EC96EF-A4F1-5933-9BD7-17B0BDB79FDE}"/>
-              </a:ext>
-            </a:extLst>
-          </p:cNvPr>
-          <p:cNvSpPr/>
-          <p:nvPr/>
-        </p:nvSpPr>
-        <p:spPr>
-          <a:xfrm rot="16200000">
-            <a:off x="1727587" y="1231094"/>
-            <a:ext cx="210739" cy="3092075"/>
-          </a:xfrm>
-          <a:prstGeom prst="rect">
-            <a:avLst/>
-          </a:prstGeom>
-          <a:gradFill>
-            <a:gsLst>
-              <a:gs pos="50000">
-                <a:schemeClr val="bg1"/>
-              </a:gs>
-              <a:gs pos="100000">
-                <a:schemeClr val="bg1">
-                  <a:alpha val="0"/>
-                </a:schemeClr>
-              </a:gs>
-            </a:gsLst>
-            <a:lin ang="0" scaled="0"/>
-          </a:gradFill>
-          <a:ln>
-            <a:noFill/>
+          <a:solidFill>
+            <a:schemeClr val="bg1">
+              <a:lumMod val="85000"/>
+            </a:schemeClr>
+          </a:solidFill>
+          <a:ln cap="rnd">
+            <a:solidFill>
+              <a:schemeClr val="tx1">
+                <a:lumMod val="65000"/>
+                <a:lumOff val="35000"/>
+              </a:schemeClr>
+            </a:solidFill>
+            <a:round/>
           </a:ln>
         </p:spPr>
         <p:style>
@@ -27309,203 +28844,496 @@
           </a:p>
         </p:txBody>
       </p:sp>
-      <p:sp>
-        <p:nvSpPr>
-          <p:cNvPr id="62" name="Textfeld 61">
+      <p:grpSp>
+        <p:nvGrpSpPr>
+          <p:cNvPr id="32" name="Gruppieren 31">
             <a:extLst>
               <a:ext uri="{FF2B5EF4-FFF2-40B4-BE49-F238E27FC236}">
-                <a16:creationId xmlns:a16="http://schemas.microsoft.com/office/drawing/2014/main" id="{1561EB07-B67D-7CB8-D5AD-EE55718FD0EF}"/>
+                <a16:creationId xmlns:a16="http://schemas.microsoft.com/office/drawing/2014/main" id="{31CE27E4-57AF-B77A-713F-E57D3279FE8A}"/>
               </a:ext>
             </a:extLst>
           </p:cNvPr>
-          <p:cNvSpPr txBox="1"/>
+          <p:cNvGrpSpPr/>
           <p:nvPr/>
-        </p:nvSpPr>
-        <p:spPr>
+        </p:nvGrpSpPr>
+        <p:grpSpPr>
           <a:xfrm>
-            <a:off x="293783" y="1854883"/>
-            <a:ext cx="220157" cy="338554"/>
+            <a:off x="2219801" y="1178264"/>
+            <a:ext cx="303372" cy="756241"/>
+            <a:chOff x="1133952" y="1178264"/>
+            <a:chExt cx="303372" cy="756241"/>
           </a:xfrm>
-          <a:prstGeom prst="rect">
-            <a:avLst/>
-          </a:prstGeom>
-          <a:noFill/>
-        </p:spPr>
-        <p:txBody>
-          <a:bodyPr wrap="square" rtlCol="0" anchor="ctr">
-            <a:spAutoFit/>
-          </a:bodyPr>
-          <a:lstStyle/>
-          <a:p>
-            <a:pPr algn="ctr"/>
-            <a:r>
-              <a:rPr lang="de-DE" sz="1600" i="1" dirty="0">
-                <a:latin typeface="CMU Serif" panose="02000603000000000000" pitchFamily="2" charset="0"/>
-                <a:ea typeface="CMU Serif" panose="02000603000000000000" pitchFamily="2" charset="0"/>
-                <a:cs typeface="CMU Serif" panose="02000603000000000000" pitchFamily="2" charset="0"/>
-              </a:rPr>
-              <a:t>d</a:t>
-            </a:r>
-          </a:p>
-        </p:txBody>
-      </p:sp>
-      <p:sp>
-        <p:nvSpPr>
-          <p:cNvPr id="64" name="Textfeld 63">
-            <a:extLst>
-              <a:ext uri="{FF2B5EF4-FFF2-40B4-BE49-F238E27FC236}">
-                <a16:creationId xmlns:a16="http://schemas.microsoft.com/office/drawing/2014/main" id="{5AE8FFFC-09F5-EE07-4FA7-63DFB991AA5B}"/>
-              </a:ext>
-            </a:extLst>
-          </p:cNvPr>
-          <p:cNvSpPr txBox="1"/>
-          <p:nvPr/>
-        </p:nvSpPr>
-        <p:spPr>
-          <a:xfrm>
-            <a:off x="596096" y="2392550"/>
-            <a:ext cx="357620" cy="338554"/>
-          </a:xfrm>
-          <a:prstGeom prst="rect">
-            <a:avLst/>
-          </a:prstGeom>
-          <a:noFill/>
-        </p:spPr>
-        <p:txBody>
-          <a:bodyPr wrap="square" rtlCol="0" anchor="ctr">
-            <a:spAutoFit/>
-          </a:bodyPr>
-          <a:lstStyle/>
-          <a:p>
-            <a:pPr algn="ctr"/>
-            <a:r>
-              <a:rPr lang="de-DE" sz="1600" i="1" dirty="0">
-                <a:solidFill>
-                  <a:srgbClr val="129F57"/>
-                </a:solidFill>
-                <a:latin typeface="CMU Serif" panose="02000603000000000000" pitchFamily="2" charset="0"/>
-                <a:ea typeface="CMU Serif" panose="02000603000000000000" pitchFamily="2" charset="0"/>
-                <a:cs typeface="CMU Serif" panose="02000603000000000000" pitchFamily="2" charset="0"/>
-              </a:rPr>
-              <a:t>d</a:t>
-            </a:r>
-            <a:r>
-              <a:rPr lang="de-DE" sz="1600" baseline="-25000" dirty="0">
-                <a:solidFill>
-                  <a:srgbClr val="129F57"/>
-                </a:solidFill>
-                <a:latin typeface="CMU Serif" panose="02000603000000000000" pitchFamily="2" charset="0"/>
-                <a:ea typeface="CMU Serif" panose="02000603000000000000" pitchFamily="2" charset="0"/>
-                <a:cs typeface="CMU Serif" panose="02000603000000000000" pitchFamily="2" charset="0"/>
-              </a:rPr>
-              <a:t>3</a:t>
-            </a:r>
-          </a:p>
-        </p:txBody>
-      </p:sp>
-      <p:cxnSp>
-        <p:nvCxnSpPr>
-          <p:cNvPr id="80" name="Gerader Verbinder 79">
-            <a:extLst>
-              <a:ext uri="{FF2B5EF4-FFF2-40B4-BE49-F238E27FC236}">
-                <a16:creationId xmlns:a16="http://schemas.microsoft.com/office/drawing/2014/main" id="{BA97D623-D15D-46D0-E160-8D188240D0F0}"/>
-              </a:ext>
-            </a:extLst>
-          </p:cNvPr>
-          <p:cNvCxnSpPr>
-            <a:cxnSpLocks/>
-          </p:cNvCxnSpPr>
-          <p:nvPr/>
-        </p:nvCxnSpPr>
-        <p:spPr>
-          <a:xfrm flipH="1">
-            <a:off x="914400" y="1768782"/>
-            <a:ext cx="2164557" cy="0"/>
-          </a:xfrm>
-          <a:prstGeom prst="line">
-            <a:avLst/>
-          </a:prstGeom>
-          <a:ln w="12700" cap="rnd">
+        </p:grpSpPr>
+        <p:sp>
+          <p:nvSpPr>
+            <p:cNvPr id="33" name="Rechteck 32">
+              <a:extLst>
+                <a:ext uri="{FF2B5EF4-FFF2-40B4-BE49-F238E27FC236}">
+                  <a16:creationId xmlns:a16="http://schemas.microsoft.com/office/drawing/2014/main" id="{954F8A97-7E2B-06B6-BBC6-090FA4AE1E92}"/>
+                </a:ext>
+              </a:extLst>
+            </p:cNvPr>
+            <p:cNvSpPr/>
+            <p:nvPr/>
+          </p:nvSpPr>
+          <p:spPr>
+            <a:xfrm>
+              <a:off x="1137285" y="1264920"/>
+              <a:ext cx="298611" cy="582930"/>
+            </a:xfrm>
+            <a:prstGeom prst="rect">
+              <a:avLst/>
+            </a:prstGeom>
             <a:solidFill>
-              <a:srgbClr val="086FBD"/>
+              <a:schemeClr val="bg1">
+                <a:lumMod val="85000"/>
+              </a:schemeClr>
             </a:solidFill>
-            <a:prstDash val="lgDashDot"/>
-            <a:round/>
-          </a:ln>
-        </p:spPr>
-        <p:style>
-          <a:lnRef idx="2">
-            <a:schemeClr val="accent1"/>
-          </a:lnRef>
-          <a:fillRef idx="0">
-            <a:schemeClr val="accent1"/>
-          </a:fillRef>
-          <a:effectRef idx="1">
-            <a:schemeClr val="accent1"/>
-          </a:effectRef>
-          <a:fontRef idx="minor">
-            <a:schemeClr val="tx1"/>
-          </a:fontRef>
-        </p:style>
-      </p:cxnSp>
-      <p:sp>
-        <p:nvSpPr>
-          <p:cNvPr id="86" name="Textfeld 85">
-            <a:extLst>
-              <a:ext uri="{FF2B5EF4-FFF2-40B4-BE49-F238E27FC236}">
-                <a16:creationId xmlns:a16="http://schemas.microsoft.com/office/drawing/2014/main" id="{EFEF53EA-4794-3F70-7C46-8456415EBA8C}"/>
-              </a:ext>
-            </a:extLst>
-          </p:cNvPr>
-          <p:cNvSpPr txBox="1"/>
-          <p:nvPr/>
-        </p:nvSpPr>
-        <p:spPr>
-          <a:xfrm>
-            <a:off x="2981840" y="2124044"/>
-            <a:ext cx="357620" cy="338554"/>
-          </a:xfrm>
-          <a:prstGeom prst="rect">
-            <a:avLst/>
-          </a:prstGeom>
-          <a:noFill/>
-        </p:spPr>
-        <p:txBody>
-          <a:bodyPr wrap="square" rtlCol="0" anchor="ctr">
-            <a:spAutoFit/>
-          </a:bodyPr>
-          <a:lstStyle/>
-          <a:p>
-            <a:pPr algn="ctr"/>
-            <a:r>
-              <a:rPr lang="de-DE" sz="1600" i="1" dirty="0">
-                <a:solidFill>
-                  <a:srgbClr val="086FBD"/>
-                </a:solidFill>
-                <a:latin typeface="CMU Serif" panose="02000603000000000000" pitchFamily="2" charset="0"/>
-                <a:ea typeface="CMU Serif" panose="02000603000000000000" pitchFamily="2" charset="0"/>
-                <a:cs typeface="CMU Serif" panose="02000603000000000000" pitchFamily="2" charset="0"/>
-              </a:rPr>
-              <a:t>d</a:t>
-            </a:r>
-            <a:r>
-              <a:rPr lang="de-DE" sz="1600" baseline="-25000" dirty="0">
-                <a:solidFill>
-                  <a:srgbClr val="086FBD"/>
-                </a:solidFill>
-                <a:latin typeface="CMU Serif" panose="02000603000000000000" pitchFamily="2" charset="0"/>
-                <a:ea typeface="CMU Serif" panose="02000603000000000000" pitchFamily="2" charset="0"/>
-                <a:cs typeface="CMU Serif" panose="02000603000000000000" pitchFamily="2" charset="0"/>
-              </a:rPr>
-              <a:t>2</a:t>
-            </a:r>
-          </a:p>
-        </p:txBody>
-      </p:sp>
+            <a:ln cap="rnd">
+              <a:solidFill>
+                <a:schemeClr val="tx1">
+                  <a:lumMod val="65000"/>
+                  <a:lumOff val="35000"/>
+                </a:schemeClr>
+              </a:solidFill>
+              <a:round/>
+            </a:ln>
+          </p:spPr>
+          <p:style>
+            <a:lnRef idx="2">
+              <a:schemeClr val="accent1">
+                <a:shade val="15000"/>
+              </a:schemeClr>
+            </a:lnRef>
+            <a:fillRef idx="1">
+              <a:schemeClr val="accent1"/>
+            </a:fillRef>
+            <a:effectRef idx="0">
+              <a:schemeClr val="accent1"/>
+            </a:effectRef>
+            <a:fontRef idx="minor">
+              <a:schemeClr val="lt1"/>
+            </a:fontRef>
+          </p:style>
+          <p:txBody>
+            <a:bodyPr rtlCol="0" anchor="ctr"/>
+            <a:lstStyle/>
+            <a:p>
+              <a:pPr algn="ctr"/>
+              <a:endParaRPr lang="de-DE"/>
+            </a:p>
+          </p:txBody>
+        </p:sp>
+        <p:sp>
+          <p:nvSpPr>
+            <p:cNvPr id="34" name="Freihandform: Form 33">
+              <a:extLst>
+                <a:ext uri="{FF2B5EF4-FFF2-40B4-BE49-F238E27FC236}">
+                  <a16:creationId xmlns:a16="http://schemas.microsoft.com/office/drawing/2014/main" id="{0BE7E2BB-32E1-12B3-5ECF-A2E2B0F97529}"/>
+                </a:ext>
+              </a:extLst>
+            </p:cNvPr>
+            <p:cNvSpPr/>
+            <p:nvPr/>
+          </p:nvSpPr>
+          <p:spPr>
+            <a:xfrm>
+              <a:off x="1133952" y="1178264"/>
+              <a:ext cx="303372" cy="179070"/>
+            </a:xfrm>
+            <a:custGeom>
+              <a:avLst/>
+              <a:gdLst>
+                <a:gd name="csX0" fmla="*/ 57153 w 352459"/>
+                <a:gd name="csY0" fmla="*/ 382905 h 382905"/>
+                <a:gd name="csX1" fmla="*/ 3 w 352459"/>
+                <a:gd name="csY1" fmla="*/ 196215 h 382905"/>
+                <a:gd name="csX2" fmla="*/ 55248 w 352459"/>
+                <a:gd name="csY2" fmla="*/ 0 h 382905"/>
+                <a:gd name="csX3" fmla="*/ 299088 w 352459"/>
+                <a:gd name="csY3" fmla="*/ 0 h 382905"/>
+                <a:gd name="csX4" fmla="*/ 352428 w 352459"/>
+                <a:gd name="csY4" fmla="*/ 192405 h 382905"/>
+                <a:gd name="csX5" fmla="*/ 300013 w 352459"/>
+                <a:gd name="csY5" fmla="*/ 381000 h 382905"/>
+                <a:gd name="csX6" fmla="*/ 57153 w 352459"/>
+                <a:gd name="csY6" fmla="*/ 382905 h 382905"/>
+              </a:gdLst>
+              <a:ahLst/>
+              <a:cxnLst>
+                <a:cxn ang="0">
+                  <a:pos x="csX0" y="csY0"/>
+                </a:cxn>
+                <a:cxn ang="0">
+                  <a:pos x="csX1" y="csY1"/>
+                </a:cxn>
+                <a:cxn ang="0">
+                  <a:pos x="csX2" y="csY2"/>
+                </a:cxn>
+                <a:cxn ang="0">
+                  <a:pos x="csX3" y="csY3"/>
+                </a:cxn>
+                <a:cxn ang="0">
+                  <a:pos x="csX4" y="csY4"/>
+                </a:cxn>
+                <a:cxn ang="0">
+                  <a:pos x="csX5" y="csY5"/>
+                </a:cxn>
+                <a:cxn ang="0">
+                  <a:pos x="csX6" y="csY6"/>
+                </a:cxn>
+              </a:cxnLst>
+              <a:rect l="l" t="t" r="r" b="b"/>
+              <a:pathLst>
+                <a:path w="352459" h="382905">
+                  <a:moveTo>
+                    <a:pt x="57153" y="382905"/>
+                  </a:moveTo>
+                  <a:cubicBezTo>
+                    <a:pt x="20481" y="318928"/>
+                    <a:pt x="320" y="260032"/>
+                    <a:pt x="3" y="196215"/>
+                  </a:cubicBezTo>
+                  <a:cubicBezTo>
+                    <a:pt x="-314" y="132398"/>
+                    <a:pt x="24768" y="51435"/>
+                    <a:pt x="55248" y="0"/>
+                  </a:cubicBezTo>
+                  <a:lnTo>
+                    <a:pt x="299088" y="0"/>
+                  </a:lnTo>
+                  <a:cubicBezTo>
+                    <a:pt x="332743" y="53975"/>
+                    <a:pt x="353381" y="128905"/>
+                    <a:pt x="352428" y="192405"/>
+                  </a:cubicBezTo>
+                  <a:cubicBezTo>
+                    <a:pt x="351476" y="255905"/>
+                    <a:pt x="340018" y="328930"/>
+                    <a:pt x="300013" y="381000"/>
+                  </a:cubicBezTo>
+                  <a:lnTo>
+                    <a:pt x="57153" y="382905"/>
+                  </a:lnTo>
+                  <a:close/>
+                </a:path>
+              </a:pathLst>
+            </a:custGeom>
+            <a:solidFill>
+              <a:schemeClr val="bg1">
+                <a:lumMod val="85000"/>
+              </a:schemeClr>
+            </a:solidFill>
+            <a:ln w="12700" cap="rnd">
+              <a:solidFill>
+                <a:schemeClr val="tx1">
+                  <a:lumMod val="65000"/>
+                  <a:lumOff val="35000"/>
+                </a:schemeClr>
+              </a:solidFill>
+              <a:round/>
+            </a:ln>
+          </p:spPr>
+          <p:style>
+            <a:lnRef idx="2">
+              <a:schemeClr val="accent1">
+                <a:shade val="15000"/>
+              </a:schemeClr>
+            </a:lnRef>
+            <a:fillRef idx="1">
+              <a:schemeClr val="accent1"/>
+            </a:fillRef>
+            <a:effectRef idx="0">
+              <a:schemeClr val="accent1"/>
+            </a:effectRef>
+            <a:fontRef idx="minor">
+              <a:schemeClr val="lt1"/>
+            </a:fontRef>
+          </p:style>
+          <p:txBody>
+            <a:bodyPr rtlCol="0" anchor="ctr"/>
+            <a:lstStyle/>
+            <a:p>
+              <a:pPr algn="ctr"/>
+              <a:endParaRPr lang="de-DE"/>
+            </a:p>
+          </p:txBody>
+        </p:sp>
+        <p:sp>
+          <p:nvSpPr>
+            <p:cNvPr id="35" name="Freihandform: Form 34">
+              <a:extLst>
+                <a:ext uri="{FF2B5EF4-FFF2-40B4-BE49-F238E27FC236}">
+                  <a16:creationId xmlns:a16="http://schemas.microsoft.com/office/drawing/2014/main" id="{0DAEC661-6621-C3BA-85BC-92294D443C24}"/>
+                </a:ext>
+              </a:extLst>
+            </p:cNvPr>
+            <p:cNvSpPr/>
+            <p:nvPr/>
+          </p:nvSpPr>
+          <p:spPr>
+            <a:xfrm>
+              <a:off x="1133952" y="1357335"/>
+              <a:ext cx="303372" cy="398102"/>
+            </a:xfrm>
+            <a:custGeom>
+              <a:avLst/>
+              <a:gdLst>
+                <a:gd name="csX0" fmla="*/ 57153 w 352459"/>
+                <a:gd name="csY0" fmla="*/ 382905 h 382905"/>
+                <a:gd name="csX1" fmla="*/ 3 w 352459"/>
+                <a:gd name="csY1" fmla="*/ 196215 h 382905"/>
+                <a:gd name="csX2" fmla="*/ 55248 w 352459"/>
+                <a:gd name="csY2" fmla="*/ 0 h 382905"/>
+                <a:gd name="csX3" fmla="*/ 299088 w 352459"/>
+                <a:gd name="csY3" fmla="*/ 0 h 382905"/>
+                <a:gd name="csX4" fmla="*/ 352428 w 352459"/>
+                <a:gd name="csY4" fmla="*/ 192405 h 382905"/>
+                <a:gd name="csX5" fmla="*/ 300013 w 352459"/>
+                <a:gd name="csY5" fmla="*/ 381000 h 382905"/>
+                <a:gd name="csX6" fmla="*/ 57153 w 352459"/>
+                <a:gd name="csY6" fmla="*/ 382905 h 382905"/>
+              </a:gdLst>
+              <a:ahLst/>
+              <a:cxnLst>
+                <a:cxn ang="0">
+                  <a:pos x="csX0" y="csY0"/>
+                </a:cxn>
+                <a:cxn ang="0">
+                  <a:pos x="csX1" y="csY1"/>
+                </a:cxn>
+                <a:cxn ang="0">
+                  <a:pos x="csX2" y="csY2"/>
+                </a:cxn>
+                <a:cxn ang="0">
+                  <a:pos x="csX3" y="csY3"/>
+                </a:cxn>
+                <a:cxn ang="0">
+                  <a:pos x="csX4" y="csY4"/>
+                </a:cxn>
+                <a:cxn ang="0">
+                  <a:pos x="csX5" y="csY5"/>
+                </a:cxn>
+                <a:cxn ang="0">
+                  <a:pos x="csX6" y="csY6"/>
+                </a:cxn>
+              </a:cxnLst>
+              <a:rect l="l" t="t" r="r" b="b"/>
+              <a:pathLst>
+                <a:path w="352459" h="382905">
+                  <a:moveTo>
+                    <a:pt x="57153" y="382905"/>
+                  </a:moveTo>
+                  <a:cubicBezTo>
+                    <a:pt x="20481" y="318928"/>
+                    <a:pt x="320" y="260032"/>
+                    <a:pt x="3" y="196215"/>
+                  </a:cubicBezTo>
+                  <a:cubicBezTo>
+                    <a:pt x="-314" y="132398"/>
+                    <a:pt x="24768" y="51435"/>
+                    <a:pt x="55248" y="0"/>
+                  </a:cubicBezTo>
+                  <a:lnTo>
+                    <a:pt x="299088" y="0"/>
+                  </a:lnTo>
+                  <a:cubicBezTo>
+                    <a:pt x="332743" y="53975"/>
+                    <a:pt x="353381" y="128905"/>
+                    <a:pt x="352428" y="192405"/>
+                  </a:cubicBezTo>
+                  <a:cubicBezTo>
+                    <a:pt x="351476" y="255905"/>
+                    <a:pt x="340018" y="328930"/>
+                    <a:pt x="300013" y="381000"/>
+                  </a:cubicBezTo>
+                  <a:lnTo>
+                    <a:pt x="57153" y="382905"/>
+                  </a:lnTo>
+                  <a:close/>
+                </a:path>
+              </a:pathLst>
+            </a:custGeom>
+            <a:solidFill>
+              <a:schemeClr val="bg1">
+                <a:lumMod val="85000"/>
+              </a:schemeClr>
+            </a:solidFill>
+            <a:ln w="12700" cap="rnd">
+              <a:solidFill>
+                <a:schemeClr val="tx1">
+                  <a:lumMod val="65000"/>
+                  <a:lumOff val="35000"/>
+                </a:schemeClr>
+              </a:solidFill>
+              <a:round/>
+            </a:ln>
+          </p:spPr>
+          <p:style>
+            <a:lnRef idx="2">
+              <a:schemeClr val="accent1">
+                <a:shade val="15000"/>
+              </a:schemeClr>
+            </a:lnRef>
+            <a:fillRef idx="1">
+              <a:schemeClr val="accent1"/>
+            </a:fillRef>
+            <a:effectRef idx="0">
+              <a:schemeClr val="accent1"/>
+            </a:effectRef>
+            <a:fontRef idx="minor">
+              <a:schemeClr val="lt1"/>
+            </a:fontRef>
+          </p:style>
+          <p:txBody>
+            <a:bodyPr rtlCol="0" anchor="ctr"/>
+            <a:lstStyle/>
+            <a:p>
+              <a:pPr algn="ctr"/>
+              <a:endParaRPr lang="de-DE"/>
+            </a:p>
+          </p:txBody>
+        </p:sp>
+        <p:sp>
+          <p:nvSpPr>
+            <p:cNvPr id="36" name="Freihandform: Form 35">
+              <a:extLst>
+                <a:ext uri="{FF2B5EF4-FFF2-40B4-BE49-F238E27FC236}">
+                  <a16:creationId xmlns:a16="http://schemas.microsoft.com/office/drawing/2014/main" id="{68ACF4E2-E9B2-0F05-2A4D-C9051087D55C}"/>
+                </a:ext>
+              </a:extLst>
+            </p:cNvPr>
+            <p:cNvSpPr/>
+            <p:nvPr/>
+          </p:nvSpPr>
+          <p:spPr>
+            <a:xfrm>
+              <a:off x="1133952" y="1755435"/>
+              <a:ext cx="303372" cy="179070"/>
+            </a:xfrm>
+            <a:custGeom>
+              <a:avLst/>
+              <a:gdLst>
+                <a:gd name="csX0" fmla="*/ 57153 w 352459"/>
+                <a:gd name="csY0" fmla="*/ 382905 h 382905"/>
+                <a:gd name="csX1" fmla="*/ 3 w 352459"/>
+                <a:gd name="csY1" fmla="*/ 196215 h 382905"/>
+                <a:gd name="csX2" fmla="*/ 55248 w 352459"/>
+                <a:gd name="csY2" fmla="*/ 0 h 382905"/>
+                <a:gd name="csX3" fmla="*/ 299088 w 352459"/>
+                <a:gd name="csY3" fmla="*/ 0 h 382905"/>
+                <a:gd name="csX4" fmla="*/ 352428 w 352459"/>
+                <a:gd name="csY4" fmla="*/ 192405 h 382905"/>
+                <a:gd name="csX5" fmla="*/ 300013 w 352459"/>
+                <a:gd name="csY5" fmla="*/ 381000 h 382905"/>
+                <a:gd name="csX6" fmla="*/ 57153 w 352459"/>
+                <a:gd name="csY6" fmla="*/ 382905 h 382905"/>
+              </a:gdLst>
+              <a:ahLst/>
+              <a:cxnLst>
+                <a:cxn ang="0">
+                  <a:pos x="csX0" y="csY0"/>
+                </a:cxn>
+                <a:cxn ang="0">
+                  <a:pos x="csX1" y="csY1"/>
+                </a:cxn>
+                <a:cxn ang="0">
+                  <a:pos x="csX2" y="csY2"/>
+                </a:cxn>
+                <a:cxn ang="0">
+                  <a:pos x="csX3" y="csY3"/>
+                </a:cxn>
+                <a:cxn ang="0">
+                  <a:pos x="csX4" y="csY4"/>
+                </a:cxn>
+                <a:cxn ang="0">
+                  <a:pos x="csX5" y="csY5"/>
+                </a:cxn>
+                <a:cxn ang="0">
+                  <a:pos x="csX6" y="csY6"/>
+                </a:cxn>
+              </a:cxnLst>
+              <a:rect l="l" t="t" r="r" b="b"/>
+              <a:pathLst>
+                <a:path w="352459" h="382905">
+                  <a:moveTo>
+                    <a:pt x="57153" y="382905"/>
+                  </a:moveTo>
+                  <a:cubicBezTo>
+                    <a:pt x="20481" y="318928"/>
+                    <a:pt x="320" y="260032"/>
+                    <a:pt x="3" y="196215"/>
+                  </a:cubicBezTo>
+                  <a:cubicBezTo>
+                    <a:pt x="-314" y="132398"/>
+                    <a:pt x="24768" y="51435"/>
+                    <a:pt x="55248" y="0"/>
+                  </a:cubicBezTo>
+                  <a:lnTo>
+                    <a:pt x="299088" y="0"/>
+                  </a:lnTo>
+                  <a:cubicBezTo>
+                    <a:pt x="332743" y="53975"/>
+                    <a:pt x="353381" y="128905"/>
+                    <a:pt x="352428" y="192405"/>
+                  </a:cubicBezTo>
+                  <a:cubicBezTo>
+                    <a:pt x="351476" y="255905"/>
+                    <a:pt x="340018" y="328930"/>
+                    <a:pt x="300013" y="381000"/>
+                  </a:cubicBezTo>
+                  <a:lnTo>
+                    <a:pt x="57153" y="382905"/>
+                  </a:lnTo>
+                  <a:close/>
+                </a:path>
+              </a:pathLst>
+            </a:custGeom>
+            <a:solidFill>
+              <a:schemeClr val="bg1">
+                <a:lumMod val="85000"/>
+              </a:schemeClr>
+            </a:solidFill>
+            <a:ln w="12700" cap="rnd">
+              <a:solidFill>
+                <a:schemeClr val="tx1">
+                  <a:lumMod val="65000"/>
+                  <a:lumOff val="35000"/>
+                </a:schemeClr>
+              </a:solidFill>
+              <a:round/>
+            </a:ln>
+          </p:spPr>
+          <p:style>
+            <a:lnRef idx="2">
+              <a:schemeClr val="accent1">
+                <a:shade val="15000"/>
+              </a:schemeClr>
+            </a:lnRef>
+            <a:fillRef idx="1">
+              <a:schemeClr val="accent1"/>
+            </a:fillRef>
+            <a:effectRef idx="0">
+              <a:schemeClr val="accent1"/>
+            </a:effectRef>
+            <a:fontRef idx="minor">
+              <a:schemeClr val="lt1"/>
+            </a:fontRef>
+          </p:style>
+          <p:txBody>
+            <a:bodyPr rtlCol="0" anchor="ctr"/>
+            <a:lstStyle/>
+            <a:p>
+              <a:pPr algn="ctr"/>
+              <a:endParaRPr lang="de-DE"/>
+            </a:p>
+          </p:txBody>
+        </p:sp>
+      </p:grpSp>
     </p:spTree>
     <p:extLst>
       <p:ext uri="{BB962C8B-B14F-4D97-AF65-F5344CB8AC3E}">
-        <p14:creationId xmlns:p14="http://schemas.microsoft.com/office/powerpoint/2010/main" val="2917571994"/>
+        <p14:creationId xmlns:p14="http://schemas.microsoft.com/office/powerpoint/2010/main" val="2290128528"/>
       </p:ext>
     </p:extLst>
   </p:cSld>

</xml_diff>

<commit_message>
another image bites the dust
</commit_message>
<xml_diff>
--- a/LaTeX B.Sc. LRT/Konstruktionslehre 1&2/images/KE-Images.pptx
+++ b/LaTeX B.Sc. LRT/Konstruktionslehre 1&2/images/KE-Images.pptx
@@ -26,8 +26,9 @@
     <p:sldId id="268" r:id="rId20"/>
     <p:sldId id="267" r:id="rId21"/>
     <p:sldId id="279" r:id="rId22"/>
-    <p:sldId id="278" r:id="rId23"/>
-    <p:sldId id="262" r:id="rId24"/>
+    <p:sldId id="280" r:id="rId23"/>
+    <p:sldId id="278" r:id="rId24"/>
+    <p:sldId id="262" r:id="rId25"/>
   </p:sldIdLst>
   <p:sldSz cx="3600450" cy="3600450"/>
   <p:notesSz cx="6858000" cy="9144000"/>
@@ -30134,6 +30135,2209 @@
         <p:cNvPr id="1" name="">
           <a:extLst>
             <a:ext uri="{FF2B5EF4-FFF2-40B4-BE49-F238E27FC236}">
+              <a16:creationId xmlns:a16="http://schemas.microsoft.com/office/drawing/2014/main" id="{30DE4938-D142-2A7D-A7EC-63CFC93EEA76}"/>
+            </a:ext>
+          </a:extLst>
+        </p:cNvPr>
+        <p:cNvGrpSpPr/>
+        <p:nvPr/>
+      </p:nvGrpSpPr>
+      <p:grpSpPr>
+        <a:xfrm>
+          <a:off x="0" y="0"/>
+          <a:ext cx="0" cy="0"/>
+          <a:chOff x="0" y="0"/>
+          <a:chExt cx="0" cy="0"/>
+        </a:xfrm>
+      </p:grpSpPr>
+      <p:sp>
+        <p:nvSpPr>
+          <p:cNvPr id="70" name="Freihandform: Form 69">
+            <a:extLst>
+              <a:ext uri="{FF2B5EF4-FFF2-40B4-BE49-F238E27FC236}">
+                <a16:creationId xmlns:a16="http://schemas.microsoft.com/office/drawing/2014/main" id="{4B7C2E7B-6BDB-4754-5C82-ED08F0199194}"/>
+              </a:ext>
+            </a:extLst>
+          </p:cNvPr>
+          <p:cNvSpPr/>
+          <p:nvPr/>
+        </p:nvSpPr>
+        <p:spPr>
+          <a:xfrm>
+            <a:off x="294640" y="1254760"/>
+            <a:ext cx="3017520" cy="876300"/>
+          </a:xfrm>
+          <a:custGeom>
+            <a:avLst/>
+            <a:gdLst>
+              <a:gd name="csX0" fmla="*/ 3810 w 3017520"/>
+              <a:gd name="csY0" fmla="*/ 863600 h 876300"/>
+              <a:gd name="csX1" fmla="*/ 0 w 3017520"/>
+              <a:gd name="csY1" fmla="*/ 0 h 876300"/>
+              <a:gd name="csX2" fmla="*/ 3017520 w 3017520"/>
+              <a:gd name="csY2" fmla="*/ 0 h 876300"/>
+              <a:gd name="csX3" fmla="*/ 3009900 w 3017520"/>
+              <a:gd name="csY3" fmla="*/ 876300 h 876300"/>
+              <a:gd name="csX4" fmla="*/ 2926080 w 3017520"/>
+              <a:gd name="csY4" fmla="*/ 754380 h 876300"/>
+              <a:gd name="csX5" fmla="*/ 2773680 w 3017520"/>
+              <a:gd name="csY5" fmla="*/ 182880 h 876300"/>
+              <a:gd name="csX6" fmla="*/ 2698115 w 3017520"/>
+              <a:gd name="csY6" fmla="*/ 95885 h 876300"/>
+              <a:gd name="csX7" fmla="*/ 2583815 w 3017520"/>
+              <a:gd name="csY7" fmla="*/ 67310 h 876300"/>
+              <a:gd name="csX8" fmla="*/ 2469515 w 3017520"/>
+              <a:gd name="csY8" fmla="*/ 97790 h 876300"/>
+              <a:gd name="csX9" fmla="*/ 2397760 w 3017520"/>
+              <a:gd name="csY9" fmla="*/ 182880 h 876300"/>
+              <a:gd name="csX10" fmla="*/ 2247900 w 3017520"/>
+              <a:gd name="csY10" fmla="*/ 751840 h 876300"/>
+              <a:gd name="csX11" fmla="*/ 2168525 w 3017520"/>
+              <a:gd name="csY11" fmla="*/ 844550 h 876300"/>
+              <a:gd name="csX12" fmla="*/ 2038985 w 3017520"/>
+              <a:gd name="csY12" fmla="*/ 875030 h 876300"/>
+              <a:gd name="csX13" fmla="*/ 1924685 w 3017520"/>
+              <a:gd name="csY13" fmla="*/ 842645 h 876300"/>
+              <a:gd name="csX14" fmla="*/ 1849120 w 3017520"/>
+              <a:gd name="csY14" fmla="*/ 751840 h 876300"/>
+              <a:gd name="csX15" fmla="*/ 1696720 w 3017520"/>
+              <a:gd name="csY15" fmla="*/ 185420 h 876300"/>
+              <a:gd name="csX16" fmla="*/ 1619885 w 3017520"/>
+              <a:gd name="csY16" fmla="*/ 92075 h 876300"/>
+              <a:gd name="csX17" fmla="*/ 1499870 w 3017520"/>
+              <a:gd name="csY17" fmla="*/ 61595 h 876300"/>
+              <a:gd name="csX18" fmla="*/ 1381760 w 3017520"/>
+              <a:gd name="csY18" fmla="*/ 99695 h 876300"/>
+              <a:gd name="csX19" fmla="*/ 1320800 w 3017520"/>
+              <a:gd name="csY19" fmla="*/ 185420 h 876300"/>
+              <a:gd name="csX20" fmla="*/ 1170940 w 3017520"/>
+              <a:gd name="csY20" fmla="*/ 754380 h 876300"/>
+              <a:gd name="csX21" fmla="*/ 1090295 w 3017520"/>
+              <a:gd name="csY21" fmla="*/ 848360 h 876300"/>
+              <a:gd name="csX22" fmla="*/ 966470 w 3017520"/>
+              <a:gd name="csY22" fmla="*/ 873125 h 876300"/>
+              <a:gd name="csX23" fmla="*/ 846455 w 3017520"/>
+              <a:gd name="csY23" fmla="*/ 842645 h 876300"/>
+              <a:gd name="csX24" fmla="*/ 769620 w 3017520"/>
+              <a:gd name="csY24" fmla="*/ 754380 h 876300"/>
+              <a:gd name="csX25" fmla="*/ 617220 w 3017520"/>
+              <a:gd name="csY25" fmla="*/ 182880 h 876300"/>
+              <a:gd name="csX26" fmla="*/ 543560 w 3017520"/>
+              <a:gd name="csY26" fmla="*/ 90170 h 876300"/>
+              <a:gd name="csX27" fmla="*/ 431165 w 3017520"/>
+              <a:gd name="csY27" fmla="*/ 69215 h 876300"/>
+              <a:gd name="csX28" fmla="*/ 330200 w 3017520"/>
+              <a:gd name="csY28" fmla="*/ 95885 h 876300"/>
+              <a:gd name="csX29" fmla="*/ 242570 w 3017520"/>
+              <a:gd name="csY29" fmla="*/ 184785 h 876300"/>
+              <a:gd name="csX30" fmla="*/ 91440 w 3017520"/>
+              <a:gd name="csY30" fmla="*/ 751840 h 876300"/>
+              <a:gd name="csX31" fmla="*/ 3810 w 3017520"/>
+              <a:gd name="csY31" fmla="*/ 863600 h 876300"/>
+            </a:gdLst>
+            <a:ahLst/>
+            <a:cxnLst>
+              <a:cxn ang="0">
+                <a:pos x="csX0" y="csY0"/>
+              </a:cxn>
+              <a:cxn ang="0">
+                <a:pos x="csX1" y="csY1"/>
+              </a:cxn>
+              <a:cxn ang="0">
+                <a:pos x="csX2" y="csY2"/>
+              </a:cxn>
+              <a:cxn ang="0">
+                <a:pos x="csX3" y="csY3"/>
+              </a:cxn>
+              <a:cxn ang="0">
+                <a:pos x="csX4" y="csY4"/>
+              </a:cxn>
+              <a:cxn ang="0">
+                <a:pos x="csX5" y="csY5"/>
+              </a:cxn>
+              <a:cxn ang="0">
+                <a:pos x="csX6" y="csY6"/>
+              </a:cxn>
+              <a:cxn ang="0">
+                <a:pos x="csX7" y="csY7"/>
+              </a:cxn>
+              <a:cxn ang="0">
+                <a:pos x="csX8" y="csY8"/>
+              </a:cxn>
+              <a:cxn ang="0">
+                <a:pos x="csX9" y="csY9"/>
+              </a:cxn>
+              <a:cxn ang="0">
+                <a:pos x="csX10" y="csY10"/>
+              </a:cxn>
+              <a:cxn ang="0">
+                <a:pos x="csX11" y="csY11"/>
+              </a:cxn>
+              <a:cxn ang="0">
+                <a:pos x="csX12" y="csY12"/>
+              </a:cxn>
+              <a:cxn ang="0">
+                <a:pos x="csX13" y="csY13"/>
+              </a:cxn>
+              <a:cxn ang="0">
+                <a:pos x="csX14" y="csY14"/>
+              </a:cxn>
+              <a:cxn ang="0">
+                <a:pos x="csX15" y="csY15"/>
+              </a:cxn>
+              <a:cxn ang="0">
+                <a:pos x="csX16" y="csY16"/>
+              </a:cxn>
+              <a:cxn ang="0">
+                <a:pos x="csX17" y="csY17"/>
+              </a:cxn>
+              <a:cxn ang="0">
+                <a:pos x="csX18" y="csY18"/>
+              </a:cxn>
+              <a:cxn ang="0">
+                <a:pos x="csX19" y="csY19"/>
+              </a:cxn>
+              <a:cxn ang="0">
+                <a:pos x="csX20" y="csY20"/>
+              </a:cxn>
+              <a:cxn ang="0">
+                <a:pos x="csX21" y="csY21"/>
+              </a:cxn>
+              <a:cxn ang="0">
+                <a:pos x="csX22" y="csY22"/>
+              </a:cxn>
+              <a:cxn ang="0">
+                <a:pos x="csX23" y="csY23"/>
+              </a:cxn>
+              <a:cxn ang="0">
+                <a:pos x="csX24" y="csY24"/>
+              </a:cxn>
+              <a:cxn ang="0">
+                <a:pos x="csX25" y="csY25"/>
+              </a:cxn>
+              <a:cxn ang="0">
+                <a:pos x="csX26" y="csY26"/>
+              </a:cxn>
+              <a:cxn ang="0">
+                <a:pos x="csX27" y="csY27"/>
+              </a:cxn>
+              <a:cxn ang="0">
+                <a:pos x="csX28" y="csY28"/>
+              </a:cxn>
+              <a:cxn ang="0">
+                <a:pos x="csX29" y="csY29"/>
+              </a:cxn>
+              <a:cxn ang="0">
+                <a:pos x="csX30" y="csY30"/>
+              </a:cxn>
+              <a:cxn ang="0">
+                <a:pos x="csX31" y="csY31"/>
+              </a:cxn>
+            </a:cxnLst>
+            <a:rect l="l" t="t" r="r" b="b"/>
+            <a:pathLst>
+              <a:path w="3017520" h="876300">
+                <a:moveTo>
+                  <a:pt x="3810" y="863600"/>
+                </a:moveTo>
+                <a:lnTo>
+                  <a:pt x="0" y="0"/>
+                </a:lnTo>
+                <a:lnTo>
+                  <a:pt x="3017520" y="0"/>
+                </a:lnTo>
+                <a:lnTo>
+                  <a:pt x="3009900" y="876300"/>
+                </a:lnTo>
+                <a:lnTo>
+                  <a:pt x="2926080" y="754380"/>
+                </a:lnTo>
+                <a:lnTo>
+                  <a:pt x="2773680" y="182880"/>
+                </a:lnTo>
+                <a:cubicBezTo>
+                  <a:pt x="2748492" y="153882"/>
+                  <a:pt x="2742353" y="136313"/>
+                  <a:pt x="2698115" y="95885"/>
+                </a:cubicBezTo>
+                <a:lnTo>
+                  <a:pt x="2583815" y="67310"/>
+                </a:lnTo>
+                <a:lnTo>
+                  <a:pt x="2469515" y="97790"/>
+                </a:lnTo>
+                <a:lnTo>
+                  <a:pt x="2397760" y="182880"/>
+                </a:lnTo>
+                <a:lnTo>
+                  <a:pt x="2247900" y="751840"/>
+                </a:lnTo>
+                <a:lnTo>
+                  <a:pt x="2168525" y="844550"/>
+                </a:lnTo>
+                <a:lnTo>
+                  <a:pt x="2038985" y="875030"/>
+                </a:lnTo>
+                <a:lnTo>
+                  <a:pt x="1924685" y="842645"/>
+                </a:lnTo>
+                <a:lnTo>
+                  <a:pt x="1849120" y="751840"/>
+                </a:lnTo>
+                <a:lnTo>
+                  <a:pt x="1696720" y="185420"/>
+                </a:lnTo>
+                <a:cubicBezTo>
+                  <a:pt x="1671108" y="152400"/>
+                  <a:pt x="1677882" y="140335"/>
+                  <a:pt x="1619885" y="92075"/>
+                </a:cubicBezTo>
+                <a:cubicBezTo>
+                  <a:pt x="1576070" y="70485"/>
+                  <a:pt x="1539875" y="69850"/>
+                  <a:pt x="1499870" y="61595"/>
+                </a:cubicBezTo>
+                <a:cubicBezTo>
+                  <a:pt x="1460500" y="74295"/>
+                  <a:pt x="1432560" y="71755"/>
+                  <a:pt x="1381760" y="99695"/>
+                </a:cubicBezTo>
+                <a:lnTo>
+                  <a:pt x="1320800" y="185420"/>
+                </a:lnTo>
+                <a:lnTo>
+                  <a:pt x="1170940" y="754380"/>
+                </a:lnTo>
+                <a:lnTo>
+                  <a:pt x="1090295" y="848360"/>
+                </a:lnTo>
+                <a:lnTo>
+                  <a:pt x="966470" y="873125"/>
+                </a:lnTo>
+                <a:lnTo>
+                  <a:pt x="846455" y="842645"/>
+                </a:lnTo>
+                <a:lnTo>
+                  <a:pt x="769620" y="754380"/>
+                </a:lnTo>
+                <a:lnTo>
+                  <a:pt x="617220" y="182880"/>
+                </a:lnTo>
+                <a:cubicBezTo>
+                  <a:pt x="592667" y="151977"/>
+                  <a:pt x="590973" y="130598"/>
+                  <a:pt x="543560" y="90170"/>
+                </a:cubicBezTo>
+                <a:cubicBezTo>
+                  <a:pt x="505460" y="81915"/>
+                  <a:pt x="478790" y="75565"/>
+                  <a:pt x="431165" y="69215"/>
+                </a:cubicBezTo>
+                <a:cubicBezTo>
+                  <a:pt x="382270" y="73025"/>
+                  <a:pt x="369570" y="86360"/>
+                  <a:pt x="330200" y="95885"/>
+                </a:cubicBezTo>
+                <a:cubicBezTo>
+                  <a:pt x="292100" y="126153"/>
+                  <a:pt x="274955" y="133562"/>
+                  <a:pt x="242570" y="184785"/>
+                </a:cubicBezTo>
+                <a:lnTo>
+                  <a:pt x="91440" y="751840"/>
+                </a:lnTo>
+                <a:lnTo>
+                  <a:pt x="3810" y="863600"/>
+                </a:lnTo>
+                <a:close/>
+              </a:path>
+            </a:pathLst>
+          </a:custGeom>
+          <a:solidFill>
+            <a:schemeClr val="bg1">
+              <a:lumMod val="75000"/>
+            </a:schemeClr>
+          </a:solidFill>
+          <a:ln>
+            <a:noFill/>
+          </a:ln>
+        </p:spPr>
+        <p:style>
+          <a:lnRef idx="2">
+            <a:schemeClr val="accent1">
+              <a:shade val="15000"/>
+            </a:schemeClr>
+          </a:lnRef>
+          <a:fillRef idx="1">
+            <a:schemeClr val="accent1"/>
+          </a:fillRef>
+          <a:effectRef idx="0">
+            <a:schemeClr val="accent1"/>
+          </a:effectRef>
+          <a:fontRef idx="minor">
+            <a:schemeClr val="lt1"/>
+          </a:fontRef>
+        </p:style>
+        <p:txBody>
+          <a:bodyPr rtlCol="0" anchor="ctr"/>
+          <a:lstStyle/>
+          <a:p>
+            <a:pPr algn="ctr"/>
+            <a:endParaRPr lang="de-DE"/>
+          </a:p>
+        </p:txBody>
+      </p:sp>
+      <p:sp>
+        <p:nvSpPr>
+          <p:cNvPr id="48" name="Freihandform: Form 47">
+            <a:extLst>
+              <a:ext uri="{FF2B5EF4-FFF2-40B4-BE49-F238E27FC236}">
+                <a16:creationId xmlns:a16="http://schemas.microsoft.com/office/drawing/2014/main" id="{F07E393D-F541-6DF2-1A38-2A4F4A03AA64}"/>
+              </a:ext>
+            </a:extLst>
+          </p:cNvPr>
+          <p:cNvSpPr/>
+          <p:nvPr/>
+        </p:nvSpPr>
+        <p:spPr>
+          <a:xfrm>
+            <a:off x="292100" y="1419225"/>
+            <a:ext cx="3017520" cy="925195"/>
+          </a:xfrm>
+          <a:custGeom>
+            <a:avLst/>
+            <a:gdLst>
+              <a:gd name="csX0" fmla="*/ 0 w 3017520"/>
+              <a:gd name="csY0" fmla="*/ 925195 h 925195"/>
+              <a:gd name="csX1" fmla="*/ 9525 w 3017520"/>
+              <a:gd name="csY1" fmla="*/ 799465 h 925195"/>
+              <a:gd name="csX2" fmla="*/ 83820 w 3017520"/>
+              <a:gd name="csY2" fmla="*/ 696595 h 925195"/>
+              <a:gd name="csX3" fmla="*/ 236220 w 3017520"/>
+              <a:gd name="csY3" fmla="*/ 135255 h 925195"/>
+              <a:gd name="csX4" fmla="*/ 306070 w 3017520"/>
+              <a:gd name="csY4" fmla="*/ 34290 h 925195"/>
+              <a:gd name="csX5" fmla="*/ 433705 w 3017520"/>
+              <a:gd name="csY5" fmla="*/ 0 h 925195"/>
+              <a:gd name="csX6" fmla="*/ 557530 w 3017520"/>
+              <a:gd name="csY6" fmla="*/ 36195 h 925195"/>
+              <a:gd name="csX7" fmla="*/ 632460 w 3017520"/>
+              <a:gd name="csY7" fmla="*/ 135255 h 925195"/>
+              <a:gd name="csX8" fmla="*/ 787400 w 3017520"/>
+              <a:gd name="csY8" fmla="*/ 699135 h 925195"/>
+              <a:gd name="csX9" fmla="*/ 856615 w 3017520"/>
+              <a:gd name="csY9" fmla="*/ 777240 h 925195"/>
+              <a:gd name="csX10" fmla="*/ 972820 w 3017520"/>
+              <a:gd name="csY10" fmla="*/ 815340 h 925195"/>
+              <a:gd name="csX11" fmla="*/ 1090930 w 3017520"/>
+              <a:gd name="csY11" fmla="*/ 781050 h 925195"/>
+              <a:gd name="csX12" fmla="*/ 1163320 w 3017520"/>
+              <a:gd name="csY12" fmla="*/ 699135 h 925195"/>
+              <a:gd name="csX13" fmla="*/ 1313180 w 3017520"/>
+              <a:gd name="csY13" fmla="*/ 132715 h 925195"/>
+              <a:gd name="csX14" fmla="*/ 1378585 w 3017520"/>
+              <a:gd name="csY14" fmla="*/ 41910 h 925195"/>
+              <a:gd name="csX15" fmla="*/ 1508125 w 3017520"/>
+              <a:gd name="csY15" fmla="*/ 1905 h 925195"/>
+              <a:gd name="csX16" fmla="*/ 1635760 w 3017520"/>
+              <a:gd name="csY16" fmla="*/ 30480 h 925195"/>
+              <a:gd name="csX17" fmla="*/ 1711960 w 3017520"/>
+              <a:gd name="csY17" fmla="*/ 132715 h 925195"/>
+              <a:gd name="csX18" fmla="*/ 1859280 w 3017520"/>
+              <a:gd name="csY18" fmla="*/ 699135 h 925195"/>
+              <a:gd name="csX19" fmla="*/ 1934845 w 3017520"/>
+              <a:gd name="csY19" fmla="*/ 782955 h 925195"/>
+              <a:gd name="csX20" fmla="*/ 2045335 w 3017520"/>
+              <a:gd name="csY20" fmla="*/ 813435 h 925195"/>
+              <a:gd name="csX21" fmla="*/ 2169160 w 3017520"/>
+              <a:gd name="csY21" fmla="*/ 775335 h 925195"/>
+              <a:gd name="csX22" fmla="*/ 2237740 w 3017520"/>
+              <a:gd name="csY22" fmla="*/ 699135 h 925195"/>
+              <a:gd name="csX23" fmla="*/ 2390140 w 3017520"/>
+              <a:gd name="csY23" fmla="*/ 132715 h 925195"/>
+              <a:gd name="csX24" fmla="*/ 2460625 w 3017520"/>
+              <a:gd name="csY24" fmla="*/ 45720 h 925195"/>
+              <a:gd name="csX25" fmla="*/ 2586355 w 3017520"/>
+              <a:gd name="csY25" fmla="*/ 9525 h 925195"/>
+              <a:gd name="csX26" fmla="*/ 2715895 w 3017520"/>
+              <a:gd name="csY26" fmla="*/ 38100 h 925195"/>
+              <a:gd name="csX27" fmla="*/ 2791460 w 3017520"/>
+              <a:gd name="csY27" fmla="*/ 132715 h 925195"/>
+              <a:gd name="csX28" fmla="*/ 2941320 w 3017520"/>
+              <a:gd name="csY28" fmla="*/ 701675 h 925195"/>
+              <a:gd name="csX29" fmla="*/ 3007995 w 3017520"/>
+              <a:gd name="csY29" fmla="*/ 802640 h 925195"/>
+              <a:gd name="csX30" fmla="*/ 3017520 w 3017520"/>
+              <a:gd name="csY30" fmla="*/ 922655 h 925195"/>
+              <a:gd name="csX31" fmla="*/ 0 w 3017520"/>
+              <a:gd name="csY31" fmla="*/ 925195 h 925195"/>
+            </a:gdLst>
+            <a:ahLst/>
+            <a:cxnLst>
+              <a:cxn ang="0">
+                <a:pos x="csX0" y="csY0"/>
+              </a:cxn>
+              <a:cxn ang="0">
+                <a:pos x="csX1" y="csY1"/>
+              </a:cxn>
+              <a:cxn ang="0">
+                <a:pos x="csX2" y="csY2"/>
+              </a:cxn>
+              <a:cxn ang="0">
+                <a:pos x="csX3" y="csY3"/>
+              </a:cxn>
+              <a:cxn ang="0">
+                <a:pos x="csX4" y="csY4"/>
+              </a:cxn>
+              <a:cxn ang="0">
+                <a:pos x="csX5" y="csY5"/>
+              </a:cxn>
+              <a:cxn ang="0">
+                <a:pos x="csX6" y="csY6"/>
+              </a:cxn>
+              <a:cxn ang="0">
+                <a:pos x="csX7" y="csY7"/>
+              </a:cxn>
+              <a:cxn ang="0">
+                <a:pos x="csX8" y="csY8"/>
+              </a:cxn>
+              <a:cxn ang="0">
+                <a:pos x="csX9" y="csY9"/>
+              </a:cxn>
+              <a:cxn ang="0">
+                <a:pos x="csX10" y="csY10"/>
+              </a:cxn>
+              <a:cxn ang="0">
+                <a:pos x="csX11" y="csY11"/>
+              </a:cxn>
+              <a:cxn ang="0">
+                <a:pos x="csX12" y="csY12"/>
+              </a:cxn>
+              <a:cxn ang="0">
+                <a:pos x="csX13" y="csY13"/>
+              </a:cxn>
+              <a:cxn ang="0">
+                <a:pos x="csX14" y="csY14"/>
+              </a:cxn>
+              <a:cxn ang="0">
+                <a:pos x="csX15" y="csY15"/>
+              </a:cxn>
+              <a:cxn ang="0">
+                <a:pos x="csX16" y="csY16"/>
+              </a:cxn>
+              <a:cxn ang="0">
+                <a:pos x="csX17" y="csY17"/>
+              </a:cxn>
+              <a:cxn ang="0">
+                <a:pos x="csX18" y="csY18"/>
+              </a:cxn>
+              <a:cxn ang="0">
+                <a:pos x="csX19" y="csY19"/>
+              </a:cxn>
+              <a:cxn ang="0">
+                <a:pos x="csX20" y="csY20"/>
+              </a:cxn>
+              <a:cxn ang="0">
+                <a:pos x="csX21" y="csY21"/>
+              </a:cxn>
+              <a:cxn ang="0">
+                <a:pos x="csX22" y="csY22"/>
+              </a:cxn>
+              <a:cxn ang="0">
+                <a:pos x="csX23" y="csY23"/>
+              </a:cxn>
+              <a:cxn ang="0">
+                <a:pos x="csX24" y="csY24"/>
+              </a:cxn>
+              <a:cxn ang="0">
+                <a:pos x="csX25" y="csY25"/>
+              </a:cxn>
+              <a:cxn ang="0">
+                <a:pos x="csX26" y="csY26"/>
+              </a:cxn>
+              <a:cxn ang="0">
+                <a:pos x="csX27" y="csY27"/>
+              </a:cxn>
+              <a:cxn ang="0">
+                <a:pos x="csX28" y="csY28"/>
+              </a:cxn>
+              <a:cxn ang="0">
+                <a:pos x="csX29" y="csY29"/>
+              </a:cxn>
+              <a:cxn ang="0">
+                <a:pos x="csX30" y="csY30"/>
+              </a:cxn>
+              <a:cxn ang="0">
+                <a:pos x="csX31" y="csY31"/>
+              </a:cxn>
+            </a:cxnLst>
+            <a:rect l="l" t="t" r="r" b="b"/>
+            <a:pathLst>
+              <a:path w="3017520" h="925195">
+                <a:moveTo>
+                  <a:pt x="0" y="925195"/>
+                </a:moveTo>
+                <a:lnTo>
+                  <a:pt x="9525" y="799465"/>
+                </a:lnTo>
+                <a:lnTo>
+                  <a:pt x="83820" y="696595"/>
+                </a:lnTo>
+                <a:lnTo>
+                  <a:pt x="236220" y="135255"/>
+                </a:lnTo>
+                <a:lnTo>
+                  <a:pt x="306070" y="34290"/>
+                </a:lnTo>
+                <a:lnTo>
+                  <a:pt x="433705" y="0"/>
+                </a:lnTo>
+                <a:lnTo>
+                  <a:pt x="557530" y="36195"/>
+                </a:lnTo>
+                <a:cubicBezTo>
+                  <a:pt x="595842" y="73025"/>
+                  <a:pt x="607483" y="102235"/>
+                  <a:pt x="632460" y="135255"/>
+                </a:cubicBezTo>
+                <a:lnTo>
+                  <a:pt x="787400" y="699135"/>
+                </a:lnTo>
+                <a:lnTo>
+                  <a:pt x="856615" y="777240"/>
+                </a:lnTo>
+                <a:lnTo>
+                  <a:pt x="972820" y="815340"/>
+                </a:lnTo>
+                <a:lnTo>
+                  <a:pt x="1090930" y="781050"/>
+                </a:lnTo>
+                <a:lnTo>
+                  <a:pt x="1163320" y="699135"/>
+                </a:lnTo>
+                <a:lnTo>
+                  <a:pt x="1313180" y="132715"/>
+                </a:lnTo>
+                <a:lnTo>
+                  <a:pt x="1378585" y="41910"/>
+                </a:lnTo>
+                <a:lnTo>
+                  <a:pt x="1508125" y="1905"/>
+                </a:lnTo>
+                <a:lnTo>
+                  <a:pt x="1635760" y="30480"/>
+                </a:lnTo>
+                <a:lnTo>
+                  <a:pt x="1711960" y="132715"/>
+                </a:lnTo>
+                <a:lnTo>
+                  <a:pt x="1859280" y="699135"/>
+                </a:lnTo>
+                <a:lnTo>
+                  <a:pt x="1934845" y="782955"/>
+                </a:lnTo>
+                <a:lnTo>
+                  <a:pt x="2045335" y="813435"/>
+                </a:lnTo>
+                <a:lnTo>
+                  <a:pt x="2169160" y="775335"/>
+                </a:lnTo>
+                <a:lnTo>
+                  <a:pt x="2237740" y="699135"/>
+                </a:lnTo>
+                <a:lnTo>
+                  <a:pt x="2390140" y="132715"/>
+                </a:lnTo>
+                <a:cubicBezTo>
+                  <a:pt x="2413635" y="103717"/>
+                  <a:pt x="2421890" y="80433"/>
+                  <a:pt x="2460625" y="45720"/>
+                </a:cubicBezTo>
+                <a:cubicBezTo>
+                  <a:pt x="2517775" y="22225"/>
+                  <a:pt x="2544445" y="21590"/>
+                  <a:pt x="2586355" y="9525"/>
+                </a:cubicBezTo>
+                <a:cubicBezTo>
+                  <a:pt x="2629535" y="19050"/>
+                  <a:pt x="2667000" y="17145"/>
+                  <a:pt x="2715895" y="38100"/>
+                </a:cubicBezTo>
+                <a:cubicBezTo>
+                  <a:pt x="2754418" y="77258"/>
+                  <a:pt x="2766272" y="101177"/>
+                  <a:pt x="2791460" y="132715"/>
+                </a:cubicBezTo>
+                <a:lnTo>
+                  <a:pt x="2941320" y="701675"/>
+                </a:lnTo>
+                <a:lnTo>
+                  <a:pt x="3007995" y="802640"/>
+                </a:lnTo>
+                <a:lnTo>
+                  <a:pt x="3017520" y="922655"/>
+                </a:lnTo>
+                <a:lnTo>
+                  <a:pt x="0" y="925195"/>
+                </a:lnTo>
+                <a:close/>
+              </a:path>
+            </a:pathLst>
+          </a:custGeom>
+          <a:solidFill>
+            <a:schemeClr val="bg1">
+              <a:lumMod val="50000"/>
+            </a:schemeClr>
+          </a:solidFill>
+          <a:ln>
+            <a:noFill/>
+          </a:ln>
+        </p:spPr>
+        <p:style>
+          <a:lnRef idx="2">
+            <a:schemeClr val="accent1">
+              <a:shade val="15000"/>
+            </a:schemeClr>
+          </a:lnRef>
+          <a:fillRef idx="1">
+            <a:schemeClr val="accent1"/>
+          </a:fillRef>
+          <a:effectRef idx="0">
+            <a:schemeClr val="accent1"/>
+          </a:effectRef>
+          <a:fontRef idx="minor">
+            <a:schemeClr val="lt1"/>
+          </a:fontRef>
+        </p:style>
+        <p:txBody>
+          <a:bodyPr rtlCol="0" anchor="ctr"/>
+          <a:lstStyle/>
+          <a:p>
+            <a:pPr algn="ctr"/>
+            <a:endParaRPr lang="de-DE" dirty="0"/>
+          </a:p>
+        </p:txBody>
+      </p:sp>
+      <p:cxnSp>
+        <p:nvCxnSpPr>
+          <p:cNvPr id="30" name="Gerader Verbinder 29">
+            <a:extLst>
+              <a:ext uri="{FF2B5EF4-FFF2-40B4-BE49-F238E27FC236}">
+                <a16:creationId xmlns:a16="http://schemas.microsoft.com/office/drawing/2014/main" id="{704CD142-4373-F43B-ADF9-2299AB552700}"/>
+              </a:ext>
+            </a:extLst>
+          </p:cNvPr>
+          <p:cNvCxnSpPr>
+            <a:cxnSpLocks/>
+          </p:cNvCxnSpPr>
+          <p:nvPr/>
+        </p:nvCxnSpPr>
+        <p:spPr>
+          <a:xfrm>
+            <a:off x="2002872" y="1553044"/>
+            <a:ext cx="151789" cy="566487"/>
+          </a:xfrm>
+          <a:prstGeom prst="line">
+            <a:avLst/>
+          </a:prstGeom>
+          <a:ln cap="rnd">
+            <a:solidFill>
+              <a:schemeClr val="tx1">
+                <a:lumMod val="75000"/>
+                <a:lumOff val="25000"/>
+              </a:schemeClr>
+            </a:solidFill>
+            <a:round/>
+          </a:ln>
+        </p:spPr>
+        <p:style>
+          <a:lnRef idx="2">
+            <a:schemeClr val="accent1"/>
+          </a:lnRef>
+          <a:fillRef idx="0">
+            <a:schemeClr val="accent1"/>
+          </a:fillRef>
+          <a:effectRef idx="1">
+            <a:schemeClr val="accent1"/>
+          </a:effectRef>
+          <a:fontRef idx="minor">
+            <a:schemeClr val="tx1"/>
+          </a:fontRef>
+        </p:style>
+      </p:cxnSp>
+      <p:cxnSp>
+        <p:nvCxnSpPr>
+          <p:cNvPr id="32" name="Gerader Verbinder 31">
+            <a:extLst>
+              <a:ext uri="{FF2B5EF4-FFF2-40B4-BE49-F238E27FC236}">
+                <a16:creationId xmlns:a16="http://schemas.microsoft.com/office/drawing/2014/main" id="{ED95AA1E-6AFC-5693-1A05-DCFB471B8234}"/>
+              </a:ext>
+            </a:extLst>
+          </p:cNvPr>
+          <p:cNvCxnSpPr>
+            <a:cxnSpLocks/>
+          </p:cNvCxnSpPr>
+          <p:nvPr/>
+        </p:nvCxnSpPr>
+        <p:spPr>
+          <a:xfrm flipH="1">
+            <a:off x="2527037" y="1552852"/>
+            <a:ext cx="150943" cy="563327"/>
+          </a:xfrm>
+          <a:prstGeom prst="line">
+            <a:avLst/>
+          </a:prstGeom>
+          <a:ln cap="rnd">
+            <a:solidFill>
+              <a:schemeClr val="tx1">
+                <a:lumMod val="75000"/>
+                <a:lumOff val="25000"/>
+              </a:schemeClr>
+            </a:solidFill>
+            <a:round/>
+          </a:ln>
+        </p:spPr>
+        <p:style>
+          <a:lnRef idx="2">
+            <a:schemeClr val="accent1"/>
+          </a:lnRef>
+          <a:fillRef idx="0">
+            <a:schemeClr val="accent1"/>
+          </a:fillRef>
+          <a:effectRef idx="1">
+            <a:schemeClr val="accent1"/>
+          </a:effectRef>
+          <a:fontRef idx="minor">
+            <a:schemeClr val="tx1"/>
+          </a:fontRef>
+        </p:style>
+      </p:cxnSp>
+      <p:cxnSp>
+        <p:nvCxnSpPr>
+          <p:cNvPr id="33" name="Gerader Verbinder 32">
+            <a:extLst>
+              <a:ext uri="{FF2B5EF4-FFF2-40B4-BE49-F238E27FC236}">
+                <a16:creationId xmlns:a16="http://schemas.microsoft.com/office/drawing/2014/main" id="{27EFA03F-3468-60B7-A571-743677DB1DEB}"/>
+              </a:ext>
+            </a:extLst>
+          </p:cNvPr>
+          <p:cNvCxnSpPr>
+            <a:cxnSpLocks/>
+          </p:cNvCxnSpPr>
+          <p:nvPr/>
+        </p:nvCxnSpPr>
+        <p:spPr>
+          <a:xfrm>
+            <a:off x="3074815" y="1552891"/>
+            <a:ext cx="150933" cy="563288"/>
+          </a:xfrm>
+          <a:prstGeom prst="line">
+            <a:avLst/>
+          </a:prstGeom>
+          <a:ln cap="rnd">
+            <a:solidFill>
+              <a:schemeClr val="tx1">
+                <a:lumMod val="75000"/>
+                <a:lumOff val="25000"/>
+              </a:schemeClr>
+            </a:solidFill>
+            <a:round/>
+          </a:ln>
+        </p:spPr>
+        <p:style>
+          <a:lnRef idx="2">
+            <a:schemeClr val="accent1"/>
+          </a:lnRef>
+          <a:fillRef idx="0">
+            <a:schemeClr val="accent1"/>
+          </a:fillRef>
+          <a:effectRef idx="1">
+            <a:schemeClr val="accent1"/>
+          </a:effectRef>
+          <a:fontRef idx="minor">
+            <a:schemeClr val="tx1"/>
+          </a:fontRef>
+        </p:style>
+      </p:cxnSp>
+      <p:cxnSp>
+        <p:nvCxnSpPr>
+          <p:cNvPr id="26" name="Gerader Verbinder 25">
+            <a:extLst>
+              <a:ext uri="{FF2B5EF4-FFF2-40B4-BE49-F238E27FC236}">
+                <a16:creationId xmlns:a16="http://schemas.microsoft.com/office/drawing/2014/main" id="{0FA4D578-1FAF-36AB-8AD1-819BE8E6BDC3}"/>
+              </a:ext>
+            </a:extLst>
+          </p:cNvPr>
+          <p:cNvCxnSpPr>
+            <a:cxnSpLocks/>
+          </p:cNvCxnSpPr>
+          <p:nvPr/>
+        </p:nvCxnSpPr>
+        <p:spPr>
+          <a:xfrm>
+            <a:off x="928017" y="1553044"/>
+            <a:ext cx="151789" cy="566487"/>
+          </a:xfrm>
+          <a:prstGeom prst="line">
+            <a:avLst/>
+          </a:prstGeom>
+          <a:ln cap="rnd">
+            <a:solidFill>
+              <a:schemeClr val="tx1">
+                <a:lumMod val="75000"/>
+                <a:lumOff val="25000"/>
+              </a:schemeClr>
+            </a:solidFill>
+            <a:round/>
+          </a:ln>
+        </p:spPr>
+        <p:style>
+          <a:lnRef idx="2">
+            <a:schemeClr val="accent1"/>
+          </a:lnRef>
+          <a:fillRef idx="0">
+            <a:schemeClr val="accent1"/>
+          </a:fillRef>
+          <a:effectRef idx="1">
+            <a:schemeClr val="accent1"/>
+          </a:effectRef>
+          <a:fontRef idx="minor">
+            <a:schemeClr val="tx1"/>
+          </a:fontRef>
+        </p:style>
+      </p:cxnSp>
+      <p:cxnSp>
+        <p:nvCxnSpPr>
+          <p:cNvPr id="28" name="Gerader Verbinder 27">
+            <a:extLst>
+              <a:ext uri="{FF2B5EF4-FFF2-40B4-BE49-F238E27FC236}">
+                <a16:creationId xmlns:a16="http://schemas.microsoft.com/office/drawing/2014/main" id="{A410496E-64CA-3E5A-B4BB-D93D20009BF8}"/>
+              </a:ext>
+            </a:extLst>
+          </p:cNvPr>
+          <p:cNvCxnSpPr>
+            <a:cxnSpLocks/>
+          </p:cNvCxnSpPr>
+          <p:nvPr/>
+        </p:nvCxnSpPr>
+        <p:spPr>
+          <a:xfrm flipH="1">
+            <a:off x="1454087" y="1552852"/>
+            <a:ext cx="150943" cy="563327"/>
+          </a:xfrm>
+          <a:prstGeom prst="line">
+            <a:avLst/>
+          </a:prstGeom>
+          <a:ln cap="rnd">
+            <a:solidFill>
+              <a:schemeClr val="tx1">
+                <a:lumMod val="75000"/>
+                <a:lumOff val="25000"/>
+              </a:schemeClr>
+            </a:solidFill>
+            <a:round/>
+          </a:ln>
+        </p:spPr>
+        <p:style>
+          <a:lnRef idx="2">
+            <a:schemeClr val="accent1"/>
+          </a:lnRef>
+          <a:fillRef idx="0">
+            <a:schemeClr val="accent1"/>
+          </a:fillRef>
+          <a:effectRef idx="1">
+            <a:schemeClr val="accent1"/>
+          </a:effectRef>
+          <a:fontRef idx="minor">
+            <a:schemeClr val="tx1"/>
+          </a:fontRef>
+        </p:style>
+      </p:cxnSp>
+      <p:cxnSp>
+        <p:nvCxnSpPr>
+          <p:cNvPr id="41" name="Gerader Verbinder 40">
+            <a:extLst>
+              <a:ext uri="{FF2B5EF4-FFF2-40B4-BE49-F238E27FC236}">
+                <a16:creationId xmlns:a16="http://schemas.microsoft.com/office/drawing/2014/main" id="{1DAF7130-46DF-E44B-E34C-955F520C272C}"/>
+              </a:ext>
+            </a:extLst>
+          </p:cNvPr>
+          <p:cNvCxnSpPr>
+            <a:cxnSpLocks/>
+          </p:cNvCxnSpPr>
+          <p:nvPr/>
+        </p:nvCxnSpPr>
+        <p:spPr>
+          <a:xfrm flipH="1">
+            <a:off x="376186" y="1552852"/>
+            <a:ext cx="150943" cy="563327"/>
+          </a:xfrm>
+          <a:prstGeom prst="line">
+            <a:avLst/>
+          </a:prstGeom>
+          <a:ln cap="rnd">
+            <a:solidFill>
+              <a:schemeClr val="tx1">
+                <a:lumMod val="75000"/>
+                <a:lumOff val="25000"/>
+              </a:schemeClr>
+            </a:solidFill>
+            <a:round/>
+          </a:ln>
+        </p:spPr>
+        <p:style>
+          <a:lnRef idx="2">
+            <a:schemeClr val="accent1"/>
+          </a:lnRef>
+          <a:fillRef idx="0">
+            <a:schemeClr val="accent1"/>
+          </a:fillRef>
+          <a:effectRef idx="1">
+            <a:schemeClr val="accent1"/>
+          </a:effectRef>
+          <a:fontRef idx="minor">
+            <a:schemeClr val="tx1"/>
+          </a:fontRef>
+        </p:style>
+      </p:cxnSp>
+      <p:sp>
+        <p:nvSpPr>
+          <p:cNvPr id="73" name="Bogen 72">
+            <a:extLst>
+              <a:ext uri="{FF2B5EF4-FFF2-40B4-BE49-F238E27FC236}">
+                <a16:creationId xmlns:a16="http://schemas.microsoft.com/office/drawing/2014/main" id="{071DDA86-8378-75B9-B1E1-C206552125D2}"/>
+              </a:ext>
+            </a:extLst>
+          </p:cNvPr>
+          <p:cNvSpPr/>
+          <p:nvPr/>
+        </p:nvSpPr>
+        <p:spPr>
+          <a:xfrm>
+            <a:off x="282064" y="1533055"/>
+            <a:ext cx="1966900" cy="1966900"/>
+          </a:xfrm>
+          <a:prstGeom prst="arc">
+            <a:avLst>
+              <a:gd name="adj1" fmla="val 15108925"/>
+              <a:gd name="adj2" fmla="val 17291101"/>
+            </a:avLst>
+          </a:prstGeom>
+          <a:ln w="19050" cap="rnd">
+            <a:solidFill>
+              <a:schemeClr val="accent5">
+                <a:lumMod val="75000"/>
+              </a:schemeClr>
+            </a:solidFill>
+            <a:round/>
+            <a:headEnd type="triangle"/>
+            <a:tailEnd type="triangle"/>
+          </a:ln>
+        </p:spPr>
+        <p:style>
+          <a:lnRef idx="2">
+            <a:schemeClr val="accent1"/>
+          </a:lnRef>
+          <a:fillRef idx="0">
+            <a:schemeClr val="accent1"/>
+          </a:fillRef>
+          <a:effectRef idx="1">
+            <a:schemeClr val="accent1"/>
+          </a:effectRef>
+          <a:fontRef idx="minor">
+            <a:schemeClr val="tx1"/>
+          </a:fontRef>
+        </p:style>
+        <p:txBody>
+          <a:bodyPr rtlCol="0" anchor="ctr"/>
+          <a:lstStyle/>
+          <a:p>
+            <a:pPr algn="ctr"/>
+            <a:endParaRPr lang="de-DE"/>
+          </a:p>
+        </p:txBody>
+      </p:sp>
+      <p:sp>
+        <p:nvSpPr>
+          <p:cNvPr id="85" name="Textfeld 84">
+            <a:extLst>
+              <a:ext uri="{FF2B5EF4-FFF2-40B4-BE49-F238E27FC236}">
+                <a16:creationId xmlns:a16="http://schemas.microsoft.com/office/drawing/2014/main" id="{5652B01C-6E29-BB1A-4440-5723ACA31CE0}"/>
+              </a:ext>
+            </a:extLst>
+          </p:cNvPr>
+          <p:cNvSpPr txBox="1"/>
+          <p:nvPr/>
+        </p:nvSpPr>
+        <p:spPr>
+          <a:xfrm>
+            <a:off x="1020874" y="1250744"/>
+            <a:ext cx="542152" cy="338554"/>
+          </a:xfrm>
+          <a:prstGeom prst="rect">
+            <a:avLst/>
+          </a:prstGeom>
+          <a:noFill/>
+        </p:spPr>
+        <p:txBody>
+          <a:bodyPr wrap="square" rtlCol="0" anchor="ctr">
+            <a:spAutoFit/>
+          </a:bodyPr>
+          <a:lstStyle/>
+          <a:p>
+            <a:pPr algn="ctr"/>
+            <a:r>
+              <a:rPr lang="de-DE" sz="1600" dirty="0">
+                <a:solidFill>
+                  <a:schemeClr val="accent5">
+                    <a:lumMod val="75000"/>
+                  </a:schemeClr>
+                </a:solidFill>
+                <a:latin typeface="CMU Serif" panose="02000603000000000000" pitchFamily="2" charset="0"/>
+                <a:ea typeface="CMU Serif" panose="02000603000000000000" pitchFamily="2" charset="0"/>
+                <a:cs typeface="CMU Serif" panose="02000603000000000000" pitchFamily="2" charset="0"/>
+              </a:rPr>
+              <a:t>30°</a:t>
+            </a:r>
+          </a:p>
+        </p:txBody>
+      </p:sp>
+      <p:sp>
+        <p:nvSpPr>
+          <p:cNvPr id="4" name="Bogen 3">
+            <a:extLst>
+              <a:ext uri="{FF2B5EF4-FFF2-40B4-BE49-F238E27FC236}">
+                <a16:creationId xmlns:a16="http://schemas.microsoft.com/office/drawing/2014/main" id="{B16EE968-4B3F-9072-1B81-1029F56277F5}"/>
+              </a:ext>
+            </a:extLst>
+          </p:cNvPr>
+          <p:cNvSpPr/>
+          <p:nvPr/>
+        </p:nvSpPr>
+        <p:spPr>
+          <a:xfrm rot="10800000">
+            <a:off x="523874" y="1326515"/>
+            <a:ext cx="405765" cy="365184"/>
+          </a:xfrm>
+          <a:prstGeom prst="arc">
+            <a:avLst>
+              <a:gd name="adj1" fmla="val 1151559"/>
+              <a:gd name="adj2" fmla="val 9637948"/>
+            </a:avLst>
+          </a:prstGeom>
+          <a:ln cap="rnd">
+            <a:solidFill>
+              <a:schemeClr val="bg1">
+                <a:lumMod val="50000"/>
+              </a:schemeClr>
+            </a:solidFill>
+            <a:round/>
+          </a:ln>
+        </p:spPr>
+        <p:style>
+          <a:lnRef idx="2">
+            <a:schemeClr val="accent1"/>
+          </a:lnRef>
+          <a:fillRef idx="0">
+            <a:schemeClr val="accent1"/>
+          </a:fillRef>
+          <a:effectRef idx="1">
+            <a:schemeClr val="accent1"/>
+          </a:effectRef>
+          <a:fontRef idx="minor">
+            <a:schemeClr val="tx1"/>
+          </a:fontRef>
+        </p:style>
+        <p:txBody>
+          <a:bodyPr rtlCol="0" anchor="ctr"/>
+          <a:lstStyle/>
+          <a:p>
+            <a:pPr algn="ctr"/>
+            <a:endParaRPr lang="de-DE"/>
+          </a:p>
+        </p:txBody>
+      </p:sp>
+      <p:sp>
+        <p:nvSpPr>
+          <p:cNvPr id="6" name="Bogen 5">
+            <a:extLst>
+              <a:ext uri="{FF2B5EF4-FFF2-40B4-BE49-F238E27FC236}">
+                <a16:creationId xmlns:a16="http://schemas.microsoft.com/office/drawing/2014/main" id="{32AB3419-922B-6B0D-CB31-74CF88C41F65}"/>
+              </a:ext>
+            </a:extLst>
+          </p:cNvPr>
+          <p:cNvSpPr/>
+          <p:nvPr/>
+        </p:nvSpPr>
+        <p:spPr>
+          <a:xfrm rot="10800000">
+            <a:off x="512445" y="1425112"/>
+            <a:ext cx="426719" cy="389298"/>
+          </a:xfrm>
+          <a:prstGeom prst="arc">
+            <a:avLst>
+              <a:gd name="adj1" fmla="val 1151559"/>
+              <a:gd name="adj2" fmla="val 9637948"/>
+            </a:avLst>
+          </a:prstGeom>
+          <a:ln cap="rnd">
+            <a:solidFill>
+              <a:schemeClr val="tx1">
+                <a:lumMod val="75000"/>
+                <a:lumOff val="25000"/>
+              </a:schemeClr>
+            </a:solidFill>
+            <a:round/>
+          </a:ln>
+        </p:spPr>
+        <p:style>
+          <a:lnRef idx="2">
+            <a:schemeClr val="accent1"/>
+          </a:lnRef>
+          <a:fillRef idx="0">
+            <a:schemeClr val="accent1"/>
+          </a:fillRef>
+          <a:effectRef idx="1">
+            <a:schemeClr val="accent1"/>
+          </a:effectRef>
+          <a:fontRef idx="minor">
+            <a:schemeClr val="tx1"/>
+          </a:fontRef>
+        </p:style>
+        <p:txBody>
+          <a:bodyPr rtlCol="0" anchor="ctr"/>
+          <a:lstStyle/>
+          <a:p>
+            <a:pPr algn="ctr"/>
+            <a:endParaRPr lang="de-DE"/>
+          </a:p>
+        </p:txBody>
+      </p:sp>
+      <p:sp>
+        <p:nvSpPr>
+          <p:cNvPr id="8" name="Bogen 7">
+            <a:extLst>
+              <a:ext uri="{FF2B5EF4-FFF2-40B4-BE49-F238E27FC236}">
+                <a16:creationId xmlns:a16="http://schemas.microsoft.com/office/drawing/2014/main" id="{29E990F7-79CD-A387-5E72-5344DF8760E3}"/>
+              </a:ext>
+            </a:extLst>
+          </p:cNvPr>
+          <p:cNvSpPr/>
+          <p:nvPr/>
+        </p:nvSpPr>
+        <p:spPr>
+          <a:xfrm rot="10800000">
+            <a:off x="1604010" y="1322646"/>
+            <a:ext cx="399782" cy="365184"/>
+          </a:xfrm>
+          <a:prstGeom prst="arc">
+            <a:avLst>
+              <a:gd name="adj1" fmla="val 1151559"/>
+              <a:gd name="adj2" fmla="val 9637948"/>
+            </a:avLst>
+          </a:prstGeom>
+          <a:ln cap="rnd">
+            <a:solidFill>
+              <a:schemeClr val="bg1">
+                <a:lumMod val="50000"/>
+              </a:schemeClr>
+            </a:solidFill>
+            <a:round/>
+          </a:ln>
+        </p:spPr>
+        <p:style>
+          <a:lnRef idx="2">
+            <a:schemeClr val="accent1"/>
+          </a:lnRef>
+          <a:fillRef idx="0">
+            <a:schemeClr val="accent1"/>
+          </a:fillRef>
+          <a:effectRef idx="1">
+            <a:schemeClr val="accent1"/>
+          </a:effectRef>
+          <a:fontRef idx="minor">
+            <a:schemeClr val="tx1"/>
+          </a:fontRef>
+        </p:style>
+        <p:txBody>
+          <a:bodyPr rtlCol="0" anchor="ctr"/>
+          <a:lstStyle/>
+          <a:p>
+            <a:pPr algn="ctr"/>
+            <a:endParaRPr lang="de-DE"/>
+          </a:p>
+        </p:txBody>
+      </p:sp>
+      <p:sp>
+        <p:nvSpPr>
+          <p:cNvPr id="10" name="Bogen 9">
+            <a:extLst>
+              <a:ext uri="{FF2B5EF4-FFF2-40B4-BE49-F238E27FC236}">
+                <a16:creationId xmlns:a16="http://schemas.microsoft.com/office/drawing/2014/main" id="{ACB60C64-F63E-9C4C-95EC-2599A0A11DF7}"/>
+              </a:ext>
+            </a:extLst>
+          </p:cNvPr>
+          <p:cNvSpPr/>
+          <p:nvPr/>
+        </p:nvSpPr>
+        <p:spPr>
+          <a:xfrm rot="10800000">
+            <a:off x="1592580" y="1425052"/>
+            <a:ext cx="423368" cy="389298"/>
+          </a:xfrm>
+          <a:prstGeom prst="arc">
+            <a:avLst>
+              <a:gd name="adj1" fmla="val 1151559"/>
+              <a:gd name="adj2" fmla="val 9637948"/>
+            </a:avLst>
+          </a:prstGeom>
+          <a:ln cap="rnd">
+            <a:solidFill>
+              <a:schemeClr val="tx1">
+                <a:lumMod val="75000"/>
+                <a:lumOff val="25000"/>
+              </a:schemeClr>
+            </a:solidFill>
+            <a:round/>
+          </a:ln>
+        </p:spPr>
+        <p:style>
+          <a:lnRef idx="2">
+            <a:schemeClr val="accent1"/>
+          </a:lnRef>
+          <a:fillRef idx="0">
+            <a:schemeClr val="accent1"/>
+          </a:fillRef>
+          <a:effectRef idx="1">
+            <a:schemeClr val="accent1"/>
+          </a:effectRef>
+          <a:fontRef idx="minor">
+            <a:schemeClr val="tx1"/>
+          </a:fontRef>
+        </p:style>
+        <p:txBody>
+          <a:bodyPr rtlCol="0" anchor="ctr"/>
+          <a:lstStyle/>
+          <a:p>
+            <a:pPr algn="ctr"/>
+            <a:endParaRPr lang="de-DE"/>
+          </a:p>
+        </p:txBody>
+      </p:sp>
+      <p:cxnSp>
+        <p:nvCxnSpPr>
+          <p:cNvPr id="50" name="Gerader Verbinder 49">
+            <a:extLst>
+              <a:ext uri="{FF2B5EF4-FFF2-40B4-BE49-F238E27FC236}">
+                <a16:creationId xmlns:a16="http://schemas.microsoft.com/office/drawing/2014/main" id="{3ACB3442-BEAE-556F-2C1B-3C7E4CB6182E}"/>
+              </a:ext>
+            </a:extLst>
+          </p:cNvPr>
+          <p:cNvCxnSpPr>
+            <a:cxnSpLocks/>
+          </p:cNvCxnSpPr>
+          <p:nvPr/>
+        </p:nvCxnSpPr>
+        <p:spPr>
+          <a:xfrm rot="10800000">
+            <a:off x="1990989" y="1439242"/>
+            <a:ext cx="151789" cy="566487"/>
+          </a:xfrm>
+          <a:prstGeom prst="line">
+            <a:avLst/>
+          </a:prstGeom>
+          <a:ln cap="rnd">
+            <a:solidFill>
+              <a:schemeClr val="tx1">
+                <a:lumMod val="50000"/>
+                <a:lumOff val="50000"/>
+              </a:schemeClr>
+            </a:solidFill>
+            <a:round/>
+          </a:ln>
+        </p:spPr>
+        <p:style>
+          <a:lnRef idx="2">
+            <a:schemeClr val="accent1"/>
+          </a:lnRef>
+          <a:fillRef idx="0">
+            <a:schemeClr val="accent1"/>
+          </a:fillRef>
+          <a:effectRef idx="1">
+            <a:schemeClr val="accent1"/>
+          </a:effectRef>
+          <a:fontRef idx="minor">
+            <a:schemeClr val="tx1"/>
+          </a:fontRef>
+        </p:style>
+      </p:cxnSp>
+      <p:cxnSp>
+        <p:nvCxnSpPr>
+          <p:cNvPr id="51" name="Gerader Verbinder 50">
+            <a:extLst>
+              <a:ext uri="{FF2B5EF4-FFF2-40B4-BE49-F238E27FC236}">
+                <a16:creationId xmlns:a16="http://schemas.microsoft.com/office/drawing/2014/main" id="{0A9D0C6B-9AE7-E52B-C244-A39DB1AB80DC}"/>
+              </a:ext>
+            </a:extLst>
+          </p:cNvPr>
+          <p:cNvCxnSpPr>
+            <a:cxnSpLocks/>
+          </p:cNvCxnSpPr>
+          <p:nvPr/>
+        </p:nvCxnSpPr>
+        <p:spPr>
+          <a:xfrm rot="10800000" flipH="1">
+            <a:off x="1465765" y="1442594"/>
+            <a:ext cx="150943" cy="563327"/>
+          </a:xfrm>
+          <a:prstGeom prst="line">
+            <a:avLst/>
+          </a:prstGeom>
+          <a:ln cap="rnd">
+            <a:solidFill>
+              <a:schemeClr val="tx1">
+                <a:lumMod val="50000"/>
+                <a:lumOff val="50000"/>
+              </a:schemeClr>
+            </a:solidFill>
+            <a:round/>
+          </a:ln>
+        </p:spPr>
+        <p:style>
+          <a:lnRef idx="2">
+            <a:schemeClr val="accent1"/>
+          </a:lnRef>
+          <a:fillRef idx="0">
+            <a:schemeClr val="accent1"/>
+          </a:fillRef>
+          <a:effectRef idx="1">
+            <a:schemeClr val="accent1"/>
+          </a:effectRef>
+          <a:fontRef idx="minor">
+            <a:schemeClr val="tx1"/>
+          </a:fontRef>
+        </p:style>
+      </p:cxnSp>
+      <p:cxnSp>
+        <p:nvCxnSpPr>
+          <p:cNvPr id="52" name="Gerader Verbinder 51">
+            <a:extLst>
+              <a:ext uri="{FF2B5EF4-FFF2-40B4-BE49-F238E27FC236}">
+                <a16:creationId xmlns:a16="http://schemas.microsoft.com/office/drawing/2014/main" id="{388ADA89-854B-D2CE-C2C8-75511BC797DF}"/>
+              </a:ext>
+            </a:extLst>
+          </p:cNvPr>
+          <p:cNvCxnSpPr>
+            <a:cxnSpLocks/>
+          </p:cNvCxnSpPr>
+          <p:nvPr/>
+        </p:nvCxnSpPr>
+        <p:spPr>
+          <a:xfrm rot="10800000">
+            <a:off x="916092" y="1442594"/>
+            <a:ext cx="150933" cy="563288"/>
+          </a:xfrm>
+          <a:prstGeom prst="line">
+            <a:avLst/>
+          </a:prstGeom>
+          <a:ln cap="rnd">
+            <a:solidFill>
+              <a:schemeClr val="tx1">
+                <a:lumMod val="50000"/>
+                <a:lumOff val="50000"/>
+              </a:schemeClr>
+            </a:solidFill>
+            <a:round/>
+          </a:ln>
+        </p:spPr>
+        <p:style>
+          <a:lnRef idx="2">
+            <a:schemeClr val="accent1"/>
+          </a:lnRef>
+          <a:fillRef idx="0">
+            <a:schemeClr val="accent1"/>
+          </a:fillRef>
+          <a:effectRef idx="1">
+            <a:schemeClr val="accent1"/>
+          </a:effectRef>
+          <a:fontRef idx="minor">
+            <a:schemeClr val="tx1"/>
+          </a:fontRef>
+        </p:style>
+      </p:cxnSp>
+      <p:cxnSp>
+        <p:nvCxnSpPr>
+          <p:cNvPr id="66" name="Gerader Verbinder 65">
+            <a:extLst>
+              <a:ext uri="{FF2B5EF4-FFF2-40B4-BE49-F238E27FC236}">
+                <a16:creationId xmlns:a16="http://schemas.microsoft.com/office/drawing/2014/main" id="{74E5E269-FDC4-34FF-6BBF-A97D3A4FE229}"/>
+              </a:ext>
+            </a:extLst>
+          </p:cNvPr>
+          <p:cNvCxnSpPr>
+            <a:cxnSpLocks/>
+          </p:cNvCxnSpPr>
+          <p:nvPr/>
+        </p:nvCxnSpPr>
+        <p:spPr>
+          <a:xfrm rot="10800000" flipH="1">
+            <a:off x="385935" y="1442593"/>
+            <a:ext cx="150943" cy="563327"/>
+          </a:xfrm>
+          <a:prstGeom prst="line">
+            <a:avLst/>
+          </a:prstGeom>
+          <a:ln cap="rnd">
+            <a:solidFill>
+              <a:schemeClr val="tx1">
+                <a:lumMod val="50000"/>
+                <a:lumOff val="50000"/>
+              </a:schemeClr>
+            </a:solidFill>
+            <a:round/>
+          </a:ln>
+        </p:spPr>
+        <p:style>
+          <a:lnRef idx="2">
+            <a:schemeClr val="accent1"/>
+          </a:lnRef>
+          <a:fillRef idx="0">
+            <a:schemeClr val="accent1"/>
+          </a:fillRef>
+          <a:effectRef idx="1">
+            <a:schemeClr val="accent1"/>
+          </a:effectRef>
+          <a:fontRef idx="minor">
+            <a:schemeClr val="tx1"/>
+          </a:fontRef>
+        </p:style>
+      </p:cxnSp>
+      <p:sp>
+        <p:nvSpPr>
+          <p:cNvPr id="12" name="Bogen 11">
+            <a:extLst>
+              <a:ext uri="{FF2B5EF4-FFF2-40B4-BE49-F238E27FC236}">
+                <a16:creationId xmlns:a16="http://schemas.microsoft.com/office/drawing/2014/main" id="{FC2B1910-FF51-BF31-4F17-78DECC1AD9FF}"/>
+              </a:ext>
+            </a:extLst>
+          </p:cNvPr>
+          <p:cNvSpPr/>
+          <p:nvPr/>
+        </p:nvSpPr>
+        <p:spPr>
+          <a:xfrm rot="10800000">
+            <a:off x="2674009" y="1330266"/>
+            <a:ext cx="406373" cy="365184"/>
+          </a:xfrm>
+          <a:prstGeom prst="arc">
+            <a:avLst>
+              <a:gd name="adj1" fmla="val 1151559"/>
+              <a:gd name="adj2" fmla="val 9637948"/>
+            </a:avLst>
+          </a:prstGeom>
+          <a:ln cap="rnd">
+            <a:solidFill>
+              <a:schemeClr val="bg1">
+                <a:lumMod val="50000"/>
+              </a:schemeClr>
+            </a:solidFill>
+            <a:round/>
+          </a:ln>
+        </p:spPr>
+        <p:style>
+          <a:lnRef idx="2">
+            <a:schemeClr val="accent1"/>
+          </a:lnRef>
+          <a:fillRef idx="0">
+            <a:schemeClr val="accent1"/>
+          </a:fillRef>
+          <a:effectRef idx="1">
+            <a:schemeClr val="accent1"/>
+          </a:effectRef>
+          <a:fontRef idx="minor">
+            <a:schemeClr val="tx1"/>
+          </a:fontRef>
+        </p:style>
+        <p:txBody>
+          <a:bodyPr rtlCol="0" anchor="ctr"/>
+          <a:lstStyle/>
+          <a:p>
+            <a:pPr algn="ctr"/>
+            <a:endParaRPr lang="de-DE"/>
+          </a:p>
+        </p:txBody>
+      </p:sp>
+      <p:sp>
+        <p:nvSpPr>
+          <p:cNvPr id="14" name="Bogen 13">
+            <a:extLst>
+              <a:ext uri="{FF2B5EF4-FFF2-40B4-BE49-F238E27FC236}">
+                <a16:creationId xmlns:a16="http://schemas.microsoft.com/office/drawing/2014/main" id="{994EADDF-6170-5B72-16C3-4664646627AB}"/>
+              </a:ext>
+            </a:extLst>
+          </p:cNvPr>
+          <p:cNvSpPr/>
+          <p:nvPr/>
+        </p:nvSpPr>
+        <p:spPr>
+          <a:xfrm rot="10800000">
+            <a:off x="2665354" y="1428862"/>
+            <a:ext cx="424556" cy="389298"/>
+          </a:xfrm>
+          <a:prstGeom prst="arc">
+            <a:avLst>
+              <a:gd name="adj1" fmla="val 1151559"/>
+              <a:gd name="adj2" fmla="val 9637948"/>
+            </a:avLst>
+          </a:prstGeom>
+          <a:ln cap="rnd">
+            <a:solidFill>
+              <a:schemeClr val="tx1">
+                <a:lumMod val="75000"/>
+                <a:lumOff val="25000"/>
+              </a:schemeClr>
+            </a:solidFill>
+            <a:round/>
+          </a:ln>
+        </p:spPr>
+        <p:style>
+          <a:lnRef idx="2">
+            <a:schemeClr val="accent1"/>
+          </a:lnRef>
+          <a:fillRef idx="0">
+            <a:schemeClr val="accent1"/>
+          </a:fillRef>
+          <a:effectRef idx="1">
+            <a:schemeClr val="accent1"/>
+          </a:effectRef>
+          <a:fontRef idx="minor">
+            <a:schemeClr val="tx1"/>
+          </a:fontRef>
+        </p:style>
+        <p:txBody>
+          <a:bodyPr rtlCol="0" anchor="ctr"/>
+          <a:lstStyle/>
+          <a:p>
+            <a:pPr algn="ctr"/>
+            <a:endParaRPr lang="de-DE"/>
+          </a:p>
+        </p:txBody>
+      </p:sp>
+      <p:cxnSp>
+        <p:nvCxnSpPr>
+          <p:cNvPr id="55" name="Gerader Verbinder 54">
+            <a:extLst>
+              <a:ext uri="{FF2B5EF4-FFF2-40B4-BE49-F238E27FC236}">
+                <a16:creationId xmlns:a16="http://schemas.microsoft.com/office/drawing/2014/main" id="{376180BC-CDEE-200E-9827-D771F57638FB}"/>
+              </a:ext>
+            </a:extLst>
+          </p:cNvPr>
+          <p:cNvCxnSpPr>
+            <a:cxnSpLocks/>
+          </p:cNvCxnSpPr>
+          <p:nvPr/>
+        </p:nvCxnSpPr>
+        <p:spPr>
+          <a:xfrm rot="10800000">
+            <a:off x="3063939" y="1439242"/>
+            <a:ext cx="151789" cy="566487"/>
+          </a:xfrm>
+          <a:prstGeom prst="line">
+            <a:avLst/>
+          </a:prstGeom>
+          <a:ln cap="rnd">
+            <a:solidFill>
+              <a:schemeClr val="tx1">
+                <a:lumMod val="50000"/>
+                <a:lumOff val="50000"/>
+              </a:schemeClr>
+            </a:solidFill>
+            <a:round/>
+          </a:ln>
+        </p:spPr>
+        <p:style>
+          <a:lnRef idx="2">
+            <a:schemeClr val="accent1"/>
+          </a:lnRef>
+          <a:fillRef idx="0">
+            <a:schemeClr val="accent1"/>
+          </a:fillRef>
+          <a:effectRef idx="1">
+            <a:schemeClr val="accent1"/>
+          </a:effectRef>
+          <a:fontRef idx="minor">
+            <a:schemeClr val="tx1"/>
+          </a:fontRef>
+        </p:style>
+      </p:cxnSp>
+      <p:cxnSp>
+        <p:nvCxnSpPr>
+          <p:cNvPr id="56" name="Gerader Verbinder 55">
+            <a:extLst>
+              <a:ext uri="{FF2B5EF4-FFF2-40B4-BE49-F238E27FC236}">
+                <a16:creationId xmlns:a16="http://schemas.microsoft.com/office/drawing/2014/main" id="{F0D63A6F-969E-99E6-27B7-C28E985DC3F1}"/>
+              </a:ext>
+            </a:extLst>
+          </p:cNvPr>
+          <p:cNvCxnSpPr>
+            <a:cxnSpLocks/>
+          </p:cNvCxnSpPr>
+          <p:nvPr/>
+        </p:nvCxnSpPr>
+        <p:spPr>
+          <a:xfrm rot="10800000" flipH="1">
+            <a:off x="2538715" y="1442594"/>
+            <a:ext cx="150943" cy="563327"/>
+          </a:xfrm>
+          <a:prstGeom prst="line">
+            <a:avLst/>
+          </a:prstGeom>
+          <a:ln cap="rnd">
+            <a:solidFill>
+              <a:schemeClr val="tx1">
+                <a:lumMod val="50000"/>
+                <a:lumOff val="50000"/>
+              </a:schemeClr>
+            </a:solidFill>
+            <a:round/>
+          </a:ln>
+        </p:spPr>
+        <p:style>
+          <a:lnRef idx="2">
+            <a:schemeClr val="accent1"/>
+          </a:lnRef>
+          <a:fillRef idx="0">
+            <a:schemeClr val="accent1"/>
+          </a:fillRef>
+          <a:effectRef idx="1">
+            <a:schemeClr val="accent1"/>
+          </a:effectRef>
+          <a:fontRef idx="minor">
+            <a:schemeClr val="tx1"/>
+          </a:fontRef>
+        </p:style>
+      </p:cxnSp>
+      <p:sp>
+        <p:nvSpPr>
+          <p:cNvPr id="17" name="Bogen 16">
+            <a:extLst>
+              <a:ext uri="{FF2B5EF4-FFF2-40B4-BE49-F238E27FC236}">
+                <a16:creationId xmlns:a16="http://schemas.microsoft.com/office/drawing/2014/main" id="{CC87F743-BB58-9010-0BA1-E457DBC76637}"/>
+              </a:ext>
+            </a:extLst>
+          </p:cNvPr>
+          <p:cNvSpPr/>
+          <p:nvPr/>
+        </p:nvSpPr>
+        <p:spPr>
+          <a:xfrm>
+            <a:off x="1062756" y="1860895"/>
+            <a:ext cx="405765" cy="365184"/>
+          </a:xfrm>
+          <a:prstGeom prst="arc">
+            <a:avLst>
+              <a:gd name="adj1" fmla="val 1151559"/>
+              <a:gd name="adj2" fmla="val 9637948"/>
+            </a:avLst>
+          </a:prstGeom>
+          <a:ln cap="rnd">
+            <a:solidFill>
+              <a:schemeClr val="tx1">
+                <a:lumMod val="75000"/>
+                <a:lumOff val="25000"/>
+              </a:schemeClr>
+            </a:solidFill>
+            <a:round/>
+          </a:ln>
+        </p:spPr>
+        <p:style>
+          <a:lnRef idx="2">
+            <a:schemeClr val="accent1"/>
+          </a:lnRef>
+          <a:fillRef idx="0">
+            <a:schemeClr val="accent1"/>
+          </a:fillRef>
+          <a:effectRef idx="1">
+            <a:schemeClr val="accent1"/>
+          </a:effectRef>
+          <a:fontRef idx="minor">
+            <a:schemeClr val="tx1"/>
+          </a:fontRef>
+        </p:style>
+        <p:txBody>
+          <a:bodyPr rtlCol="0" anchor="ctr"/>
+          <a:lstStyle/>
+          <a:p>
+            <a:pPr algn="ctr"/>
+            <a:endParaRPr lang="de-DE"/>
+          </a:p>
+        </p:txBody>
+      </p:sp>
+      <p:sp>
+        <p:nvSpPr>
+          <p:cNvPr id="19" name="Bogen 18">
+            <a:extLst>
+              <a:ext uri="{FF2B5EF4-FFF2-40B4-BE49-F238E27FC236}">
+                <a16:creationId xmlns:a16="http://schemas.microsoft.com/office/drawing/2014/main" id="{EA115380-A783-6DAD-B12C-7040702A7F0D}"/>
+              </a:ext>
+            </a:extLst>
+          </p:cNvPr>
+          <p:cNvSpPr/>
+          <p:nvPr/>
+        </p:nvSpPr>
+        <p:spPr>
+          <a:xfrm>
+            <a:off x="1053231" y="1738184"/>
+            <a:ext cx="426719" cy="389298"/>
+          </a:xfrm>
+          <a:prstGeom prst="arc">
+            <a:avLst>
+              <a:gd name="adj1" fmla="val 1151559"/>
+              <a:gd name="adj2" fmla="val 9637948"/>
+            </a:avLst>
+          </a:prstGeom>
+          <a:ln cap="rnd">
+            <a:solidFill>
+              <a:schemeClr val="tx1">
+                <a:lumMod val="50000"/>
+                <a:lumOff val="50000"/>
+              </a:schemeClr>
+            </a:solidFill>
+            <a:round/>
+          </a:ln>
+        </p:spPr>
+        <p:style>
+          <a:lnRef idx="2">
+            <a:schemeClr val="accent1"/>
+          </a:lnRef>
+          <a:fillRef idx="0">
+            <a:schemeClr val="accent1"/>
+          </a:fillRef>
+          <a:effectRef idx="1">
+            <a:schemeClr val="accent1"/>
+          </a:effectRef>
+          <a:fontRef idx="minor">
+            <a:schemeClr val="tx1"/>
+          </a:fontRef>
+        </p:style>
+        <p:txBody>
+          <a:bodyPr rtlCol="0" anchor="ctr"/>
+          <a:lstStyle/>
+          <a:p>
+            <a:pPr algn="ctr"/>
+            <a:endParaRPr lang="de-DE"/>
+          </a:p>
+        </p:txBody>
+      </p:sp>
+      <p:sp>
+        <p:nvSpPr>
+          <p:cNvPr id="22" name="Bogen 21">
+            <a:extLst>
+              <a:ext uri="{FF2B5EF4-FFF2-40B4-BE49-F238E27FC236}">
+                <a16:creationId xmlns:a16="http://schemas.microsoft.com/office/drawing/2014/main" id="{28D601EE-ECCA-CCD6-57B8-0B4CD932A48B}"/>
+              </a:ext>
+            </a:extLst>
+          </p:cNvPr>
+          <p:cNvSpPr/>
+          <p:nvPr/>
+        </p:nvSpPr>
+        <p:spPr>
+          <a:xfrm>
+            <a:off x="2137725" y="1860839"/>
+            <a:ext cx="405765" cy="365184"/>
+          </a:xfrm>
+          <a:prstGeom prst="arc">
+            <a:avLst>
+              <a:gd name="adj1" fmla="val 1151559"/>
+              <a:gd name="adj2" fmla="val 9637948"/>
+            </a:avLst>
+          </a:prstGeom>
+          <a:ln cap="rnd">
+            <a:solidFill>
+              <a:schemeClr val="tx1">
+                <a:lumMod val="75000"/>
+                <a:lumOff val="25000"/>
+              </a:schemeClr>
+            </a:solidFill>
+            <a:round/>
+          </a:ln>
+        </p:spPr>
+        <p:style>
+          <a:lnRef idx="2">
+            <a:schemeClr val="accent1"/>
+          </a:lnRef>
+          <a:fillRef idx="0">
+            <a:schemeClr val="accent1"/>
+          </a:fillRef>
+          <a:effectRef idx="1">
+            <a:schemeClr val="accent1"/>
+          </a:effectRef>
+          <a:fontRef idx="minor">
+            <a:schemeClr val="tx1"/>
+          </a:fontRef>
+        </p:style>
+        <p:txBody>
+          <a:bodyPr rtlCol="0" anchor="ctr"/>
+          <a:lstStyle/>
+          <a:p>
+            <a:pPr algn="ctr"/>
+            <a:endParaRPr lang="de-DE"/>
+          </a:p>
+        </p:txBody>
+      </p:sp>
+      <p:sp>
+        <p:nvSpPr>
+          <p:cNvPr id="24" name="Bogen 23">
+            <a:extLst>
+              <a:ext uri="{FF2B5EF4-FFF2-40B4-BE49-F238E27FC236}">
+                <a16:creationId xmlns:a16="http://schemas.microsoft.com/office/drawing/2014/main" id="{E31AD02F-3472-8918-C405-88318A178DE3}"/>
+              </a:ext>
+            </a:extLst>
+          </p:cNvPr>
+          <p:cNvSpPr/>
+          <p:nvPr/>
+        </p:nvSpPr>
+        <p:spPr>
+          <a:xfrm>
+            <a:off x="2128200" y="1738128"/>
+            <a:ext cx="426719" cy="389298"/>
+          </a:xfrm>
+          <a:prstGeom prst="arc">
+            <a:avLst>
+              <a:gd name="adj1" fmla="val 1151559"/>
+              <a:gd name="adj2" fmla="val 9637948"/>
+            </a:avLst>
+          </a:prstGeom>
+          <a:ln cap="rnd">
+            <a:solidFill>
+              <a:schemeClr val="tx1">
+                <a:lumMod val="50000"/>
+                <a:lumOff val="50000"/>
+              </a:schemeClr>
+            </a:solidFill>
+            <a:round/>
+          </a:ln>
+        </p:spPr>
+        <p:style>
+          <a:lnRef idx="2">
+            <a:schemeClr val="accent1"/>
+          </a:lnRef>
+          <a:fillRef idx="0">
+            <a:schemeClr val="accent1"/>
+          </a:fillRef>
+          <a:effectRef idx="1">
+            <a:schemeClr val="accent1"/>
+          </a:effectRef>
+          <a:fontRef idx="minor">
+            <a:schemeClr val="tx1"/>
+          </a:fontRef>
+        </p:style>
+        <p:txBody>
+          <a:bodyPr rtlCol="0" anchor="ctr"/>
+          <a:lstStyle/>
+          <a:p>
+            <a:pPr algn="ctr"/>
+            <a:endParaRPr lang="de-DE"/>
+          </a:p>
+        </p:txBody>
+      </p:sp>
+      <p:sp>
+        <p:nvSpPr>
+          <p:cNvPr id="27" name="Bogen 26">
+            <a:extLst>
+              <a:ext uri="{FF2B5EF4-FFF2-40B4-BE49-F238E27FC236}">
+                <a16:creationId xmlns:a16="http://schemas.microsoft.com/office/drawing/2014/main" id="{B1759E70-A903-555E-C9F1-D7439801CD60}"/>
+              </a:ext>
+            </a:extLst>
+          </p:cNvPr>
+          <p:cNvSpPr/>
+          <p:nvPr/>
+        </p:nvSpPr>
+        <p:spPr>
+          <a:xfrm>
+            <a:off x="-15857" y="1862744"/>
+            <a:ext cx="405765" cy="365184"/>
+          </a:xfrm>
+          <a:prstGeom prst="arc">
+            <a:avLst>
+              <a:gd name="adj1" fmla="val 1151559"/>
+              <a:gd name="adj2" fmla="val 3202927"/>
+            </a:avLst>
+          </a:prstGeom>
+          <a:ln cap="rnd">
+            <a:solidFill>
+              <a:schemeClr val="tx1">
+                <a:lumMod val="75000"/>
+                <a:lumOff val="25000"/>
+              </a:schemeClr>
+            </a:solidFill>
+            <a:round/>
+          </a:ln>
+        </p:spPr>
+        <p:style>
+          <a:lnRef idx="2">
+            <a:schemeClr val="accent1"/>
+          </a:lnRef>
+          <a:fillRef idx="0">
+            <a:schemeClr val="accent1"/>
+          </a:fillRef>
+          <a:effectRef idx="1">
+            <a:schemeClr val="accent1"/>
+          </a:effectRef>
+          <a:fontRef idx="minor">
+            <a:schemeClr val="tx1"/>
+          </a:fontRef>
+        </p:style>
+        <p:txBody>
+          <a:bodyPr rtlCol="0" anchor="ctr"/>
+          <a:lstStyle/>
+          <a:p>
+            <a:pPr algn="ctr"/>
+            <a:endParaRPr lang="de-DE"/>
+          </a:p>
+        </p:txBody>
+      </p:sp>
+      <p:sp>
+        <p:nvSpPr>
+          <p:cNvPr id="31" name="Bogen 30">
+            <a:extLst>
+              <a:ext uri="{FF2B5EF4-FFF2-40B4-BE49-F238E27FC236}">
+                <a16:creationId xmlns:a16="http://schemas.microsoft.com/office/drawing/2014/main" id="{CB993EE7-46AC-25AB-5281-874F70E17BF1}"/>
+              </a:ext>
+            </a:extLst>
+          </p:cNvPr>
+          <p:cNvSpPr/>
+          <p:nvPr/>
+        </p:nvSpPr>
+        <p:spPr>
+          <a:xfrm>
+            <a:off x="-25382" y="1738128"/>
+            <a:ext cx="426719" cy="389298"/>
+          </a:xfrm>
+          <a:prstGeom prst="arc">
+            <a:avLst>
+              <a:gd name="adj1" fmla="val 1151559"/>
+              <a:gd name="adj2" fmla="val 3495597"/>
+            </a:avLst>
+          </a:prstGeom>
+          <a:ln cap="rnd">
+            <a:solidFill>
+              <a:schemeClr val="tx1">
+                <a:lumMod val="50000"/>
+                <a:lumOff val="50000"/>
+              </a:schemeClr>
+            </a:solidFill>
+            <a:round/>
+          </a:ln>
+        </p:spPr>
+        <p:style>
+          <a:lnRef idx="2">
+            <a:schemeClr val="accent1"/>
+          </a:lnRef>
+          <a:fillRef idx="0">
+            <a:schemeClr val="accent1"/>
+          </a:fillRef>
+          <a:effectRef idx="1">
+            <a:schemeClr val="accent1"/>
+          </a:effectRef>
+          <a:fontRef idx="minor">
+            <a:schemeClr val="tx1"/>
+          </a:fontRef>
+        </p:style>
+        <p:txBody>
+          <a:bodyPr rtlCol="0" anchor="ctr"/>
+          <a:lstStyle/>
+          <a:p>
+            <a:pPr algn="ctr"/>
+            <a:endParaRPr lang="de-DE"/>
+          </a:p>
+        </p:txBody>
+      </p:sp>
+      <p:sp>
+        <p:nvSpPr>
+          <p:cNvPr id="37" name="Bogen 36">
+            <a:extLst>
+              <a:ext uri="{FF2B5EF4-FFF2-40B4-BE49-F238E27FC236}">
+                <a16:creationId xmlns:a16="http://schemas.microsoft.com/office/drawing/2014/main" id="{6DBF449F-D6FB-0367-48E1-3ED223BBA193}"/>
+              </a:ext>
+            </a:extLst>
+          </p:cNvPr>
+          <p:cNvSpPr/>
+          <p:nvPr/>
+        </p:nvSpPr>
+        <p:spPr>
+          <a:xfrm>
+            <a:off x="3209870" y="1860839"/>
+            <a:ext cx="405765" cy="365184"/>
+          </a:xfrm>
+          <a:prstGeom prst="arc">
+            <a:avLst>
+              <a:gd name="adj1" fmla="val 7703059"/>
+              <a:gd name="adj2" fmla="val 9637948"/>
+            </a:avLst>
+          </a:prstGeom>
+          <a:ln cap="rnd">
+            <a:solidFill>
+              <a:schemeClr val="tx1">
+                <a:lumMod val="75000"/>
+                <a:lumOff val="25000"/>
+              </a:schemeClr>
+            </a:solidFill>
+            <a:round/>
+          </a:ln>
+        </p:spPr>
+        <p:style>
+          <a:lnRef idx="2">
+            <a:schemeClr val="accent1"/>
+          </a:lnRef>
+          <a:fillRef idx="0">
+            <a:schemeClr val="accent1"/>
+          </a:fillRef>
+          <a:effectRef idx="1">
+            <a:schemeClr val="accent1"/>
+          </a:effectRef>
+          <a:fontRef idx="minor">
+            <a:schemeClr val="tx1"/>
+          </a:fontRef>
+        </p:style>
+        <p:txBody>
+          <a:bodyPr rtlCol="0" anchor="ctr"/>
+          <a:lstStyle/>
+          <a:p>
+            <a:pPr algn="ctr"/>
+            <a:endParaRPr lang="de-DE"/>
+          </a:p>
+        </p:txBody>
+      </p:sp>
+      <p:sp>
+        <p:nvSpPr>
+          <p:cNvPr id="40" name="Bogen 39">
+            <a:extLst>
+              <a:ext uri="{FF2B5EF4-FFF2-40B4-BE49-F238E27FC236}">
+                <a16:creationId xmlns:a16="http://schemas.microsoft.com/office/drawing/2014/main" id="{C6DE6B71-4F41-4D6F-898D-222BABBD18A6}"/>
+              </a:ext>
+            </a:extLst>
+          </p:cNvPr>
+          <p:cNvSpPr/>
+          <p:nvPr/>
+        </p:nvSpPr>
+        <p:spPr>
+          <a:xfrm>
+            <a:off x="3200345" y="1738128"/>
+            <a:ext cx="426719" cy="389298"/>
+          </a:xfrm>
+          <a:prstGeom prst="arc">
+            <a:avLst>
+              <a:gd name="adj1" fmla="val 7485783"/>
+              <a:gd name="adj2" fmla="val 9637948"/>
+            </a:avLst>
+          </a:prstGeom>
+          <a:ln cap="rnd">
+            <a:solidFill>
+              <a:schemeClr val="tx1">
+                <a:lumMod val="50000"/>
+                <a:lumOff val="50000"/>
+              </a:schemeClr>
+            </a:solidFill>
+            <a:round/>
+          </a:ln>
+        </p:spPr>
+        <p:style>
+          <a:lnRef idx="2">
+            <a:schemeClr val="accent1"/>
+          </a:lnRef>
+          <a:fillRef idx="0">
+            <a:schemeClr val="accent1"/>
+          </a:fillRef>
+          <a:effectRef idx="1">
+            <a:schemeClr val="accent1"/>
+          </a:effectRef>
+          <a:fontRef idx="minor">
+            <a:schemeClr val="tx1"/>
+          </a:fontRef>
+        </p:style>
+        <p:txBody>
+          <a:bodyPr rtlCol="0" anchor="ctr"/>
+          <a:lstStyle/>
+          <a:p>
+            <a:pPr algn="ctr"/>
+            <a:endParaRPr lang="de-DE"/>
+          </a:p>
+        </p:txBody>
+      </p:sp>
+      <p:sp>
+        <p:nvSpPr>
+          <p:cNvPr id="92" name="Rechteck 91">
+            <a:extLst>
+              <a:ext uri="{FF2B5EF4-FFF2-40B4-BE49-F238E27FC236}">
+                <a16:creationId xmlns:a16="http://schemas.microsoft.com/office/drawing/2014/main" id="{F78000E4-B249-9F84-DC20-EA708E44B31E}"/>
+              </a:ext>
+            </a:extLst>
+          </p:cNvPr>
+          <p:cNvSpPr/>
+          <p:nvPr/>
+        </p:nvSpPr>
+        <p:spPr>
+          <a:xfrm>
+            <a:off x="294322" y="1251585"/>
+            <a:ext cx="3011805" cy="1097280"/>
+          </a:xfrm>
+          <a:prstGeom prst="rect">
+            <a:avLst/>
+          </a:prstGeom>
+          <a:noFill/>
+          <a:ln w="63500">
+            <a:solidFill>
+              <a:schemeClr val="bg1"/>
+            </a:solidFill>
+          </a:ln>
+        </p:spPr>
+        <p:style>
+          <a:lnRef idx="2">
+            <a:schemeClr val="accent1">
+              <a:shade val="15000"/>
+            </a:schemeClr>
+          </a:lnRef>
+          <a:fillRef idx="1">
+            <a:schemeClr val="accent1"/>
+          </a:fillRef>
+          <a:effectRef idx="0">
+            <a:schemeClr val="accent1"/>
+          </a:effectRef>
+          <a:fontRef idx="minor">
+            <a:schemeClr val="lt1"/>
+          </a:fontRef>
+        </p:style>
+        <p:txBody>
+          <a:bodyPr rtlCol="0" anchor="ctr"/>
+          <a:lstStyle/>
+          <a:p>
+            <a:pPr algn="ctr"/>
+            <a:endParaRPr lang="de-DE"/>
+          </a:p>
+        </p:txBody>
+      </p:sp>
+    </p:spTree>
+    <p:extLst>
+      <p:ext uri="{BB962C8B-B14F-4D97-AF65-F5344CB8AC3E}">
+        <p14:creationId xmlns:p14="http://schemas.microsoft.com/office/powerpoint/2010/main" val="1350884112"/>
+      </p:ext>
+    </p:extLst>
+  </p:cSld>
+  <p:clrMapOvr>
+    <a:masterClrMapping/>
+  </p:clrMapOvr>
+</p:sld>
+</file>
+
+<file path=ppt/slides/slide23.xml><?xml version="1.0" encoding="utf-8"?>
+<p:sld xmlns:a="http://schemas.openxmlformats.org/drawingml/2006/main" xmlns:r="http://schemas.openxmlformats.org/officeDocument/2006/relationships" xmlns:p="http://schemas.openxmlformats.org/presentationml/2006/main">
+  <p:cSld>
+    <p:spTree>
+      <p:nvGrpSpPr>
+        <p:cNvPr id="1" name="">
+          <a:extLst>
+            <a:ext uri="{FF2B5EF4-FFF2-40B4-BE49-F238E27FC236}">
               <a16:creationId xmlns:a16="http://schemas.microsoft.com/office/drawing/2014/main" id="{B435F373-EB64-62D3-C4EF-E1C84766BA32}"/>
             </a:ext>
           </a:extLst>
@@ -30162,7 +32366,7 @@
 </p:sld>
 </file>
 
-<file path=ppt/slides/slide23.xml><?xml version="1.0" encoding="utf-8"?>
+<file path=ppt/slides/slide24.xml><?xml version="1.0" encoding="utf-8"?>
 <p:sld xmlns:a="http://schemas.openxmlformats.org/drawingml/2006/main" xmlns:r="http://schemas.openxmlformats.org/officeDocument/2006/relationships" xmlns:p="http://schemas.openxmlformats.org/presentationml/2006/main">
   <p:cSld>
     <p:spTree>

</xml_diff>